<commit_message>
Team slide: split NET NEW HEADCOUNT into FY26/FY27; tag MLOps Engineer as FY26 hire
Co-Authored-By: Claude Sonnet 4.6 <noreply@anthropic.com>
</commit_message>
<xml_diff>
--- a/jhbi-roadmap-2026.pptx
+++ b/jhbi-roadmap-2026.pptx
@@ -2394,7 +2394,7 @@
         <p:spPr>
           <a:xfrm>
             <a:off x="5961888" y="576072"/>
-            <a:ext cx="3017520" cy="768096"/>
+            <a:ext cx="3017520" cy="896112"/>
           </a:xfrm>
           <a:prstGeom prst="rect">
             <a:avLst/>
@@ -2561,7 +2561,7 @@
         <p:spPr>
           <a:xfrm>
             <a:off x="6967728" y="758952"/>
-            <a:ext cx="0" cy="365760"/>
+            <a:ext cx="0" cy="493776"/>
           </a:xfrm>
           <a:prstGeom prst="line">
             <a:avLst/>
@@ -2662,7 +2662,7 @@
         <p:spPr>
           <a:xfrm>
             <a:off x="7973568" y="758952"/>
-            <a:ext cx="0" cy="365760"/>
+            <a:ext cx="0" cy="493776"/>
           </a:xfrm>
           <a:prstGeom prst="line">
             <a:avLst/>
@@ -2763,7 +2763,671 @@
         <p:spPr>
           <a:xfrm>
             <a:off x="5961888" y="1124712"/>
-            <a:ext cx="3017520" cy="219456"/>
+            <a:ext cx="3017520" cy="164592"/>
+          </a:xfrm>
+          <a:prstGeom prst="rect">
+            <a:avLst/>
+          </a:prstGeom>
+          <a:solidFill>
+            <a:srgbClr val="0A5CA8">
+              <a:alpha val="25000"/>
+            </a:srgbClr>
+          </a:solidFill>
+          <a:ln w="6350">
+            <a:solidFill>
+              <a:srgbClr val="E7ECF0"/>
+            </a:solidFill>
+            <a:prstDash val="solid"/>
+          </a:ln>
+        </p:spPr>
+      </p:sp>
+      <p:sp>
+        <p:nvSpPr>
+          <p:cNvPr id="23" name="Text 21"/>
+          <p:cNvSpPr/>
+          <p:nvPr/>
+        </p:nvSpPr>
+        <p:spPr>
+          <a:xfrm>
+            <a:off x="5961888" y="1124712"/>
+            <a:ext cx="3017520" cy="164592"/>
+          </a:xfrm>
+          <a:prstGeom prst="rect">
+            <a:avLst/>
+          </a:prstGeom>
+          <a:noFill/>
+          <a:ln/>
+        </p:spPr>
+        <p:txBody>
+          <a:bodyPr wrap="square" lIns="0" tIns="0" rIns="0" bIns="0" rtlCol="0" anchor="ctr"/>
+          <a:lstStyle/>
+          <a:p>
+            <a:pPr algn="ctr" indent="0" marL="0">
+              <a:buNone/>
+            </a:pPr>
+            <a:r>
+              <a:rPr lang="en-US" sz="700" dirty="0">
+                <a:solidFill>
+                  <a:srgbClr val="0A5CA8"/>
+                </a:solidFill>
+                <a:latin typeface="Calibri" pitchFamily="34" charset="0"/>
+                <a:ea typeface="Calibri" pitchFamily="34" charset="-122"/>
+                <a:cs typeface="Calibri" pitchFamily="34" charset="-120"/>
+              </a:rPr>
+              <a:t>FY26  ·  1 Position  (MLOps Engineer)</a:t>
+            </a:r>
+            <a:endParaRPr lang="en-US" sz="700" dirty="0"/>
+          </a:p>
+        </p:txBody>
+      </p:sp>
+      <p:sp>
+        <p:nvSpPr>
+          <p:cNvPr id="24" name="Shape 22"/>
+          <p:cNvSpPr/>
+          <p:nvPr/>
+        </p:nvSpPr>
+        <p:spPr>
+          <a:xfrm>
+            <a:off x="5961888" y="1289304"/>
+            <a:ext cx="3017520" cy="182880"/>
+          </a:xfrm>
+          <a:prstGeom prst="rect">
+            <a:avLst/>
+          </a:prstGeom>
+          <a:solidFill>
+            <a:srgbClr val="06185F"/>
+          </a:solidFill>
+          <a:ln w="12700">
+            <a:solidFill>
+              <a:srgbClr val="06185F"/>
+            </a:solidFill>
+            <a:prstDash val="solid"/>
+          </a:ln>
+        </p:spPr>
+      </p:sp>
+      <p:sp>
+        <p:nvSpPr>
+          <p:cNvPr id="25" name="Text 23"/>
+          <p:cNvSpPr/>
+          <p:nvPr/>
+        </p:nvSpPr>
+        <p:spPr>
+          <a:xfrm>
+            <a:off x="5961888" y="1289304"/>
+            <a:ext cx="3017520" cy="182880"/>
+          </a:xfrm>
+          <a:prstGeom prst="rect">
+            <a:avLst/>
+          </a:prstGeom>
+          <a:noFill/>
+          <a:ln/>
+        </p:spPr>
+        <p:txBody>
+          <a:bodyPr wrap="square" lIns="0" tIns="0" rIns="0" bIns="0" rtlCol="0" anchor="ctr"/>
+          <a:lstStyle/>
+          <a:p>
+            <a:pPr algn="ctr" indent="0" marL="0">
+              <a:buNone/>
+            </a:pPr>
+            <a:r>
+              <a:rPr lang="en-US" sz="850" b="1" dirty="0">
+                <a:solidFill>
+                  <a:srgbClr val="FFFFFF"/>
+                </a:solidFill>
+                <a:latin typeface="Calibri" pitchFamily="34" charset="0"/>
+                <a:ea typeface="Calibri" pitchFamily="34" charset="-122"/>
+                <a:cs typeface="Calibri" pitchFamily="34" charset="-120"/>
+              </a:rPr>
+              <a:t>FY27  ·  13 Positions</a:t>
+            </a:r>
+            <a:endParaRPr lang="en-US" sz="850" dirty="0"/>
+          </a:p>
+        </p:txBody>
+      </p:sp>
+      <p:sp>
+        <p:nvSpPr>
+          <p:cNvPr id="26" name="Shape 24"/>
+          <p:cNvSpPr/>
+          <p:nvPr/>
+        </p:nvSpPr>
+        <p:spPr>
+          <a:xfrm>
+            <a:off x="4572000" y="1161288"/>
+            <a:ext cx="0" cy="141732"/>
+          </a:xfrm>
+          <a:prstGeom prst="line">
+            <a:avLst/>
+          </a:prstGeom>
+          <a:noFill/>
+          <a:ln w="19050">
+            <a:solidFill>
+              <a:srgbClr val="B6BBC0"/>
+            </a:solidFill>
+            <a:prstDash val="solid"/>
+          </a:ln>
+        </p:spPr>
+      </p:sp>
+      <p:sp>
+        <p:nvSpPr>
+          <p:cNvPr id="27" name="Shape 25"/>
+          <p:cNvSpPr/>
+          <p:nvPr/>
+        </p:nvSpPr>
+        <p:spPr>
+          <a:xfrm>
+            <a:off x="1548384" y="1303020"/>
+            <a:ext cx="6047232" cy="0"/>
+          </a:xfrm>
+          <a:prstGeom prst="line">
+            <a:avLst/>
+          </a:prstGeom>
+          <a:noFill/>
+          <a:ln w="19050">
+            <a:solidFill>
+              <a:srgbClr val="B6BBC0"/>
+            </a:solidFill>
+            <a:prstDash val="solid"/>
+          </a:ln>
+        </p:spPr>
+      </p:sp>
+      <p:sp>
+        <p:nvSpPr>
+          <p:cNvPr id="28" name="Shape 26"/>
+          <p:cNvSpPr/>
+          <p:nvPr/>
+        </p:nvSpPr>
+        <p:spPr>
+          <a:xfrm>
+            <a:off x="1548384" y="1303020"/>
+            <a:ext cx="0" cy="141732"/>
+          </a:xfrm>
+          <a:prstGeom prst="line">
+            <a:avLst/>
+          </a:prstGeom>
+          <a:noFill/>
+          <a:ln w="19050">
+            <a:solidFill>
+              <a:srgbClr val="B6BBC0"/>
+            </a:solidFill>
+            <a:prstDash val="solid"/>
+          </a:ln>
+        </p:spPr>
+      </p:sp>
+      <p:sp>
+        <p:nvSpPr>
+          <p:cNvPr id="29" name="Shape 27"/>
+          <p:cNvSpPr/>
+          <p:nvPr/>
+        </p:nvSpPr>
+        <p:spPr>
+          <a:xfrm>
+            <a:off x="4572000" y="1303020"/>
+            <a:ext cx="0" cy="141732"/>
+          </a:xfrm>
+          <a:prstGeom prst="line">
+            <a:avLst/>
+          </a:prstGeom>
+          <a:noFill/>
+          <a:ln w="19050">
+            <a:solidFill>
+              <a:srgbClr val="B6BBC0"/>
+            </a:solidFill>
+            <a:prstDash val="solid"/>
+          </a:ln>
+        </p:spPr>
+      </p:sp>
+      <p:sp>
+        <p:nvSpPr>
+          <p:cNvPr id="30" name="Shape 28"/>
+          <p:cNvSpPr/>
+          <p:nvPr/>
+        </p:nvSpPr>
+        <p:spPr>
+          <a:xfrm>
+            <a:off x="7595616" y="1303020"/>
+            <a:ext cx="0" cy="141732"/>
+          </a:xfrm>
+          <a:prstGeom prst="line">
+            <a:avLst/>
+          </a:prstGeom>
+          <a:noFill/>
+          <a:ln w="19050">
+            <a:solidFill>
+              <a:srgbClr val="B6BBC0"/>
+            </a:solidFill>
+            <a:prstDash val="solid"/>
+          </a:ln>
+        </p:spPr>
+      </p:sp>
+      <p:sp>
+        <p:nvSpPr>
+          <p:cNvPr id="31" name="Shape 29"/>
+          <p:cNvSpPr/>
+          <p:nvPr/>
+        </p:nvSpPr>
+        <p:spPr>
+          <a:xfrm>
+            <a:off x="91440" y="1444752"/>
+            <a:ext cx="2913888" cy="585216"/>
+          </a:xfrm>
+          <a:prstGeom prst="rect">
+            <a:avLst/>
+          </a:prstGeom>
+          <a:solidFill>
+            <a:srgbClr val="085CE5"/>
+          </a:solidFill>
+          <a:ln w="12700">
+            <a:solidFill>
+              <a:srgbClr val="085CE5"/>
+            </a:solidFill>
+            <a:prstDash val="solid"/>
+          </a:ln>
+        </p:spPr>
+      </p:sp>
+      <p:sp>
+        <p:nvSpPr>
+          <p:cNvPr id="32" name="Shape 30"/>
+          <p:cNvSpPr/>
+          <p:nvPr/>
+        </p:nvSpPr>
+        <p:spPr>
+          <a:xfrm>
+            <a:off x="91440" y="1444752"/>
+            <a:ext cx="2913888" cy="50292"/>
+          </a:xfrm>
+          <a:prstGeom prst="rect">
+            <a:avLst/>
+          </a:prstGeom>
+          <a:solidFill>
+            <a:srgbClr val="FFFFFF">
+              <a:alpha val="60000"/>
+            </a:srgbClr>
+          </a:solidFill>
+          <a:ln w="12700">
+            <a:solidFill>
+              <a:srgbClr val="FFFFFF">
+                <a:alpha val="60000"/>
+              </a:srgbClr>
+            </a:solidFill>
+            <a:prstDash val="solid"/>
+          </a:ln>
+        </p:spPr>
+      </p:sp>
+      <p:sp>
+        <p:nvSpPr>
+          <p:cNvPr id="33" name="Text 31"/>
+          <p:cNvSpPr/>
+          <p:nvPr/>
+        </p:nvSpPr>
+        <p:spPr>
+          <a:xfrm>
+            <a:off x="182880" y="1499616"/>
+            <a:ext cx="2731008" cy="237744"/>
+          </a:xfrm>
+          <a:prstGeom prst="rect">
+            <a:avLst/>
+          </a:prstGeom>
+          <a:noFill/>
+          <a:ln/>
+        </p:spPr>
+        <p:txBody>
+          <a:bodyPr wrap="square" rtlCol="0" anchor="ctr"/>
+          <a:lstStyle/>
+          <a:p>
+            <a:pPr algn="ctr" indent="0" marL="0">
+              <a:buNone/>
+            </a:pPr>
+            <a:r>
+              <a:rPr lang="en-US" sz="1050" b="1" dirty="0">
+                <a:solidFill>
+                  <a:srgbClr val="FFFFFF"/>
+                </a:solidFill>
+                <a:latin typeface="Calibri" pitchFamily="34" charset="0"/>
+                <a:ea typeface="Calibri" pitchFamily="34" charset="-122"/>
+                <a:cs typeface="Calibri" pitchFamily="34" charset="-120"/>
+              </a:rPr>
+              <a:t>Michael Goolsby</a:t>
+            </a:r>
+            <a:endParaRPr lang="en-US" sz="1050" dirty="0"/>
+          </a:p>
+        </p:txBody>
+      </p:sp>
+      <p:sp>
+        <p:nvSpPr>
+          <p:cNvPr id="34" name="Text 32"/>
+          <p:cNvSpPr/>
+          <p:nvPr/>
+        </p:nvSpPr>
+        <p:spPr>
+          <a:xfrm>
+            <a:off x="182880" y="1764792"/>
+            <a:ext cx="2731008" cy="201168"/>
+          </a:xfrm>
+          <a:prstGeom prst="rect">
+            <a:avLst/>
+          </a:prstGeom>
+          <a:noFill/>
+          <a:ln/>
+        </p:spPr>
+        <p:txBody>
+          <a:bodyPr wrap="square" rtlCol="0" anchor="ctr"/>
+          <a:lstStyle/>
+          <a:p>
+            <a:pPr algn="ctr" indent="0" marL="0">
+              <a:buNone/>
+            </a:pPr>
+            <a:r>
+              <a:rPr lang="en-US" sz="800" dirty="0">
+                <a:solidFill>
+                  <a:srgbClr val="FFFFFF"/>
+                </a:solidFill>
+                <a:latin typeface="Calibri" pitchFamily="34" charset="0"/>
+                <a:ea typeface="Calibri" pitchFamily="34" charset="-122"/>
+                <a:cs typeface="Calibri" pitchFamily="34" charset="-120"/>
+              </a:rPr>
+              <a:t>Director, Software Development</a:t>
+            </a:r>
+            <a:endParaRPr lang="en-US" sz="800" dirty="0"/>
+          </a:p>
+        </p:txBody>
+      </p:sp>
+      <p:sp>
+        <p:nvSpPr>
+          <p:cNvPr id="35" name="Shape 33"/>
+          <p:cNvSpPr/>
+          <p:nvPr/>
+        </p:nvSpPr>
+        <p:spPr>
+          <a:xfrm>
+            <a:off x="3115056" y="1444752"/>
+            <a:ext cx="2913888" cy="585216"/>
+          </a:xfrm>
+          <a:prstGeom prst="rect">
+            <a:avLst/>
+          </a:prstGeom>
+          <a:solidFill>
+            <a:srgbClr val="0A5CA8"/>
+          </a:solidFill>
+          <a:ln w="12700">
+            <a:solidFill>
+              <a:srgbClr val="0A5CA8"/>
+            </a:solidFill>
+            <a:prstDash val="solid"/>
+          </a:ln>
+        </p:spPr>
+      </p:sp>
+      <p:sp>
+        <p:nvSpPr>
+          <p:cNvPr id="36" name="Shape 34"/>
+          <p:cNvSpPr/>
+          <p:nvPr/>
+        </p:nvSpPr>
+        <p:spPr>
+          <a:xfrm>
+            <a:off x="3115056" y="1444752"/>
+            <a:ext cx="2913888" cy="50292"/>
+          </a:xfrm>
+          <a:prstGeom prst="rect">
+            <a:avLst/>
+          </a:prstGeom>
+          <a:solidFill>
+            <a:srgbClr val="FFFFFF">
+              <a:alpha val="60000"/>
+            </a:srgbClr>
+          </a:solidFill>
+          <a:ln w="12700">
+            <a:solidFill>
+              <a:srgbClr val="FFFFFF">
+                <a:alpha val="60000"/>
+              </a:srgbClr>
+            </a:solidFill>
+            <a:prstDash val="solid"/>
+          </a:ln>
+        </p:spPr>
+      </p:sp>
+      <p:sp>
+        <p:nvSpPr>
+          <p:cNvPr id="37" name="Text 35"/>
+          <p:cNvSpPr/>
+          <p:nvPr/>
+        </p:nvSpPr>
+        <p:spPr>
+          <a:xfrm>
+            <a:off x="3206496" y="1499616"/>
+            <a:ext cx="2731008" cy="237744"/>
+          </a:xfrm>
+          <a:prstGeom prst="rect">
+            <a:avLst/>
+          </a:prstGeom>
+          <a:noFill/>
+          <a:ln/>
+        </p:spPr>
+        <p:txBody>
+          <a:bodyPr wrap="square" rtlCol="0" anchor="ctr"/>
+          <a:lstStyle/>
+          <a:p>
+            <a:pPr algn="ctr" indent="0" marL="0">
+              <a:buNone/>
+            </a:pPr>
+            <a:r>
+              <a:rPr lang="en-US" sz="1050" b="1" dirty="0">
+                <a:solidFill>
+                  <a:srgbClr val="FFFFFF"/>
+                </a:solidFill>
+                <a:latin typeface="Calibri" pitchFamily="34" charset="0"/>
+                <a:ea typeface="Calibri" pitchFamily="34" charset="-122"/>
+                <a:cs typeface="Calibri" pitchFamily="34" charset="-120"/>
+              </a:rPr>
+              <a:t>[TBD]</a:t>
+            </a:r>
+            <a:endParaRPr lang="en-US" sz="1050" dirty="0"/>
+          </a:p>
+        </p:txBody>
+      </p:sp>
+      <p:sp>
+        <p:nvSpPr>
+          <p:cNvPr id="38" name="Text 36"/>
+          <p:cNvSpPr/>
+          <p:nvPr/>
+        </p:nvSpPr>
+        <p:spPr>
+          <a:xfrm>
+            <a:off x="3206496" y="1764792"/>
+            <a:ext cx="2731008" cy="201168"/>
+          </a:xfrm>
+          <a:prstGeom prst="rect">
+            <a:avLst/>
+          </a:prstGeom>
+          <a:noFill/>
+          <a:ln/>
+        </p:spPr>
+        <p:txBody>
+          <a:bodyPr wrap="square" rtlCol="0" anchor="ctr"/>
+          <a:lstStyle/>
+          <a:p>
+            <a:pPr algn="ctr" indent="0" marL="0">
+              <a:buNone/>
+            </a:pPr>
+            <a:r>
+              <a:rPr lang="en-US" sz="800" dirty="0">
+                <a:solidFill>
+                  <a:srgbClr val="FFFFFF"/>
+                </a:solidFill>
+                <a:latin typeface="Calibri" pitchFamily="34" charset="0"/>
+                <a:ea typeface="Calibri" pitchFamily="34" charset="-122"/>
+                <a:cs typeface="Calibri" pitchFamily="34" charset="-120"/>
+              </a:rPr>
+              <a:t>Mgr, JHBI Product Mgmt &amp; GTM</a:t>
+            </a:r>
+            <a:endParaRPr lang="en-US" sz="800" dirty="0"/>
+          </a:p>
+        </p:txBody>
+      </p:sp>
+      <p:sp>
+        <p:nvSpPr>
+          <p:cNvPr id="39" name="Shape 37"/>
+          <p:cNvSpPr/>
+          <p:nvPr/>
+        </p:nvSpPr>
+        <p:spPr>
+          <a:xfrm>
+            <a:off x="6138672" y="1444752"/>
+            <a:ext cx="2913888" cy="585216"/>
+          </a:xfrm>
+          <a:prstGeom prst="rect">
+            <a:avLst/>
+          </a:prstGeom>
+          <a:solidFill>
+            <a:srgbClr val="0A5C47"/>
+          </a:solidFill>
+          <a:ln w="12700">
+            <a:solidFill>
+              <a:srgbClr val="0A5C47"/>
+            </a:solidFill>
+            <a:prstDash val="solid"/>
+          </a:ln>
+        </p:spPr>
+      </p:sp>
+      <p:sp>
+        <p:nvSpPr>
+          <p:cNvPr id="40" name="Shape 38"/>
+          <p:cNvSpPr/>
+          <p:nvPr/>
+        </p:nvSpPr>
+        <p:spPr>
+          <a:xfrm>
+            <a:off x="6138672" y="1444752"/>
+            <a:ext cx="2913888" cy="50292"/>
+          </a:xfrm>
+          <a:prstGeom prst="rect">
+            <a:avLst/>
+          </a:prstGeom>
+          <a:solidFill>
+            <a:srgbClr val="FFFFFF">
+              <a:alpha val="60000"/>
+            </a:srgbClr>
+          </a:solidFill>
+          <a:ln w="12700">
+            <a:solidFill>
+              <a:srgbClr val="FFFFFF">
+                <a:alpha val="60000"/>
+              </a:srgbClr>
+            </a:solidFill>
+            <a:prstDash val="solid"/>
+          </a:ln>
+        </p:spPr>
+      </p:sp>
+      <p:sp>
+        <p:nvSpPr>
+          <p:cNvPr id="41" name="Text 39"/>
+          <p:cNvSpPr/>
+          <p:nvPr/>
+        </p:nvSpPr>
+        <p:spPr>
+          <a:xfrm>
+            <a:off x="6230112" y="1499616"/>
+            <a:ext cx="2731008" cy="237744"/>
+          </a:xfrm>
+          <a:prstGeom prst="rect">
+            <a:avLst/>
+          </a:prstGeom>
+          <a:noFill/>
+          <a:ln/>
+        </p:spPr>
+        <p:txBody>
+          <a:bodyPr wrap="square" rtlCol="0" anchor="ctr"/>
+          <a:lstStyle/>
+          <a:p>
+            <a:pPr algn="ctr" indent="0" marL="0">
+              <a:buNone/>
+            </a:pPr>
+            <a:r>
+              <a:rPr lang="en-US" sz="1050" b="1" dirty="0">
+                <a:solidFill>
+                  <a:srgbClr val="FFFFFF"/>
+                </a:solidFill>
+                <a:latin typeface="Calibri" pitchFamily="34" charset="0"/>
+                <a:ea typeface="Calibri" pitchFamily="34" charset="-122"/>
+                <a:cs typeface="Calibri" pitchFamily="34" charset="-120"/>
+              </a:rPr>
+              <a:t>[TBD]</a:t>
+            </a:r>
+            <a:endParaRPr lang="en-US" sz="1050" dirty="0"/>
+          </a:p>
+        </p:txBody>
+      </p:sp>
+      <p:sp>
+        <p:nvSpPr>
+          <p:cNvPr id="42" name="Text 40"/>
+          <p:cNvSpPr/>
+          <p:nvPr/>
+        </p:nvSpPr>
+        <p:spPr>
+          <a:xfrm>
+            <a:off x="6230112" y="1764792"/>
+            <a:ext cx="2731008" cy="201168"/>
+          </a:xfrm>
+          <a:prstGeom prst="rect">
+            <a:avLst/>
+          </a:prstGeom>
+          <a:noFill/>
+          <a:ln/>
+        </p:spPr>
+        <p:txBody>
+          <a:bodyPr wrap="square" rtlCol="0" anchor="ctr"/>
+          <a:lstStyle/>
+          <a:p>
+            <a:pPr algn="ctr" indent="0" marL="0">
+              <a:buNone/>
+            </a:pPr>
+            <a:r>
+              <a:rPr lang="en-US" sz="800" dirty="0">
+                <a:solidFill>
+                  <a:srgbClr val="FFFFFF"/>
+                </a:solidFill>
+                <a:latin typeface="Calibri" pitchFamily="34" charset="0"/>
+                <a:ea typeface="Calibri" pitchFamily="34" charset="-122"/>
+                <a:cs typeface="Calibri" pitchFamily="34" charset="-120"/>
+              </a:rPr>
+              <a:t>Data Science Lead</a:t>
+            </a:r>
+            <a:endParaRPr lang="en-US" sz="800" dirty="0"/>
+          </a:p>
+        </p:txBody>
+      </p:sp>
+      <p:sp>
+        <p:nvSpPr>
+          <p:cNvPr id="43" name="Shape 41"/>
+          <p:cNvSpPr/>
+          <p:nvPr/>
+        </p:nvSpPr>
+        <p:spPr>
+          <a:xfrm>
+            <a:off x="1548384" y="2029968"/>
+            <a:ext cx="0" cy="128016"/>
+          </a:xfrm>
+          <a:prstGeom prst="line">
+            <a:avLst/>
+          </a:prstGeom>
+          <a:noFill/>
+          <a:ln w="15240">
+            <a:solidFill>
+              <a:srgbClr val="085CE5"/>
+            </a:solidFill>
+            <a:prstDash val="solid"/>
+          </a:ln>
+        </p:spPr>
+      </p:sp>
+      <p:sp>
+        <p:nvSpPr>
+          <p:cNvPr id="44" name="Shape 42"/>
+          <p:cNvSpPr/>
+          <p:nvPr/>
+        </p:nvSpPr>
+        <p:spPr>
+          <a:xfrm>
+            <a:off x="146304" y="2157984"/>
+            <a:ext cx="2804160" cy="457200"/>
           </a:xfrm>
           <a:prstGeom prst="rect">
             <a:avLst/>
@@ -2773,24 +3437,117 @@
               <a:alpha val="80000"/>
             </a:srgbClr>
           </a:solidFill>
+          <a:ln w="9525">
+            <a:solidFill>
+              <a:srgbClr val="085CE5"/>
+            </a:solidFill>
+            <a:prstDash val="solid"/>
+          </a:ln>
+        </p:spPr>
+      </p:sp>
+      <p:sp>
+        <p:nvSpPr>
+          <p:cNvPr id="45" name="Shape 43"/>
+          <p:cNvSpPr/>
+          <p:nvPr/>
+        </p:nvSpPr>
+        <p:spPr>
+          <a:xfrm>
+            <a:off x="146304" y="2157984"/>
+            <a:ext cx="50292" cy="457200"/>
+          </a:xfrm>
+          <a:prstGeom prst="rect">
+            <a:avLst/>
+          </a:prstGeom>
+          <a:solidFill>
+            <a:srgbClr val="085CE5">
+              <a:alpha val="70000"/>
+            </a:srgbClr>
+          </a:solidFill>
           <a:ln w="12700">
             <a:solidFill>
-              <a:srgbClr val="E7ECF0"/>
-            </a:solidFill>
-            <a:prstDash val="solid"/>
-          </a:ln>
-        </p:spPr>
-      </p:sp>
-      <p:sp>
-        <p:nvSpPr>
-          <p:cNvPr id="23" name="Text 21"/>
-          <p:cNvSpPr/>
-          <p:nvPr/>
-        </p:nvSpPr>
-        <p:spPr>
-          <a:xfrm>
-            <a:off x="5961888" y="1124712"/>
-            <a:ext cx="3017520" cy="219456"/>
+              <a:srgbClr val="085CE5">
+                <a:alpha val="70000"/>
+              </a:srgbClr>
+            </a:solidFill>
+            <a:prstDash val="solid"/>
+          </a:ln>
+        </p:spPr>
+      </p:sp>
+      <p:sp>
+        <p:nvSpPr>
+          <p:cNvPr id="46" name="Text 44"/>
+          <p:cNvSpPr/>
+          <p:nvPr/>
+        </p:nvSpPr>
+        <p:spPr>
+          <a:xfrm>
+            <a:off x="237744" y="2194560"/>
+            <a:ext cx="2328672" cy="201168"/>
+          </a:xfrm>
+          <a:prstGeom prst="rect">
+            <a:avLst/>
+          </a:prstGeom>
+          <a:noFill/>
+          <a:ln/>
+        </p:spPr>
+        <p:txBody>
+          <a:bodyPr wrap="square" rtlCol="0" anchor="ctr"/>
+          <a:lstStyle/>
+          <a:p>
+            <a:pPr indent="0" marL="0">
+              <a:buNone/>
+            </a:pPr>
+            <a:r>
+              <a:rPr lang="en-US" sz="850" b="1" dirty="0">
+                <a:solidFill>
+                  <a:srgbClr val="06185F"/>
+                </a:solidFill>
+                <a:latin typeface="Calibri" pitchFamily="34" charset="0"/>
+                <a:ea typeface="Calibri" pitchFamily="34" charset="-122"/>
+                <a:cs typeface="Calibri" pitchFamily="34" charset="-120"/>
+              </a:rPr>
+              <a:t>Data Acq. &amp; Engineering</a:t>
+            </a:r>
+            <a:endParaRPr lang="en-US" sz="850" dirty="0"/>
+          </a:p>
+        </p:txBody>
+      </p:sp>
+      <p:sp>
+        <p:nvSpPr>
+          <p:cNvPr id="47" name="Shape 45"/>
+          <p:cNvSpPr/>
+          <p:nvPr/>
+        </p:nvSpPr>
+        <p:spPr>
+          <a:xfrm>
+            <a:off x="2548128" y="2212848"/>
+            <a:ext cx="347472" cy="182880"/>
+          </a:xfrm>
+          <a:prstGeom prst="rect">
+            <a:avLst/>
+          </a:prstGeom>
+          <a:solidFill>
+            <a:srgbClr val="085CE5"/>
+          </a:solidFill>
+          <a:ln w="12700">
+            <a:solidFill>
+              <a:srgbClr val="085CE5"/>
+            </a:solidFill>
+            <a:prstDash val="solid"/>
+          </a:ln>
+        </p:spPr>
+      </p:sp>
+      <p:sp>
+        <p:nvSpPr>
+          <p:cNvPr id="48" name="Text 46"/>
+          <p:cNvSpPr/>
+          <p:nvPr/>
+        </p:nvSpPr>
+        <p:spPr>
+          <a:xfrm>
+            <a:off x="2548128" y="2212848"/>
+            <a:ext cx="347472" cy="182880"/>
           </a:xfrm>
           <a:prstGeom prst="rect">
             <a:avLst/>
@@ -2806,199 +3563,30 @@
               <a:buNone/>
             </a:pPr>
             <a:r>
-              <a:rPr lang="en-US" sz="850" b="1" dirty="0">
-                <a:solidFill>
-                  <a:srgbClr val="06185F"/>
-                </a:solidFill>
-                <a:latin typeface="Calibri" pitchFamily="34" charset="0"/>
-                <a:ea typeface="Calibri" pitchFamily="34" charset="-122"/>
-                <a:cs typeface="Calibri" pitchFamily="34" charset="-120"/>
-              </a:rPr>
-              <a:t>14 Open Positions</a:t>
-            </a:r>
-            <a:endParaRPr lang="en-US" sz="850" dirty="0"/>
-          </a:p>
-        </p:txBody>
-      </p:sp>
-      <p:sp>
-        <p:nvSpPr>
-          <p:cNvPr id="24" name="Shape 22"/>
-          <p:cNvSpPr/>
-          <p:nvPr/>
-        </p:nvSpPr>
-        <p:spPr>
-          <a:xfrm>
-            <a:off x="4572000" y="1161288"/>
-            <a:ext cx="0" cy="141732"/>
-          </a:xfrm>
-          <a:prstGeom prst="line">
-            <a:avLst/>
-          </a:prstGeom>
-          <a:noFill/>
-          <a:ln w="19050">
-            <a:solidFill>
-              <a:srgbClr val="B6BBC0"/>
-            </a:solidFill>
-            <a:prstDash val="solid"/>
-          </a:ln>
-        </p:spPr>
-      </p:sp>
-      <p:sp>
-        <p:nvSpPr>
-          <p:cNvPr id="25" name="Shape 23"/>
-          <p:cNvSpPr/>
-          <p:nvPr/>
-        </p:nvSpPr>
-        <p:spPr>
-          <a:xfrm>
-            <a:off x="1548384" y="1303020"/>
-            <a:ext cx="6047232" cy="0"/>
-          </a:xfrm>
-          <a:prstGeom prst="line">
-            <a:avLst/>
-          </a:prstGeom>
-          <a:noFill/>
-          <a:ln w="19050">
-            <a:solidFill>
-              <a:srgbClr val="B6BBC0"/>
-            </a:solidFill>
-            <a:prstDash val="solid"/>
-          </a:ln>
-        </p:spPr>
-      </p:sp>
-      <p:sp>
-        <p:nvSpPr>
-          <p:cNvPr id="26" name="Shape 24"/>
-          <p:cNvSpPr/>
-          <p:nvPr/>
-        </p:nvSpPr>
-        <p:spPr>
-          <a:xfrm>
-            <a:off x="1548384" y="1303020"/>
-            <a:ext cx="0" cy="141732"/>
-          </a:xfrm>
-          <a:prstGeom prst="line">
-            <a:avLst/>
-          </a:prstGeom>
-          <a:noFill/>
-          <a:ln w="19050">
-            <a:solidFill>
-              <a:srgbClr val="B6BBC0"/>
-            </a:solidFill>
-            <a:prstDash val="solid"/>
-          </a:ln>
-        </p:spPr>
-      </p:sp>
-      <p:sp>
-        <p:nvSpPr>
-          <p:cNvPr id="27" name="Shape 25"/>
-          <p:cNvSpPr/>
-          <p:nvPr/>
-        </p:nvSpPr>
-        <p:spPr>
-          <a:xfrm>
-            <a:off x="4572000" y="1303020"/>
-            <a:ext cx="0" cy="141732"/>
-          </a:xfrm>
-          <a:prstGeom prst="line">
-            <a:avLst/>
-          </a:prstGeom>
-          <a:noFill/>
-          <a:ln w="19050">
-            <a:solidFill>
-              <a:srgbClr val="B6BBC0"/>
-            </a:solidFill>
-            <a:prstDash val="solid"/>
-          </a:ln>
-        </p:spPr>
-      </p:sp>
-      <p:sp>
-        <p:nvSpPr>
-          <p:cNvPr id="28" name="Shape 26"/>
-          <p:cNvSpPr/>
-          <p:nvPr/>
-        </p:nvSpPr>
-        <p:spPr>
-          <a:xfrm>
-            <a:off x="7595616" y="1303020"/>
-            <a:ext cx="0" cy="141732"/>
-          </a:xfrm>
-          <a:prstGeom prst="line">
-            <a:avLst/>
-          </a:prstGeom>
-          <a:noFill/>
-          <a:ln w="19050">
-            <a:solidFill>
-              <a:srgbClr val="B6BBC0"/>
-            </a:solidFill>
-            <a:prstDash val="solid"/>
-          </a:ln>
-        </p:spPr>
-      </p:sp>
-      <p:sp>
-        <p:nvSpPr>
-          <p:cNvPr id="29" name="Shape 27"/>
-          <p:cNvSpPr/>
-          <p:nvPr/>
-        </p:nvSpPr>
-        <p:spPr>
-          <a:xfrm>
-            <a:off x="91440" y="1444752"/>
-            <a:ext cx="2913888" cy="585216"/>
-          </a:xfrm>
-          <a:prstGeom prst="rect">
-            <a:avLst/>
-          </a:prstGeom>
-          <a:solidFill>
-            <a:srgbClr val="085CE5"/>
-          </a:solidFill>
-          <a:ln w="12700">
-            <a:solidFill>
-              <a:srgbClr val="085CE5"/>
-            </a:solidFill>
-            <a:prstDash val="solid"/>
-          </a:ln>
-        </p:spPr>
-      </p:sp>
-      <p:sp>
-        <p:nvSpPr>
-          <p:cNvPr id="30" name="Shape 28"/>
-          <p:cNvSpPr/>
-          <p:nvPr/>
-        </p:nvSpPr>
-        <p:spPr>
-          <a:xfrm>
-            <a:off x="91440" y="1444752"/>
-            <a:ext cx="2913888" cy="50292"/>
-          </a:xfrm>
-          <a:prstGeom prst="rect">
-            <a:avLst/>
-          </a:prstGeom>
-          <a:solidFill>
-            <a:srgbClr val="FFFFFF">
-              <a:alpha val="60000"/>
-            </a:srgbClr>
-          </a:solidFill>
-          <a:ln w="12700">
-            <a:solidFill>
-              <a:srgbClr val="FFFFFF">
-                <a:alpha val="60000"/>
-              </a:srgbClr>
-            </a:solidFill>
-            <a:prstDash val="solid"/>
-          </a:ln>
-        </p:spPr>
-      </p:sp>
-      <p:sp>
-        <p:nvSpPr>
-          <p:cNvPr id="31" name="Text 29"/>
-          <p:cNvSpPr/>
-          <p:nvPr/>
-        </p:nvSpPr>
-        <p:spPr>
-          <a:xfrm>
-            <a:off x="182880" y="1499616"/>
-            <a:ext cx="2731008" cy="237744"/>
+              <a:rPr lang="en-US" sz="750" b="1" dirty="0">
+                <a:solidFill>
+                  <a:srgbClr val="FFFFFF"/>
+                </a:solidFill>
+                <a:latin typeface="Calibri" pitchFamily="34" charset="0"/>
+                <a:ea typeface="Calibri" pitchFamily="34" charset="-122"/>
+                <a:cs typeface="Calibri" pitchFamily="34" charset="-120"/>
+              </a:rPr>
+              <a:t>3</a:t>
+            </a:r>
+            <a:endParaRPr lang="en-US" sz="750" dirty="0"/>
+          </a:p>
+        </p:txBody>
+      </p:sp>
+      <p:sp>
+        <p:nvSpPr>
+          <p:cNvPr id="49" name="Text 47"/>
+          <p:cNvSpPr/>
+          <p:nvPr/>
+        </p:nvSpPr>
+        <p:spPr>
+          <a:xfrm>
+            <a:off x="237744" y="2395728"/>
+            <a:ext cx="2657856" cy="164592"/>
           </a:xfrm>
           <a:prstGeom prst="rect">
             <a:avLst/>
@@ -3010,359 +3598,33 @@
           <a:bodyPr wrap="square" rtlCol="0" anchor="ctr"/>
           <a:lstStyle/>
           <a:p>
-            <a:pPr algn="ctr" indent="0" marL="0">
-              <a:buNone/>
-            </a:pPr>
-            <a:r>
-              <a:rPr lang="en-US" sz="1050" b="1" dirty="0">
-                <a:solidFill>
-                  <a:srgbClr val="FFFFFF"/>
-                </a:solidFill>
-                <a:latin typeface="Calibri" pitchFamily="34" charset="0"/>
-                <a:ea typeface="Calibri" pitchFamily="34" charset="-122"/>
-                <a:cs typeface="Calibri" pitchFamily="34" charset="-120"/>
-              </a:rPr>
-              <a:t>Michael Goolsby</a:t>
-            </a:r>
-            <a:endParaRPr lang="en-US" sz="1050" dirty="0"/>
-          </a:p>
-        </p:txBody>
-      </p:sp>
-      <p:sp>
-        <p:nvSpPr>
-          <p:cNvPr id="32" name="Text 30"/>
-          <p:cNvSpPr/>
-          <p:nvPr/>
-        </p:nvSpPr>
-        <p:spPr>
-          <a:xfrm>
-            <a:off x="182880" y="1764792"/>
-            <a:ext cx="2731008" cy="201168"/>
-          </a:xfrm>
-          <a:prstGeom prst="rect">
-            <a:avLst/>
-          </a:prstGeom>
-          <a:noFill/>
-          <a:ln/>
-        </p:spPr>
-        <p:txBody>
-          <a:bodyPr wrap="square" rtlCol="0" anchor="ctr"/>
-          <a:lstStyle/>
-          <a:p>
-            <a:pPr algn="ctr" indent="0" marL="0">
-              <a:buNone/>
-            </a:pPr>
-            <a:r>
-              <a:rPr lang="en-US" sz="800" dirty="0">
-                <a:solidFill>
-                  <a:srgbClr val="FFFFFF"/>
-                </a:solidFill>
-                <a:latin typeface="Calibri" pitchFamily="34" charset="0"/>
-                <a:ea typeface="Calibri" pitchFamily="34" charset="-122"/>
-                <a:cs typeface="Calibri" pitchFamily="34" charset="-120"/>
-              </a:rPr>
-              <a:t>Director, Software Development</a:t>
-            </a:r>
-            <a:endParaRPr lang="en-US" sz="800" dirty="0"/>
-          </a:p>
-        </p:txBody>
-      </p:sp>
-      <p:sp>
-        <p:nvSpPr>
-          <p:cNvPr id="33" name="Shape 31"/>
-          <p:cNvSpPr/>
-          <p:nvPr/>
-        </p:nvSpPr>
-        <p:spPr>
-          <a:xfrm>
-            <a:off x="3115056" y="1444752"/>
-            <a:ext cx="2913888" cy="585216"/>
-          </a:xfrm>
-          <a:prstGeom prst="rect">
-            <a:avLst/>
-          </a:prstGeom>
-          <a:solidFill>
-            <a:srgbClr val="0A5CA8"/>
-          </a:solidFill>
-          <a:ln w="12700">
-            <a:solidFill>
-              <a:srgbClr val="0A5CA8"/>
-            </a:solidFill>
-            <a:prstDash val="solid"/>
-          </a:ln>
-        </p:spPr>
-      </p:sp>
-      <p:sp>
-        <p:nvSpPr>
-          <p:cNvPr id="34" name="Shape 32"/>
-          <p:cNvSpPr/>
-          <p:nvPr/>
-        </p:nvSpPr>
-        <p:spPr>
-          <a:xfrm>
-            <a:off x="3115056" y="1444752"/>
-            <a:ext cx="2913888" cy="50292"/>
-          </a:xfrm>
-          <a:prstGeom prst="rect">
-            <a:avLst/>
-          </a:prstGeom>
-          <a:solidFill>
-            <a:srgbClr val="FFFFFF">
-              <a:alpha val="60000"/>
-            </a:srgbClr>
-          </a:solidFill>
-          <a:ln w="12700">
-            <a:solidFill>
-              <a:srgbClr val="FFFFFF">
-                <a:alpha val="60000"/>
-              </a:srgbClr>
-            </a:solidFill>
-            <a:prstDash val="solid"/>
-          </a:ln>
-        </p:spPr>
-      </p:sp>
-      <p:sp>
-        <p:nvSpPr>
-          <p:cNvPr id="35" name="Text 33"/>
-          <p:cNvSpPr/>
-          <p:nvPr/>
-        </p:nvSpPr>
-        <p:spPr>
-          <a:xfrm>
-            <a:off x="3206496" y="1499616"/>
-            <a:ext cx="2731008" cy="237744"/>
-          </a:xfrm>
-          <a:prstGeom prst="rect">
-            <a:avLst/>
-          </a:prstGeom>
-          <a:noFill/>
-          <a:ln/>
-        </p:spPr>
-        <p:txBody>
-          <a:bodyPr wrap="square" rtlCol="0" anchor="ctr"/>
-          <a:lstStyle/>
-          <a:p>
-            <a:pPr algn="ctr" indent="0" marL="0">
-              <a:buNone/>
-            </a:pPr>
-            <a:r>
-              <a:rPr lang="en-US" sz="1050" b="1" dirty="0">
-                <a:solidFill>
-                  <a:srgbClr val="FFFFFF"/>
-                </a:solidFill>
-                <a:latin typeface="Calibri" pitchFamily="34" charset="0"/>
-                <a:ea typeface="Calibri" pitchFamily="34" charset="-122"/>
-                <a:cs typeface="Calibri" pitchFamily="34" charset="-120"/>
-              </a:rPr>
-              <a:t>[TBD]</a:t>
-            </a:r>
-            <a:endParaRPr lang="en-US" sz="1050" dirty="0"/>
-          </a:p>
-        </p:txBody>
-      </p:sp>
-      <p:sp>
-        <p:nvSpPr>
-          <p:cNvPr id="36" name="Text 34"/>
-          <p:cNvSpPr/>
-          <p:nvPr/>
-        </p:nvSpPr>
-        <p:spPr>
-          <a:xfrm>
-            <a:off x="3206496" y="1764792"/>
-            <a:ext cx="2731008" cy="201168"/>
-          </a:xfrm>
-          <a:prstGeom prst="rect">
-            <a:avLst/>
-          </a:prstGeom>
-          <a:noFill/>
-          <a:ln/>
-        </p:spPr>
-        <p:txBody>
-          <a:bodyPr wrap="square" rtlCol="0" anchor="ctr"/>
-          <a:lstStyle/>
-          <a:p>
-            <a:pPr algn="ctr" indent="0" marL="0">
-              <a:buNone/>
-            </a:pPr>
-            <a:r>
-              <a:rPr lang="en-US" sz="800" dirty="0">
-                <a:solidFill>
-                  <a:srgbClr val="FFFFFF"/>
-                </a:solidFill>
-                <a:latin typeface="Calibri" pitchFamily="34" charset="0"/>
-                <a:ea typeface="Calibri" pitchFamily="34" charset="-122"/>
-                <a:cs typeface="Calibri" pitchFamily="34" charset="-120"/>
-              </a:rPr>
-              <a:t>Mgr, JHBI Product Mgmt &amp; GTM</a:t>
-            </a:r>
-            <a:endParaRPr lang="en-US" sz="800" dirty="0"/>
-          </a:p>
-        </p:txBody>
-      </p:sp>
-      <p:sp>
-        <p:nvSpPr>
-          <p:cNvPr id="37" name="Shape 35"/>
-          <p:cNvSpPr/>
-          <p:nvPr/>
-        </p:nvSpPr>
-        <p:spPr>
-          <a:xfrm>
-            <a:off x="6138672" y="1444752"/>
-            <a:ext cx="2913888" cy="585216"/>
-          </a:xfrm>
-          <a:prstGeom prst="rect">
-            <a:avLst/>
-          </a:prstGeom>
-          <a:solidFill>
-            <a:srgbClr val="0A5C47"/>
-          </a:solidFill>
-          <a:ln w="12700">
-            <a:solidFill>
-              <a:srgbClr val="0A5C47"/>
-            </a:solidFill>
-            <a:prstDash val="solid"/>
-          </a:ln>
-        </p:spPr>
-      </p:sp>
-      <p:sp>
-        <p:nvSpPr>
-          <p:cNvPr id="38" name="Shape 36"/>
-          <p:cNvSpPr/>
-          <p:nvPr/>
-        </p:nvSpPr>
-        <p:spPr>
-          <a:xfrm>
-            <a:off x="6138672" y="1444752"/>
-            <a:ext cx="2913888" cy="50292"/>
-          </a:xfrm>
-          <a:prstGeom prst="rect">
-            <a:avLst/>
-          </a:prstGeom>
-          <a:solidFill>
-            <a:srgbClr val="FFFFFF">
-              <a:alpha val="60000"/>
-            </a:srgbClr>
-          </a:solidFill>
-          <a:ln w="12700">
-            <a:solidFill>
-              <a:srgbClr val="FFFFFF">
-                <a:alpha val="60000"/>
-              </a:srgbClr>
-            </a:solidFill>
-            <a:prstDash val="solid"/>
-          </a:ln>
-        </p:spPr>
-      </p:sp>
-      <p:sp>
-        <p:nvSpPr>
-          <p:cNvPr id="39" name="Text 37"/>
-          <p:cNvSpPr/>
-          <p:nvPr/>
-        </p:nvSpPr>
-        <p:spPr>
-          <a:xfrm>
-            <a:off x="6230112" y="1499616"/>
-            <a:ext cx="2731008" cy="237744"/>
-          </a:xfrm>
-          <a:prstGeom prst="rect">
-            <a:avLst/>
-          </a:prstGeom>
-          <a:noFill/>
-          <a:ln/>
-        </p:spPr>
-        <p:txBody>
-          <a:bodyPr wrap="square" rtlCol="0" anchor="ctr"/>
-          <a:lstStyle/>
-          <a:p>
-            <a:pPr algn="ctr" indent="0" marL="0">
-              <a:buNone/>
-            </a:pPr>
-            <a:r>
-              <a:rPr lang="en-US" sz="1050" b="1" dirty="0">
-                <a:solidFill>
-                  <a:srgbClr val="FFFFFF"/>
-                </a:solidFill>
-                <a:latin typeface="Calibri" pitchFamily="34" charset="0"/>
-                <a:ea typeface="Calibri" pitchFamily="34" charset="-122"/>
-                <a:cs typeface="Calibri" pitchFamily="34" charset="-120"/>
-              </a:rPr>
-              <a:t>[TBD]</a:t>
-            </a:r>
-            <a:endParaRPr lang="en-US" sz="1050" dirty="0"/>
-          </a:p>
-        </p:txBody>
-      </p:sp>
-      <p:sp>
-        <p:nvSpPr>
-          <p:cNvPr id="40" name="Text 38"/>
-          <p:cNvSpPr/>
-          <p:nvPr/>
-        </p:nvSpPr>
-        <p:spPr>
-          <a:xfrm>
-            <a:off x="6230112" y="1764792"/>
-            <a:ext cx="2731008" cy="201168"/>
-          </a:xfrm>
-          <a:prstGeom prst="rect">
-            <a:avLst/>
-          </a:prstGeom>
-          <a:noFill/>
-          <a:ln/>
-        </p:spPr>
-        <p:txBody>
-          <a:bodyPr wrap="square" rtlCol="0" anchor="ctr"/>
-          <a:lstStyle/>
-          <a:p>
-            <a:pPr algn="ctr" indent="0" marL="0">
-              <a:buNone/>
-            </a:pPr>
-            <a:r>
-              <a:rPr lang="en-US" sz="800" dirty="0">
-                <a:solidFill>
-                  <a:srgbClr val="FFFFFF"/>
-                </a:solidFill>
-                <a:latin typeface="Calibri" pitchFamily="34" charset="0"/>
-                <a:ea typeface="Calibri" pitchFamily="34" charset="-122"/>
-                <a:cs typeface="Calibri" pitchFamily="34" charset="-120"/>
-              </a:rPr>
-              <a:t>Data Science Lead</a:t>
-            </a:r>
-            <a:endParaRPr lang="en-US" sz="800" dirty="0"/>
-          </a:p>
-        </p:txBody>
-      </p:sp>
-      <p:sp>
-        <p:nvSpPr>
-          <p:cNvPr id="41" name="Shape 39"/>
-          <p:cNvSpPr/>
-          <p:nvPr/>
-        </p:nvSpPr>
-        <p:spPr>
-          <a:xfrm>
-            <a:off x="1548384" y="2029968"/>
-            <a:ext cx="0" cy="128016"/>
-          </a:xfrm>
-          <a:prstGeom prst="line">
-            <a:avLst/>
-          </a:prstGeom>
-          <a:noFill/>
-          <a:ln w="15240">
-            <a:solidFill>
-              <a:srgbClr val="085CE5"/>
-            </a:solidFill>
-            <a:prstDash val="solid"/>
-          </a:ln>
-        </p:spPr>
-      </p:sp>
-      <p:sp>
-        <p:nvSpPr>
-          <p:cNvPr id="42" name="Shape 40"/>
-          <p:cNvSpPr/>
-          <p:nvPr/>
-        </p:nvSpPr>
-        <p:spPr>
-          <a:xfrm>
-            <a:off x="146304" y="2157984"/>
+            <a:pPr indent="0" marL="0">
+              <a:buNone/>
+            </a:pPr>
+            <a:r>
+              <a:rPr lang="en-US" sz="700" i="1" dirty="0">
+                <a:solidFill>
+                  <a:srgbClr val="575A5D"/>
+                </a:solidFill>
+                <a:latin typeface="Calibri" pitchFamily="34" charset="0"/>
+                <a:ea typeface="Calibri" pitchFamily="34" charset="-122"/>
+                <a:cs typeface="Calibri" pitchFamily="34" charset="-120"/>
+              </a:rPr>
+              <a:t>Open Positions</a:t>
+            </a:r>
+            <a:endParaRPr lang="en-US" sz="700" dirty="0"/>
+          </a:p>
+        </p:txBody>
+      </p:sp>
+      <p:sp>
+        <p:nvSpPr>
+          <p:cNvPr id="50" name="Shape 48"/>
+          <p:cNvSpPr/>
+          <p:nvPr/>
+        </p:nvSpPr>
+        <p:spPr>
+          <a:xfrm>
+            <a:off x="146304" y="2670048"/>
             <a:ext cx="2804160" cy="457200"/>
           </a:xfrm>
           <a:prstGeom prst="rect">
@@ -3383,13 +3645,13 @@
       </p:sp>
       <p:sp>
         <p:nvSpPr>
-          <p:cNvPr id="43" name="Shape 41"/>
-          <p:cNvSpPr/>
-          <p:nvPr/>
-        </p:nvSpPr>
-        <p:spPr>
-          <a:xfrm>
-            <a:off x="146304" y="2157984"/>
+          <p:cNvPr id="51" name="Shape 49"/>
+          <p:cNvSpPr/>
+          <p:nvPr/>
+        </p:nvSpPr>
+        <p:spPr>
+          <a:xfrm>
+            <a:off x="146304" y="2670048"/>
             <a:ext cx="50292" cy="457200"/>
           </a:xfrm>
           <a:prstGeom prst="rect">
@@ -3412,13 +3674,13 @@
       </p:sp>
       <p:sp>
         <p:nvSpPr>
-          <p:cNvPr id="44" name="Text 42"/>
-          <p:cNvSpPr/>
-          <p:nvPr/>
-        </p:nvSpPr>
-        <p:spPr>
-          <a:xfrm>
-            <a:off x="237744" y="2194560"/>
+          <p:cNvPr id="52" name="Text 50"/>
+          <p:cNvSpPr/>
+          <p:nvPr/>
+        </p:nvSpPr>
+        <p:spPr>
+          <a:xfrm>
+            <a:off x="237744" y="2706624"/>
             <a:ext cx="2328672" cy="201168"/>
           </a:xfrm>
           <a:prstGeom prst="rect">
@@ -3443,7 +3705,7 @@
                 <a:ea typeface="Calibri" pitchFamily="34" charset="-122"/>
                 <a:cs typeface="Calibri" pitchFamily="34" charset="-120"/>
               </a:rPr>
-              <a:t>Data Acq. &amp; Engineering</a:t>
+              <a:t>Visualization</a:t>
             </a:r>
             <a:endParaRPr lang="en-US" sz="850" dirty="0"/>
           </a:p>
@@ -3451,13 +3713,13 @@
       </p:sp>
       <p:sp>
         <p:nvSpPr>
-          <p:cNvPr id="45" name="Shape 43"/>
-          <p:cNvSpPr/>
-          <p:nvPr/>
-        </p:nvSpPr>
-        <p:spPr>
-          <a:xfrm>
-            <a:off x="2548128" y="2212848"/>
+          <p:cNvPr id="53" name="Shape 51"/>
+          <p:cNvSpPr/>
+          <p:nvPr/>
+        </p:nvSpPr>
+        <p:spPr>
+          <a:xfrm>
+            <a:off x="2548128" y="2724912"/>
             <a:ext cx="347472" cy="182880"/>
           </a:xfrm>
           <a:prstGeom prst="rect">
@@ -3476,13 +3738,13 @@
       </p:sp>
       <p:sp>
         <p:nvSpPr>
-          <p:cNvPr id="46" name="Text 44"/>
-          <p:cNvSpPr/>
-          <p:nvPr/>
-        </p:nvSpPr>
-        <p:spPr>
-          <a:xfrm>
-            <a:off x="2548128" y="2212848"/>
+          <p:cNvPr id="54" name="Text 52"/>
+          <p:cNvSpPr/>
+          <p:nvPr/>
+        </p:nvSpPr>
+        <p:spPr>
+          <a:xfrm>
+            <a:off x="2548128" y="2724912"/>
             <a:ext cx="347472" cy="182880"/>
           </a:xfrm>
           <a:prstGeom prst="rect">
@@ -3507,7 +3769,7 @@
                 <a:ea typeface="Calibri" pitchFamily="34" charset="-122"/>
                 <a:cs typeface="Calibri" pitchFamily="34" charset="-120"/>
               </a:rPr>
-              <a:t>3</a:t>
+              <a:t>2</a:t>
             </a:r>
             <a:endParaRPr lang="en-US" sz="750" dirty="0"/>
           </a:p>
@@ -3515,13 +3777,13 @@
       </p:sp>
       <p:sp>
         <p:nvSpPr>
-          <p:cNvPr id="47" name="Text 45"/>
-          <p:cNvSpPr/>
-          <p:nvPr/>
-        </p:nvSpPr>
-        <p:spPr>
-          <a:xfrm>
-            <a:off x="237744" y="2395728"/>
+          <p:cNvPr id="55" name="Text 53"/>
+          <p:cNvSpPr/>
+          <p:nvPr/>
+        </p:nvSpPr>
+        <p:spPr>
+          <a:xfrm>
+            <a:off x="237744" y="2907792"/>
             <a:ext cx="2657856" cy="164592"/>
           </a:xfrm>
           <a:prstGeom prst="rect">
@@ -3554,13 +3816,13 @@
       </p:sp>
       <p:sp>
         <p:nvSpPr>
-          <p:cNvPr id="48" name="Shape 46"/>
-          <p:cNvSpPr/>
-          <p:nvPr/>
-        </p:nvSpPr>
-        <p:spPr>
-          <a:xfrm>
-            <a:off x="146304" y="2670048"/>
+          <p:cNvPr id="56" name="Shape 54"/>
+          <p:cNvSpPr/>
+          <p:nvPr/>
+        </p:nvSpPr>
+        <p:spPr>
+          <a:xfrm>
+            <a:off x="146304" y="3182112"/>
             <a:ext cx="2804160" cy="457200"/>
           </a:xfrm>
           <a:prstGeom prst="rect">
@@ -3581,13 +3843,13 @@
       </p:sp>
       <p:sp>
         <p:nvSpPr>
-          <p:cNvPr id="49" name="Shape 47"/>
-          <p:cNvSpPr/>
-          <p:nvPr/>
-        </p:nvSpPr>
-        <p:spPr>
-          <a:xfrm>
-            <a:off x="146304" y="2670048"/>
+          <p:cNvPr id="57" name="Shape 55"/>
+          <p:cNvSpPr/>
+          <p:nvPr/>
+        </p:nvSpPr>
+        <p:spPr>
+          <a:xfrm>
+            <a:off x="146304" y="3182112"/>
             <a:ext cx="50292" cy="457200"/>
           </a:xfrm>
           <a:prstGeom prst="rect">
@@ -3610,13 +3872,13 @@
       </p:sp>
       <p:sp>
         <p:nvSpPr>
-          <p:cNvPr id="50" name="Text 48"/>
-          <p:cNvSpPr/>
-          <p:nvPr/>
-        </p:nvSpPr>
-        <p:spPr>
-          <a:xfrm>
-            <a:off x="237744" y="2706624"/>
+          <p:cNvPr id="58" name="Text 56"/>
+          <p:cNvSpPr/>
+          <p:nvPr/>
+        </p:nvSpPr>
+        <p:spPr>
+          <a:xfrm>
+            <a:off x="237744" y="3218688"/>
             <a:ext cx="2328672" cy="201168"/>
           </a:xfrm>
           <a:prstGeom prst="rect">
@@ -3641,7 +3903,7 @@
                 <a:ea typeface="Calibri" pitchFamily="34" charset="-122"/>
                 <a:cs typeface="Calibri" pitchFamily="34" charset="-120"/>
               </a:rPr>
-              <a:t>Visualization</a:t>
+              <a:t>App Dev</a:t>
             </a:r>
             <a:endParaRPr lang="en-US" sz="850" dirty="0"/>
           </a:p>
@@ -3649,13 +3911,13 @@
       </p:sp>
       <p:sp>
         <p:nvSpPr>
-          <p:cNvPr id="51" name="Shape 49"/>
-          <p:cNvSpPr/>
-          <p:nvPr/>
-        </p:nvSpPr>
-        <p:spPr>
-          <a:xfrm>
-            <a:off x="2548128" y="2724912"/>
+          <p:cNvPr id="59" name="Shape 57"/>
+          <p:cNvSpPr/>
+          <p:nvPr/>
+        </p:nvSpPr>
+        <p:spPr>
+          <a:xfrm>
+            <a:off x="2548128" y="3236976"/>
             <a:ext cx="347472" cy="182880"/>
           </a:xfrm>
           <a:prstGeom prst="rect">
@@ -3674,13 +3936,13 @@
       </p:sp>
       <p:sp>
         <p:nvSpPr>
-          <p:cNvPr id="52" name="Text 50"/>
-          <p:cNvSpPr/>
-          <p:nvPr/>
-        </p:nvSpPr>
-        <p:spPr>
-          <a:xfrm>
-            <a:off x="2548128" y="2724912"/>
+          <p:cNvPr id="60" name="Text 58"/>
+          <p:cNvSpPr/>
+          <p:nvPr/>
+        </p:nvSpPr>
+        <p:spPr>
+          <a:xfrm>
+            <a:off x="2548128" y="3236976"/>
             <a:ext cx="347472" cy="182880"/>
           </a:xfrm>
           <a:prstGeom prst="rect">
@@ -3713,13 +3975,13 @@
       </p:sp>
       <p:sp>
         <p:nvSpPr>
-          <p:cNvPr id="53" name="Text 51"/>
-          <p:cNvSpPr/>
-          <p:nvPr/>
-        </p:nvSpPr>
-        <p:spPr>
-          <a:xfrm>
-            <a:off x="237744" y="2907792"/>
+          <p:cNvPr id="61" name="Text 59"/>
+          <p:cNvSpPr/>
+          <p:nvPr/>
+        </p:nvSpPr>
+        <p:spPr>
+          <a:xfrm>
+            <a:off x="237744" y="3419856"/>
             <a:ext cx="2657856" cy="164592"/>
           </a:xfrm>
           <a:prstGeom prst="rect">
@@ -3752,13 +4014,443 @@
       </p:sp>
       <p:sp>
         <p:nvSpPr>
-          <p:cNvPr id="54" name="Shape 52"/>
-          <p:cNvSpPr/>
-          <p:nvPr/>
-        </p:nvSpPr>
-        <p:spPr>
-          <a:xfrm>
-            <a:off x="146304" y="3182112"/>
+          <p:cNvPr id="62" name="Shape 60"/>
+          <p:cNvSpPr/>
+          <p:nvPr/>
+        </p:nvSpPr>
+        <p:spPr>
+          <a:xfrm>
+            <a:off x="4572000" y="2029968"/>
+            <a:ext cx="0" cy="128016"/>
+          </a:xfrm>
+          <a:prstGeom prst="line">
+            <a:avLst/>
+          </a:prstGeom>
+          <a:noFill/>
+          <a:ln w="15240">
+            <a:solidFill>
+              <a:srgbClr val="0A5CA8"/>
+            </a:solidFill>
+            <a:prstDash val="solid"/>
+          </a:ln>
+        </p:spPr>
+      </p:sp>
+      <p:sp>
+        <p:nvSpPr>
+          <p:cNvPr id="63" name="Shape 61"/>
+          <p:cNvSpPr/>
+          <p:nvPr/>
+        </p:nvSpPr>
+        <p:spPr>
+          <a:xfrm>
+            <a:off x="3169920" y="2157984"/>
+            <a:ext cx="2804160" cy="457200"/>
+          </a:xfrm>
+          <a:prstGeom prst="rect">
+            <a:avLst/>
+          </a:prstGeom>
+          <a:solidFill>
+            <a:srgbClr val="FFFFFF"/>
+          </a:solidFill>
+          <a:ln w="6350">
+            <a:solidFill>
+              <a:srgbClr val="B6BBC0"/>
+            </a:solidFill>
+            <a:prstDash val="solid"/>
+          </a:ln>
+        </p:spPr>
+      </p:sp>
+      <p:sp>
+        <p:nvSpPr>
+          <p:cNvPr id="64" name="Shape 62"/>
+          <p:cNvSpPr/>
+          <p:nvPr/>
+        </p:nvSpPr>
+        <p:spPr>
+          <a:xfrm>
+            <a:off x="3169920" y="2157984"/>
+            <a:ext cx="50292" cy="457200"/>
+          </a:xfrm>
+          <a:prstGeom prst="rect">
+            <a:avLst/>
+          </a:prstGeom>
+          <a:solidFill>
+            <a:srgbClr val="0A5CA8"/>
+          </a:solidFill>
+          <a:ln w="12700">
+            <a:solidFill>
+              <a:srgbClr val="0A5CA8"/>
+            </a:solidFill>
+            <a:prstDash val="solid"/>
+          </a:ln>
+        </p:spPr>
+      </p:sp>
+      <p:sp>
+        <p:nvSpPr>
+          <p:cNvPr id="65" name="Text 63"/>
+          <p:cNvSpPr/>
+          <p:nvPr/>
+        </p:nvSpPr>
+        <p:spPr>
+          <a:xfrm>
+            <a:off x="3261360" y="2194560"/>
+            <a:ext cx="2657856" cy="201168"/>
+          </a:xfrm>
+          <a:prstGeom prst="rect">
+            <a:avLst/>
+          </a:prstGeom>
+          <a:noFill/>
+          <a:ln/>
+        </p:spPr>
+        <p:txBody>
+          <a:bodyPr wrap="square" rtlCol="0" anchor="ctr"/>
+          <a:lstStyle/>
+          <a:p>
+            <a:pPr indent="0" marL="0">
+              <a:buNone/>
+            </a:pPr>
+            <a:r>
+              <a:rPr lang="en-US" sz="850" b="1" dirty="0">
+                <a:solidFill>
+                  <a:srgbClr val="06185F"/>
+                </a:solidFill>
+                <a:latin typeface="Calibri" pitchFamily="34" charset="0"/>
+                <a:ea typeface="Calibri" pitchFamily="34" charset="-122"/>
+                <a:cs typeface="Calibri" pitchFamily="34" charset="-120"/>
+              </a:rPr>
+              <a:t>Elspeth Bloodgood</a:t>
+            </a:r>
+            <a:endParaRPr lang="en-US" sz="850" dirty="0"/>
+          </a:p>
+        </p:txBody>
+      </p:sp>
+      <p:sp>
+        <p:nvSpPr>
+          <p:cNvPr id="66" name="Text 64"/>
+          <p:cNvSpPr/>
+          <p:nvPr/>
+        </p:nvSpPr>
+        <p:spPr>
+          <a:xfrm>
+            <a:off x="3261360" y="2395728"/>
+            <a:ext cx="2657856" cy="182880"/>
+          </a:xfrm>
+          <a:prstGeom prst="rect">
+            <a:avLst/>
+          </a:prstGeom>
+          <a:noFill/>
+          <a:ln/>
+        </p:spPr>
+        <p:txBody>
+          <a:bodyPr wrap="square" rtlCol="0" anchor="ctr"/>
+          <a:lstStyle/>
+          <a:p>
+            <a:pPr indent="0" marL="0">
+              <a:buNone/>
+            </a:pPr>
+            <a:r>
+              <a:rPr lang="en-US" sz="750" dirty="0">
+                <a:solidFill>
+                  <a:srgbClr val="575A5D"/>
+                </a:solidFill>
+                <a:latin typeface="Calibri" pitchFamily="34" charset="0"/>
+                <a:ea typeface="Calibri" pitchFamily="34" charset="-122"/>
+                <a:cs typeface="Calibri" pitchFamily="34" charset="-120"/>
+              </a:rPr>
+              <a:t>PM, Go-to-Market &amp; Visualization</a:t>
+            </a:r>
+            <a:endParaRPr lang="en-US" sz="750" dirty="0"/>
+          </a:p>
+        </p:txBody>
+      </p:sp>
+      <p:sp>
+        <p:nvSpPr>
+          <p:cNvPr id="67" name="Shape 65"/>
+          <p:cNvSpPr/>
+          <p:nvPr/>
+        </p:nvSpPr>
+        <p:spPr>
+          <a:xfrm>
+            <a:off x="3169920" y="2670048"/>
+            <a:ext cx="2804160" cy="457200"/>
+          </a:xfrm>
+          <a:prstGeom prst="rect">
+            <a:avLst/>
+          </a:prstGeom>
+          <a:solidFill>
+            <a:srgbClr val="FFFFFF"/>
+          </a:solidFill>
+          <a:ln w="6350">
+            <a:solidFill>
+              <a:srgbClr val="B6BBC0"/>
+            </a:solidFill>
+            <a:prstDash val="solid"/>
+          </a:ln>
+        </p:spPr>
+      </p:sp>
+      <p:sp>
+        <p:nvSpPr>
+          <p:cNvPr id="68" name="Shape 66"/>
+          <p:cNvSpPr/>
+          <p:nvPr/>
+        </p:nvSpPr>
+        <p:spPr>
+          <a:xfrm>
+            <a:off x="3169920" y="2670048"/>
+            <a:ext cx="50292" cy="457200"/>
+          </a:xfrm>
+          <a:prstGeom prst="rect">
+            <a:avLst/>
+          </a:prstGeom>
+          <a:solidFill>
+            <a:srgbClr val="0A5CA8"/>
+          </a:solidFill>
+          <a:ln w="12700">
+            <a:solidFill>
+              <a:srgbClr val="0A5CA8"/>
+            </a:solidFill>
+            <a:prstDash val="solid"/>
+          </a:ln>
+        </p:spPr>
+      </p:sp>
+      <p:sp>
+        <p:nvSpPr>
+          <p:cNvPr id="69" name="Text 67"/>
+          <p:cNvSpPr/>
+          <p:nvPr/>
+        </p:nvSpPr>
+        <p:spPr>
+          <a:xfrm>
+            <a:off x="3261360" y="2706624"/>
+            <a:ext cx="2657856" cy="201168"/>
+          </a:xfrm>
+          <a:prstGeom prst="rect">
+            <a:avLst/>
+          </a:prstGeom>
+          <a:noFill/>
+          <a:ln/>
+        </p:spPr>
+        <p:txBody>
+          <a:bodyPr wrap="square" rtlCol="0" anchor="ctr"/>
+          <a:lstStyle/>
+          <a:p>
+            <a:pPr indent="0" marL="0">
+              <a:buNone/>
+            </a:pPr>
+            <a:r>
+              <a:rPr lang="en-US" sz="850" b="1" dirty="0">
+                <a:solidFill>
+                  <a:srgbClr val="06185F"/>
+                </a:solidFill>
+                <a:latin typeface="Calibri" pitchFamily="34" charset="0"/>
+                <a:ea typeface="Calibri" pitchFamily="34" charset="-122"/>
+                <a:cs typeface="Calibri" pitchFamily="34" charset="-120"/>
+              </a:rPr>
+              <a:t>Ashley Greenhaw</a:t>
+            </a:r>
+            <a:endParaRPr lang="en-US" sz="850" dirty="0"/>
+          </a:p>
+        </p:txBody>
+      </p:sp>
+      <p:sp>
+        <p:nvSpPr>
+          <p:cNvPr id="70" name="Text 68"/>
+          <p:cNvSpPr/>
+          <p:nvPr/>
+        </p:nvSpPr>
+        <p:spPr>
+          <a:xfrm>
+            <a:off x="3261360" y="2907792"/>
+            <a:ext cx="2657856" cy="182880"/>
+          </a:xfrm>
+          <a:prstGeom prst="rect">
+            <a:avLst/>
+          </a:prstGeom>
+          <a:noFill/>
+          <a:ln/>
+        </p:spPr>
+        <p:txBody>
+          <a:bodyPr wrap="square" rtlCol="0" anchor="ctr"/>
+          <a:lstStyle/>
+          <a:p>
+            <a:pPr indent="0" marL="0">
+              <a:buNone/>
+            </a:pPr>
+            <a:r>
+              <a:rPr lang="en-US" sz="750" dirty="0">
+                <a:solidFill>
+                  <a:srgbClr val="575A5D"/>
+                </a:solidFill>
+                <a:latin typeface="Calibri" pitchFamily="34" charset="0"/>
+                <a:ea typeface="Calibri" pitchFamily="34" charset="-122"/>
+                <a:cs typeface="Calibri" pitchFamily="34" charset="-120"/>
+              </a:rPr>
+              <a:t>PM, Application Development</a:t>
+            </a:r>
+            <a:endParaRPr lang="en-US" sz="750" dirty="0"/>
+          </a:p>
+        </p:txBody>
+      </p:sp>
+      <p:sp>
+        <p:nvSpPr>
+          <p:cNvPr id="71" name="Shape 69"/>
+          <p:cNvSpPr/>
+          <p:nvPr/>
+        </p:nvSpPr>
+        <p:spPr>
+          <a:xfrm>
+            <a:off x="3169920" y="3182112"/>
+            <a:ext cx="2804160" cy="457200"/>
+          </a:xfrm>
+          <a:prstGeom prst="rect">
+            <a:avLst/>
+          </a:prstGeom>
+          <a:solidFill>
+            <a:srgbClr val="FFFFFF"/>
+          </a:solidFill>
+          <a:ln w="6350">
+            <a:solidFill>
+              <a:srgbClr val="B6BBC0"/>
+            </a:solidFill>
+            <a:prstDash val="solid"/>
+          </a:ln>
+        </p:spPr>
+      </p:sp>
+      <p:sp>
+        <p:nvSpPr>
+          <p:cNvPr id="72" name="Shape 70"/>
+          <p:cNvSpPr/>
+          <p:nvPr/>
+        </p:nvSpPr>
+        <p:spPr>
+          <a:xfrm>
+            <a:off x="3169920" y="3182112"/>
+            <a:ext cx="50292" cy="457200"/>
+          </a:xfrm>
+          <a:prstGeom prst="rect">
+            <a:avLst/>
+          </a:prstGeom>
+          <a:solidFill>
+            <a:srgbClr val="0A5CA8"/>
+          </a:solidFill>
+          <a:ln w="12700">
+            <a:solidFill>
+              <a:srgbClr val="0A5CA8"/>
+            </a:solidFill>
+            <a:prstDash val="solid"/>
+          </a:ln>
+        </p:spPr>
+      </p:sp>
+      <p:sp>
+        <p:nvSpPr>
+          <p:cNvPr id="73" name="Text 71"/>
+          <p:cNvSpPr/>
+          <p:nvPr/>
+        </p:nvSpPr>
+        <p:spPr>
+          <a:xfrm>
+            <a:off x="3261360" y="3218688"/>
+            <a:ext cx="2657856" cy="201168"/>
+          </a:xfrm>
+          <a:prstGeom prst="rect">
+            <a:avLst/>
+          </a:prstGeom>
+          <a:noFill/>
+          <a:ln/>
+        </p:spPr>
+        <p:txBody>
+          <a:bodyPr wrap="square" rtlCol="0" anchor="ctr"/>
+          <a:lstStyle/>
+          <a:p>
+            <a:pPr indent="0" marL="0">
+              <a:buNone/>
+            </a:pPr>
+            <a:r>
+              <a:rPr lang="en-US" sz="850" b="1" dirty="0">
+                <a:solidFill>
+                  <a:srgbClr val="06185F"/>
+                </a:solidFill>
+                <a:latin typeface="Calibri" pitchFamily="34" charset="0"/>
+                <a:ea typeface="Calibri" pitchFamily="34" charset="-122"/>
+                <a:cs typeface="Calibri" pitchFamily="34" charset="-120"/>
+              </a:rPr>
+              <a:t>Mike Saunders</a:t>
+            </a:r>
+            <a:endParaRPr lang="en-US" sz="850" dirty="0"/>
+          </a:p>
+        </p:txBody>
+      </p:sp>
+      <p:sp>
+        <p:nvSpPr>
+          <p:cNvPr id="74" name="Text 72"/>
+          <p:cNvSpPr/>
+          <p:nvPr/>
+        </p:nvSpPr>
+        <p:spPr>
+          <a:xfrm>
+            <a:off x="3261360" y="3419856"/>
+            <a:ext cx="2657856" cy="182880"/>
+          </a:xfrm>
+          <a:prstGeom prst="rect">
+            <a:avLst/>
+          </a:prstGeom>
+          <a:noFill/>
+          <a:ln/>
+        </p:spPr>
+        <p:txBody>
+          <a:bodyPr wrap="square" rtlCol="0" anchor="ctr"/>
+          <a:lstStyle/>
+          <a:p>
+            <a:pPr indent="0" marL="0">
+              <a:buNone/>
+            </a:pPr>
+            <a:r>
+              <a:rPr lang="en-US" sz="750" dirty="0">
+                <a:solidFill>
+                  <a:srgbClr val="575A5D"/>
+                </a:solidFill>
+                <a:latin typeface="Calibri" pitchFamily="34" charset="0"/>
+                <a:ea typeface="Calibri" pitchFamily="34" charset="-122"/>
+                <a:cs typeface="Calibri" pitchFamily="34" charset="-120"/>
+              </a:rPr>
+              <a:t>PM, Data Acq. &amp; Engineering</a:t>
+            </a:r>
+            <a:endParaRPr lang="en-US" sz="750" dirty="0"/>
+          </a:p>
+        </p:txBody>
+      </p:sp>
+      <p:sp>
+        <p:nvSpPr>
+          <p:cNvPr id="75" name="Shape 73"/>
+          <p:cNvSpPr/>
+          <p:nvPr/>
+        </p:nvSpPr>
+        <p:spPr>
+          <a:xfrm>
+            <a:off x="7595616" y="2029968"/>
+            <a:ext cx="0" cy="128016"/>
+          </a:xfrm>
+          <a:prstGeom prst="line">
+            <a:avLst/>
+          </a:prstGeom>
+          <a:noFill/>
+          <a:ln w="15240">
+            <a:solidFill>
+              <a:srgbClr val="0A5C47"/>
+            </a:solidFill>
+            <a:prstDash val="solid"/>
+          </a:ln>
+        </p:spPr>
+      </p:sp>
+      <p:sp>
+        <p:nvSpPr>
+          <p:cNvPr id="76" name="Shape 74"/>
+          <p:cNvSpPr/>
+          <p:nvPr/>
+        </p:nvSpPr>
+        <p:spPr>
+          <a:xfrm>
+            <a:off x="6193536" y="2157984"/>
             <a:ext cx="2804160" cy="457200"/>
           </a:xfrm>
           <a:prstGeom prst="rect">
@@ -3771,34 +4463,34 @@
           </a:solidFill>
           <a:ln w="9525">
             <a:solidFill>
-              <a:srgbClr val="085CE5"/>
-            </a:solidFill>
-            <a:prstDash val="solid"/>
-          </a:ln>
-        </p:spPr>
-      </p:sp>
-      <p:sp>
-        <p:nvSpPr>
-          <p:cNvPr id="55" name="Shape 53"/>
-          <p:cNvSpPr/>
-          <p:nvPr/>
-        </p:nvSpPr>
-        <p:spPr>
-          <a:xfrm>
-            <a:off x="146304" y="3182112"/>
+              <a:srgbClr val="0A5C47"/>
+            </a:solidFill>
+            <a:prstDash val="solid"/>
+          </a:ln>
+        </p:spPr>
+      </p:sp>
+      <p:sp>
+        <p:nvSpPr>
+          <p:cNvPr id="77" name="Shape 75"/>
+          <p:cNvSpPr/>
+          <p:nvPr/>
+        </p:nvSpPr>
+        <p:spPr>
+          <a:xfrm>
+            <a:off x="6193536" y="2157984"/>
             <a:ext cx="50292" cy="457200"/>
           </a:xfrm>
           <a:prstGeom prst="rect">
             <a:avLst/>
           </a:prstGeom>
           <a:solidFill>
-            <a:srgbClr val="085CE5">
+            <a:srgbClr val="0A5C47">
               <a:alpha val="70000"/>
             </a:srgbClr>
           </a:solidFill>
           <a:ln w="12700">
             <a:solidFill>
-              <a:srgbClr val="085CE5">
+              <a:srgbClr val="0A5C47">
                 <a:alpha val="70000"/>
               </a:srgbClr>
             </a:solidFill>
@@ -3808,13 +4500,13 @@
       </p:sp>
       <p:sp>
         <p:nvSpPr>
-          <p:cNvPr id="56" name="Text 54"/>
-          <p:cNvSpPr/>
-          <p:nvPr/>
-        </p:nvSpPr>
-        <p:spPr>
-          <a:xfrm>
-            <a:off x="237744" y="3218688"/>
+          <p:cNvPr id="78" name="Text 76"/>
+          <p:cNvSpPr/>
+          <p:nvPr/>
+        </p:nvSpPr>
+        <p:spPr>
+          <a:xfrm>
+            <a:off x="6284976" y="2194560"/>
             <a:ext cx="2328672" cy="201168"/>
           </a:xfrm>
           <a:prstGeom prst="rect">
@@ -3839,7 +4531,7 @@
                 <a:ea typeface="Calibri" pitchFamily="34" charset="-122"/>
                 <a:cs typeface="Calibri" pitchFamily="34" charset="-120"/>
               </a:rPr>
-              <a:t>App Dev</a:t>
+              <a:t>Data Scientist</a:t>
             </a:r>
             <a:endParaRPr lang="en-US" sz="850" dirty="0"/>
           </a:p>
@@ -3847,38 +4539,38 @@
       </p:sp>
       <p:sp>
         <p:nvSpPr>
-          <p:cNvPr id="57" name="Shape 55"/>
-          <p:cNvSpPr/>
-          <p:nvPr/>
-        </p:nvSpPr>
-        <p:spPr>
-          <a:xfrm>
-            <a:off x="2548128" y="3236976"/>
+          <p:cNvPr id="79" name="Shape 77"/>
+          <p:cNvSpPr/>
+          <p:nvPr/>
+        </p:nvSpPr>
+        <p:spPr>
+          <a:xfrm>
+            <a:off x="8595360" y="2212848"/>
             <a:ext cx="347472" cy="182880"/>
           </a:xfrm>
           <a:prstGeom prst="rect">
             <a:avLst/>
           </a:prstGeom>
           <a:solidFill>
-            <a:srgbClr val="085CE5"/>
+            <a:srgbClr val="0A5C47"/>
           </a:solidFill>
           <a:ln w="12700">
             <a:solidFill>
-              <a:srgbClr val="085CE5"/>
-            </a:solidFill>
-            <a:prstDash val="solid"/>
-          </a:ln>
-        </p:spPr>
-      </p:sp>
-      <p:sp>
-        <p:nvSpPr>
-          <p:cNvPr id="58" name="Text 56"/>
-          <p:cNvSpPr/>
-          <p:nvPr/>
-        </p:nvSpPr>
-        <p:spPr>
-          <a:xfrm>
-            <a:off x="2548128" y="3236976"/>
+              <a:srgbClr val="0A5C47"/>
+            </a:solidFill>
+            <a:prstDash val="solid"/>
+          </a:ln>
+        </p:spPr>
+      </p:sp>
+      <p:sp>
+        <p:nvSpPr>
+          <p:cNvPr id="80" name="Text 78"/>
+          <p:cNvSpPr/>
+          <p:nvPr/>
+        </p:nvSpPr>
+        <p:spPr>
+          <a:xfrm>
+            <a:off x="8595360" y="2212848"/>
             <a:ext cx="347472" cy="182880"/>
           </a:xfrm>
           <a:prstGeom prst="rect">
@@ -3903,7 +4595,7 @@
                 <a:ea typeface="Calibri" pitchFamily="34" charset="-122"/>
                 <a:cs typeface="Calibri" pitchFamily="34" charset="-120"/>
               </a:rPr>
-              <a:t>2</a:t>
+              <a:t>4</a:t>
             </a:r>
             <a:endParaRPr lang="en-US" sz="750" dirty="0"/>
           </a:p>
@@ -3911,13 +4603,13 @@
       </p:sp>
       <p:sp>
         <p:nvSpPr>
-          <p:cNvPr id="59" name="Text 57"/>
-          <p:cNvSpPr/>
-          <p:nvPr/>
-        </p:nvSpPr>
-        <p:spPr>
-          <a:xfrm>
-            <a:off x="237744" y="3419856"/>
+          <p:cNvPr id="81" name="Text 79"/>
+          <p:cNvSpPr/>
+          <p:nvPr/>
+        </p:nvSpPr>
+        <p:spPr>
+          <a:xfrm>
+            <a:off x="6284976" y="2395728"/>
             <a:ext cx="2657856" cy="164592"/>
           </a:xfrm>
           <a:prstGeom prst="rect">
@@ -3950,443 +4642,13 @@
       </p:sp>
       <p:sp>
         <p:nvSpPr>
-          <p:cNvPr id="60" name="Shape 58"/>
-          <p:cNvSpPr/>
-          <p:nvPr/>
-        </p:nvSpPr>
-        <p:spPr>
-          <a:xfrm>
-            <a:off x="4572000" y="2029968"/>
-            <a:ext cx="0" cy="128016"/>
-          </a:xfrm>
-          <a:prstGeom prst="line">
-            <a:avLst/>
-          </a:prstGeom>
-          <a:noFill/>
-          <a:ln w="15240">
-            <a:solidFill>
-              <a:srgbClr val="0A5CA8"/>
-            </a:solidFill>
-            <a:prstDash val="solid"/>
-          </a:ln>
-        </p:spPr>
-      </p:sp>
-      <p:sp>
-        <p:nvSpPr>
-          <p:cNvPr id="61" name="Shape 59"/>
-          <p:cNvSpPr/>
-          <p:nvPr/>
-        </p:nvSpPr>
-        <p:spPr>
-          <a:xfrm>
-            <a:off x="3169920" y="2157984"/>
-            <a:ext cx="2804160" cy="457200"/>
-          </a:xfrm>
-          <a:prstGeom prst="rect">
-            <a:avLst/>
-          </a:prstGeom>
-          <a:solidFill>
-            <a:srgbClr val="FFFFFF"/>
-          </a:solidFill>
-          <a:ln w="6350">
-            <a:solidFill>
-              <a:srgbClr val="B6BBC0"/>
-            </a:solidFill>
-            <a:prstDash val="solid"/>
-          </a:ln>
-        </p:spPr>
-      </p:sp>
-      <p:sp>
-        <p:nvSpPr>
-          <p:cNvPr id="62" name="Shape 60"/>
-          <p:cNvSpPr/>
-          <p:nvPr/>
-        </p:nvSpPr>
-        <p:spPr>
-          <a:xfrm>
-            <a:off x="3169920" y="2157984"/>
-            <a:ext cx="50292" cy="457200"/>
-          </a:xfrm>
-          <a:prstGeom prst="rect">
-            <a:avLst/>
-          </a:prstGeom>
-          <a:solidFill>
-            <a:srgbClr val="0A5CA8"/>
-          </a:solidFill>
-          <a:ln w="12700">
-            <a:solidFill>
-              <a:srgbClr val="0A5CA8"/>
-            </a:solidFill>
-            <a:prstDash val="solid"/>
-          </a:ln>
-        </p:spPr>
-      </p:sp>
-      <p:sp>
-        <p:nvSpPr>
-          <p:cNvPr id="63" name="Text 61"/>
-          <p:cNvSpPr/>
-          <p:nvPr/>
-        </p:nvSpPr>
-        <p:spPr>
-          <a:xfrm>
-            <a:off x="3261360" y="2194560"/>
-            <a:ext cx="2657856" cy="201168"/>
-          </a:xfrm>
-          <a:prstGeom prst="rect">
-            <a:avLst/>
-          </a:prstGeom>
-          <a:noFill/>
-          <a:ln/>
-        </p:spPr>
-        <p:txBody>
-          <a:bodyPr wrap="square" rtlCol="0" anchor="ctr"/>
-          <a:lstStyle/>
-          <a:p>
-            <a:pPr indent="0" marL="0">
-              <a:buNone/>
-            </a:pPr>
-            <a:r>
-              <a:rPr lang="en-US" sz="850" b="1" dirty="0">
-                <a:solidFill>
-                  <a:srgbClr val="06185F"/>
-                </a:solidFill>
-                <a:latin typeface="Calibri" pitchFamily="34" charset="0"/>
-                <a:ea typeface="Calibri" pitchFamily="34" charset="-122"/>
-                <a:cs typeface="Calibri" pitchFamily="34" charset="-120"/>
-              </a:rPr>
-              <a:t>Elspeth Bloodgood</a:t>
-            </a:r>
-            <a:endParaRPr lang="en-US" sz="850" dirty="0"/>
-          </a:p>
-        </p:txBody>
-      </p:sp>
-      <p:sp>
-        <p:nvSpPr>
-          <p:cNvPr id="64" name="Text 62"/>
-          <p:cNvSpPr/>
-          <p:nvPr/>
-        </p:nvSpPr>
-        <p:spPr>
-          <a:xfrm>
-            <a:off x="3261360" y="2395728"/>
-            <a:ext cx="2657856" cy="182880"/>
-          </a:xfrm>
-          <a:prstGeom prst="rect">
-            <a:avLst/>
-          </a:prstGeom>
-          <a:noFill/>
-          <a:ln/>
-        </p:spPr>
-        <p:txBody>
-          <a:bodyPr wrap="square" rtlCol="0" anchor="ctr"/>
-          <a:lstStyle/>
-          <a:p>
-            <a:pPr indent="0" marL="0">
-              <a:buNone/>
-            </a:pPr>
-            <a:r>
-              <a:rPr lang="en-US" sz="750" dirty="0">
-                <a:solidFill>
-                  <a:srgbClr val="575A5D"/>
-                </a:solidFill>
-                <a:latin typeface="Calibri" pitchFamily="34" charset="0"/>
-                <a:ea typeface="Calibri" pitchFamily="34" charset="-122"/>
-                <a:cs typeface="Calibri" pitchFamily="34" charset="-120"/>
-              </a:rPr>
-              <a:t>PM, Go-to-Market &amp; Visualization</a:t>
-            </a:r>
-            <a:endParaRPr lang="en-US" sz="750" dirty="0"/>
-          </a:p>
-        </p:txBody>
-      </p:sp>
-      <p:sp>
-        <p:nvSpPr>
-          <p:cNvPr id="65" name="Shape 63"/>
-          <p:cNvSpPr/>
-          <p:nvPr/>
-        </p:nvSpPr>
-        <p:spPr>
-          <a:xfrm>
-            <a:off x="3169920" y="2670048"/>
-            <a:ext cx="2804160" cy="457200"/>
-          </a:xfrm>
-          <a:prstGeom prst="rect">
-            <a:avLst/>
-          </a:prstGeom>
-          <a:solidFill>
-            <a:srgbClr val="FFFFFF"/>
-          </a:solidFill>
-          <a:ln w="6350">
-            <a:solidFill>
-              <a:srgbClr val="B6BBC0"/>
-            </a:solidFill>
-            <a:prstDash val="solid"/>
-          </a:ln>
-        </p:spPr>
-      </p:sp>
-      <p:sp>
-        <p:nvSpPr>
-          <p:cNvPr id="66" name="Shape 64"/>
-          <p:cNvSpPr/>
-          <p:nvPr/>
-        </p:nvSpPr>
-        <p:spPr>
-          <a:xfrm>
-            <a:off x="3169920" y="2670048"/>
-            <a:ext cx="50292" cy="457200"/>
-          </a:xfrm>
-          <a:prstGeom prst="rect">
-            <a:avLst/>
-          </a:prstGeom>
-          <a:solidFill>
-            <a:srgbClr val="0A5CA8"/>
-          </a:solidFill>
-          <a:ln w="12700">
-            <a:solidFill>
-              <a:srgbClr val="0A5CA8"/>
-            </a:solidFill>
-            <a:prstDash val="solid"/>
-          </a:ln>
-        </p:spPr>
-      </p:sp>
-      <p:sp>
-        <p:nvSpPr>
-          <p:cNvPr id="67" name="Text 65"/>
-          <p:cNvSpPr/>
-          <p:nvPr/>
-        </p:nvSpPr>
-        <p:spPr>
-          <a:xfrm>
-            <a:off x="3261360" y="2706624"/>
-            <a:ext cx="2657856" cy="201168"/>
-          </a:xfrm>
-          <a:prstGeom prst="rect">
-            <a:avLst/>
-          </a:prstGeom>
-          <a:noFill/>
-          <a:ln/>
-        </p:spPr>
-        <p:txBody>
-          <a:bodyPr wrap="square" rtlCol="0" anchor="ctr"/>
-          <a:lstStyle/>
-          <a:p>
-            <a:pPr indent="0" marL="0">
-              <a:buNone/>
-            </a:pPr>
-            <a:r>
-              <a:rPr lang="en-US" sz="850" b="1" dirty="0">
-                <a:solidFill>
-                  <a:srgbClr val="06185F"/>
-                </a:solidFill>
-                <a:latin typeface="Calibri" pitchFamily="34" charset="0"/>
-                <a:ea typeface="Calibri" pitchFamily="34" charset="-122"/>
-                <a:cs typeface="Calibri" pitchFamily="34" charset="-120"/>
-              </a:rPr>
-              <a:t>Ashley Greenhaw</a:t>
-            </a:r>
-            <a:endParaRPr lang="en-US" sz="850" dirty="0"/>
-          </a:p>
-        </p:txBody>
-      </p:sp>
-      <p:sp>
-        <p:nvSpPr>
-          <p:cNvPr id="68" name="Text 66"/>
-          <p:cNvSpPr/>
-          <p:nvPr/>
-        </p:nvSpPr>
-        <p:spPr>
-          <a:xfrm>
-            <a:off x="3261360" y="2907792"/>
-            <a:ext cx="2657856" cy="182880"/>
-          </a:xfrm>
-          <a:prstGeom prst="rect">
-            <a:avLst/>
-          </a:prstGeom>
-          <a:noFill/>
-          <a:ln/>
-        </p:spPr>
-        <p:txBody>
-          <a:bodyPr wrap="square" rtlCol="0" anchor="ctr"/>
-          <a:lstStyle/>
-          <a:p>
-            <a:pPr indent="0" marL="0">
-              <a:buNone/>
-            </a:pPr>
-            <a:r>
-              <a:rPr lang="en-US" sz="750" dirty="0">
-                <a:solidFill>
-                  <a:srgbClr val="575A5D"/>
-                </a:solidFill>
-                <a:latin typeface="Calibri" pitchFamily="34" charset="0"/>
-                <a:ea typeface="Calibri" pitchFamily="34" charset="-122"/>
-                <a:cs typeface="Calibri" pitchFamily="34" charset="-120"/>
-              </a:rPr>
-              <a:t>PM, Application Development</a:t>
-            </a:r>
-            <a:endParaRPr lang="en-US" sz="750" dirty="0"/>
-          </a:p>
-        </p:txBody>
-      </p:sp>
-      <p:sp>
-        <p:nvSpPr>
-          <p:cNvPr id="69" name="Shape 67"/>
-          <p:cNvSpPr/>
-          <p:nvPr/>
-        </p:nvSpPr>
-        <p:spPr>
-          <a:xfrm>
-            <a:off x="3169920" y="3182112"/>
-            <a:ext cx="2804160" cy="457200"/>
-          </a:xfrm>
-          <a:prstGeom prst="rect">
-            <a:avLst/>
-          </a:prstGeom>
-          <a:solidFill>
-            <a:srgbClr val="FFFFFF"/>
-          </a:solidFill>
-          <a:ln w="6350">
-            <a:solidFill>
-              <a:srgbClr val="B6BBC0"/>
-            </a:solidFill>
-            <a:prstDash val="solid"/>
-          </a:ln>
-        </p:spPr>
-      </p:sp>
-      <p:sp>
-        <p:nvSpPr>
-          <p:cNvPr id="70" name="Shape 68"/>
-          <p:cNvSpPr/>
-          <p:nvPr/>
-        </p:nvSpPr>
-        <p:spPr>
-          <a:xfrm>
-            <a:off x="3169920" y="3182112"/>
-            <a:ext cx="50292" cy="457200"/>
-          </a:xfrm>
-          <a:prstGeom prst="rect">
-            <a:avLst/>
-          </a:prstGeom>
-          <a:solidFill>
-            <a:srgbClr val="0A5CA8"/>
-          </a:solidFill>
-          <a:ln w="12700">
-            <a:solidFill>
-              <a:srgbClr val="0A5CA8"/>
-            </a:solidFill>
-            <a:prstDash val="solid"/>
-          </a:ln>
-        </p:spPr>
-      </p:sp>
-      <p:sp>
-        <p:nvSpPr>
-          <p:cNvPr id="71" name="Text 69"/>
-          <p:cNvSpPr/>
-          <p:nvPr/>
-        </p:nvSpPr>
-        <p:spPr>
-          <a:xfrm>
-            <a:off x="3261360" y="3218688"/>
-            <a:ext cx="2657856" cy="201168"/>
-          </a:xfrm>
-          <a:prstGeom prst="rect">
-            <a:avLst/>
-          </a:prstGeom>
-          <a:noFill/>
-          <a:ln/>
-        </p:spPr>
-        <p:txBody>
-          <a:bodyPr wrap="square" rtlCol="0" anchor="ctr"/>
-          <a:lstStyle/>
-          <a:p>
-            <a:pPr indent="0" marL="0">
-              <a:buNone/>
-            </a:pPr>
-            <a:r>
-              <a:rPr lang="en-US" sz="850" b="1" dirty="0">
-                <a:solidFill>
-                  <a:srgbClr val="06185F"/>
-                </a:solidFill>
-                <a:latin typeface="Calibri" pitchFamily="34" charset="0"/>
-                <a:ea typeface="Calibri" pitchFamily="34" charset="-122"/>
-                <a:cs typeface="Calibri" pitchFamily="34" charset="-120"/>
-              </a:rPr>
-              <a:t>Mike Saunders</a:t>
-            </a:r>
-            <a:endParaRPr lang="en-US" sz="850" dirty="0"/>
-          </a:p>
-        </p:txBody>
-      </p:sp>
-      <p:sp>
-        <p:nvSpPr>
-          <p:cNvPr id="72" name="Text 70"/>
-          <p:cNvSpPr/>
-          <p:nvPr/>
-        </p:nvSpPr>
-        <p:spPr>
-          <a:xfrm>
-            <a:off x="3261360" y="3419856"/>
-            <a:ext cx="2657856" cy="182880"/>
-          </a:xfrm>
-          <a:prstGeom prst="rect">
-            <a:avLst/>
-          </a:prstGeom>
-          <a:noFill/>
-          <a:ln/>
-        </p:spPr>
-        <p:txBody>
-          <a:bodyPr wrap="square" rtlCol="0" anchor="ctr"/>
-          <a:lstStyle/>
-          <a:p>
-            <a:pPr indent="0" marL="0">
-              <a:buNone/>
-            </a:pPr>
-            <a:r>
-              <a:rPr lang="en-US" sz="750" dirty="0">
-                <a:solidFill>
-                  <a:srgbClr val="575A5D"/>
-                </a:solidFill>
-                <a:latin typeface="Calibri" pitchFamily="34" charset="0"/>
-                <a:ea typeface="Calibri" pitchFamily="34" charset="-122"/>
-                <a:cs typeface="Calibri" pitchFamily="34" charset="-120"/>
-              </a:rPr>
-              <a:t>PM, Data Acq. &amp; Engineering</a:t>
-            </a:r>
-            <a:endParaRPr lang="en-US" sz="750" dirty="0"/>
-          </a:p>
-        </p:txBody>
-      </p:sp>
-      <p:sp>
-        <p:nvSpPr>
-          <p:cNvPr id="73" name="Shape 71"/>
-          <p:cNvSpPr/>
-          <p:nvPr/>
-        </p:nvSpPr>
-        <p:spPr>
-          <a:xfrm>
-            <a:off x="7595616" y="2029968"/>
-            <a:ext cx="0" cy="128016"/>
-          </a:xfrm>
-          <a:prstGeom prst="line">
-            <a:avLst/>
-          </a:prstGeom>
-          <a:noFill/>
-          <a:ln w="15240">
-            <a:solidFill>
-              <a:srgbClr val="0A5C47"/>
-            </a:solidFill>
-            <a:prstDash val="solid"/>
-          </a:ln>
-        </p:spPr>
-      </p:sp>
-      <p:sp>
-        <p:nvSpPr>
-          <p:cNvPr id="74" name="Shape 72"/>
-          <p:cNvSpPr/>
-          <p:nvPr/>
-        </p:nvSpPr>
-        <p:spPr>
-          <a:xfrm>
-            <a:off x="6193536" y="2157984"/>
+          <p:cNvPr id="82" name="Shape 80"/>
+          <p:cNvSpPr/>
+          <p:nvPr/>
+        </p:nvSpPr>
+        <p:spPr>
+          <a:xfrm>
+            <a:off x="6193536" y="2670048"/>
             <a:ext cx="2804160" cy="457200"/>
           </a:xfrm>
           <a:prstGeom prst="rect">
@@ -4407,13 +4669,13 @@
       </p:sp>
       <p:sp>
         <p:nvSpPr>
-          <p:cNvPr id="75" name="Shape 73"/>
-          <p:cNvSpPr/>
-          <p:nvPr/>
-        </p:nvSpPr>
-        <p:spPr>
-          <a:xfrm>
-            <a:off x="6193536" y="2157984"/>
+          <p:cNvPr id="83" name="Shape 81"/>
+          <p:cNvSpPr/>
+          <p:nvPr/>
+        </p:nvSpPr>
+        <p:spPr>
+          <a:xfrm>
+            <a:off x="6193536" y="2670048"/>
             <a:ext cx="50292" cy="457200"/>
           </a:xfrm>
           <a:prstGeom prst="rect">
@@ -4436,205 +4698,7 @@
       </p:sp>
       <p:sp>
         <p:nvSpPr>
-          <p:cNvPr id="76" name="Text 74"/>
-          <p:cNvSpPr/>
-          <p:nvPr/>
-        </p:nvSpPr>
-        <p:spPr>
-          <a:xfrm>
-            <a:off x="6284976" y="2194560"/>
-            <a:ext cx="2328672" cy="201168"/>
-          </a:xfrm>
-          <a:prstGeom prst="rect">
-            <a:avLst/>
-          </a:prstGeom>
-          <a:noFill/>
-          <a:ln/>
-        </p:spPr>
-        <p:txBody>
-          <a:bodyPr wrap="square" rtlCol="0" anchor="ctr"/>
-          <a:lstStyle/>
-          <a:p>
-            <a:pPr indent="0" marL="0">
-              <a:buNone/>
-            </a:pPr>
-            <a:r>
-              <a:rPr lang="en-US" sz="850" b="1" dirty="0">
-                <a:solidFill>
-                  <a:srgbClr val="06185F"/>
-                </a:solidFill>
-                <a:latin typeface="Calibri" pitchFamily="34" charset="0"/>
-                <a:ea typeface="Calibri" pitchFamily="34" charset="-122"/>
-                <a:cs typeface="Calibri" pitchFamily="34" charset="-120"/>
-              </a:rPr>
-              <a:t>Data Scientist</a:t>
-            </a:r>
-            <a:endParaRPr lang="en-US" sz="850" dirty="0"/>
-          </a:p>
-        </p:txBody>
-      </p:sp>
-      <p:sp>
-        <p:nvSpPr>
-          <p:cNvPr id="77" name="Shape 75"/>
-          <p:cNvSpPr/>
-          <p:nvPr/>
-        </p:nvSpPr>
-        <p:spPr>
-          <a:xfrm>
-            <a:off x="8595360" y="2212848"/>
-            <a:ext cx="347472" cy="182880"/>
-          </a:xfrm>
-          <a:prstGeom prst="rect">
-            <a:avLst/>
-          </a:prstGeom>
-          <a:solidFill>
-            <a:srgbClr val="0A5C47"/>
-          </a:solidFill>
-          <a:ln w="12700">
-            <a:solidFill>
-              <a:srgbClr val="0A5C47"/>
-            </a:solidFill>
-            <a:prstDash val="solid"/>
-          </a:ln>
-        </p:spPr>
-      </p:sp>
-      <p:sp>
-        <p:nvSpPr>
-          <p:cNvPr id="78" name="Text 76"/>
-          <p:cNvSpPr/>
-          <p:nvPr/>
-        </p:nvSpPr>
-        <p:spPr>
-          <a:xfrm>
-            <a:off x="8595360" y="2212848"/>
-            <a:ext cx="347472" cy="182880"/>
-          </a:xfrm>
-          <a:prstGeom prst="rect">
-            <a:avLst/>
-          </a:prstGeom>
-          <a:noFill/>
-          <a:ln/>
-        </p:spPr>
-        <p:txBody>
-          <a:bodyPr wrap="square" lIns="0" tIns="0" rIns="0" bIns="0" rtlCol="0" anchor="ctr"/>
-          <a:lstStyle/>
-          <a:p>
-            <a:pPr algn="ctr" indent="0" marL="0">
-              <a:buNone/>
-            </a:pPr>
-            <a:r>
-              <a:rPr lang="en-US" sz="750" b="1" dirty="0">
-                <a:solidFill>
-                  <a:srgbClr val="FFFFFF"/>
-                </a:solidFill>
-                <a:latin typeface="Calibri" pitchFamily="34" charset="0"/>
-                <a:ea typeface="Calibri" pitchFamily="34" charset="-122"/>
-                <a:cs typeface="Calibri" pitchFamily="34" charset="-120"/>
-              </a:rPr>
-              <a:t>4</a:t>
-            </a:r>
-            <a:endParaRPr lang="en-US" sz="750" dirty="0"/>
-          </a:p>
-        </p:txBody>
-      </p:sp>
-      <p:sp>
-        <p:nvSpPr>
-          <p:cNvPr id="79" name="Text 77"/>
-          <p:cNvSpPr/>
-          <p:nvPr/>
-        </p:nvSpPr>
-        <p:spPr>
-          <a:xfrm>
-            <a:off x="6284976" y="2395728"/>
-            <a:ext cx="2657856" cy="164592"/>
-          </a:xfrm>
-          <a:prstGeom prst="rect">
-            <a:avLst/>
-          </a:prstGeom>
-          <a:noFill/>
-          <a:ln/>
-        </p:spPr>
-        <p:txBody>
-          <a:bodyPr wrap="square" rtlCol="0" anchor="ctr"/>
-          <a:lstStyle/>
-          <a:p>
-            <a:pPr indent="0" marL="0">
-              <a:buNone/>
-            </a:pPr>
-            <a:r>
-              <a:rPr lang="en-US" sz="700" i="1" dirty="0">
-                <a:solidFill>
-                  <a:srgbClr val="575A5D"/>
-                </a:solidFill>
-                <a:latin typeface="Calibri" pitchFamily="34" charset="0"/>
-                <a:ea typeface="Calibri" pitchFamily="34" charset="-122"/>
-                <a:cs typeface="Calibri" pitchFamily="34" charset="-120"/>
-              </a:rPr>
-              <a:t>Open Positions</a:t>
-            </a:r>
-            <a:endParaRPr lang="en-US" sz="700" dirty="0"/>
-          </a:p>
-        </p:txBody>
-      </p:sp>
-      <p:sp>
-        <p:nvSpPr>
-          <p:cNvPr id="80" name="Shape 78"/>
-          <p:cNvSpPr/>
-          <p:nvPr/>
-        </p:nvSpPr>
-        <p:spPr>
-          <a:xfrm>
-            <a:off x="6193536" y="2670048"/>
-            <a:ext cx="2804160" cy="457200"/>
-          </a:xfrm>
-          <a:prstGeom prst="rect">
-            <a:avLst/>
-          </a:prstGeom>
-          <a:solidFill>
-            <a:srgbClr val="E7ECF0">
-              <a:alpha val="80000"/>
-            </a:srgbClr>
-          </a:solidFill>
-          <a:ln w="9525">
-            <a:solidFill>
-              <a:srgbClr val="0A5C47"/>
-            </a:solidFill>
-            <a:prstDash val="solid"/>
-          </a:ln>
-        </p:spPr>
-      </p:sp>
-      <p:sp>
-        <p:nvSpPr>
-          <p:cNvPr id="81" name="Shape 79"/>
-          <p:cNvSpPr/>
-          <p:nvPr/>
-        </p:nvSpPr>
-        <p:spPr>
-          <a:xfrm>
-            <a:off x="6193536" y="2670048"/>
-            <a:ext cx="50292" cy="457200"/>
-          </a:xfrm>
-          <a:prstGeom prst="rect">
-            <a:avLst/>
-          </a:prstGeom>
-          <a:solidFill>
-            <a:srgbClr val="0A5C47">
-              <a:alpha val="70000"/>
-            </a:srgbClr>
-          </a:solidFill>
-          <a:ln w="12700">
-            <a:solidFill>
-              <a:srgbClr val="0A5C47">
-                <a:alpha val="70000"/>
-              </a:srgbClr>
-            </a:solidFill>
-            <a:prstDash val="solid"/>
-          </a:ln>
-        </p:spPr>
-      </p:sp>
-      <p:sp>
-        <p:nvSpPr>
-          <p:cNvPr id="82" name="Text 80"/>
+          <p:cNvPr id="84" name="Text 82"/>
           <p:cNvSpPr/>
           <p:nvPr/>
         </p:nvSpPr>
@@ -4673,7 +4737,7 @@
       </p:sp>
       <p:sp>
         <p:nvSpPr>
-          <p:cNvPr id="83" name="Shape 81"/>
+          <p:cNvPr id="85" name="Shape 83"/>
           <p:cNvSpPr/>
           <p:nvPr/>
         </p:nvSpPr>
@@ -4698,7 +4762,7 @@
       </p:sp>
       <p:sp>
         <p:nvSpPr>
-          <p:cNvPr id="84" name="Text 82"/>
+          <p:cNvPr id="86" name="Text 84"/>
           <p:cNvSpPr/>
           <p:nvPr/>
         </p:nvSpPr>
@@ -4737,7 +4801,7 @@
       </p:sp>
       <p:sp>
         <p:nvSpPr>
-          <p:cNvPr id="85" name="Text 83"/>
+          <p:cNvPr id="87" name="Text 85"/>
           <p:cNvSpPr/>
           <p:nvPr/>
         </p:nvSpPr>
@@ -4762,13 +4826,13 @@
             <a:r>
               <a:rPr lang="en-US" sz="700" i="1" dirty="0">
                 <a:solidFill>
-                  <a:srgbClr val="575A5D"/>
-                </a:solidFill>
-                <a:latin typeface="Calibri" pitchFamily="34" charset="0"/>
-                <a:ea typeface="Calibri" pitchFamily="34" charset="-122"/>
-                <a:cs typeface="Calibri" pitchFamily="34" charset="-120"/>
-              </a:rPr>
-              <a:t>Open Position</a:t>
+                  <a:srgbClr val="0A5CA8"/>
+                </a:solidFill>
+                <a:latin typeface="Calibri" pitchFamily="34" charset="0"/>
+                <a:ea typeface="Calibri" pitchFamily="34" charset="-122"/>
+                <a:cs typeface="Calibri" pitchFamily="34" charset="-120"/>
+              </a:rPr>
+              <a:t>Open Position · FY26</a:t>
             </a:r>
             <a:endParaRPr lang="en-US" sz="700" dirty="0"/>
           </a:p>
@@ -4776,7 +4840,7 @@
       </p:sp>
       <p:sp>
         <p:nvSpPr>
-          <p:cNvPr id="86" name="Shape 84"/>
+          <p:cNvPr id="88" name="Shape 86"/>
           <p:cNvSpPr/>
           <p:nvPr/>
         </p:nvSpPr>
@@ -4801,7 +4865,7 @@
       </p:sp>
       <p:sp>
         <p:nvSpPr>
-          <p:cNvPr id="87" name="Text 85"/>
+          <p:cNvPr id="89" name="Text 87"/>
           <p:cNvSpPr/>
           <p:nvPr/>
         </p:nvSpPr>
@@ -4840,7 +4904,7 @@
       </p:sp>
       <p:sp>
         <p:nvSpPr>
-          <p:cNvPr id="88" name="Shape 86"/>
+          <p:cNvPr id="90" name="Shape 88"/>
           <p:cNvSpPr/>
           <p:nvPr/>
         </p:nvSpPr>
@@ -4865,7 +4929,7 @@
       </p:sp>
       <p:sp>
         <p:nvSpPr>
-          <p:cNvPr id="89" name="Text 87"/>
+          <p:cNvPr id="91" name="Text 89"/>
           <p:cNvSpPr/>
           <p:nvPr/>
         </p:nvSpPr>
@@ -4904,7 +4968,7 @@
       </p:sp>
       <p:sp>
         <p:nvSpPr>
-          <p:cNvPr id="90" name="Shape 88"/>
+          <p:cNvPr id="92" name="Shape 90"/>
           <p:cNvSpPr/>
           <p:nvPr/>
         </p:nvSpPr>
@@ -4929,7 +4993,7 @@
       </p:sp>
       <p:sp>
         <p:nvSpPr>
-          <p:cNvPr id="91" name="Text 89"/>
+          <p:cNvPr id="93" name="Text 91"/>
           <p:cNvSpPr/>
           <p:nvPr/>
         </p:nvSpPr>

</xml_diff>

<commit_message>
Team slide: add pillar tags to L3 cards + Pillar Ownership row below org chart
Co-Authored-By: Claude Sonnet 4.6 <noreply@anthropic.com>
</commit_message>
<xml_diff>
--- a/jhbi-roadmap-2026.pptx
+++ b/jhbi-roadmap-2026.pptx
@@ -3427,7 +3427,7 @@
         <p:spPr>
           <a:xfrm>
             <a:off x="146304" y="2157984"/>
-            <a:ext cx="2804160" cy="457200"/>
+            <a:ext cx="2804160" cy="566928"/>
           </a:xfrm>
           <a:prstGeom prst="rect">
             <a:avLst/>
@@ -3454,7 +3454,7 @@
         <p:spPr>
           <a:xfrm>
             <a:off x="146304" y="2157984"/>
-            <a:ext cx="50292" cy="457200"/>
+            <a:ext cx="50292" cy="566928"/>
           </a:xfrm>
           <a:prstGeom prst="rect">
             <a:avLst/>
@@ -3624,8 +3624,74 @@
         </p:nvSpPr>
         <p:spPr>
           <a:xfrm>
-            <a:off x="146304" y="2670048"/>
-            <a:ext cx="2804160" cy="457200"/>
+            <a:off x="237744" y="2596896"/>
+            <a:ext cx="541325" cy="100584"/>
+          </a:xfrm>
+          <a:prstGeom prst="rect">
+            <a:avLst/>
+          </a:prstGeom>
+          <a:solidFill>
+            <a:srgbClr val="06185F">
+              <a:alpha val="30000"/>
+            </a:srgbClr>
+          </a:solidFill>
+          <a:ln w="6350">
+            <a:solidFill>
+              <a:srgbClr val="06185F"/>
+            </a:solidFill>
+            <a:prstDash val="solid"/>
+          </a:ln>
+        </p:spPr>
+      </p:sp>
+      <p:sp>
+        <p:nvSpPr>
+          <p:cNvPr id="51" name="Text 49"/>
+          <p:cNvSpPr/>
+          <p:nvPr/>
+        </p:nvSpPr>
+        <p:spPr>
+          <a:xfrm>
+            <a:off x="237744" y="2596896"/>
+            <a:ext cx="541325" cy="100584"/>
+          </a:xfrm>
+          <a:prstGeom prst="rect">
+            <a:avLst/>
+          </a:prstGeom>
+          <a:noFill/>
+          <a:ln/>
+        </p:spPr>
+        <p:txBody>
+          <a:bodyPr wrap="square" lIns="0" tIns="0" rIns="0" bIns="0" rtlCol="0" anchor="ctr"/>
+          <a:lstStyle/>
+          <a:p>
+            <a:pPr algn="ctr" indent="0" marL="0">
+              <a:buNone/>
+            </a:pPr>
+            <a:r>
+              <a:rPr lang="en-US" sz="550" b="1" dirty="0">
+                <a:solidFill>
+                  <a:srgbClr val="06185F"/>
+                </a:solidFill>
+                <a:latin typeface="Calibri" pitchFamily="34" charset="0"/>
+                <a:ea typeface="Calibri" pitchFamily="34" charset="-122"/>
+                <a:cs typeface="Calibri" pitchFamily="34" charset="-120"/>
+              </a:rPr>
+              <a:t>Data Acq.</a:t>
+            </a:r>
+            <a:endParaRPr lang="en-US" sz="550" dirty="0"/>
+          </a:p>
+        </p:txBody>
+      </p:sp>
+      <p:sp>
+        <p:nvSpPr>
+          <p:cNvPr id="52" name="Shape 50"/>
+          <p:cNvSpPr/>
+          <p:nvPr/>
+        </p:nvSpPr>
+        <p:spPr>
+          <a:xfrm>
+            <a:off x="146304" y="2779776"/>
+            <a:ext cx="2804160" cy="566928"/>
           </a:xfrm>
           <a:prstGeom prst="rect">
             <a:avLst/>
@@ -3645,14 +3711,14 @@
       </p:sp>
       <p:sp>
         <p:nvSpPr>
-          <p:cNvPr id="51" name="Shape 49"/>
-          <p:cNvSpPr/>
-          <p:nvPr/>
-        </p:nvSpPr>
-        <p:spPr>
-          <a:xfrm>
-            <a:off x="146304" y="2670048"/>
-            <a:ext cx="50292" cy="457200"/>
+          <p:cNvPr id="53" name="Shape 51"/>
+          <p:cNvSpPr/>
+          <p:nvPr/>
+        </p:nvSpPr>
+        <p:spPr>
+          <a:xfrm>
+            <a:off x="146304" y="2779776"/>
+            <a:ext cx="50292" cy="566928"/>
           </a:xfrm>
           <a:prstGeom prst="rect">
             <a:avLst/>
@@ -3674,13 +3740,13 @@
       </p:sp>
       <p:sp>
         <p:nvSpPr>
-          <p:cNvPr id="52" name="Text 50"/>
-          <p:cNvSpPr/>
-          <p:nvPr/>
-        </p:nvSpPr>
-        <p:spPr>
-          <a:xfrm>
-            <a:off x="237744" y="2706624"/>
+          <p:cNvPr id="54" name="Text 52"/>
+          <p:cNvSpPr/>
+          <p:nvPr/>
+        </p:nvSpPr>
+        <p:spPr>
+          <a:xfrm>
+            <a:off x="237744" y="2816352"/>
             <a:ext cx="2328672" cy="201168"/>
           </a:xfrm>
           <a:prstGeom prst="rect">
@@ -3713,13 +3779,13 @@
       </p:sp>
       <p:sp>
         <p:nvSpPr>
-          <p:cNvPr id="53" name="Shape 51"/>
-          <p:cNvSpPr/>
-          <p:nvPr/>
-        </p:nvSpPr>
-        <p:spPr>
-          <a:xfrm>
-            <a:off x="2548128" y="2724912"/>
+          <p:cNvPr id="55" name="Shape 53"/>
+          <p:cNvSpPr/>
+          <p:nvPr/>
+        </p:nvSpPr>
+        <p:spPr>
+          <a:xfrm>
+            <a:off x="2548128" y="2834640"/>
             <a:ext cx="347472" cy="182880"/>
           </a:xfrm>
           <a:prstGeom prst="rect">
@@ -3738,13 +3804,13 @@
       </p:sp>
       <p:sp>
         <p:nvSpPr>
-          <p:cNvPr id="54" name="Text 52"/>
-          <p:cNvSpPr/>
-          <p:nvPr/>
-        </p:nvSpPr>
-        <p:spPr>
-          <a:xfrm>
-            <a:off x="2548128" y="2724912"/>
+          <p:cNvPr id="56" name="Text 54"/>
+          <p:cNvSpPr/>
+          <p:nvPr/>
+        </p:nvSpPr>
+        <p:spPr>
+          <a:xfrm>
+            <a:off x="2548128" y="2834640"/>
             <a:ext cx="347472" cy="182880"/>
           </a:xfrm>
           <a:prstGeom prst="rect">
@@ -3777,13 +3843,13 @@
       </p:sp>
       <p:sp>
         <p:nvSpPr>
-          <p:cNvPr id="55" name="Text 53"/>
-          <p:cNvSpPr/>
-          <p:nvPr/>
-        </p:nvSpPr>
-        <p:spPr>
-          <a:xfrm>
-            <a:off x="237744" y="2907792"/>
+          <p:cNvPr id="57" name="Text 55"/>
+          <p:cNvSpPr/>
+          <p:nvPr/>
+        </p:nvSpPr>
+        <p:spPr>
+          <a:xfrm>
+            <a:off x="237744" y="3017520"/>
             <a:ext cx="2657856" cy="164592"/>
           </a:xfrm>
           <a:prstGeom prst="rect">
@@ -3816,14 +3882,80 @@
       </p:sp>
       <p:sp>
         <p:nvSpPr>
-          <p:cNvPr id="56" name="Shape 54"/>
-          <p:cNvSpPr/>
-          <p:nvPr/>
-        </p:nvSpPr>
-        <p:spPr>
-          <a:xfrm>
-            <a:off x="146304" y="3182112"/>
-            <a:ext cx="2804160" cy="457200"/>
+          <p:cNvPr id="58" name="Shape 56"/>
+          <p:cNvSpPr/>
+          <p:nvPr/>
+        </p:nvSpPr>
+        <p:spPr>
+          <a:xfrm>
+            <a:off x="237744" y="3218688"/>
+            <a:ext cx="541325" cy="100584"/>
+          </a:xfrm>
+          <a:prstGeom prst="rect">
+            <a:avLst/>
+          </a:prstGeom>
+          <a:solidFill>
+            <a:srgbClr val="085CE5">
+              <a:alpha val="30000"/>
+            </a:srgbClr>
+          </a:solidFill>
+          <a:ln w="6350">
+            <a:solidFill>
+              <a:srgbClr val="085CE5"/>
+            </a:solidFill>
+            <a:prstDash val="solid"/>
+          </a:ln>
+        </p:spPr>
+      </p:sp>
+      <p:sp>
+        <p:nvSpPr>
+          <p:cNvPr id="59" name="Text 57"/>
+          <p:cNvSpPr/>
+          <p:nvPr/>
+        </p:nvSpPr>
+        <p:spPr>
+          <a:xfrm>
+            <a:off x="237744" y="3218688"/>
+            <a:ext cx="541325" cy="100584"/>
+          </a:xfrm>
+          <a:prstGeom prst="rect">
+            <a:avLst/>
+          </a:prstGeom>
+          <a:noFill/>
+          <a:ln/>
+        </p:spPr>
+        <p:txBody>
+          <a:bodyPr wrap="square" lIns="0" tIns="0" rIns="0" bIns="0" rtlCol="0" anchor="ctr"/>
+          <a:lstStyle/>
+          <a:p>
+            <a:pPr algn="ctr" indent="0" marL="0">
+              <a:buNone/>
+            </a:pPr>
+            <a:r>
+              <a:rPr lang="en-US" sz="550" b="1" dirty="0">
+                <a:solidFill>
+                  <a:srgbClr val="085CE5"/>
+                </a:solidFill>
+                <a:latin typeface="Calibri" pitchFamily="34" charset="0"/>
+                <a:ea typeface="Calibri" pitchFamily="34" charset="-122"/>
+                <a:cs typeface="Calibri" pitchFamily="34" charset="-120"/>
+              </a:rPr>
+              <a:t>Reporting</a:t>
+            </a:r>
+            <a:endParaRPr lang="en-US" sz="550" dirty="0"/>
+          </a:p>
+        </p:txBody>
+      </p:sp>
+      <p:sp>
+        <p:nvSpPr>
+          <p:cNvPr id="60" name="Shape 58"/>
+          <p:cNvSpPr/>
+          <p:nvPr/>
+        </p:nvSpPr>
+        <p:spPr>
+          <a:xfrm>
+            <a:off x="146304" y="3401568"/>
+            <a:ext cx="2804160" cy="566928"/>
           </a:xfrm>
           <a:prstGeom prst="rect">
             <a:avLst/>
@@ -3843,14 +3975,14 @@
       </p:sp>
       <p:sp>
         <p:nvSpPr>
-          <p:cNvPr id="57" name="Shape 55"/>
-          <p:cNvSpPr/>
-          <p:nvPr/>
-        </p:nvSpPr>
-        <p:spPr>
-          <a:xfrm>
-            <a:off x="146304" y="3182112"/>
-            <a:ext cx="50292" cy="457200"/>
+          <p:cNvPr id="61" name="Shape 59"/>
+          <p:cNvSpPr/>
+          <p:nvPr/>
+        </p:nvSpPr>
+        <p:spPr>
+          <a:xfrm>
+            <a:off x="146304" y="3401568"/>
+            <a:ext cx="50292" cy="566928"/>
           </a:xfrm>
           <a:prstGeom prst="rect">
             <a:avLst/>
@@ -3872,13 +4004,13 @@
       </p:sp>
       <p:sp>
         <p:nvSpPr>
-          <p:cNvPr id="58" name="Text 56"/>
-          <p:cNvSpPr/>
-          <p:nvPr/>
-        </p:nvSpPr>
-        <p:spPr>
-          <a:xfrm>
-            <a:off x="237744" y="3218688"/>
+          <p:cNvPr id="62" name="Text 60"/>
+          <p:cNvSpPr/>
+          <p:nvPr/>
+        </p:nvSpPr>
+        <p:spPr>
+          <a:xfrm>
+            <a:off x="237744" y="3438144"/>
             <a:ext cx="2328672" cy="201168"/>
           </a:xfrm>
           <a:prstGeom prst="rect">
@@ -3911,13 +4043,13 @@
       </p:sp>
       <p:sp>
         <p:nvSpPr>
-          <p:cNvPr id="59" name="Shape 57"/>
-          <p:cNvSpPr/>
-          <p:nvPr/>
-        </p:nvSpPr>
-        <p:spPr>
-          <a:xfrm>
-            <a:off x="2548128" y="3236976"/>
+          <p:cNvPr id="63" name="Shape 61"/>
+          <p:cNvSpPr/>
+          <p:nvPr/>
+        </p:nvSpPr>
+        <p:spPr>
+          <a:xfrm>
+            <a:off x="2548128" y="3456432"/>
             <a:ext cx="347472" cy="182880"/>
           </a:xfrm>
           <a:prstGeom prst="rect">
@@ -3936,13 +4068,13 @@
       </p:sp>
       <p:sp>
         <p:nvSpPr>
-          <p:cNvPr id="60" name="Text 58"/>
-          <p:cNvSpPr/>
-          <p:nvPr/>
-        </p:nvSpPr>
-        <p:spPr>
-          <a:xfrm>
-            <a:off x="2548128" y="3236976"/>
+          <p:cNvPr id="64" name="Text 62"/>
+          <p:cNvSpPr/>
+          <p:nvPr/>
+        </p:nvSpPr>
+        <p:spPr>
+          <a:xfrm>
+            <a:off x="2548128" y="3456432"/>
             <a:ext cx="347472" cy="182880"/>
           </a:xfrm>
           <a:prstGeom prst="rect">
@@ -3975,13 +4107,13 @@
       </p:sp>
       <p:sp>
         <p:nvSpPr>
-          <p:cNvPr id="61" name="Text 59"/>
-          <p:cNvSpPr/>
-          <p:nvPr/>
-        </p:nvSpPr>
-        <p:spPr>
-          <a:xfrm>
-            <a:off x="237744" y="3419856"/>
+          <p:cNvPr id="65" name="Text 63"/>
+          <p:cNvSpPr/>
+          <p:nvPr/>
+        </p:nvSpPr>
+        <p:spPr>
+          <a:xfrm>
+            <a:off x="237744" y="3639312"/>
             <a:ext cx="2657856" cy="164592"/>
           </a:xfrm>
           <a:prstGeom prst="rect">
@@ -4014,7 +4146,73 @@
       </p:sp>
       <p:sp>
         <p:nvSpPr>
-          <p:cNvPr id="62" name="Shape 60"/>
+          <p:cNvPr id="66" name="Shape 64"/>
+          <p:cNvSpPr/>
+          <p:nvPr/>
+        </p:nvSpPr>
+        <p:spPr>
+          <a:xfrm>
+            <a:off x="237744" y="3840480"/>
+            <a:ext cx="409651" cy="100584"/>
+          </a:xfrm>
+          <a:prstGeom prst="rect">
+            <a:avLst/>
+          </a:prstGeom>
+          <a:solidFill>
+            <a:srgbClr val="0A5CA8">
+              <a:alpha val="30000"/>
+            </a:srgbClr>
+          </a:solidFill>
+          <a:ln w="6350">
+            <a:solidFill>
+              <a:srgbClr val="0A5CA8"/>
+            </a:solidFill>
+            <a:prstDash val="solid"/>
+          </a:ln>
+        </p:spPr>
+      </p:sp>
+      <p:sp>
+        <p:nvSpPr>
+          <p:cNvPr id="67" name="Text 65"/>
+          <p:cNvSpPr/>
+          <p:nvPr/>
+        </p:nvSpPr>
+        <p:spPr>
+          <a:xfrm>
+            <a:off x="237744" y="3840480"/>
+            <a:ext cx="409651" cy="100584"/>
+          </a:xfrm>
+          <a:prstGeom prst="rect">
+            <a:avLst/>
+          </a:prstGeom>
+          <a:noFill/>
+          <a:ln/>
+        </p:spPr>
+        <p:txBody>
+          <a:bodyPr wrap="square" lIns="0" tIns="0" rIns="0" bIns="0" rtlCol="0" anchor="ctr"/>
+          <a:lstStyle/>
+          <a:p>
+            <a:pPr algn="ctr" indent="0" marL="0">
+              <a:buNone/>
+            </a:pPr>
+            <a:r>
+              <a:rPr lang="en-US" sz="550" b="1" dirty="0">
+                <a:solidFill>
+                  <a:srgbClr val="0A5CA8"/>
+                </a:solidFill>
+                <a:latin typeface="Calibri" pitchFamily="34" charset="0"/>
+                <a:ea typeface="Calibri" pitchFamily="34" charset="-122"/>
+                <a:cs typeface="Calibri" pitchFamily="34" charset="-120"/>
+              </a:rPr>
+              <a:t>Portal</a:t>
+            </a:r>
+            <a:endParaRPr lang="en-US" sz="550" dirty="0"/>
+          </a:p>
+        </p:txBody>
+      </p:sp>
+      <p:sp>
+        <p:nvSpPr>
+          <p:cNvPr id="68" name="Shape 66"/>
           <p:cNvSpPr/>
           <p:nvPr/>
         </p:nvSpPr>
@@ -4037,14 +4235,14 @@
       </p:sp>
       <p:sp>
         <p:nvSpPr>
-          <p:cNvPr id="63" name="Shape 61"/>
+          <p:cNvPr id="69" name="Shape 67"/>
           <p:cNvSpPr/>
           <p:nvPr/>
         </p:nvSpPr>
         <p:spPr>
           <a:xfrm>
             <a:off x="3169920" y="2157984"/>
-            <a:ext cx="2804160" cy="457200"/>
+            <a:ext cx="2804160" cy="566928"/>
           </a:xfrm>
           <a:prstGeom prst="rect">
             <a:avLst/>
@@ -4062,14 +4260,14 @@
       </p:sp>
       <p:sp>
         <p:nvSpPr>
-          <p:cNvPr id="64" name="Shape 62"/>
+          <p:cNvPr id="70" name="Shape 68"/>
           <p:cNvSpPr/>
           <p:nvPr/>
         </p:nvSpPr>
         <p:spPr>
           <a:xfrm>
             <a:off x="3169920" y="2157984"/>
-            <a:ext cx="50292" cy="457200"/>
+            <a:ext cx="50292" cy="566928"/>
           </a:xfrm>
           <a:prstGeom prst="rect">
             <a:avLst/>
@@ -4087,7 +4285,7 @@
       </p:sp>
       <p:sp>
         <p:nvSpPr>
-          <p:cNvPr id="65" name="Text 63"/>
+          <p:cNvPr id="71" name="Text 69"/>
           <p:cNvSpPr/>
           <p:nvPr/>
         </p:nvSpPr>
@@ -4126,7 +4324,7 @@
       </p:sp>
       <p:sp>
         <p:nvSpPr>
-          <p:cNvPr id="66" name="Text 64"/>
+          <p:cNvPr id="72" name="Text 70"/>
           <p:cNvSpPr/>
           <p:nvPr/>
         </p:nvSpPr>
@@ -4165,14 +4363,80 @@
       </p:sp>
       <p:sp>
         <p:nvSpPr>
-          <p:cNvPr id="67" name="Shape 65"/>
-          <p:cNvSpPr/>
-          <p:nvPr/>
-        </p:nvSpPr>
-        <p:spPr>
-          <a:xfrm>
-            <a:off x="3169920" y="2670048"/>
-            <a:ext cx="2804160" cy="457200"/>
+          <p:cNvPr id="73" name="Shape 71"/>
+          <p:cNvSpPr/>
+          <p:nvPr/>
+        </p:nvSpPr>
+        <p:spPr>
+          <a:xfrm>
+            <a:off x="3261360" y="2596896"/>
+            <a:ext cx="541325" cy="100584"/>
+          </a:xfrm>
+          <a:prstGeom prst="rect">
+            <a:avLst/>
+          </a:prstGeom>
+          <a:solidFill>
+            <a:srgbClr val="085CE5">
+              <a:alpha val="30000"/>
+            </a:srgbClr>
+          </a:solidFill>
+          <a:ln w="6350">
+            <a:solidFill>
+              <a:srgbClr val="085CE5"/>
+            </a:solidFill>
+            <a:prstDash val="solid"/>
+          </a:ln>
+        </p:spPr>
+      </p:sp>
+      <p:sp>
+        <p:nvSpPr>
+          <p:cNvPr id="74" name="Text 72"/>
+          <p:cNvSpPr/>
+          <p:nvPr/>
+        </p:nvSpPr>
+        <p:spPr>
+          <a:xfrm>
+            <a:off x="3261360" y="2596896"/>
+            <a:ext cx="541325" cy="100584"/>
+          </a:xfrm>
+          <a:prstGeom prst="rect">
+            <a:avLst/>
+          </a:prstGeom>
+          <a:noFill/>
+          <a:ln/>
+        </p:spPr>
+        <p:txBody>
+          <a:bodyPr wrap="square" lIns="0" tIns="0" rIns="0" bIns="0" rtlCol="0" anchor="ctr"/>
+          <a:lstStyle/>
+          <a:p>
+            <a:pPr algn="ctr" indent="0" marL="0">
+              <a:buNone/>
+            </a:pPr>
+            <a:r>
+              <a:rPr lang="en-US" sz="550" b="1" dirty="0">
+                <a:solidFill>
+                  <a:srgbClr val="085CE5"/>
+                </a:solidFill>
+                <a:latin typeface="Calibri" pitchFamily="34" charset="0"/>
+                <a:ea typeface="Calibri" pitchFamily="34" charset="-122"/>
+                <a:cs typeface="Calibri" pitchFamily="34" charset="-120"/>
+              </a:rPr>
+              <a:t>Reporting</a:t>
+            </a:r>
+            <a:endParaRPr lang="en-US" sz="550" dirty="0"/>
+          </a:p>
+        </p:txBody>
+      </p:sp>
+      <p:sp>
+        <p:nvSpPr>
+          <p:cNvPr id="75" name="Shape 73"/>
+          <p:cNvSpPr/>
+          <p:nvPr/>
+        </p:nvSpPr>
+        <p:spPr>
+          <a:xfrm>
+            <a:off x="3169920" y="2779776"/>
+            <a:ext cx="2804160" cy="566928"/>
           </a:xfrm>
           <a:prstGeom prst="rect">
             <a:avLst/>
@@ -4190,14 +4454,14 @@
       </p:sp>
       <p:sp>
         <p:nvSpPr>
-          <p:cNvPr id="68" name="Shape 66"/>
-          <p:cNvSpPr/>
-          <p:nvPr/>
-        </p:nvSpPr>
-        <p:spPr>
-          <a:xfrm>
-            <a:off x="3169920" y="2670048"/>
-            <a:ext cx="50292" cy="457200"/>
+          <p:cNvPr id="76" name="Shape 74"/>
+          <p:cNvSpPr/>
+          <p:nvPr/>
+        </p:nvSpPr>
+        <p:spPr>
+          <a:xfrm>
+            <a:off x="3169920" y="2779776"/>
+            <a:ext cx="50292" cy="566928"/>
           </a:xfrm>
           <a:prstGeom prst="rect">
             <a:avLst/>
@@ -4215,13 +4479,13 @@
       </p:sp>
       <p:sp>
         <p:nvSpPr>
-          <p:cNvPr id="69" name="Text 67"/>
-          <p:cNvSpPr/>
-          <p:nvPr/>
-        </p:nvSpPr>
-        <p:spPr>
-          <a:xfrm>
-            <a:off x="3261360" y="2706624"/>
+          <p:cNvPr id="77" name="Text 75"/>
+          <p:cNvSpPr/>
+          <p:nvPr/>
+        </p:nvSpPr>
+        <p:spPr>
+          <a:xfrm>
+            <a:off x="3261360" y="2816352"/>
             <a:ext cx="2657856" cy="201168"/>
           </a:xfrm>
           <a:prstGeom prst="rect">
@@ -4254,13 +4518,13 @@
       </p:sp>
       <p:sp>
         <p:nvSpPr>
-          <p:cNvPr id="70" name="Text 68"/>
-          <p:cNvSpPr/>
-          <p:nvPr/>
-        </p:nvSpPr>
-        <p:spPr>
-          <a:xfrm>
-            <a:off x="3261360" y="2907792"/>
+          <p:cNvPr id="78" name="Text 76"/>
+          <p:cNvSpPr/>
+          <p:nvPr/>
+        </p:nvSpPr>
+        <p:spPr>
+          <a:xfrm>
+            <a:off x="3261360" y="3017520"/>
             <a:ext cx="2657856" cy="182880"/>
           </a:xfrm>
           <a:prstGeom prst="rect">
@@ -4293,14 +4557,80 @@
       </p:sp>
       <p:sp>
         <p:nvSpPr>
-          <p:cNvPr id="71" name="Shape 69"/>
-          <p:cNvSpPr/>
-          <p:nvPr/>
-        </p:nvSpPr>
-        <p:spPr>
-          <a:xfrm>
-            <a:off x="3169920" y="3182112"/>
-            <a:ext cx="2804160" cy="457200"/>
+          <p:cNvPr id="79" name="Shape 77"/>
+          <p:cNvSpPr/>
+          <p:nvPr/>
+        </p:nvSpPr>
+        <p:spPr>
+          <a:xfrm>
+            <a:off x="3261360" y="3218688"/>
+            <a:ext cx="409651" cy="100584"/>
+          </a:xfrm>
+          <a:prstGeom prst="rect">
+            <a:avLst/>
+          </a:prstGeom>
+          <a:solidFill>
+            <a:srgbClr val="0A5CA8">
+              <a:alpha val="30000"/>
+            </a:srgbClr>
+          </a:solidFill>
+          <a:ln w="6350">
+            <a:solidFill>
+              <a:srgbClr val="0A5CA8"/>
+            </a:solidFill>
+            <a:prstDash val="solid"/>
+          </a:ln>
+        </p:spPr>
+      </p:sp>
+      <p:sp>
+        <p:nvSpPr>
+          <p:cNvPr id="80" name="Text 78"/>
+          <p:cNvSpPr/>
+          <p:nvPr/>
+        </p:nvSpPr>
+        <p:spPr>
+          <a:xfrm>
+            <a:off x="3261360" y="3218688"/>
+            <a:ext cx="409651" cy="100584"/>
+          </a:xfrm>
+          <a:prstGeom prst="rect">
+            <a:avLst/>
+          </a:prstGeom>
+          <a:noFill/>
+          <a:ln/>
+        </p:spPr>
+        <p:txBody>
+          <a:bodyPr wrap="square" lIns="0" tIns="0" rIns="0" bIns="0" rtlCol="0" anchor="ctr"/>
+          <a:lstStyle/>
+          <a:p>
+            <a:pPr algn="ctr" indent="0" marL="0">
+              <a:buNone/>
+            </a:pPr>
+            <a:r>
+              <a:rPr lang="en-US" sz="550" b="1" dirty="0">
+                <a:solidFill>
+                  <a:srgbClr val="0A5CA8"/>
+                </a:solidFill>
+                <a:latin typeface="Calibri" pitchFamily="34" charset="0"/>
+                <a:ea typeface="Calibri" pitchFamily="34" charset="-122"/>
+                <a:cs typeface="Calibri" pitchFamily="34" charset="-120"/>
+              </a:rPr>
+              <a:t>Portal</a:t>
+            </a:r>
+            <a:endParaRPr lang="en-US" sz="550" dirty="0"/>
+          </a:p>
+        </p:txBody>
+      </p:sp>
+      <p:sp>
+        <p:nvSpPr>
+          <p:cNvPr id="81" name="Shape 79"/>
+          <p:cNvSpPr/>
+          <p:nvPr/>
+        </p:nvSpPr>
+        <p:spPr>
+          <a:xfrm>
+            <a:off x="3169920" y="3401568"/>
+            <a:ext cx="2804160" cy="566928"/>
           </a:xfrm>
           <a:prstGeom prst="rect">
             <a:avLst/>
@@ -4318,14 +4648,14 @@
       </p:sp>
       <p:sp>
         <p:nvSpPr>
-          <p:cNvPr id="72" name="Shape 70"/>
-          <p:cNvSpPr/>
-          <p:nvPr/>
-        </p:nvSpPr>
-        <p:spPr>
-          <a:xfrm>
-            <a:off x="3169920" y="3182112"/>
-            <a:ext cx="50292" cy="457200"/>
+          <p:cNvPr id="82" name="Shape 80"/>
+          <p:cNvSpPr/>
+          <p:nvPr/>
+        </p:nvSpPr>
+        <p:spPr>
+          <a:xfrm>
+            <a:off x="3169920" y="3401568"/>
+            <a:ext cx="50292" cy="566928"/>
           </a:xfrm>
           <a:prstGeom prst="rect">
             <a:avLst/>
@@ -4343,13 +4673,13 @@
       </p:sp>
       <p:sp>
         <p:nvSpPr>
-          <p:cNvPr id="73" name="Text 71"/>
-          <p:cNvSpPr/>
-          <p:nvPr/>
-        </p:nvSpPr>
-        <p:spPr>
-          <a:xfrm>
-            <a:off x="3261360" y="3218688"/>
+          <p:cNvPr id="83" name="Text 81"/>
+          <p:cNvSpPr/>
+          <p:nvPr/>
+        </p:nvSpPr>
+        <p:spPr>
+          <a:xfrm>
+            <a:off x="3261360" y="3438144"/>
             <a:ext cx="2657856" cy="201168"/>
           </a:xfrm>
           <a:prstGeom prst="rect">
@@ -4382,13 +4712,13 @@
       </p:sp>
       <p:sp>
         <p:nvSpPr>
-          <p:cNvPr id="74" name="Text 72"/>
-          <p:cNvSpPr/>
-          <p:nvPr/>
-        </p:nvSpPr>
-        <p:spPr>
-          <a:xfrm>
-            <a:off x="3261360" y="3419856"/>
+          <p:cNvPr id="84" name="Text 82"/>
+          <p:cNvSpPr/>
+          <p:nvPr/>
+        </p:nvSpPr>
+        <p:spPr>
+          <a:xfrm>
+            <a:off x="3261360" y="3639312"/>
             <a:ext cx="2657856" cy="182880"/>
           </a:xfrm>
           <a:prstGeom prst="rect">
@@ -4421,7 +4751,73 @@
       </p:sp>
       <p:sp>
         <p:nvSpPr>
-          <p:cNvPr id="75" name="Shape 73"/>
+          <p:cNvPr id="85" name="Shape 83"/>
+          <p:cNvSpPr/>
+          <p:nvPr/>
+        </p:nvSpPr>
+        <p:spPr>
+          <a:xfrm>
+            <a:off x="3261360" y="3840480"/>
+            <a:ext cx="541325" cy="100584"/>
+          </a:xfrm>
+          <a:prstGeom prst="rect">
+            <a:avLst/>
+          </a:prstGeom>
+          <a:solidFill>
+            <a:srgbClr val="06185F">
+              <a:alpha val="30000"/>
+            </a:srgbClr>
+          </a:solidFill>
+          <a:ln w="6350">
+            <a:solidFill>
+              <a:srgbClr val="06185F"/>
+            </a:solidFill>
+            <a:prstDash val="solid"/>
+          </a:ln>
+        </p:spPr>
+      </p:sp>
+      <p:sp>
+        <p:nvSpPr>
+          <p:cNvPr id="86" name="Text 84"/>
+          <p:cNvSpPr/>
+          <p:nvPr/>
+        </p:nvSpPr>
+        <p:spPr>
+          <a:xfrm>
+            <a:off x="3261360" y="3840480"/>
+            <a:ext cx="541325" cy="100584"/>
+          </a:xfrm>
+          <a:prstGeom prst="rect">
+            <a:avLst/>
+          </a:prstGeom>
+          <a:noFill/>
+          <a:ln/>
+        </p:spPr>
+        <p:txBody>
+          <a:bodyPr wrap="square" lIns="0" tIns="0" rIns="0" bIns="0" rtlCol="0" anchor="ctr"/>
+          <a:lstStyle/>
+          <a:p>
+            <a:pPr algn="ctr" indent="0" marL="0">
+              <a:buNone/>
+            </a:pPr>
+            <a:r>
+              <a:rPr lang="en-US" sz="550" b="1" dirty="0">
+                <a:solidFill>
+                  <a:srgbClr val="06185F"/>
+                </a:solidFill>
+                <a:latin typeface="Calibri" pitchFamily="34" charset="0"/>
+                <a:ea typeface="Calibri" pitchFamily="34" charset="-122"/>
+                <a:cs typeface="Calibri" pitchFamily="34" charset="-120"/>
+              </a:rPr>
+              <a:t>Data Acq.</a:t>
+            </a:r>
+            <a:endParaRPr lang="en-US" sz="550" dirty="0"/>
+          </a:p>
+        </p:txBody>
+      </p:sp>
+      <p:sp>
+        <p:nvSpPr>
+          <p:cNvPr id="87" name="Shape 85"/>
           <p:cNvSpPr/>
           <p:nvPr/>
         </p:nvSpPr>
@@ -4444,14 +4840,14 @@
       </p:sp>
       <p:sp>
         <p:nvSpPr>
-          <p:cNvPr id="76" name="Shape 74"/>
+          <p:cNvPr id="88" name="Shape 86"/>
           <p:cNvSpPr/>
           <p:nvPr/>
         </p:nvSpPr>
         <p:spPr>
           <a:xfrm>
             <a:off x="6193536" y="2157984"/>
-            <a:ext cx="2804160" cy="457200"/>
+            <a:ext cx="2804160" cy="566928"/>
           </a:xfrm>
           <a:prstGeom prst="rect">
             <a:avLst/>
@@ -4471,14 +4867,14 @@
       </p:sp>
       <p:sp>
         <p:nvSpPr>
-          <p:cNvPr id="77" name="Shape 75"/>
+          <p:cNvPr id="89" name="Shape 87"/>
           <p:cNvSpPr/>
           <p:nvPr/>
         </p:nvSpPr>
         <p:spPr>
           <a:xfrm>
             <a:off x="6193536" y="2157984"/>
-            <a:ext cx="50292" cy="457200"/>
+            <a:ext cx="50292" cy="566928"/>
           </a:xfrm>
           <a:prstGeom prst="rect">
             <a:avLst/>
@@ -4500,7 +4896,7 @@
       </p:sp>
       <p:sp>
         <p:nvSpPr>
-          <p:cNvPr id="78" name="Text 76"/>
+          <p:cNvPr id="90" name="Text 88"/>
           <p:cNvSpPr/>
           <p:nvPr/>
         </p:nvSpPr>
@@ -4539,7 +4935,7 @@
       </p:sp>
       <p:sp>
         <p:nvSpPr>
-          <p:cNvPr id="79" name="Shape 77"/>
+          <p:cNvPr id="91" name="Shape 89"/>
           <p:cNvSpPr/>
           <p:nvPr/>
         </p:nvSpPr>
@@ -4564,7 +4960,7 @@
       </p:sp>
       <p:sp>
         <p:nvSpPr>
-          <p:cNvPr id="80" name="Text 78"/>
+          <p:cNvPr id="92" name="Text 90"/>
           <p:cNvSpPr/>
           <p:nvPr/>
         </p:nvSpPr>
@@ -4603,7 +4999,7 @@
       </p:sp>
       <p:sp>
         <p:nvSpPr>
-          <p:cNvPr id="81" name="Text 79"/>
+          <p:cNvPr id="93" name="Text 91"/>
           <p:cNvSpPr/>
           <p:nvPr/>
         </p:nvSpPr>
@@ -4642,14 +5038,80 @@
       </p:sp>
       <p:sp>
         <p:nvSpPr>
-          <p:cNvPr id="82" name="Shape 80"/>
-          <p:cNvSpPr/>
-          <p:nvPr/>
-        </p:nvSpPr>
-        <p:spPr>
-          <a:xfrm>
-            <a:off x="6193536" y="2670048"/>
-            <a:ext cx="2804160" cy="457200"/>
+          <p:cNvPr id="94" name="Shape 92"/>
+          <p:cNvSpPr/>
+          <p:nvPr/>
+        </p:nvSpPr>
+        <p:spPr>
+          <a:xfrm>
+            <a:off x="6284976" y="2596896"/>
+            <a:ext cx="672998" cy="100584"/>
+          </a:xfrm>
+          <a:prstGeom prst="rect">
+            <a:avLst/>
+          </a:prstGeom>
+          <a:solidFill>
+            <a:srgbClr val="0A5C47">
+              <a:alpha val="30000"/>
+            </a:srgbClr>
+          </a:solidFill>
+          <a:ln w="6350">
+            <a:solidFill>
+              <a:srgbClr val="0A5C47"/>
+            </a:solidFill>
+            <a:prstDash val="solid"/>
+          </a:ln>
+        </p:spPr>
+      </p:sp>
+      <p:sp>
+        <p:nvSpPr>
+          <p:cNvPr id="95" name="Text 93"/>
+          <p:cNvSpPr/>
+          <p:nvPr/>
+        </p:nvSpPr>
+        <p:spPr>
+          <a:xfrm>
+            <a:off x="6284976" y="2596896"/>
+            <a:ext cx="672998" cy="100584"/>
+          </a:xfrm>
+          <a:prstGeom prst="rect">
+            <a:avLst/>
+          </a:prstGeom>
+          <a:noFill/>
+          <a:ln/>
+        </p:spPr>
+        <p:txBody>
+          <a:bodyPr wrap="square" lIns="0" tIns="0" rIns="0" bIns="0" rtlCol="0" anchor="ctr"/>
+          <a:lstStyle/>
+          <a:p>
+            <a:pPr algn="ctr" indent="0" marL="0">
+              <a:buNone/>
+            </a:pPr>
+            <a:r>
+              <a:rPr lang="en-US" sz="550" b="1" dirty="0">
+                <a:solidFill>
+                  <a:srgbClr val="0A5C47"/>
+                </a:solidFill>
+                <a:latin typeface="Calibri" pitchFamily="34" charset="0"/>
+                <a:ea typeface="Calibri" pitchFamily="34" charset="-122"/>
+                <a:cs typeface="Calibri" pitchFamily="34" charset="-120"/>
+              </a:rPr>
+              <a:t>Data Science</a:t>
+            </a:r>
+            <a:endParaRPr lang="en-US" sz="550" dirty="0"/>
+          </a:p>
+        </p:txBody>
+      </p:sp>
+      <p:sp>
+        <p:nvSpPr>
+          <p:cNvPr id="96" name="Shape 94"/>
+          <p:cNvSpPr/>
+          <p:nvPr/>
+        </p:nvSpPr>
+        <p:spPr>
+          <a:xfrm>
+            <a:off x="6193536" y="2779776"/>
+            <a:ext cx="2804160" cy="566928"/>
           </a:xfrm>
           <a:prstGeom prst="rect">
             <a:avLst/>
@@ -4669,14 +5131,14 @@
       </p:sp>
       <p:sp>
         <p:nvSpPr>
-          <p:cNvPr id="83" name="Shape 81"/>
-          <p:cNvSpPr/>
-          <p:nvPr/>
-        </p:nvSpPr>
-        <p:spPr>
-          <a:xfrm>
-            <a:off x="6193536" y="2670048"/>
-            <a:ext cx="50292" cy="457200"/>
+          <p:cNvPr id="97" name="Shape 95"/>
+          <p:cNvSpPr/>
+          <p:nvPr/>
+        </p:nvSpPr>
+        <p:spPr>
+          <a:xfrm>
+            <a:off x="6193536" y="2779776"/>
+            <a:ext cx="50292" cy="566928"/>
           </a:xfrm>
           <a:prstGeom prst="rect">
             <a:avLst/>
@@ -4698,13 +5160,13 @@
       </p:sp>
       <p:sp>
         <p:nvSpPr>
-          <p:cNvPr id="84" name="Text 82"/>
-          <p:cNvSpPr/>
-          <p:nvPr/>
-        </p:nvSpPr>
-        <p:spPr>
-          <a:xfrm>
-            <a:off x="6284976" y="2706624"/>
+          <p:cNvPr id="98" name="Text 96"/>
+          <p:cNvSpPr/>
+          <p:nvPr/>
+        </p:nvSpPr>
+        <p:spPr>
+          <a:xfrm>
+            <a:off x="6284976" y="2816352"/>
             <a:ext cx="2328672" cy="201168"/>
           </a:xfrm>
           <a:prstGeom prst="rect">
@@ -4737,13 +5199,13 @@
       </p:sp>
       <p:sp>
         <p:nvSpPr>
-          <p:cNvPr id="85" name="Shape 83"/>
-          <p:cNvSpPr/>
-          <p:nvPr/>
-        </p:nvSpPr>
-        <p:spPr>
-          <a:xfrm>
-            <a:off x="8595360" y="2724912"/>
+          <p:cNvPr id="99" name="Shape 97"/>
+          <p:cNvSpPr/>
+          <p:nvPr/>
+        </p:nvSpPr>
+        <p:spPr>
+          <a:xfrm>
+            <a:off x="8595360" y="2834640"/>
             <a:ext cx="347472" cy="182880"/>
           </a:xfrm>
           <a:prstGeom prst="rect">
@@ -4762,13 +5224,13 @@
       </p:sp>
       <p:sp>
         <p:nvSpPr>
-          <p:cNvPr id="86" name="Text 84"/>
-          <p:cNvSpPr/>
-          <p:nvPr/>
-        </p:nvSpPr>
-        <p:spPr>
-          <a:xfrm>
-            <a:off x="8595360" y="2724912"/>
+          <p:cNvPr id="100" name="Text 98"/>
+          <p:cNvSpPr/>
+          <p:nvPr/>
+        </p:nvSpPr>
+        <p:spPr>
+          <a:xfrm>
+            <a:off x="8595360" y="2834640"/>
             <a:ext cx="347472" cy="182880"/>
           </a:xfrm>
           <a:prstGeom prst="rect">
@@ -4801,13 +5263,13 @@
       </p:sp>
       <p:sp>
         <p:nvSpPr>
-          <p:cNvPr id="87" name="Text 85"/>
-          <p:cNvSpPr/>
-          <p:nvPr/>
-        </p:nvSpPr>
-        <p:spPr>
-          <a:xfrm>
-            <a:off x="6284976" y="2907792"/>
+          <p:cNvPr id="101" name="Text 99"/>
+          <p:cNvSpPr/>
+          <p:nvPr/>
+        </p:nvSpPr>
+        <p:spPr>
+          <a:xfrm>
+            <a:off x="6284976" y="3017520"/>
             <a:ext cx="2657856" cy="164592"/>
           </a:xfrm>
           <a:prstGeom prst="rect">
@@ -4840,7 +5302,492 @@
       </p:sp>
       <p:sp>
         <p:nvSpPr>
-          <p:cNvPr id="88" name="Shape 86"/>
+          <p:cNvPr id="102" name="Shape 100"/>
+          <p:cNvSpPr/>
+          <p:nvPr/>
+        </p:nvSpPr>
+        <p:spPr>
+          <a:xfrm>
+            <a:off x="6284976" y="3218688"/>
+            <a:ext cx="672998" cy="100584"/>
+          </a:xfrm>
+          <a:prstGeom prst="rect">
+            <a:avLst/>
+          </a:prstGeom>
+          <a:solidFill>
+            <a:srgbClr val="0A5C47">
+              <a:alpha val="30000"/>
+            </a:srgbClr>
+          </a:solidFill>
+          <a:ln w="6350">
+            <a:solidFill>
+              <a:srgbClr val="0A5C47"/>
+            </a:solidFill>
+            <a:prstDash val="solid"/>
+          </a:ln>
+        </p:spPr>
+      </p:sp>
+      <p:sp>
+        <p:nvSpPr>
+          <p:cNvPr id="103" name="Text 101"/>
+          <p:cNvSpPr/>
+          <p:nvPr/>
+        </p:nvSpPr>
+        <p:spPr>
+          <a:xfrm>
+            <a:off x="6284976" y="3218688"/>
+            <a:ext cx="672998" cy="100584"/>
+          </a:xfrm>
+          <a:prstGeom prst="rect">
+            <a:avLst/>
+          </a:prstGeom>
+          <a:noFill/>
+          <a:ln/>
+        </p:spPr>
+        <p:txBody>
+          <a:bodyPr wrap="square" lIns="0" tIns="0" rIns="0" bIns="0" rtlCol="0" anchor="ctr"/>
+          <a:lstStyle/>
+          <a:p>
+            <a:pPr algn="ctr" indent="0" marL="0">
+              <a:buNone/>
+            </a:pPr>
+            <a:r>
+              <a:rPr lang="en-US" sz="550" b="1" dirty="0">
+                <a:solidFill>
+                  <a:srgbClr val="0A5C47"/>
+                </a:solidFill>
+                <a:latin typeface="Calibri" pitchFamily="34" charset="0"/>
+                <a:ea typeface="Calibri" pitchFamily="34" charset="-122"/>
+                <a:cs typeface="Calibri" pitchFamily="34" charset="-120"/>
+              </a:rPr>
+              <a:t>Data Science</a:t>
+            </a:r>
+            <a:endParaRPr lang="en-US" sz="550" dirty="0"/>
+          </a:p>
+        </p:txBody>
+      </p:sp>
+      <p:sp>
+        <p:nvSpPr>
+          <p:cNvPr id="104" name="Text 102"/>
+          <p:cNvSpPr/>
+          <p:nvPr/>
+        </p:nvSpPr>
+        <p:spPr>
+          <a:xfrm>
+            <a:off x="365760" y="3968496"/>
+            <a:ext cx="2743200" cy="146304"/>
+          </a:xfrm>
+          <a:prstGeom prst="rect">
+            <a:avLst/>
+          </a:prstGeom>
+          <a:noFill/>
+          <a:ln/>
+        </p:spPr>
+        <p:txBody>
+          <a:bodyPr wrap="square" rtlCol="0" anchor="ctr"/>
+          <a:lstStyle/>
+          <a:p>
+            <a:pPr indent="0" marL="0">
+              <a:buNone/>
+            </a:pPr>
+            <a:r>
+              <a:rPr lang="en-US" sz="600" b="1" dirty="0">
+                <a:solidFill>
+                  <a:srgbClr val="B6BBC0"/>
+                </a:solidFill>
+                <a:latin typeface="Calibri" pitchFamily="34" charset="0"/>
+                <a:ea typeface="Calibri" pitchFamily="34" charset="-122"/>
+                <a:cs typeface="Calibri" pitchFamily="34" charset="-120"/>
+              </a:rPr>
+              <a:t>PILLAR OWNERSHIP</a:t>
+            </a:r>
+            <a:endParaRPr lang="en-US" sz="600" dirty="0"/>
+          </a:p>
+        </p:txBody>
+      </p:sp>
+      <p:sp>
+        <p:nvSpPr>
+          <p:cNvPr id="105" name="Shape 103"/>
+          <p:cNvSpPr/>
+          <p:nvPr/>
+        </p:nvSpPr>
+        <p:spPr>
+          <a:xfrm>
+            <a:off x="365760" y="4133088"/>
+            <a:ext cx="2020824" cy="329184"/>
+          </a:xfrm>
+          <a:prstGeom prst="rect">
+            <a:avLst/>
+          </a:prstGeom>
+          <a:solidFill>
+            <a:srgbClr val="06185F">
+              <a:alpha val="82000"/>
+            </a:srgbClr>
+          </a:solidFill>
+          <a:ln w="12700">
+            <a:solidFill>
+              <a:srgbClr val="06185F"/>
+            </a:solidFill>
+            <a:prstDash val="solid"/>
+          </a:ln>
+        </p:spPr>
+      </p:sp>
+      <p:sp>
+        <p:nvSpPr>
+          <p:cNvPr id="106" name="Shape 104"/>
+          <p:cNvSpPr/>
+          <p:nvPr/>
+        </p:nvSpPr>
+        <p:spPr>
+          <a:xfrm>
+            <a:off x="365760" y="4133088"/>
+            <a:ext cx="2020824" cy="45720"/>
+          </a:xfrm>
+          <a:prstGeom prst="rect">
+            <a:avLst/>
+          </a:prstGeom>
+          <a:solidFill>
+            <a:srgbClr val="FFFFFF">
+              <a:alpha val="50000"/>
+            </a:srgbClr>
+          </a:solidFill>
+          <a:ln w="12700">
+            <a:solidFill>
+              <a:srgbClr val="FFFFFF">
+                <a:alpha val="50000"/>
+              </a:srgbClr>
+            </a:solidFill>
+            <a:prstDash val="solid"/>
+          </a:ln>
+        </p:spPr>
+      </p:sp>
+      <p:sp>
+        <p:nvSpPr>
+          <p:cNvPr id="107" name="Text 105"/>
+          <p:cNvSpPr/>
+          <p:nvPr/>
+        </p:nvSpPr>
+        <p:spPr>
+          <a:xfrm>
+            <a:off x="365760" y="4133088"/>
+            <a:ext cx="2020824" cy="329184"/>
+          </a:xfrm>
+          <a:prstGeom prst="rect">
+            <a:avLst/>
+          </a:prstGeom>
+          <a:noFill/>
+          <a:ln/>
+        </p:spPr>
+        <p:txBody>
+          <a:bodyPr wrap="square" rtlCol="0" anchor="ctr"/>
+          <a:lstStyle/>
+          <a:p>
+            <a:pPr algn="ctr" indent="0" marL="0">
+              <a:buNone/>
+            </a:pPr>
+            <a:r>
+              <a:rPr lang="en-US" sz="850" b="1" dirty="0">
+                <a:solidFill>
+                  <a:srgbClr val="FFFFFF"/>
+                </a:solidFill>
+                <a:latin typeface="Calibri" pitchFamily="34" charset="0"/>
+                <a:ea typeface="Calibri" pitchFamily="34" charset="-122"/>
+                <a:cs typeface="Calibri" pitchFamily="34" charset="-120"/>
+              </a:rPr>
+              <a:t>Data Acquisition</a:t>
+            </a:r>
+            <a:endParaRPr lang="en-US" sz="850" dirty="0"/>
+          </a:p>
+        </p:txBody>
+      </p:sp>
+      <p:sp>
+        <p:nvSpPr>
+          <p:cNvPr id="108" name="Shape 106"/>
+          <p:cNvSpPr/>
+          <p:nvPr/>
+        </p:nvSpPr>
+        <p:spPr>
+          <a:xfrm>
+            <a:off x="2496312" y="4133088"/>
+            <a:ext cx="2020824" cy="329184"/>
+          </a:xfrm>
+          <a:prstGeom prst="rect">
+            <a:avLst/>
+          </a:prstGeom>
+          <a:solidFill>
+            <a:srgbClr val="085CE5">
+              <a:alpha val="82000"/>
+            </a:srgbClr>
+          </a:solidFill>
+          <a:ln w="12700">
+            <a:solidFill>
+              <a:srgbClr val="085CE5"/>
+            </a:solidFill>
+            <a:prstDash val="solid"/>
+          </a:ln>
+        </p:spPr>
+      </p:sp>
+      <p:sp>
+        <p:nvSpPr>
+          <p:cNvPr id="109" name="Shape 107"/>
+          <p:cNvSpPr/>
+          <p:nvPr/>
+        </p:nvSpPr>
+        <p:spPr>
+          <a:xfrm>
+            <a:off x="2496312" y="4133088"/>
+            <a:ext cx="2020824" cy="45720"/>
+          </a:xfrm>
+          <a:prstGeom prst="rect">
+            <a:avLst/>
+          </a:prstGeom>
+          <a:solidFill>
+            <a:srgbClr val="FFFFFF">
+              <a:alpha val="50000"/>
+            </a:srgbClr>
+          </a:solidFill>
+          <a:ln w="12700">
+            <a:solidFill>
+              <a:srgbClr val="FFFFFF">
+                <a:alpha val="50000"/>
+              </a:srgbClr>
+            </a:solidFill>
+            <a:prstDash val="solid"/>
+          </a:ln>
+        </p:spPr>
+      </p:sp>
+      <p:sp>
+        <p:nvSpPr>
+          <p:cNvPr id="110" name="Text 108"/>
+          <p:cNvSpPr/>
+          <p:nvPr/>
+        </p:nvSpPr>
+        <p:spPr>
+          <a:xfrm>
+            <a:off x="2496312" y="4133088"/>
+            <a:ext cx="2020824" cy="329184"/>
+          </a:xfrm>
+          <a:prstGeom prst="rect">
+            <a:avLst/>
+          </a:prstGeom>
+          <a:noFill/>
+          <a:ln/>
+        </p:spPr>
+        <p:txBody>
+          <a:bodyPr wrap="square" rtlCol="0" anchor="ctr"/>
+          <a:lstStyle/>
+          <a:p>
+            <a:pPr algn="ctr" indent="0" marL="0">
+              <a:buNone/>
+            </a:pPr>
+            <a:r>
+              <a:rPr lang="en-US" sz="850" b="1" dirty="0">
+                <a:solidFill>
+                  <a:srgbClr val="FFFFFF"/>
+                </a:solidFill>
+                <a:latin typeface="Calibri" pitchFamily="34" charset="0"/>
+                <a:ea typeface="Calibri" pitchFamily="34" charset="-122"/>
+                <a:cs typeface="Calibri" pitchFamily="34" charset="-120"/>
+              </a:rPr>
+              <a:t>Reporting &amp; Dashboards</a:t>
+            </a:r>
+            <a:endParaRPr lang="en-US" sz="850" dirty="0"/>
+          </a:p>
+        </p:txBody>
+      </p:sp>
+      <p:sp>
+        <p:nvSpPr>
+          <p:cNvPr id="111" name="Shape 109"/>
+          <p:cNvSpPr/>
+          <p:nvPr/>
+        </p:nvSpPr>
+        <p:spPr>
+          <a:xfrm>
+            <a:off x="4626864" y="4133088"/>
+            <a:ext cx="2020824" cy="329184"/>
+          </a:xfrm>
+          <a:prstGeom prst="rect">
+            <a:avLst/>
+          </a:prstGeom>
+          <a:solidFill>
+            <a:srgbClr val="0A5CA8">
+              <a:alpha val="82000"/>
+            </a:srgbClr>
+          </a:solidFill>
+          <a:ln w="12700">
+            <a:solidFill>
+              <a:srgbClr val="0A5CA8"/>
+            </a:solidFill>
+            <a:prstDash val="solid"/>
+          </a:ln>
+        </p:spPr>
+      </p:sp>
+      <p:sp>
+        <p:nvSpPr>
+          <p:cNvPr id="112" name="Shape 110"/>
+          <p:cNvSpPr/>
+          <p:nvPr/>
+        </p:nvSpPr>
+        <p:spPr>
+          <a:xfrm>
+            <a:off x="4626864" y="4133088"/>
+            <a:ext cx="2020824" cy="45720"/>
+          </a:xfrm>
+          <a:prstGeom prst="rect">
+            <a:avLst/>
+          </a:prstGeom>
+          <a:solidFill>
+            <a:srgbClr val="FFFFFF">
+              <a:alpha val="50000"/>
+            </a:srgbClr>
+          </a:solidFill>
+          <a:ln w="12700">
+            <a:solidFill>
+              <a:srgbClr val="FFFFFF">
+                <a:alpha val="50000"/>
+              </a:srgbClr>
+            </a:solidFill>
+            <a:prstDash val="solid"/>
+          </a:ln>
+        </p:spPr>
+      </p:sp>
+      <p:sp>
+        <p:nvSpPr>
+          <p:cNvPr id="113" name="Text 111"/>
+          <p:cNvSpPr/>
+          <p:nvPr/>
+        </p:nvSpPr>
+        <p:spPr>
+          <a:xfrm>
+            <a:off x="4626864" y="4133088"/>
+            <a:ext cx="2020824" cy="329184"/>
+          </a:xfrm>
+          <a:prstGeom prst="rect">
+            <a:avLst/>
+          </a:prstGeom>
+          <a:noFill/>
+          <a:ln/>
+        </p:spPr>
+        <p:txBody>
+          <a:bodyPr wrap="square" rtlCol="0" anchor="ctr"/>
+          <a:lstStyle/>
+          <a:p>
+            <a:pPr algn="ctr" indent="0" marL="0">
+              <a:buNone/>
+            </a:pPr>
+            <a:r>
+              <a:rPr lang="en-US" sz="850" b="1" dirty="0">
+                <a:solidFill>
+                  <a:srgbClr val="FFFFFF"/>
+                </a:solidFill>
+                <a:latin typeface="Calibri" pitchFamily="34" charset="0"/>
+                <a:ea typeface="Calibri" pitchFamily="34" charset="-122"/>
+                <a:cs typeface="Calibri" pitchFamily="34" charset="-120"/>
+              </a:rPr>
+              <a:t>Portal / Self Service</a:t>
+            </a:r>
+            <a:endParaRPr lang="en-US" sz="850" dirty="0"/>
+          </a:p>
+        </p:txBody>
+      </p:sp>
+      <p:sp>
+        <p:nvSpPr>
+          <p:cNvPr id="114" name="Shape 112"/>
+          <p:cNvSpPr/>
+          <p:nvPr/>
+        </p:nvSpPr>
+        <p:spPr>
+          <a:xfrm>
+            <a:off x="6757416" y="4133088"/>
+            <a:ext cx="2020824" cy="329184"/>
+          </a:xfrm>
+          <a:prstGeom prst="rect">
+            <a:avLst/>
+          </a:prstGeom>
+          <a:solidFill>
+            <a:srgbClr val="0A5C47">
+              <a:alpha val="82000"/>
+            </a:srgbClr>
+          </a:solidFill>
+          <a:ln w="12700">
+            <a:solidFill>
+              <a:srgbClr val="0A5C47"/>
+            </a:solidFill>
+            <a:prstDash val="solid"/>
+          </a:ln>
+        </p:spPr>
+      </p:sp>
+      <p:sp>
+        <p:nvSpPr>
+          <p:cNvPr id="115" name="Shape 113"/>
+          <p:cNvSpPr/>
+          <p:nvPr/>
+        </p:nvSpPr>
+        <p:spPr>
+          <a:xfrm>
+            <a:off x="6757416" y="4133088"/>
+            <a:ext cx="2020824" cy="45720"/>
+          </a:xfrm>
+          <a:prstGeom prst="rect">
+            <a:avLst/>
+          </a:prstGeom>
+          <a:solidFill>
+            <a:srgbClr val="FFFFFF">
+              <a:alpha val="50000"/>
+            </a:srgbClr>
+          </a:solidFill>
+          <a:ln w="12700">
+            <a:solidFill>
+              <a:srgbClr val="FFFFFF">
+                <a:alpha val="50000"/>
+              </a:srgbClr>
+            </a:solidFill>
+            <a:prstDash val="solid"/>
+          </a:ln>
+        </p:spPr>
+      </p:sp>
+      <p:sp>
+        <p:nvSpPr>
+          <p:cNvPr id="116" name="Text 114"/>
+          <p:cNvSpPr/>
+          <p:nvPr/>
+        </p:nvSpPr>
+        <p:spPr>
+          <a:xfrm>
+            <a:off x="6757416" y="4133088"/>
+            <a:ext cx="2020824" cy="329184"/>
+          </a:xfrm>
+          <a:prstGeom prst="rect">
+            <a:avLst/>
+          </a:prstGeom>
+          <a:noFill/>
+          <a:ln/>
+        </p:spPr>
+        <p:txBody>
+          <a:bodyPr wrap="square" rtlCol="0" anchor="ctr"/>
+          <a:lstStyle/>
+          <a:p>
+            <a:pPr algn="ctr" indent="0" marL="0">
+              <a:buNone/>
+            </a:pPr>
+            <a:r>
+              <a:rPr lang="en-US" sz="850" b="1" dirty="0">
+                <a:solidFill>
+                  <a:srgbClr val="FFFFFF"/>
+                </a:solidFill>
+                <a:latin typeface="Calibri" pitchFamily="34" charset="0"/>
+                <a:ea typeface="Calibri" pitchFamily="34" charset="-122"/>
+                <a:cs typeface="Calibri" pitchFamily="34" charset="-120"/>
+              </a:rPr>
+              <a:t>Data Science Apps</a:t>
+            </a:r>
+            <a:endParaRPr lang="en-US" sz="850" dirty="0"/>
+          </a:p>
+        </p:txBody>
+      </p:sp>
+      <p:sp>
+        <p:nvSpPr>
+          <p:cNvPr id="117" name="Shape 115"/>
           <p:cNvSpPr/>
           <p:nvPr/>
         </p:nvSpPr>
@@ -4865,7 +5812,7 @@
       </p:sp>
       <p:sp>
         <p:nvSpPr>
-          <p:cNvPr id="89" name="Text 87"/>
+          <p:cNvPr id="118" name="Text 116"/>
           <p:cNvSpPr/>
           <p:nvPr/>
         </p:nvSpPr>
@@ -4904,7 +5851,7 @@
       </p:sp>
       <p:sp>
         <p:nvSpPr>
-          <p:cNvPr id="90" name="Shape 88"/>
+          <p:cNvPr id="119" name="Shape 117"/>
           <p:cNvSpPr/>
           <p:nvPr/>
         </p:nvSpPr>
@@ -4929,7 +5876,7 @@
       </p:sp>
       <p:sp>
         <p:nvSpPr>
-          <p:cNvPr id="91" name="Text 89"/>
+          <p:cNvPr id="120" name="Text 118"/>
           <p:cNvSpPr/>
           <p:nvPr/>
         </p:nvSpPr>
@@ -4968,7 +5915,7 @@
       </p:sp>
       <p:sp>
         <p:nvSpPr>
-          <p:cNvPr id="92" name="Shape 90"/>
+          <p:cNvPr id="121" name="Shape 119"/>
           <p:cNvSpPr/>
           <p:nvPr/>
         </p:nvSpPr>
@@ -4993,7 +5940,7 @@
       </p:sp>
       <p:sp>
         <p:nvSpPr>
-          <p:cNvPr id="93" name="Text 91"/>
+          <p:cNvPr id="122" name="Text 120"/>
           <p:cNvSpPr/>
           <p:nvPr/>
         </p:nvSpPr>

</xml_diff>

<commit_message>
Team slide redesign: per-card heights, 4th PM stats card, Data Scientist to stats format, fix overflow
Co-Authored-By: Claude Sonnet 4.6 <noreply@anthropic.com>
</commit_message>
<xml_diff>
--- a/jhbi-roadmap-2026.pptx
+++ b/jhbi-roadmap-2026.pptx
@@ -5022,7 +5022,7 @@
         <p:spPr>
           <a:xfrm>
             <a:off x="146304" y="2157984"/>
-            <a:ext cx="2804160" cy="694944"/>
+            <a:ext cx="2804160" cy="621792"/>
           </a:xfrm>
           <a:prstGeom prst="rect">
             <a:avLst/>
@@ -5047,7 +5047,7 @@
         <p:spPr>
           <a:xfrm>
             <a:off x="146304" y="2157984"/>
-            <a:ext cx="50292" cy="694944"/>
+            <a:ext cx="50292" cy="621792"/>
           </a:xfrm>
           <a:prstGeom prst="rect">
             <a:avLst/>
@@ -5071,8 +5071,8 @@
         </p:nvSpPr>
         <p:spPr>
           <a:xfrm>
-            <a:off x="237744" y="2194560"/>
-            <a:ext cx="2657856" cy="155448"/>
+            <a:off x="237744" y="2185416"/>
+            <a:ext cx="2657856" cy="128016"/>
           </a:xfrm>
           <a:prstGeom prst="rect">
             <a:avLst/>
@@ -5088,7 +5088,7 @@
               <a:buNone/>
             </a:pPr>
             <a:r>
-              <a:rPr lang="en-US" sz="800" b="1" dirty="0">
+              <a:rPr lang="en-US" sz="750" b="1" dirty="0">
                 <a:solidFill>
                   <a:srgbClr val="06185F"/>
                 </a:solidFill>
@@ -5098,7 +5098,7 @@
               </a:rPr>
               <a:t>Data Acq. &amp; Engineering</a:t>
             </a:r>
-            <a:endParaRPr lang="en-US" sz="800" dirty="0"/>
+            <a:endParaRPr lang="en-US" sz="750" dirty="0"/>
           </a:p>
         </p:txBody>
       </p:sp>
@@ -5110,7 +5110,7 @@
         </p:nvSpPr>
         <p:spPr>
           <a:xfrm>
-            <a:off x="219456" y="2368296"/>
+            <a:off x="219456" y="2331720"/>
             <a:ext cx="2657856" cy="0"/>
           </a:xfrm>
           <a:prstGeom prst="line">
@@ -5133,8 +5133,8 @@
         </p:nvSpPr>
         <p:spPr>
           <a:xfrm>
-            <a:off x="196596" y="2386584"/>
-            <a:ext cx="917956" cy="201168"/>
+            <a:off x="196596" y="2350008"/>
+            <a:ext cx="917956" cy="182880"/>
           </a:xfrm>
           <a:prstGeom prst="rect">
             <a:avLst/>
@@ -5150,7 +5150,7 @@
               <a:buNone/>
             </a:pPr>
             <a:r>
-              <a:rPr lang="en-US" sz="1500" b="1" dirty="0">
+              <a:rPr lang="en-US" sz="1300" b="1" dirty="0">
                 <a:solidFill>
                   <a:srgbClr val="06185F"/>
                 </a:solidFill>
@@ -5160,7 +5160,7 @@
               </a:rPr>
               <a:t>—</a:t>
             </a:r>
-            <a:endParaRPr lang="en-US" sz="1500" dirty="0"/>
+            <a:endParaRPr lang="en-US" sz="1300" dirty="0"/>
           </a:p>
         </p:txBody>
       </p:sp>
@@ -5172,8 +5172,8 @@
         </p:nvSpPr>
         <p:spPr>
           <a:xfrm>
-            <a:off x="196596" y="2596896"/>
-            <a:ext cx="917956" cy="109728"/>
+            <a:off x="196596" y="2542032"/>
+            <a:ext cx="917956" cy="91440"/>
           </a:xfrm>
           <a:prstGeom prst="rect">
             <a:avLst/>
@@ -5211,8 +5211,8 @@
         </p:nvSpPr>
         <p:spPr>
           <a:xfrm>
-            <a:off x="1114552" y="2386584"/>
-            <a:ext cx="0" cy="338328"/>
+            <a:off x="1114552" y="2350008"/>
+            <a:ext cx="0" cy="320040"/>
           </a:xfrm>
           <a:prstGeom prst="line">
             <a:avLst/>
@@ -5234,8 +5234,8 @@
         </p:nvSpPr>
         <p:spPr>
           <a:xfrm>
-            <a:off x="1114552" y="2386584"/>
-            <a:ext cx="917956" cy="201168"/>
+            <a:off x="1114552" y="2350008"/>
+            <a:ext cx="917956" cy="182880"/>
           </a:xfrm>
           <a:prstGeom prst="rect">
             <a:avLst/>
@@ -5251,7 +5251,7 @@
               <a:buNone/>
             </a:pPr>
             <a:r>
-              <a:rPr lang="en-US" sz="1500" b="1" dirty="0">
+              <a:rPr lang="en-US" sz="1300" b="1" dirty="0">
                 <a:solidFill>
                   <a:srgbClr val="0A5CA8"/>
                 </a:solidFill>
@@ -5261,7 +5261,7 @@
               </a:rPr>
               <a:t>—</a:t>
             </a:r>
-            <a:endParaRPr lang="en-US" sz="1500" dirty="0"/>
+            <a:endParaRPr lang="en-US" sz="1300" dirty="0"/>
           </a:p>
         </p:txBody>
       </p:sp>
@@ -5273,8 +5273,8 @@
         </p:nvSpPr>
         <p:spPr>
           <a:xfrm>
-            <a:off x="1114552" y="2596896"/>
-            <a:ext cx="917956" cy="109728"/>
+            <a:off x="1114552" y="2542032"/>
+            <a:ext cx="917956" cy="91440"/>
           </a:xfrm>
           <a:prstGeom prst="rect">
             <a:avLst/>
@@ -5312,8 +5312,8 @@
         </p:nvSpPr>
         <p:spPr>
           <a:xfrm>
-            <a:off x="2032508" y="2386584"/>
-            <a:ext cx="0" cy="338328"/>
+            <a:off x="2032508" y="2350008"/>
+            <a:ext cx="0" cy="320040"/>
           </a:xfrm>
           <a:prstGeom prst="line">
             <a:avLst/>
@@ -5335,8 +5335,8 @@
         </p:nvSpPr>
         <p:spPr>
           <a:xfrm>
-            <a:off x="2032508" y="2386584"/>
-            <a:ext cx="917956" cy="201168"/>
+            <a:off x="2032508" y="2350008"/>
+            <a:ext cx="917956" cy="182880"/>
           </a:xfrm>
           <a:prstGeom prst="rect">
             <a:avLst/>
@@ -5352,7 +5352,7 @@
               <a:buNone/>
             </a:pPr>
             <a:r>
-              <a:rPr lang="en-US" sz="1500" b="1" dirty="0">
+              <a:rPr lang="en-US" sz="1300" b="1" dirty="0">
                 <a:solidFill>
                   <a:srgbClr val="0A5C47"/>
                 </a:solidFill>
@@ -5362,7 +5362,7 @@
               </a:rPr>
               <a:t>—</a:t>
             </a:r>
-            <a:endParaRPr lang="en-US" sz="1500" dirty="0"/>
+            <a:endParaRPr lang="en-US" sz="1300" dirty="0"/>
           </a:p>
         </p:txBody>
       </p:sp>
@@ -5374,8 +5374,8 @@
         </p:nvSpPr>
         <p:spPr>
           <a:xfrm>
-            <a:off x="2032508" y="2596896"/>
-            <a:ext cx="917956" cy="109728"/>
+            <a:off x="2032508" y="2542032"/>
+            <a:ext cx="917956" cy="91440"/>
           </a:xfrm>
           <a:prstGeom prst="rect">
             <a:avLst/>
@@ -5413,7 +5413,7 @@
         </p:nvSpPr>
         <p:spPr>
           <a:xfrm>
-            <a:off x="237744" y="2724912"/>
+            <a:off x="237744" y="2660904"/>
             <a:ext cx="585216" cy="100584"/>
           </a:xfrm>
           <a:prstGeom prst="rect">
@@ -5440,7 +5440,7 @@
         </p:nvSpPr>
         <p:spPr>
           <a:xfrm>
-            <a:off x="237744" y="2724912"/>
+            <a:off x="237744" y="2660904"/>
             <a:ext cx="585216" cy="100584"/>
           </a:xfrm>
           <a:prstGeom prst="rect">
@@ -5479,8 +5479,8 @@
         </p:nvSpPr>
         <p:spPr>
           <a:xfrm>
-            <a:off x="146304" y="2907792"/>
-            <a:ext cx="2804160" cy="694944"/>
+            <a:off x="146304" y="2834640"/>
+            <a:ext cx="2804160" cy="621792"/>
           </a:xfrm>
           <a:prstGeom prst="rect">
             <a:avLst/>
@@ -5504,8 +5504,8 @@
         </p:nvSpPr>
         <p:spPr>
           <a:xfrm>
-            <a:off x="146304" y="2907792"/>
-            <a:ext cx="50292" cy="694944"/>
+            <a:off x="146304" y="2834640"/>
+            <a:ext cx="50292" cy="621792"/>
           </a:xfrm>
           <a:prstGeom prst="rect">
             <a:avLst/>
@@ -5529,8 +5529,8 @@
         </p:nvSpPr>
         <p:spPr>
           <a:xfrm>
-            <a:off x="237744" y="2944368"/>
-            <a:ext cx="2657856" cy="155448"/>
+            <a:off x="237744" y="2862072"/>
+            <a:ext cx="2657856" cy="128016"/>
           </a:xfrm>
           <a:prstGeom prst="rect">
             <a:avLst/>
@@ -5546,7 +5546,7 @@
               <a:buNone/>
             </a:pPr>
             <a:r>
-              <a:rPr lang="en-US" sz="800" b="1" dirty="0">
+              <a:rPr lang="en-US" sz="750" b="1" dirty="0">
                 <a:solidFill>
                   <a:srgbClr val="06185F"/>
                 </a:solidFill>
@@ -5556,7 +5556,7 @@
               </a:rPr>
               <a:t>Visualization</a:t>
             </a:r>
-            <a:endParaRPr lang="en-US" sz="800" dirty="0"/>
+            <a:endParaRPr lang="en-US" sz="750" dirty="0"/>
           </a:p>
         </p:txBody>
       </p:sp>
@@ -5568,7 +5568,7 @@
         </p:nvSpPr>
         <p:spPr>
           <a:xfrm>
-            <a:off x="219456" y="3118104"/>
+            <a:off x="219456" y="3008376"/>
             <a:ext cx="2657856" cy="0"/>
           </a:xfrm>
           <a:prstGeom prst="line">
@@ -5591,8 +5591,8 @@
         </p:nvSpPr>
         <p:spPr>
           <a:xfrm>
-            <a:off x="196596" y="3136392"/>
-            <a:ext cx="917956" cy="201168"/>
+            <a:off x="196596" y="3026664"/>
+            <a:ext cx="917956" cy="182880"/>
           </a:xfrm>
           <a:prstGeom prst="rect">
             <a:avLst/>
@@ -5608,7 +5608,7 @@
               <a:buNone/>
             </a:pPr>
             <a:r>
-              <a:rPr lang="en-US" sz="1500" b="1" dirty="0">
+              <a:rPr lang="en-US" sz="1300" b="1" dirty="0">
                 <a:solidFill>
                   <a:srgbClr val="06185F"/>
                 </a:solidFill>
@@ -5618,7 +5618,7 @@
               </a:rPr>
               <a:t>—</a:t>
             </a:r>
-            <a:endParaRPr lang="en-US" sz="1500" dirty="0"/>
+            <a:endParaRPr lang="en-US" sz="1300" dirty="0"/>
           </a:p>
         </p:txBody>
       </p:sp>
@@ -5630,8 +5630,8 @@
         </p:nvSpPr>
         <p:spPr>
           <a:xfrm>
-            <a:off x="196596" y="3346704"/>
-            <a:ext cx="917956" cy="109728"/>
+            <a:off x="196596" y="3218688"/>
+            <a:ext cx="917956" cy="91440"/>
           </a:xfrm>
           <a:prstGeom prst="rect">
             <a:avLst/>
@@ -5669,8 +5669,8 @@
         </p:nvSpPr>
         <p:spPr>
           <a:xfrm>
-            <a:off x="1114552" y="3136392"/>
-            <a:ext cx="0" cy="338328"/>
+            <a:off x="1114552" y="3026664"/>
+            <a:ext cx="0" cy="320040"/>
           </a:xfrm>
           <a:prstGeom prst="line">
             <a:avLst/>
@@ -5692,8 +5692,8 @@
         </p:nvSpPr>
         <p:spPr>
           <a:xfrm>
-            <a:off x="1114552" y="3136392"/>
-            <a:ext cx="917956" cy="201168"/>
+            <a:off x="1114552" y="3026664"/>
+            <a:ext cx="917956" cy="182880"/>
           </a:xfrm>
           <a:prstGeom prst="rect">
             <a:avLst/>
@@ -5709,7 +5709,7 @@
               <a:buNone/>
             </a:pPr>
             <a:r>
-              <a:rPr lang="en-US" sz="1500" b="1" dirty="0">
+              <a:rPr lang="en-US" sz="1300" b="1" dirty="0">
                 <a:solidFill>
                   <a:srgbClr val="0A5CA8"/>
                 </a:solidFill>
@@ -5719,7 +5719,7 @@
               </a:rPr>
               <a:t>—</a:t>
             </a:r>
-            <a:endParaRPr lang="en-US" sz="1500" dirty="0"/>
+            <a:endParaRPr lang="en-US" sz="1300" dirty="0"/>
           </a:p>
         </p:txBody>
       </p:sp>
@@ -5731,8 +5731,8 @@
         </p:nvSpPr>
         <p:spPr>
           <a:xfrm>
-            <a:off x="1114552" y="3346704"/>
-            <a:ext cx="917956" cy="109728"/>
+            <a:off x="1114552" y="3218688"/>
+            <a:ext cx="917956" cy="91440"/>
           </a:xfrm>
           <a:prstGeom prst="rect">
             <a:avLst/>
@@ -5770,8 +5770,8 @@
         </p:nvSpPr>
         <p:spPr>
           <a:xfrm>
-            <a:off x="2032508" y="3136392"/>
-            <a:ext cx="0" cy="338328"/>
+            <a:off x="2032508" y="3026664"/>
+            <a:ext cx="0" cy="320040"/>
           </a:xfrm>
           <a:prstGeom prst="line">
             <a:avLst/>
@@ -5793,8 +5793,8 @@
         </p:nvSpPr>
         <p:spPr>
           <a:xfrm>
-            <a:off x="2032508" y="3136392"/>
-            <a:ext cx="917956" cy="201168"/>
+            <a:off x="2032508" y="3026664"/>
+            <a:ext cx="917956" cy="182880"/>
           </a:xfrm>
           <a:prstGeom prst="rect">
             <a:avLst/>
@@ -5810,7 +5810,7 @@
               <a:buNone/>
             </a:pPr>
             <a:r>
-              <a:rPr lang="en-US" sz="1500" b="1" dirty="0">
+              <a:rPr lang="en-US" sz="1300" b="1" dirty="0">
                 <a:solidFill>
                   <a:srgbClr val="0A5C47"/>
                 </a:solidFill>
@@ -5820,7 +5820,7 @@
               </a:rPr>
               <a:t>—</a:t>
             </a:r>
-            <a:endParaRPr lang="en-US" sz="1500" dirty="0"/>
+            <a:endParaRPr lang="en-US" sz="1300" dirty="0"/>
           </a:p>
         </p:txBody>
       </p:sp>
@@ -5832,8 +5832,8 @@
         </p:nvSpPr>
         <p:spPr>
           <a:xfrm>
-            <a:off x="2032508" y="3346704"/>
-            <a:ext cx="917956" cy="109728"/>
+            <a:off x="2032508" y="3218688"/>
+            <a:ext cx="917956" cy="91440"/>
           </a:xfrm>
           <a:prstGeom prst="rect">
             <a:avLst/>
@@ -5871,7 +5871,7 @@
         </p:nvSpPr>
         <p:spPr>
           <a:xfrm>
-            <a:off x="237744" y="3474720"/>
+            <a:off x="237744" y="3337560"/>
             <a:ext cx="497434" cy="100584"/>
           </a:xfrm>
           <a:prstGeom prst="rect">
@@ -5898,7 +5898,7 @@
         </p:nvSpPr>
         <p:spPr>
           <a:xfrm>
-            <a:off x="237744" y="3474720"/>
+            <a:off x="237744" y="3337560"/>
             <a:ext cx="497434" cy="100584"/>
           </a:xfrm>
           <a:prstGeom prst="rect">
@@ -5937,8 +5937,8 @@
         </p:nvSpPr>
         <p:spPr>
           <a:xfrm>
-            <a:off x="146304" y="3657600"/>
-            <a:ext cx="2804160" cy="694944"/>
+            <a:off x="146304" y="3511296"/>
+            <a:ext cx="2804160" cy="621792"/>
           </a:xfrm>
           <a:prstGeom prst="rect">
             <a:avLst/>
@@ -5962,8 +5962,8 @@
         </p:nvSpPr>
         <p:spPr>
           <a:xfrm>
-            <a:off x="146304" y="3657600"/>
-            <a:ext cx="50292" cy="694944"/>
+            <a:off x="146304" y="3511296"/>
+            <a:ext cx="50292" cy="621792"/>
           </a:xfrm>
           <a:prstGeom prst="rect">
             <a:avLst/>
@@ -5987,8 +5987,8 @@
         </p:nvSpPr>
         <p:spPr>
           <a:xfrm>
-            <a:off x="237744" y="3694176"/>
-            <a:ext cx="2657856" cy="155448"/>
+            <a:off x="237744" y="3538728"/>
+            <a:ext cx="2657856" cy="128016"/>
           </a:xfrm>
           <a:prstGeom prst="rect">
             <a:avLst/>
@@ -6004,7 +6004,7 @@
               <a:buNone/>
             </a:pPr>
             <a:r>
-              <a:rPr lang="en-US" sz="800" b="1" dirty="0">
+              <a:rPr lang="en-US" sz="750" b="1" dirty="0">
                 <a:solidFill>
                   <a:srgbClr val="06185F"/>
                 </a:solidFill>
@@ -6014,7 +6014,7 @@
               </a:rPr>
               <a:t>App Dev</a:t>
             </a:r>
-            <a:endParaRPr lang="en-US" sz="800" dirty="0"/>
+            <a:endParaRPr lang="en-US" sz="750" dirty="0"/>
           </a:p>
         </p:txBody>
       </p:sp>
@@ -6026,7 +6026,7 @@
         </p:nvSpPr>
         <p:spPr>
           <a:xfrm>
-            <a:off x="219456" y="3867912"/>
+            <a:off x="219456" y="3685032"/>
             <a:ext cx="2657856" cy="0"/>
           </a:xfrm>
           <a:prstGeom prst="line">
@@ -6049,8 +6049,8 @@
         </p:nvSpPr>
         <p:spPr>
           <a:xfrm>
-            <a:off x="196596" y="3886200"/>
-            <a:ext cx="917956" cy="201168"/>
+            <a:off x="196596" y="3703320"/>
+            <a:ext cx="917956" cy="182880"/>
           </a:xfrm>
           <a:prstGeom prst="rect">
             <a:avLst/>
@@ -6066,7 +6066,7 @@
               <a:buNone/>
             </a:pPr>
             <a:r>
-              <a:rPr lang="en-US" sz="1500" b="1" dirty="0">
+              <a:rPr lang="en-US" sz="1300" b="1" dirty="0">
                 <a:solidFill>
                   <a:srgbClr val="06185F"/>
                 </a:solidFill>
@@ -6076,7 +6076,7 @@
               </a:rPr>
               <a:t>—</a:t>
             </a:r>
-            <a:endParaRPr lang="en-US" sz="1500" dirty="0"/>
+            <a:endParaRPr lang="en-US" sz="1300" dirty="0"/>
           </a:p>
         </p:txBody>
       </p:sp>
@@ -6088,8 +6088,8 @@
         </p:nvSpPr>
         <p:spPr>
           <a:xfrm>
-            <a:off x="196596" y="4096512"/>
-            <a:ext cx="917956" cy="109728"/>
+            <a:off x="196596" y="3895344"/>
+            <a:ext cx="917956" cy="91440"/>
           </a:xfrm>
           <a:prstGeom prst="rect">
             <a:avLst/>
@@ -6127,8 +6127,8 @@
         </p:nvSpPr>
         <p:spPr>
           <a:xfrm>
-            <a:off x="1114552" y="3886200"/>
-            <a:ext cx="0" cy="338328"/>
+            <a:off x="1114552" y="3703320"/>
+            <a:ext cx="0" cy="320040"/>
           </a:xfrm>
           <a:prstGeom prst="line">
             <a:avLst/>
@@ -6150,8 +6150,8 @@
         </p:nvSpPr>
         <p:spPr>
           <a:xfrm>
-            <a:off x="1114552" y="3886200"/>
-            <a:ext cx="917956" cy="201168"/>
+            <a:off x="1114552" y="3703320"/>
+            <a:ext cx="917956" cy="182880"/>
           </a:xfrm>
           <a:prstGeom prst="rect">
             <a:avLst/>
@@ -6167,7 +6167,7 @@
               <a:buNone/>
             </a:pPr>
             <a:r>
-              <a:rPr lang="en-US" sz="1500" b="1" dirty="0">
+              <a:rPr lang="en-US" sz="1300" b="1" dirty="0">
                 <a:solidFill>
                   <a:srgbClr val="0A5CA8"/>
                 </a:solidFill>
@@ -6177,7 +6177,7 @@
               </a:rPr>
               <a:t>—</a:t>
             </a:r>
-            <a:endParaRPr lang="en-US" sz="1500" dirty="0"/>
+            <a:endParaRPr lang="en-US" sz="1300" dirty="0"/>
           </a:p>
         </p:txBody>
       </p:sp>
@@ -6189,8 +6189,8 @@
         </p:nvSpPr>
         <p:spPr>
           <a:xfrm>
-            <a:off x="1114552" y="4096512"/>
-            <a:ext cx="917956" cy="109728"/>
+            <a:off x="1114552" y="3895344"/>
+            <a:ext cx="917956" cy="91440"/>
           </a:xfrm>
           <a:prstGeom prst="rect">
             <a:avLst/>
@@ -6228,8 +6228,8 @@
         </p:nvSpPr>
         <p:spPr>
           <a:xfrm>
-            <a:off x="2032508" y="3886200"/>
-            <a:ext cx="0" cy="338328"/>
+            <a:off x="2032508" y="3703320"/>
+            <a:ext cx="0" cy="320040"/>
           </a:xfrm>
           <a:prstGeom prst="line">
             <a:avLst/>
@@ -6251,8 +6251,8 @@
         </p:nvSpPr>
         <p:spPr>
           <a:xfrm>
-            <a:off x="2032508" y="3886200"/>
-            <a:ext cx="917956" cy="201168"/>
+            <a:off x="2032508" y="3703320"/>
+            <a:ext cx="917956" cy="182880"/>
           </a:xfrm>
           <a:prstGeom prst="rect">
             <a:avLst/>
@@ -6268,7 +6268,7 @@
               <a:buNone/>
             </a:pPr>
             <a:r>
-              <a:rPr lang="en-US" sz="1500" b="1" dirty="0">
+              <a:rPr lang="en-US" sz="1300" b="1" dirty="0">
                 <a:solidFill>
                   <a:srgbClr val="0A5C47"/>
                 </a:solidFill>
@@ -6278,7 +6278,7 @@
               </a:rPr>
               <a:t>—</a:t>
             </a:r>
-            <a:endParaRPr lang="en-US" sz="1500" dirty="0"/>
+            <a:endParaRPr lang="en-US" sz="1300" dirty="0"/>
           </a:p>
         </p:txBody>
       </p:sp>
@@ -6290,8 +6290,8 @@
         </p:nvSpPr>
         <p:spPr>
           <a:xfrm>
-            <a:off x="2032508" y="4096512"/>
-            <a:ext cx="917956" cy="109728"/>
+            <a:off x="2032508" y="3895344"/>
+            <a:ext cx="917956" cy="91440"/>
           </a:xfrm>
           <a:prstGeom prst="rect">
             <a:avLst/>
@@ -6329,7 +6329,7 @@
         </p:nvSpPr>
         <p:spPr>
           <a:xfrm>
-            <a:off x="237744" y="4224528"/>
+            <a:off x="237744" y="4014216"/>
             <a:ext cx="541325" cy="100584"/>
           </a:xfrm>
           <a:prstGeom prst="rect">
@@ -6356,7 +6356,7 @@
         </p:nvSpPr>
         <p:spPr>
           <a:xfrm>
-            <a:off x="237744" y="4224528"/>
+            <a:off x="237744" y="4014216"/>
             <a:ext cx="541325" cy="100584"/>
           </a:xfrm>
           <a:prstGeom prst="rect">
@@ -6419,7 +6419,7 @@
         <p:spPr>
           <a:xfrm>
             <a:off x="3169920" y="2157984"/>
-            <a:ext cx="2804160" cy="694944"/>
+            <a:ext cx="2804160" cy="438912"/>
           </a:xfrm>
           <a:prstGeom prst="rect">
             <a:avLst/>
@@ -6444,7 +6444,7 @@
         <p:spPr>
           <a:xfrm>
             <a:off x="3169920" y="2157984"/>
-            <a:ext cx="50292" cy="694944"/>
+            <a:ext cx="50292" cy="438912"/>
           </a:xfrm>
           <a:prstGeom prst="rect">
             <a:avLst/>
@@ -6468,8 +6468,8 @@
         </p:nvSpPr>
         <p:spPr>
           <a:xfrm>
-            <a:off x="3261360" y="2194560"/>
-            <a:ext cx="2657856" cy="201168"/>
+            <a:off x="3261360" y="2185416"/>
+            <a:ext cx="2657856" cy="164592"/>
           </a:xfrm>
           <a:prstGeom prst="rect">
             <a:avLst/>
@@ -6507,8 +6507,8 @@
         </p:nvSpPr>
         <p:spPr>
           <a:xfrm>
-            <a:off x="3261360" y="2395728"/>
-            <a:ext cx="2657856" cy="182880"/>
+            <a:off x="3261360" y="2368296"/>
+            <a:ext cx="2657856" cy="128016"/>
           </a:xfrm>
           <a:prstGeom prst="rect">
             <a:avLst/>
@@ -6524,7 +6524,7 @@
               <a:buNone/>
             </a:pPr>
             <a:r>
-              <a:rPr lang="en-US" sz="750" dirty="0">
+              <a:rPr lang="en-US" sz="700" dirty="0">
                 <a:solidFill>
                   <a:srgbClr val="575A5D"/>
                 </a:solidFill>
@@ -6534,7 +6534,7 @@
               </a:rPr>
               <a:t>PM, Go-to-Market &amp; Visualization</a:t>
             </a:r>
-            <a:endParaRPr lang="en-US" sz="750" dirty="0"/>
+            <a:endParaRPr lang="en-US" sz="700" dirty="0"/>
           </a:p>
         </p:txBody>
       </p:sp>
@@ -6546,7 +6546,7 @@
         </p:nvSpPr>
         <p:spPr>
           <a:xfrm>
-            <a:off x="3261360" y="2724912"/>
+            <a:off x="3261360" y="2478024"/>
             <a:ext cx="497434" cy="100584"/>
           </a:xfrm>
           <a:prstGeom prst="rect">
@@ -6573,7 +6573,7 @@
         </p:nvSpPr>
         <p:spPr>
           <a:xfrm>
-            <a:off x="3261360" y="2724912"/>
+            <a:off x="3261360" y="2478024"/>
             <a:ext cx="497434" cy="100584"/>
           </a:xfrm>
           <a:prstGeom prst="rect">
@@ -6612,8 +6612,8 @@
         </p:nvSpPr>
         <p:spPr>
           <a:xfrm>
-            <a:off x="3169920" y="2907792"/>
-            <a:ext cx="2804160" cy="694944"/>
+            <a:off x="3169920" y="2651760"/>
+            <a:ext cx="2804160" cy="438912"/>
           </a:xfrm>
           <a:prstGeom prst="rect">
             <a:avLst/>
@@ -6637,8 +6637,8 @@
         </p:nvSpPr>
         <p:spPr>
           <a:xfrm>
-            <a:off x="3169920" y="2907792"/>
-            <a:ext cx="50292" cy="694944"/>
+            <a:off x="3169920" y="2651760"/>
+            <a:ext cx="50292" cy="438912"/>
           </a:xfrm>
           <a:prstGeom prst="rect">
             <a:avLst/>
@@ -6662,8 +6662,8 @@
         </p:nvSpPr>
         <p:spPr>
           <a:xfrm>
-            <a:off x="3261360" y="2944368"/>
-            <a:ext cx="2657856" cy="201168"/>
+            <a:off x="3261360" y="2679192"/>
+            <a:ext cx="2657856" cy="164592"/>
           </a:xfrm>
           <a:prstGeom prst="rect">
             <a:avLst/>
@@ -6701,8 +6701,8 @@
         </p:nvSpPr>
         <p:spPr>
           <a:xfrm>
-            <a:off x="3261360" y="3145536"/>
-            <a:ext cx="2657856" cy="182880"/>
+            <a:off x="3261360" y="2862072"/>
+            <a:ext cx="2657856" cy="128016"/>
           </a:xfrm>
           <a:prstGeom prst="rect">
             <a:avLst/>
@@ -6718,7 +6718,7 @@
               <a:buNone/>
             </a:pPr>
             <a:r>
-              <a:rPr lang="en-US" sz="750" dirty="0">
+              <a:rPr lang="en-US" sz="700" dirty="0">
                 <a:solidFill>
                   <a:srgbClr val="575A5D"/>
                 </a:solidFill>
@@ -6728,7 +6728,7 @@
               </a:rPr>
               <a:t>PM, Application Development</a:t>
             </a:r>
-            <a:endParaRPr lang="en-US" sz="750" dirty="0"/>
+            <a:endParaRPr lang="en-US" sz="700" dirty="0"/>
           </a:p>
         </p:txBody>
       </p:sp>
@@ -6740,7 +6740,7 @@
         </p:nvSpPr>
         <p:spPr>
           <a:xfrm>
-            <a:off x="3261360" y="3474720"/>
+            <a:off x="3261360" y="2971800"/>
             <a:ext cx="541325" cy="100584"/>
           </a:xfrm>
           <a:prstGeom prst="rect">
@@ -6767,7 +6767,7 @@
         </p:nvSpPr>
         <p:spPr>
           <a:xfrm>
-            <a:off x="3261360" y="3474720"/>
+            <a:off x="3261360" y="2971800"/>
             <a:ext cx="541325" cy="100584"/>
           </a:xfrm>
           <a:prstGeom prst="rect">
@@ -6806,8 +6806,8 @@
         </p:nvSpPr>
         <p:spPr>
           <a:xfrm>
-            <a:off x="3169920" y="3657600"/>
-            <a:ext cx="2804160" cy="694944"/>
+            <a:off x="3169920" y="3145536"/>
+            <a:ext cx="2804160" cy="438912"/>
           </a:xfrm>
           <a:prstGeom prst="rect">
             <a:avLst/>
@@ -6831,8 +6831,8 @@
         </p:nvSpPr>
         <p:spPr>
           <a:xfrm>
-            <a:off x="3169920" y="3657600"/>
-            <a:ext cx="50292" cy="694944"/>
+            <a:off x="3169920" y="3145536"/>
+            <a:ext cx="50292" cy="438912"/>
           </a:xfrm>
           <a:prstGeom prst="rect">
             <a:avLst/>
@@ -6856,8 +6856,8 @@
         </p:nvSpPr>
         <p:spPr>
           <a:xfrm>
-            <a:off x="3261360" y="3694176"/>
-            <a:ext cx="2657856" cy="201168"/>
+            <a:off x="3261360" y="3172968"/>
+            <a:ext cx="2657856" cy="164592"/>
           </a:xfrm>
           <a:prstGeom prst="rect">
             <a:avLst/>
@@ -6895,8 +6895,8 @@
         </p:nvSpPr>
         <p:spPr>
           <a:xfrm>
-            <a:off x="3261360" y="3895344"/>
-            <a:ext cx="2657856" cy="182880"/>
+            <a:off x="3261360" y="3355848"/>
+            <a:ext cx="2657856" cy="128016"/>
           </a:xfrm>
           <a:prstGeom prst="rect">
             <a:avLst/>
@@ -6912,7 +6912,7 @@
               <a:buNone/>
             </a:pPr>
             <a:r>
-              <a:rPr lang="en-US" sz="750" dirty="0">
+              <a:rPr lang="en-US" sz="700" dirty="0">
                 <a:solidFill>
                   <a:srgbClr val="575A5D"/>
                 </a:solidFill>
@@ -6922,7 +6922,7 @@
               </a:rPr>
               <a:t>PM, Data Acq. &amp; Engineering</a:t>
             </a:r>
-            <a:endParaRPr lang="en-US" sz="750" dirty="0"/>
+            <a:endParaRPr lang="en-US" sz="700" dirty="0"/>
           </a:p>
         </p:txBody>
       </p:sp>
@@ -6934,7 +6934,7 @@
         </p:nvSpPr>
         <p:spPr>
           <a:xfrm>
-            <a:off x="3261360" y="4224528"/>
+            <a:off x="3261360" y="3465576"/>
             <a:ext cx="585216" cy="100584"/>
           </a:xfrm>
           <a:prstGeom prst="rect">
@@ -6961,7 +6961,7 @@
         </p:nvSpPr>
         <p:spPr>
           <a:xfrm>
-            <a:off x="3261360" y="4224528"/>
+            <a:off x="3261360" y="3465576"/>
             <a:ext cx="585216" cy="100584"/>
           </a:xfrm>
           <a:prstGeom prst="rect">
@@ -6995,6 +6995,464 @@
       <p:sp>
         <p:nvSpPr>
           <p:cNvPr id="105" name="Shape 103"/>
+          <p:cNvSpPr/>
+          <p:nvPr/>
+        </p:nvSpPr>
+        <p:spPr>
+          <a:xfrm>
+            <a:off x="3169920" y="3639312"/>
+            <a:ext cx="2804160" cy="621792"/>
+          </a:xfrm>
+          <a:prstGeom prst="rect">
+            <a:avLst/>
+          </a:prstGeom>
+          <a:solidFill>
+            <a:srgbClr val="FFFFFF"/>
+          </a:solidFill>
+          <a:ln w="9525">
+            <a:solidFill>
+              <a:srgbClr val="0A5CA8"/>
+            </a:solidFill>
+            <a:prstDash val="solid"/>
+          </a:ln>
+        </p:spPr>
+      </p:sp>
+      <p:sp>
+        <p:nvSpPr>
+          <p:cNvPr id="106" name="Shape 104"/>
+          <p:cNvSpPr/>
+          <p:nvPr/>
+        </p:nvSpPr>
+        <p:spPr>
+          <a:xfrm>
+            <a:off x="3169920" y="3639312"/>
+            <a:ext cx="50292" cy="621792"/>
+          </a:xfrm>
+          <a:prstGeom prst="rect">
+            <a:avLst/>
+          </a:prstGeom>
+          <a:solidFill>
+            <a:srgbClr val="0A5CA8"/>
+          </a:solidFill>
+          <a:ln w="12700">
+            <a:solidFill>
+              <a:srgbClr val="0A5CA8"/>
+            </a:solidFill>
+            <a:prstDash val="solid"/>
+          </a:ln>
+        </p:spPr>
+      </p:sp>
+      <p:sp>
+        <p:nvSpPr>
+          <p:cNvPr id="107" name="Text 105"/>
+          <p:cNvSpPr/>
+          <p:nvPr/>
+        </p:nvSpPr>
+        <p:spPr>
+          <a:xfrm>
+            <a:off x="3261360" y="3666744"/>
+            <a:ext cx="2657856" cy="128016"/>
+          </a:xfrm>
+          <a:prstGeom prst="rect">
+            <a:avLst/>
+          </a:prstGeom>
+          <a:noFill/>
+          <a:ln/>
+        </p:spPr>
+        <p:txBody>
+          <a:bodyPr wrap="square" rtlCol="0" anchor="ctr"/>
+          <a:lstStyle/>
+          <a:p>
+            <a:pPr indent="0" marL="0">
+              <a:buNone/>
+            </a:pPr>
+            <a:r>
+              <a:rPr lang="en-US" sz="750" b="1" dirty="0">
+                <a:solidFill>
+                  <a:srgbClr val="06185F"/>
+                </a:solidFill>
+                <a:latin typeface="Calibri" pitchFamily="34" charset="0"/>
+                <a:ea typeface="Calibri" pitchFamily="34" charset="-122"/>
+                <a:cs typeface="Calibri" pitchFamily="34" charset="-120"/>
+              </a:rPr>
+              <a:t>[PM Function TBD]</a:t>
+            </a:r>
+            <a:endParaRPr lang="en-US" sz="750" dirty="0"/>
+          </a:p>
+        </p:txBody>
+      </p:sp>
+      <p:sp>
+        <p:nvSpPr>
+          <p:cNvPr id="108" name="Shape 106"/>
+          <p:cNvSpPr/>
+          <p:nvPr/>
+        </p:nvSpPr>
+        <p:spPr>
+          <a:xfrm>
+            <a:off x="3243072" y="3813048"/>
+            <a:ext cx="2657856" cy="0"/>
+          </a:xfrm>
+          <a:prstGeom prst="line">
+            <a:avLst/>
+          </a:prstGeom>
+          <a:noFill/>
+          <a:ln w="6350">
+            <a:solidFill>
+              <a:srgbClr val="E7ECF0"/>
+            </a:solidFill>
+            <a:prstDash val="solid"/>
+          </a:ln>
+        </p:spPr>
+      </p:sp>
+      <p:sp>
+        <p:nvSpPr>
+          <p:cNvPr id="109" name="Text 107"/>
+          <p:cNvSpPr/>
+          <p:nvPr/>
+        </p:nvSpPr>
+        <p:spPr>
+          <a:xfrm>
+            <a:off x="3220212" y="3831336"/>
+            <a:ext cx="917956" cy="182880"/>
+          </a:xfrm>
+          <a:prstGeom prst="rect">
+            <a:avLst/>
+          </a:prstGeom>
+          <a:noFill/>
+          <a:ln/>
+        </p:spPr>
+        <p:txBody>
+          <a:bodyPr wrap="square" rtlCol="0" anchor="ctr"/>
+          <a:lstStyle/>
+          <a:p>
+            <a:pPr algn="ctr" indent="0" marL="0">
+              <a:buNone/>
+            </a:pPr>
+            <a:r>
+              <a:rPr lang="en-US" sz="1300" b="1" dirty="0">
+                <a:solidFill>
+                  <a:srgbClr val="06185F"/>
+                </a:solidFill>
+                <a:latin typeface="Calibri" pitchFamily="34" charset="0"/>
+                <a:ea typeface="Calibri" pitchFamily="34" charset="-122"/>
+                <a:cs typeface="Calibri" pitchFamily="34" charset="-120"/>
+              </a:rPr>
+              <a:t>—</a:t>
+            </a:r>
+            <a:endParaRPr lang="en-US" sz="1300" dirty="0"/>
+          </a:p>
+        </p:txBody>
+      </p:sp>
+      <p:sp>
+        <p:nvSpPr>
+          <p:cNvPr id="110" name="Text 108"/>
+          <p:cNvSpPr/>
+          <p:nvPr/>
+        </p:nvSpPr>
+        <p:spPr>
+          <a:xfrm>
+            <a:off x="3220212" y="4023360"/>
+            <a:ext cx="917956" cy="91440"/>
+          </a:xfrm>
+          <a:prstGeom prst="rect">
+            <a:avLst/>
+          </a:prstGeom>
+          <a:noFill/>
+          <a:ln/>
+        </p:spPr>
+        <p:txBody>
+          <a:bodyPr wrap="square" rtlCol="0" anchor="ctr"/>
+          <a:lstStyle/>
+          <a:p>
+            <a:pPr algn="ctr" indent="0" marL="0">
+              <a:buNone/>
+            </a:pPr>
+            <a:r>
+              <a:rPr lang="en-US" sz="550" dirty="0">
+                <a:solidFill>
+                  <a:srgbClr val="575A5D"/>
+                </a:solidFill>
+                <a:latin typeface="Calibri" pitchFamily="34" charset="0"/>
+                <a:ea typeface="Calibri" pitchFamily="34" charset="-122"/>
+                <a:cs typeface="Calibri" pitchFamily="34" charset="-120"/>
+              </a:rPr>
+              <a:t>Existing FTEs</a:t>
+            </a:r>
+            <a:endParaRPr lang="en-US" sz="550" dirty="0"/>
+          </a:p>
+        </p:txBody>
+      </p:sp>
+      <p:sp>
+        <p:nvSpPr>
+          <p:cNvPr id="111" name="Shape 109"/>
+          <p:cNvSpPr/>
+          <p:nvPr/>
+        </p:nvSpPr>
+        <p:spPr>
+          <a:xfrm>
+            <a:off x="4138168" y="3831336"/>
+            <a:ext cx="0" cy="320040"/>
+          </a:xfrm>
+          <a:prstGeom prst="line">
+            <a:avLst/>
+          </a:prstGeom>
+          <a:noFill/>
+          <a:ln w="6350">
+            <a:solidFill>
+              <a:srgbClr val="E7ECF0"/>
+            </a:solidFill>
+            <a:prstDash val="solid"/>
+          </a:ln>
+        </p:spPr>
+      </p:sp>
+      <p:sp>
+        <p:nvSpPr>
+          <p:cNvPr id="112" name="Text 110"/>
+          <p:cNvSpPr/>
+          <p:nvPr/>
+        </p:nvSpPr>
+        <p:spPr>
+          <a:xfrm>
+            <a:off x="4138168" y="3831336"/>
+            <a:ext cx="917956" cy="182880"/>
+          </a:xfrm>
+          <a:prstGeom prst="rect">
+            <a:avLst/>
+          </a:prstGeom>
+          <a:noFill/>
+          <a:ln/>
+        </p:spPr>
+        <p:txBody>
+          <a:bodyPr wrap="square" rtlCol="0" anchor="ctr"/>
+          <a:lstStyle/>
+          <a:p>
+            <a:pPr algn="ctr" indent="0" marL="0">
+              <a:buNone/>
+            </a:pPr>
+            <a:r>
+              <a:rPr lang="en-US" sz="1300" b="1" dirty="0">
+                <a:solidFill>
+                  <a:srgbClr val="0A5CA8"/>
+                </a:solidFill>
+                <a:latin typeface="Calibri" pitchFamily="34" charset="0"/>
+                <a:ea typeface="Calibri" pitchFamily="34" charset="-122"/>
+                <a:cs typeface="Calibri" pitchFamily="34" charset="-120"/>
+              </a:rPr>
+              <a:t>—</a:t>
+            </a:r>
+            <a:endParaRPr lang="en-US" sz="1300" dirty="0"/>
+          </a:p>
+        </p:txBody>
+      </p:sp>
+      <p:sp>
+        <p:nvSpPr>
+          <p:cNvPr id="113" name="Text 111"/>
+          <p:cNvSpPr/>
+          <p:nvPr/>
+        </p:nvSpPr>
+        <p:spPr>
+          <a:xfrm>
+            <a:off x="4138168" y="4023360"/>
+            <a:ext cx="917956" cy="91440"/>
+          </a:xfrm>
+          <a:prstGeom prst="rect">
+            <a:avLst/>
+          </a:prstGeom>
+          <a:noFill/>
+          <a:ln/>
+        </p:spPr>
+        <p:txBody>
+          <a:bodyPr wrap="square" rtlCol="0" anchor="ctr"/>
+          <a:lstStyle/>
+          <a:p>
+            <a:pPr algn="ctr" indent="0" marL="0">
+              <a:buNone/>
+            </a:pPr>
+            <a:r>
+              <a:rPr lang="en-US" sz="550" dirty="0">
+                <a:solidFill>
+                  <a:srgbClr val="575A5D"/>
+                </a:solidFill>
+                <a:latin typeface="Calibri" pitchFamily="34" charset="0"/>
+                <a:ea typeface="Calibri" pitchFamily="34" charset="-122"/>
+                <a:cs typeface="Calibri" pitchFamily="34" charset="-120"/>
+              </a:rPr>
+              <a:t>Contractors</a:t>
+            </a:r>
+            <a:endParaRPr lang="en-US" sz="550" dirty="0"/>
+          </a:p>
+        </p:txBody>
+      </p:sp>
+      <p:sp>
+        <p:nvSpPr>
+          <p:cNvPr id="114" name="Shape 112"/>
+          <p:cNvSpPr/>
+          <p:nvPr/>
+        </p:nvSpPr>
+        <p:spPr>
+          <a:xfrm>
+            <a:off x="5056124" y="3831336"/>
+            <a:ext cx="0" cy="320040"/>
+          </a:xfrm>
+          <a:prstGeom prst="line">
+            <a:avLst/>
+          </a:prstGeom>
+          <a:noFill/>
+          <a:ln w="6350">
+            <a:solidFill>
+              <a:srgbClr val="E7ECF0"/>
+            </a:solidFill>
+            <a:prstDash val="solid"/>
+          </a:ln>
+        </p:spPr>
+      </p:sp>
+      <p:sp>
+        <p:nvSpPr>
+          <p:cNvPr id="115" name="Text 113"/>
+          <p:cNvSpPr/>
+          <p:nvPr/>
+        </p:nvSpPr>
+        <p:spPr>
+          <a:xfrm>
+            <a:off x="5056124" y="3831336"/>
+            <a:ext cx="917956" cy="182880"/>
+          </a:xfrm>
+          <a:prstGeom prst="rect">
+            <a:avLst/>
+          </a:prstGeom>
+          <a:noFill/>
+          <a:ln/>
+        </p:spPr>
+        <p:txBody>
+          <a:bodyPr wrap="square" rtlCol="0" anchor="ctr"/>
+          <a:lstStyle/>
+          <a:p>
+            <a:pPr algn="ctr" indent="0" marL="0">
+              <a:buNone/>
+            </a:pPr>
+            <a:r>
+              <a:rPr lang="en-US" sz="1300" b="1" dirty="0">
+                <a:solidFill>
+                  <a:srgbClr val="0A5C47"/>
+                </a:solidFill>
+                <a:latin typeface="Calibri" pitchFamily="34" charset="0"/>
+                <a:ea typeface="Calibri" pitchFamily="34" charset="-122"/>
+                <a:cs typeface="Calibri" pitchFamily="34" charset="-120"/>
+              </a:rPr>
+              <a:t>—</a:t>
+            </a:r>
+            <a:endParaRPr lang="en-US" sz="1300" dirty="0"/>
+          </a:p>
+        </p:txBody>
+      </p:sp>
+      <p:sp>
+        <p:nvSpPr>
+          <p:cNvPr id="116" name="Text 114"/>
+          <p:cNvSpPr/>
+          <p:nvPr/>
+        </p:nvSpPr>
+        <p:spPr>
+          <a:xfrm>
+            <a:off x="5056124" y="4023360"/>
+            <a:ext cx="917956" cy="91440"/>
+          </a:xfrm>
+          <a:prstGeom prst="rect">
+            <a:avLst/>
+          </a:prstGeom>
+          <a:noFill/>
+          <a:ln/>
+        </p:spPr>
+        <p:txBody>
+          <a:bodyPr wrap="square" rtlCol="0" anchor="ctr"/>
+          <a:lstStyle/>
+          <a:p>
+            <a:pPr algn="ctr" indent="0" marL="0">
+              <a:buNone/>
+            </a:pPr>
+            <a:r>
+              <a:rPr lang="en-US" sz="550" dirty="0">
+                <a:solidFill>
+                  <a:srgbClr val="575A5D"/>
+                </a:solidFill>
+                <a:latin typeface="Calibri" pitchFamily="34" charset="0"/>
+                <a:ea typeface="Calibri" pitchFamily="34" charset="-122"/>
+                <a:cs typeface="Calibri" pitchFamily="34" charset="-120"/>
+              </a:rPr>
+              <a:t>New FTEs Req.</a:t>
+            </a:r>
+            <a:endParaRPr lang="en-US" sz="550" dirty="0"/>
+          </a:p>
+        </p:txBody>
+      </p:sp>
+      <p:sp>
+        <p:nvSpPr>
+          <p:cNvPr id="117" name="Shape 115"/>
+          <p:cNvSpPr/>
+          <p:nvPr/>
+        </p:nvSpPr>
+        <p:spPr>
+          <a:xfrm>
+            <a:off x="3261360" y="4142232"/>
+            <a:ext cx="585216" cy="100584"/>
+          </a:xfrm>
+          <a:prstGeom prst="rect">
+            <a:avLst/>
+          </a:prstGeom>
+          <a:solidFill>
+            <a:srgbClr val="0A5C47">
+              <a:alpha val="30000"/>
+            </a:srgbClr>
+          </a:solidFill>
+          <a:ln w="6350">
+            <a:solidFill>
+              <a:srgbClr val="0A5C47"/>
+            </a:solidFill>
+            <a:prstDash val="solid"/>
+          </a:ln>
+        </p:spPr>
+      </p:sp>
+      <p:sp>
+        <p:nvSpPr>
+          <p:cNvPr id="118" name="Text 116"/>
+          <p:cNvSpPr/>
+          <p:nvPr/>
+        </p:nvSpPr>
+        <p:spPr>
+          <a:xfrm>
+            <a:off x="3261360" y="4142232"/>
+            <a:ext cx="585216" cy="100584"/>
+          </a:xfrm>
+          <a:prstGeom prst="rect">
+            <a:avLst/>
+          </a:prstGeom>
+          <a:noFill/>
+          <a:ln/>
+        </p:spPr>
+        <p:txBody>
+          <a:bodyPr wrap="square" lIns="0" tIns="0" rIns="0" bIns="0" rtlCol="0" anchor="ctr"/>
+          <a:lstStyle/>
+          <a:p>
+            <a:pPr algn="ctr" indent="0" marL="0">
+              <a:buNone/>
+            </a:pPr>
+            <a:r>
+              <a:rPr lang="en-US" sz="550" b="1" dirty="0">
+                <a:solidFill>
+                  <a:srgbClr val="0A5C47"/>
+                </a:solidFill>
+                <a:latin typeface="Calibri" pitchFamily="34" charset="0"/>
+                <a:ea typeface="Calibri" pitchFamily="34" charset="-122"/>
+                <a:cs typeface="Calibri" pitchFamily="34" charset="-120"/>
+              </a:rPr>
+              <a:t>The Engine</a:t>
+            </a:r>
+            <a:endParaRPr lang="en-US" sz="550" dirty="0"/>
+          </a:p>
+        </p:txBody>
+      </p:sp>
+      <p:sp>
+        <p:nvSpPr>
+          <p:cNvPr id="119" name="Shape 117"/>
           <p:cNvSpPr/>
           <p:nvPr/>
         </p:nvSpPr>
@@ -7017,14 +7475,472 @@
       </p:sp>
       <p:sp>
         <p:nvSpPr>
-          <p:cNvPr id="106" name="Shape 104"/>
+          <p:cNvPr id="120" name="Shape 118"/>
           <p:cNvSpPr/>
           <p:nvPr/>
         </p:nvSpPr>
         <p:spPr>
           <a:xfrm>
             <a:off x="6193536" y="2157984"/>
-            <a:ext cx="2804160" cy="694944"/>
+            <a:ext cx="2804160" cy="621792"/>
+          </a:xfrm>
+          <a:prstGeom prst="rect">
+            <a:avLst/>
+          </a:prstGeom>
+          <a:solidFill>
+            <a:srgbClr val="FFFFFF"/>
+          </a:solidFill>
+          <a:ln w="9525">
+            <a:solidFill>
+              <a:srgbClr val="0A5C47"/>
+            </a:solidFill>
+            <a:prstDash val="solid"/>
+          </a:ln>
+        </p:spPr>
+      </p:sp>
+      <p:sp>
+        <p:nvSpPr>
+          <p:cNvPr id="121" name="Shape 119"/>
+          <p:cNvSpPr/>
+          <p:nvPr/>
+        </p:nvSpPr>
+        <p:spPr>
+          <a:xfrm>
+            <a:off x="6193536" y="2157984"/>
+            <a:ext cx="50292" cy="621792"/>
+          </a:xfrm>
+          <a:prstGeom prst="rect">
+            <a:avLst/>
+          </a:prstGeom>
+          <a:solidFill>
+            <a:srgbClr val="0A5C47"/>
+          </a:solidFill>
+          <a:ln w="12700">
+            <a:solidFill>
+              <a:srgbClr val="0A5C47"/>
+            </a:solidFill>
+            <a:prstDash val="solid"/>
+          </a:ln>
+        </p:spPr>
+      </p:sp>
+      <p:sp>
+        <p:nvSpPr>
+          <p:cNvPr id="122" name="Text 120"/>
+          <p:cNvSpPr/>
+          <p:nvPr/>
+        </p:nvSpPr>
+        <p:spPr>
+          <a:xfrm>
+            <a:off x="6284976" y="2185416"/>
+            <a:ext cx="2657856" cy="128016"/>
+          </a:xfrm>
+          <a:prstGeom prst="rect">
+            <a:avLst/>
+          </a:prstGeom>
+          <a:noFill/>
+          <a:ln/>
+        </p:spPr>
+        <p:txBody>
+          <a:bodyPr wrap="square" rtlCol="0" anchor="ctr"/>
+          <a:lstStyle/>
+          <a:p>
+            <a:pPr indent="0" marL="0">
+              <a:buNone/>
+            </a:pPr>
+            <a:r>
+              <a:rPr lang="en-US" sz="750" b="1" dirty="0">
+                <a:solidFill>
+                  <a:srgbClr val="06185F"/>
+                </a:solidFill>
+                <a:latin typeface="Calibri" pitchFamily="34" charset="0"/>
+                <a:ea typeface="Calibri" pitchFamily="34" charset="-122"/>
+                <a:cs typeface="Calibri" pitchFamily="34" charset="-120"/>
+              </a:rPr>
+              <a:t>Data Scientist</a:t>
+            </a:r>
+            <a:endParaRPr lang="en-US" sz="750" dirty="0"/>
+          </a:p>
+        </p:txBody>
+      </p:sp>
+      <p:sp>
+        <p:nvSpPr>
+          <p:cNvPr id="123" name="Shape 121"/>
+          <p:cNvSpPr/>
+          <p:nvPr/>
+        </p:nvSpPr>
+        <p:spPr>
+          <a:xfrm>
+            <a:off x="6266688" y="2331720"/>
+            <a:ext cx="2657856" cy="0"/>
+          </a:xfrm>
+          <a:prstGeom prst="line">
+            <a:avLst/>
+          </a:prstGeom>
+          <a:noFill/>
+          <a:ln w="6350">
+            <a:solidFill>
+              <a:srgbClr val="E7ECF0"/>
+            </a:solidFill>
+            <a:prstDash val="solid"/>
+          </a:ln>
+        </p:spPr>
+      </p:sp>
+      <p:sp>
+        <p:nvSpPr>
+          <p:cNvPr id="124" name="Text 122"/>
+          <p:cNvSpPr/>
+          <p:nvPr/>
+        </p:nvSpPr>
+        <p:spPr>
+          <a:xfrm>
+            <a:off x="6243828" y="2350008"/>
+            <a:ext cx="917956" cy="182880"/>
+          </a:xfrm>
+          <a:prstGeom prst="rect">
+            <a:avLst/>
+          </a:prstGeom>
+          <a:noFill/>
+          <a:ln/>
+        </p:spPr>
+        <p:txBody>
+          <a:bodyPr wrap="square" rtlCol="0" anchor="ctr"/>
+          <a:lstStyle/>
+          <a:p>
+            <a:pPr algn="ctr" indent="0" marL="0">
+              <a:buNone/>
+            </a:pPr>
+            <a:r>
+              <a:rPr lang="en-US" sz="1300" b="1" dirty="0">
+                <a:solidFill>
+                  <a:srgbClr val="06185F"/>
+                </a:solidFill>
+                <a:latin typeface="Calibri" pitchFamily="34" charset="0"/>
+                <a:ea typeface="Calibri" pitchFamily="34" charset="-122"/>
+                <a:cs typeface="Calibri" pitchFamily="34" charset="-120"/>
+              </a:rPr>
+              <a:t>—</a:t>
+            </a:r>
+            <a:endParaRPr lang="en-US" sz="1300" dirty="0"/>
+          </a:p>
+        </p:txBody>
+      </p:sp>
+      <p:sp>
+        <p:nvSpPr>
+          <p:cNvPr id="125" name="Text 123"/>
+          <p:cNvSpPr/>
+          <p:nvPr/>
+        </p:nvSpPr>
+        <p:spPr>
+          <a:xfrm>
+            <a:off x="6243828" y="2542032"/>
+            <a:ext cx="917956" cy="91440"/>
+          </a:xfrm>
+          <a:prstGeom prst="rect">
+            <a:avLst/>
+          </a:prstGeom>
+          <a:noFill/>
+          <a:ln/>
+        </p:spPr>
+        <p:txBody>
+          <a:bodyPr wrap="square" rtlCol="0" anchor="ctr"/>
+          <a:lstStyle/>
+          <a:p>
+            <a:pPr algn="ctr" indent="0" marL="0">
+              <a:buNone/>
+            </a:pPr>
+            <a:r>
+              <a:rPr lang="en-US" sz="550" dirty="0">
+                <a:solidFill>
+                  <a:srgbClr val="575A5D"/>
+                </a:solidFill>
+                <a:latin typeface="Calibri" pitchFamily="34" charset="0"/>
+                <a:ea typeface="Calibri" pitchFamily="34" charset="-122"/>
+                <a:cs typeface="Calibri" pitchFamily="34" charset="-120"/>
+              </a:rPr>
+              <a:t>Existing FTEs</a:t>
+            </a:r>
+            <a:endParaRPr lang="en-US" sz="550" dirty="0"/>
+          </a:p>
+        </p:txBody>
+      </p:sp>
+      <p:sp>
+        <p:nvSpPr>
+          <p:cNvPr id="126" name="Shape 124"/>
+          <p:cNvSpPr/>
+          <p:nvPr/>
+        </p:nvSpPr>
+        <p:spPr>
+          <a:xfrm>
+            <a:off x="7161784" y="2350008"/>
+            <a:ext cx="0" cy="320040"/>
+          </a:xfrm>
+          <a:prstGeom prst="line">
+            <a:avLst/>
+          </a:prstGeom>
+          <a:noFill/>
+          <a:ln w="6350">
+            <a:solidFill>
+              <a:srgbClr val="E7ECF0"/>
+            </a:solidFill>
+            <a:prstDash val="solid"/>
+          </a:ln>
+        </p:spPr>
+      </p:sp>
+      <p:sp>
+        <p:nvSpPr>
+          <p:cNvPr id="127" name="Text 125"/>
+          <p:cNvSpPr/>
+          <p:nvPr/>
+        </p:nvSpPr>
+        <p:spPr>
+          <a:xfrm>
+            <a:off x="7161784" y="2350008"/>
+            <a:ext cx="917956" cy="182880"/>
+          </a:xfrm>
+          <a:prstGeom prst="rect">
+            <a:avLst/>
+          </a:prstGeom>
+          <a:noFill/>
+          <a:ln/>
+        </p:spPr>
+        <p:txBody>
+          <a:bodyPr wrap="square" rtlCol="0" anchor="ctr"/>
+          <a:lstStyle/>
+          <a:p>
+            <a:pPr algn="ctr" indent="0" marL="0">
+              <a:buNone/>
+            </a:pPr>
+            <a:r>
+              <a:rPr lang="en-US" sz="1300" b="1" dirty="0">
+                <a:solidFill>
+                  <a:srgbClr val="0A5CA8"/>
+                </a:solidFill>
+                <a:latin typeface="Calibri" pitchFamily="34" charset="0"/>
+                <a:ea typeface="Calibri" pitchFamily="34" charset="-122"/>
+                <a:cs typeface="Calibri" pitchFamily="34" charset="-120"/>
+              </a:rPr>
+              <a:t>—</a:t>
+            </a:r>
+            <a:endParaRPr lang="en-US" sz="1300" dirty="0"/>
+          </a:p>
+        </p:txBody>
+      </p:sp>
+      <p:sp>
+        <p:nvSpPr>
+          <p:cNvPr id="128" name="Text 126"/>
+          <p:cNvSpPr/>
+          <p:nvPr/>
+        </p:nvSpPr>
+        <p:spPr>
+          <a:xfrm>
+            <a:off x="7161784" y="2542032"/>
+            <a:ext cx="917956" cy="91440"/>
+          </a:xfrm>
+          <a:prstGeom prst="rect">
+            <a:avLst/>
+          </a:prstGeom>
+          <a:noFill/>
+          <a:ln/>
+        </p:spPr>
+        <p:txBody>
+          <a:bodyPr wrap="square" rtlCol="0" anchor="ctr"/>
+          <a:lstStyle/>
+          <a:p>
+            <a:pPr algn="ctr" indent="0" marL="0">
+              <a:buNone/>
+            </a:pPr>
+            <a:r>
+              <a:rPr lang="en-US" sz="550" dirty="0">
+                <a:solidFill>
+                  <a:srgbClr val="575A5D"/>
+                </a:solidFill>
+                <a:latin typeface="Calibri" pitchFamily="34" charset="0"/>
+                <a:ea typeface="Calibri" pitchFamily="34" charset="-122"/>
+                <a:cs typeface="Calibri" pitchFamily="34" charset="-120"/>
+              </a:rPr>
+              <a:t>Contractors</a:t>
+            </a:r>
+            <a:endParaRPr lang="en-US" sz="550" dirty="0"/>
+          </a:p>
+        </p:txBody>
+      </p:sp>
+      <p:sp>
+        <p:nvSpPr>
+          <p:cNvPr id="129" name="Shape 127"/>
+          <p:cNvSpPr/>
+          <p:nvPr/>
+        </p:nvSpPr>
+        <p:spPr>
+          <a:xfrm>
+            <a:off x="8079740" y="2350008"/>
+            <a:ext cx="0" cy="320040"/>
+          </a:xfrm>
+          <a:prstGeom prst="line">
+            <a:avLst/>
+          </a:prstGeom>
+          <a:noFill/>
+          <a:ln w="6350">
+            <a:solidFill>
+              <a:srgbClr val="E7ECF0"/>
+            </a:solidFill>
+            <a:prstDash val="solid"/>
+          </a:ln>
+        </p:spPr>
+      </p:sp>
+      <p:sp>
+        <p:nvSpPr>
+          <p:cNvPr id="130" name="Text 128"/>
+          <p:cNvSpPr/>
+          <p:nvPr/>
+        </p:nvSpPr>
+        <p:spPr>
+          <a:xfrm>
+            <a:off x="8079740" y="2350008"/>
+            <a:ext cx="917956" cy="182880"/>
+          </a:xfrm>
+          <a:prstGeom prst="rect">
+            <a:avLst/>
+          </a:prstGeom>
+          <a:noFill/>
+          <a:ln/>
+        </p:spPr>
+        <p:txBody>
+          <a:bodyPr wrap="square" rtlCol="0" anchor="ctr"/>
+          <a:lstStyle/>
+          <a:p>
+            <a:pPr algn="ctr" indent="0" marL="0">
+              <a:buNone/>
+            </a:pPr>
+            <a:r>
+              <a:rPr lang="en-US" sz="1300" b="1" dirty="0">
+                <a:solidFill>
+                  <a:srgbClr val="0A5C47"/>
+                </a:solidFill>
+                <a:latin typeface="Calibri" pitchFamily="34" charset="0"/>
+                <a:ea typeface="Calibri" pitchFamily="34" charset="-122"/>
+                <a:cs typeface="Calibri" pitchFamily="34" charset="-120"/>
+              </a:rPr>
+              <a:t>—</a:t>
+            </a:r>
+            <a:endParaRPr lang="en-US" sz="1300" dirty="0"/>
+          </a:p>
+        </p:txBody>
+      </p:sp>
+      <p:sp>
+        <p:nvSpPr>
+          <p:cNvPr id="131" name="Text 129"/>
+          <p:cNvSpPr/>
+          <p:nvPr/>
+        </p:nvSpPr>
+        <p:spPr>
+          <a:xfrm>
+            <a:off x="8079740" y="2542032"/>
+            <a:ext cx="917956" cy="91440"/>
+          </a:xfrm>
+          <a:prstGeom prst="rect">
+            <a:avLst/>
+          </a:prstGeom>
+          <a:noFill/>
+          <a:ln/>
+        </p:spPr>
+        <p:txBody>
+          <a:bodyPr wrap="square" rtlCol="0" anchor="ctr"/>
+          <a:lstStyle/>
+          <a:p>
+            <a:pPr algn="ctr" indent="0" marL="0">
+              <a:buNone/>
+            </a:pPr>
+            <a:r>
+              <a:rPr lang="en-US" sz="550" dirty="0">
+                <a:solidFill>
+                  <a:srgbClr val="575A5D"/>
+                </a:solidFill>
+                <a:latin typeface="Calibri" pitchFamily="34" charset="0"/>
+                <a:ea typeface="Calibri" pitchFamily="34" charset="-122"/>
+                <a:cs typeface="Calibri" pitchFamily="34" charset="-120"/>
+              </a:rPr>
+              <a:t>New FTEs Req.</a:t>
+            </a:r>
+            <a:endParaRPr lang="en-US" sz="550" dirty="0"/>
+          </a:p>
+        </p:txBody>
+      </p:sp>
+      <p:sp>
+        <p:nvSpPr>
+          <p:cNvPr id="132" name="Shape 130"/>
+          <p:cNvSpPr/>
+          <p:nvPr/>
+        </p:nvSpPr>
+        <p:spPr>
+          <a:xfrm>
+            <a:off x="6284976" y="2660904"/>
+            <a:ext cx="585216" cy="100584"/>
+          </a:xfrm>
+          <a:prstGeom prst="rect">
+            <a:avLst/>
+          </a:prstGeom>
+          <a:solidFill>
+            <a:srgbClr val="0A5C47">
+              <a:alpha val="30000"/>
+            </a:srgbClr>
+          </a:solidFill>
+          <a:ln w="6350">
+            <a:solidFill>
+              <a:srgbClr val="0A5C47"/>
+            </a:solidFill>
+            <a:prstDash val="solid"/>
+          </a:ln>
+        </p:spPr>
+      </p:sp>
+      <p:sp>
+        <p:nvSpPr>
+          <p:cNvPr id="133" name="Text 131"/>
+          <p:cNvSpPr/>
+          <p:nvPr/>
+        </p:nvSpPr>
+        <p:spPr>
+          <a:xfrm>
+            <a:off x="6284976" y="2660904"/>
+            <a:ext cx="585216" cy="100584"/>
+          </a:xfrm>
+          <a:prstGeom prst="rect">
+            <a:avLst/>
+          </a:prstGeom>
+          <a:noFill/>
+          <a:ln/>
+        </p:spPr>
+        <p:txBody>
+          <a:bodyPr wrap="square" lIns="0" tIns="0" rIns="0" bIns="0" rtlCol="0" anchor="ctr"/>
+          <a:lstStyle/>
+          <a:p>
+            <a:pPr algn="ctr" indent="0" marL="0">
+              <a:buNone/>
+            </a:pPr>
+            <a:r>
+              <a:rPr lang="en-US" sz="550" b="1" dirty="0">
+                <a:solidFill>
+                  <a:srgbClr val="0A5C47"/>
+                </a:solidFill>
+                <a:latin typeface="Calibri" pitchFamily="34" charset="0"/>
+                <a:ea typeface="Calibri" pitchFamily="34" charset="-122"/>
+                <a:cs typeface="Calibri" pitchFamily="34" charset="-120"/>
+              </a:rPr>
+              <a:t>The Engine</a:t>
+            </a:r>
+            <a:endParaRPr lang="en-US" sz="550" dirty="0"/>
+          </a:p>
+        </p:txBody>
+      </p:sp>
+      <p:sp>
+        <p:nvSpPr>
+          <p:cNvPr id="134" name="Shape 132"/>
+          <p:cNvSpPr/>
+          <p:nvPr/>
+        </p:nvSpPr>
+        <p:spPr>
+          <a:xfrm>
+            <a:off x="6193536" y="2834640"/>
+            <a:ext cx="2804160" cy="457200"/>
           </a:xfrm>
           <a:prstGeom prst="rect">
             <a:avLst/>
@@ -7044,14 +7960,14 @@
       </p:sp>
       <p:sp>
         <p:nvSpPr>
-          <p:cNvPr id="107" name="Shape 105"/>
-          <p:cNvSpPr/>
-          <p:nvPr/>
-        </p:nvSpPr>
-        <p:spPr>
-          <a:xfrm>
-            <a:off x="6193536" y="2157984"/>
-            <a:ext cx="50292" cy="694944"/>
+          <p:cNvPr id="135" name="Shape 133"/>
+          <p:cNvSpPr/>
+          <p:nvPr/>
+        </p:nvSpPr>
+        <p:spPr>
+          <a:xfrm>
+            <a:off x="6193536" y="2834640"/>
+            <a:ext cx="50292" cy="457200"/>
           </a:xfrm>
           <a:prstGeom prst="rect">
             <a:avLst/>
@@ -7073,14 +7989,14 @@
       </p:sp>
       <p:sp>
         <p:nvSpPr>
-          <p:cNvPr id="108" name="Text 106"/>
-          <p:cNvSpPr/>
-          <p:nvPr/>
-        </p:nvSpPr>
-        <p:spPr>
-          <a:xfrm>
-            <a:off x="6284976" y="2194560"/>
-            <a:ext cx="2328672" cy="201168"/>
+          <p:cNvPr id="136" name="Text 134"/>
+          <p:cNvSpPr/>
+          <p:nvPr/>
+        </p:nvSpPr>
+        <p:spPr>
+          <a:xfrm>
+            <a:off x="6284976" y="2862072"/>
+            <a:ext cx="2328672" cy="182880"/>
           </a:xfrm>
           <a:prstGeom prst="rect">
             <a:avLst/>
@@ -7104,7 +8020,7 @@
                 <a:ea typeface="Calibri" pitchFamily="34" charset="-122"/>
                 <a:cs typeface="Calibri" pitchFamily="34" charset="-120"/>
               </a:rPr>
-              <a:t>Data Scientist</a:t>
+              <a:t>MLOps Engineer</a:t>
             </a:r>
             <a:endParaRPr lang="en-US" sz="850" dirty="0"/>
           </a:p>
@@ -7112,13 +8028,13 @@
       </p:sp>
       <p:sp>
         <p:nvSpPr>
-          <p:cNvPr id="109" name="Shape 107"/>
-          <p:cNvSpPr/>
-          <p:nvPr/>
-        </p:nvSpPr>
-        <p:spPr>
-          <a:xfrm>
-            <a:off x="8595360" y="2212848"/>
+          <p:cNvPr id="137" name="Shape 135"/>
+          <p:cNvSpPr/>
+          <p:nvPr/>
+        </p:nvSpPr>
+        <p:spPr>
+          <a:xfrm>
+            <a:off x="8595360" y="2880360"/>
             <a:ext cx="347472" cy="182880"/>
           </a:xfrm>
           <a:prstGeom prst="rect">
@@ -7137,13 +8053,13 @@
       </p:sp>
       <p:sp>
         <p:nvSpPr>
-          <p:cNvPr id="110" name="Text 108"/>
-          <p:cNvSpPr/>
-          <p:nvPr/>
-        </p:nvSpPr>
-        <p:spPr>
-          <a:xfrm>
-            <a:off x="8595360" y="2212848"/>
+          <p:cNvPr id="138" name="Text 136"/>
+          <p:cNvSpPr/>
+          <p:nvPr/>
+        </p:nvSpPr>
+        <p:spPr>
+          <a:xfrm>
+            <a:off x="8595360" y="2880360"/>
             <a:ext cx="347472" cy="182880"/>
           </a:xfrm>
           <a:prstGeom prst="rect">
@@ -7168,7 +8084,7 @@
                 <a:ea typeface="Calibri" pitchFamily="34" charset="-122"/>
                 <a:cs typeface="Calibri" pitchFamily="34" charset="-120"/>
               </a:rPr>
-              <a:t>4</a:t>
+              <a:t>1</a:t>
             </a:r>
             <a:endParaRPr lang="en-US" sz="750" dirty="0"/>
           </a:p>
@@ -7176,14 +8092,14 @@
       </p:sp>
       <p:sp>
         <p:nvSpPr>
-          <p:cNvPr id="111" name="Text 109"/>
-          <p:cNvSpPr/>
-          <p:nvPr/>
-        </p:nvSpPr>
-        <p:spPr>
-          <a:xfrm>
-            <a:off x="6284976" y="2395728"/>
-            <a:ext cx="2657856" cy="164592"/>
+          <p:cNvPr id="139" name="Text 137"/>
+          <p:cNvSpPr/>
+          <p:nvPr/>
+        </p:nvSpPr>
+        <p:spPr>
+          <a:xfrm>
+            <a:off x="6284976" y="3081528"/>
+            <a:ext cx="2657856" cy="118872"/>
           </a:xfrm>
           <a:prstGeom prst="rect">
             <a:avLst/>
@@ -7201,13 +8117,13 @@
             <a:r>
               <a:rPr lang="en-US" sz="700" i="1" dirty="0">
                 <a:solidFill>
-                  <a:srgbClr val="575A5D"/>
-                </a:solidFill>
-                <a:latin typeface="Calibri" pitchFamily="34" charset="0"/>
-                <a:ea typeface="Calibri" pitchFamily="34" charset="-122"/>
-                <a:cs typeface="Calibri" pitchFamily="34" charset="-120"/>
-              </a:rPr>
-              <a:t>Open Positions</a:t>
+                  <a:srgbClr val="0A5CA8"/>
+                </a:solidFill>
+                <a:latin typeface="Calibri" pitchFamily="34" charset="0"/>
+                <a:ea typeface="Calibri" pitchFamily="34" charset="-122"/>
+                <a:cs typeface="Calibri" pitchFamily="34" charset="-120"/>
+              </a:rPr>
+              <a:t>Open Position · FY26</a:t>
             </a:r>
             <a:endParaRPr lang="en-US" sz="700" dirty="0"/>
           </a:p>
@@ -7215,13 +8131,13 @@
       </p:sp>
       <p:sp>
         <p:nvSpPr>
-          <p:cNvPr id="112" name="Shape 110"/>
-          <p:cNvSpPr/>
-          <p:nvPr/>
-        </p:nvSpPr>
-        <p:spPr>
-          <a:xfrm>
-            <a:off x="6284976" y="2724912"/>
+          <p:cNvPr id="140" name="Shape 138"/>
+          <p:cNvSpPr/>
+          <p:nvPr/>
+        </p:nvSpPr>
+        <p:spPr>
+          <a:xfrm>
+            <a:off x="6284976" y="3172968"/>
             <a:ext cx="585216" cy="100584"/>
           </a:xfrm>
           <a:prstGeom prst="rect">
@@ -7242,13 +8158,13 @@
       </p:sp>
       <p:sp>
         <p:nvSpPr>
-          <p:cNvPr id="113" name="Text 111"/>
-          <p:cNvSpPr/>
-          <p:nvPr/>
-        </p:nvSpPr>
-        <p:spPr>
-          <a:xfrm>
-            <a:off x="6284976" y="2724912"/>
+          <p:cNvPr id="141" name="Text 139"/>
+          <p:cNvSpPr/>
+          <p:nvPr/>
+        </p:nvSpPr>
+        <p:spPr>
+          <a:xfrm>
+            <a:off x="6284976" y="3172968"/>
             <a:ext cx="585216" cy="100584"/>
           </a:xfrm>
           <a:prstGeom prst="rect">
@@ -7281,70 +8197,14 @@
       </p:sp>
       <p:sp>
         <p:nvSpPr>
-          <p:cNvPr id="114" name="Shape 112"/>
-          <p:cNvSpPr/>
-          <p:nvPr/>
-        </p:nvSpPr>
-        <p:spPr>
-          <a:xfrm>
-            <a:off x="6193536" y="2907792"/>
-            <a:ext cx="2804160" cy="694944"/>
-          </a:xfrm>
-          <a:prstGeom prst="rect">
-            <a:avLst/>
-          </a:prstGeom>
-          <a:solidFill>
-            <a:srgbClr val="E7ECF0">
-              <a:alpha val="80000"/>
-            </a:srgbClr>
-          </a:solidFill>
-          <a:ln w="9525">
-            <a:solidFill>
-              <a:srgbClr val="0A5C47"/>
-            </a:solidFill>
-            <a:prstDash val="solid"/>
-          </a:ln>
-        </p:spPr>
-      </p:sp>
-      <p:sp>
-        <p:nvSpPr>
-          <p:cNvPr id="115" name="Shape 113"/>
-          <p:cNvSpPr/>
-          <p:nvPr/>
-        </p:nvSpPr>
-        <p:spPr>
-          <a:xfrm>
-            <a:off x="6193536" y="2907792"/>
-            <a:ext cx="50292" cy="694944"/>
-          </a:xfrm>
-          <a:prstGeom prst="rect">
-            <a:avLst/>
-          </a:prstGeom>
-          <a:solidFill>
-            <a:srgbClr val="0A5C47">
-              <a:alpha val="70000"/>
-            </a:srgbClr>
-          </a:solidFill>
-          <a:ln w="12700">
-            <a:solidFill>
-              <a:srgbClr val="0A5C47">
-                <a:alpha val="70000"/>
-              </a:srgbClr>
-            </a:solidFill>
-            <a:prstDash val="solid"/>
-          </a:ln>
-        </p:spPr>
-      </p:sp>
-      <p:sp>
-        <p:nvSpPr>
-          <p:cNvPr id="116" name="Text 114"/>
-          <p:cNvSpPr/>
-          <p:nvPr/>
-        </p:nvSpPr>
-        <p:spPr>
-          <a:xfrm>
-            <a:off x="6284976" y="2944368"/>
-            <a:ext cx="2328672" cy="201168"/>
+          <p:cNvPr id="142" name="Text 140"/>
+          <p:cNvSpPr/>
+          <p:nvPr/>
+        </p:nvSpPr>
+        <p:spPr>
+          <a:xfrm>
+            <a:off x="365760" y="4169664"/>
+            <a:ext cx="2743200" cy="128016"/>
           </a:xfrm>
           <a:prstGeom prst="rect">
             <a:avLst/>
@@ -7360,214 +8220,6 @@
               <a:buNone/>
             </a:pPr>
             <a:r>
-              <a:rPr lang="en-US" sz="850" b="1" dirty="0">
-                <a:solidFill>
-                  <a:srgbClr val="06185F"/>
-                </a:solidFill>
-                <a:latin typeface="Calibri" pitchFamily="34" charset="0"/>
-                <a:ea typeface="Calibri" pitchFamily="34" charset="-122"/>
-                <a:cs typeface="Calibri" pitchFamily="34" charset="-120"/>
-              </a:rPr>
-              <a:t>MLOps Engineer</a:t>
-            </a:r>
-            <a:endParaRPr lang="en-US" sz="850" dirty="0"/>
-          </a:p>
-        </p:txBody>
-      </p:sp>
-      <p:sp>
-        <p:nvSpPr>
-          <p:cNvPr id="117" name="Shape 115"/>
-          <p:cNvSpPr/>
-          <p:nvPr/>
-        </p:nvSpPr>
-        <p:spPr>
-          <a:xfrm>
-            <a:off x="8595360" y="2962656"/>
-            <a:ext cx="347472" cy="182880"/>
-          </a:xfrm>
-          <a:prstGeom prst="rect">
-            <a:avLst/>
-          </a:prstGeom>
-          <a:solidFill>
-            <a:srgbClr val="0A5C47"/>
-          </a:solidFill>
-          <a:ln w="12700">
-            <a:solidFill>
-              <a:srgbClr val="0A5C47"/>
-            </a:solidFill>
-            <a:prstDash val="solid"/>
-          </a:ln>
-        </p:spPr>
-      </p:sp>
-      <p:sp>
-        <p:nvSpPr>
-          <p:cNvPr id="118" name="Text 116"/>
-          <p:cNvSpPr/>
-          <p:nvPr/>
-        </p:nvSpPr>
-        <p:spPr>
-          <a:xfrm>
-            <a:off x="8595360" y="2962656"/>
-            <a:ext cx="347472" cy="182880"/>
-          </a:xfrm>
-          <a:prstGeom prst="rect">
-            <a:avLst/>
-          </a:prstGeom>
-          <a:noFill/>
-          <a:ln/>
-        </p:spPr>
-        <p:txBody>
-          <a:bodyPr wrap="square" lIns="0" tIns="0" rIns="0" bIns="0" rtlCol="0" anchor="ctr"/>
-          <a:lstStyle/>
-          <a:p>
-            <a:pPr algn="ctr" indent="0" marL="0">
-              <a:buNone/>
-            </a:pPr>
-            <a:r>
-              <a:rPr lang="en-US" sz="750" b="1" dirty="0">
-                <a:solidFill>
-                  <a:srgbClr val="FFFFFF"/>
-                </a:solidFill>
-                <a:latin typeface="Calibri" pitchFamily="34" charset="0"/>
-                <a:ea typeface="Calibri" pitchFamily="34" charset="-122"/>
-                <a:cs typeface="Calibri" pitchFamily="34" charset="-120"/>
-              </a:rPr>
-              <a:t>1</a:t>
-            </a:r>
-            <a:endParaRPr lang="en-US" sz="750" dirty="0"/>
-          </a:p>
-        </p:txBody>
-      </p:sp>
-      <p:sp>
-        <p:nvSpPr>
-          <p:cNvPr id="119" name="Text 117"/>
-          <p:cNvSpPr/>
-          <p:nvPr/>
-        </p:nvSpPr>
-        <p:spPr>
-          <a:xfrm>
-            <a:off x="6284976" y="3145536"/>
-            <a:ext cx="2657856" cy="164592"/>
-          </a:xfrm>
-          <a:prstGeom prst="rect">
-            <a:avLst/>
-          </a:prstGeom>
-          <a:noFill/>
-          <a:ln/>
-        </p:spPr>
-        <p:txBody>
-          <a:bodyPr wrap="square" rtlCol="0" anchor="ctr"/>
-          <a:lstStyle/>
-          <a:p>
-            <a:pPr indent="0" marL="0">
-              <a:buNone/>
-            </a:pPr>
-            <a:r>
-              <a:rPr lang="en-US" sz="700" i="1" dirty="0">
-                <a:solidFill>
-                  <a:srgbClr val="0A5CA8"/>
-                </a:solidFill>
-                <a:latin typeface="Calibri" pitchFamily="34" charset="0"/>
-                <a:ea typeface="Calibri" pitchFamily="34" charset="-122"/>
-                <a:cs typeface="Calibri" pitchFamily="34" charset="-120"/>
-              </a:rPr>
-              <a:t>Open Position · FY26</a:t>
-            </a:r>
-            <a:endParaRPr lang="en-US" sz="700" dirty="0"/>
-          </a:p>
-        </p:txBody>
-      </p:sp>
-      <p:sp>
-        <p:nvSpPr>
-          <p:cNvPr id="120" name="Shape 118"/>
-          <p:cNvSpPr/>
-          <p:nvPr/>
-        </p:nvSpPr>
-        <p:spPr>
-          <a:xfrm>
-            <a:off x="6284976" y="3474720"/>
-            <a:ext cx="585216" cy="100584"/>
-          </a:xfrm>
-          <a:prstGeom prst="rect">
-            <a:avLst/>
-          </a:prstGeom>
-          <a:solidFill>
-            <a:srgbClr val="0A5C47">
-              <a:alpha val="30000"/>
-            </a:srgbClr>
-          </a:solidFill>
-          <a:ln w="6350">
-            <a:solidFill>
-              <a:srgbClr val="0A5C47"/>
-            </a:solidFill>
-            <a:prstDash val="solid"/>
-          </a:ln>
-        </p:spPr>
-      </p:sp>
-      <p:sp>
-        <p:nvSpPr>
-          <p:cNvPr id="121" name="Text 119"/>
-          <p:cNvSpPr/>
-          <p:nvPr/>
-        </p:nvSpPr>
-        <p:spPr>
-          <a:xfrm>
-            <a:off x="6284976" y="3474720"/>
-            <a:ext cx="585216" cy="100584"/>
-          </a:xfrm>
-          <a:prstGeom prst="rect">
-            <a:avLst/>
-          </a:prstGeom>
-          <a:noFill/>
-          <a:ln/>
-        </p:spPr>
-        <p:txBody>
-          <a:bodyPr wrap="square" lIns="0" tIns="0" rIns="0" bIns="0" rtlCol="0" anchor="ctr"/>
-          <a:lstStyle/>
-          <a:p>
-            <a:pPr algn="ctr" indent="0" marL="0">
-              <a:buNone/>
-            </a:pPr>
-            <a:r>
-              <a:rPr lang="en-US" sz="550" b="1" dirty="0">
-                <a:solidFill>
-                  <a:srgbClr val="0A5C47"/>
-                </a:solidFill>
-                <a:latin typeface="Calibri" pitchFamily="34" charset="0"/>
-                <a:ea typeface="Calibri" pitchFamily="34" charset="-122"/>
-                <a:cs typeface="Calibri" pitchFamily="34" charset="-120"/>
-              </a:rPr>
-              <a:t>The Engine</a:t>
-            </a:r>
-            <a:endParaRPr lang="en-US" sz="550" dirty="0"/>
-          </a:p>
-        </p:txBody>
-      </p:sp>
-      <p:sp>
-        <p:nvSpPr>
-          <p:cNvPr id="122" name="Text 120"/>
-          <p:cNvSpPr/>
-          <p:nvPr/>
-        </p:nvSpPr>
-        <p:spPr>
-          <a:xfrm>
-            <a:off x="365760" y="3968496"/>
-            <a:ext cx="2743200" cy="146304"/>
-          </a:xfrm>
-          <a:prstGeom prst="rect">
-            <a:avLst/>
-          </a:prstGeom>
-          <a:noFill/>
-          <a:ln/>
-        </p:spPr>
-        <p:txBody>
-          <a:bodyPr wrap="square" rtlCol="0" anchor="ctr"/>
-          <a:lstStyle/>
-          <a:p>
-            <a:pPr indent="0" marL="0">
-              <a:buNone/>
-            </a:pPr>
-            <a:r>
               <a:rPr lang="en-US" sz="600" b="1" dirty="0">
                 <a:solidFill>
                   <a:srgbClr val="B6BBC0"/>
@@ -7584,14 +8236,14 @@
       </p:sp>
       <p:sp>
         <p:nvSpPr>
-          <p:cNvPr id="123" name="Shape 121"/>
-          <p:cNvSpPr/>
-          <p:nvPr/>
-        </p:nvSpPr>
-        <p:spPr>
-          <a:xfrm>
-            <a:off x="365760" y="4133088"/>
-            <a:ext cx="2020824" cy="329184"/>
+          <p:cNvPr id="143" name="Shape 141"/>
+          <p:cNvSpPr/>
+          <p:nvPr/>
+        </p:nvSpPr>
+        <p:spPr>
+          <a:xfrm>
+            <a:off x="365760" y="4315968"/>
+            <a:ext cx="2020824" cy="219456"/>
           </a:xfrm>
           <a:prstGeom prst="rect">
             <a:avLst/>
@@ -7611,14 +8263,14 @@
       </p:sp>
       <p:sp>
         <p:nvSpPr>
-          <p:cNvPr id="124" name="Shape 122"/>
-          <p:cNvSpPr/>
-          <p:nvPr/>
-        </p:nvSpPr>
-        <p:spPr>
-          <a:xfrm>
-            <a:off x="365760" y="4133088"/>
-            <a:ext cx="2020824" cy="45720"/>
+          <p:cNvPr id="144" name="Shape 142"/>
+          <p:cNvSpPr/>
+          <p:nvPr/>
+        </p:nvSpPr>
+        <p:spPr>
+          <a:xfrm>
+            <a:off x="365760" y="4315968"/>
+            <a:ext cx="2020824" cy="36576"/>
           </a:xfrm>
           <a:prstGeom prst="rect">
             <a:avLst/>
@@ -7640,14 +8292,14 @@
       </p:sp>
       <p:sp>
         <p:nvSpPr>
-          <p:cNvPr id="125" name="Text 123"/>
-          <p:cNvSpPr/>
-          <p:nvPr/>
-        </p:nvSpPr>
-        <p:spPr>
-          <a:xfrm>
-            <a:off x="365760" y="4133088"/>
-            <a:ext cx="2020824" cy="329184"/>
+          <p:cNvPr id="145" name="Text 143"/>
+          <p:cNvSpPr/>
+          <p:nvPr/>
+        </p:nvSpPr>
+        <p:spPr>
+          <a:xfrm>
+            <a:off x="365760" y="4315968"/>
+            <a:ext cx="2020824" cy="219456"/>
           </a:xfrm>
           <a:prstGeom prst="rect">
             <a:avLst/>
@@ -7663,7 +8315,7 @@
               <a:buNone/>
             </a:pPr>
             <a:r>
-              <a:rPr lang="en-US" sz="850" b="1" dirty="0">
+              <a:rPr lang="en-US" sz="800" b="1" dirty="0">
                 <a:solidFill>
                   <a:srgbClr val="FFFFFF"/>
                 </a:solidFill>
@@ -7673,20 +8325,20 @@
               </a:rPr>
               <a:t>The Foundation</a:t>
             </a:r>
-            <a:endParaRPr lang="en-US" sz="850" dirty="0"/>
-          </a:p>
-        </p:txBody>
-      </p:sp>
-      <p:sp>
-        <p:nvSpPr>
-          <p:cNvPr id="126" name="Shape 124"/>
-          <p:cNvSpPr/>
-          <p:nvPr/>
-        </p:nvSpPr>
-        <p:spPr>
-          <a:xfrm>
-            <a:off x="2496312" y="4133088"/>
-            <a:ext cx="2020824" cy="329184"/>
+            <a:endParaRPr lang="en-US" sz="800" dirty="0"/>
+          </a:p>
+        </p:txBody>
+      </p:sp>
+      <p:sp>
+        <p:nvSpPr>
+          <p:cNvPr id="146" name="Shape 144"/>
+          <p:cNvSpPr/>
+          <p:nvPr/>
+        </p:nvSpPr>
+        <p:spPr>
+          <a:xfrm>
+            <a:off x="2496312" y="4315968"/>
+            <a:ext cx="2020824" cy="219456"/>
           </a:xfrm>
           <a:prstGeom prst="rect">
             <a:avLst/>
@@ -7706,14 +8358,14 @@
       </p:sp>
       <p:sp>
         <p:nvSpPr>
-          <p:cNvPr id="127" name="Shape 125"/>
-          <p:cNvSpPr/>
-          <p:nvPr/>
-        </p:nvSpPr>
-        <p:spPr>
-          <a:xfrm>
-            <a:off x="2496312" y="4133088"/>
-            <a:ext cx="2020824" cy="45720"/>
+          <p:cNvPr id="147" name="Shape 145"/>
+          <p:cNvSpPr/>
+          <p:nvPr/>
+        </p:nvSpPr>
+        <p:spPr>
+          <a:xfrm>
+            <a:off x="2496312" y="4315968"/>
+            <a:ext cx="2020824" cy="36576"/>
           </a:xfrm>
           <a:prstGeom prst="rect">
             <a:avLst/>
@@ -7735,14 +8387,14 @@
       </p:sp>
       <p:sp>
         <p:nvSpPr>
-          <p:cNvPr id="128" name="Text 126"/>
-          <p:cNvSpPr/>
-          <p:nvPr/>
-        </p:nvSpPr>
-        <p:spPr>
-          <a:xfrm>
-            <a:off x="2496312" y="4133088"/>
-            <a:ext cx="2020824" cy="329184"/>
+          <p:cNvPr id="148" name="Text 146"/>
+          <p:cNvSpPr/>
+          <p:nvPr/>
+        </p:nvSpPr>
+        <p:spPr>
+          <a:xfrm>
+            <a:off x="2496312" y="4315968"/>
+            <a:ext cx="2020824" cy="219456"/>
           </a:xfrm>
           <a:prstGeom prst="rect">
             <a:avLst/>
@@ -7758,7 +8410,7 @@
               <a:buNone/>
             </a:pPr>
             <a:r>
-              <a:rPr lang="en-US" sz="850" b="1" dirty="0">
+              <a:rPr lang="en-US" sz="800" b="1" dirty="0">
                 <a:solidFill>
                   <a:srgbClr val="FFFFFF"/>
                 </a:solidFill>
@@ -7768,20 +8420,20 @@
               </a:rPr>
               <a:t>The Lens</a:t>
             </a:r>
-            <a:endParaRPr lang="en-US" sz="850" dirty="0"/>
-          </a:p>
-        </p:txBody>
-      </p:sp>
-      <p:sp>
-        <p:nvSpPr>
-          <p:cNvPr id="129" name="Shape 127"/>
-          <p:cNvSpPr/>
-          <p:nvPr/>
-        </p:nvSpPr>
-        <p:spPr>
-          <a:xfrm>
-            <a:off x="4626864" y="4133088"/>
-            <a:ext cx="2020824" cy="329184"/>
+            <a:endParaRPr lang="en-US" sz="800" dirty="0"/>
+          </a:p>
+        </p:txBody>
+      </p:sp>
+      <p:sp>
+        <p:nvSpPr>
+          <p:cNvPr id="149" name="Shape 147"/>
+          <p:cNvSpPr/>
+          <p:nvPr/>
+        </p:nvSpPr>
+        <p:spPr>
+          <a:xfrm>
+            <a:off x="4626864" y="4315968"/>
+            <a:ext cx="2020824" cy="219456"/>
           </a:xfrm>
           <a:prstGeom prst="rect">
             <a:avLst/>
@@ -7801,14 +8453,14 @@
       </p:sp>
       <p:sp>
         <p:nvSpPr>
-          <p:cNvPr id="130" name="Shape 128"/>
-          <p:cNvSpPr/>
-          <p:nvPr/>
-        </p:nvSpPr>
-        <p:spPr>
-          <a:xfrm>
-            <a:off x="4626864" y="4133088"/>
-            <a:ext cx="2020824" cy="45720"/>
+          <p:cNvPr id="150" name="Shape 148"/>
+          <p:cNvSpPr/>
+          <p:nvPr/>
+        </p:nvSpPr>
+        <p:spPr>
+          <a:xfrm>
+            <a:off x="4626864" y="4315968"/>
+            <a:ext cx="2020824" cy="36576"/>
           </a:xfrm>
           <a:prstGeom prst="rect">
             <a:avLst/>
@@ -7830,14 +8482,14 @@
       </p:sp>
       <p:sp>
         <p:nvSpPr>
-          <p:cNvPr id="131" name="Text 129"/>
-          <p:cNvSpPr/>
-          <p:nvPr/>
-        </p:nvSpPr>
-        <p:spPr>
-          <a:xfrm>
-            <a:off x="4626864" y="4133088"/>
-            <a:ext cx="2020824" cy="329184"/>
+          <p:cNvPr id="151" name="Text 149"/>
+          <p:cNvSpPr/>
+          <p:nvPr/>
+        </p:nvSpPr>
+        <p:spPr>
+          <a:xfrm>
+            <a:off x="4626864" y="4315968"/>
+            <a:ext cx="2020824" cy="219456"/>
           </a:xfrm>
           <a:prstGeom prst="rect">
             <a:avLst/>
@@ -7853,7 +8505,7 @@
               <a:buNone/>
             </a:pPr>
             <a:r>
-              <a:rPr lang="en-US" sz="850" b="1" dirty="0">
+              <a:rPr lang="en-US" sz="800" b="1" dirty="0">
                 <a:solidFill>
                   <a:srgbClr val="FFFFFF"/>
                 </a:solidFill>
@@ -7863,20 +8515,20 @@
               </a:rPr>
               <a:t>The Interface</a:t>
             </a:r>
-            <a:endParaRPr lang="en-US" sz="850" dirty="0"/>
-          </a:p>
-        </p:txBody>
-      </p:sp>
-      <p:sp>
-        <p:nvSpPr>
-          <p:cNvPr id="132" name="Shape 130"/>
-          <p:cNvSpPr/>
-          <p:nvPr/>
-        </p:nvSpPr>
-        <p:spPr>
-          <a:xfrm>
-            <a:off x="6757416" y="4133088"/>
-            <a:ext cx="2020824" cy="329184"/>
+            <a:endParaRPr lang="en-US" sz="800" dirty="0"/>
+          </a:p>
+        </p:txBody>
+      </p:sp>
+      <p:sp>
+        <p:nvSpPr>
+          <p:cNvPr id="152" name="Shape 150"/>
+          <p:cNvSpPr/>
+          <p:nvPr/>
+        </p:nvSpPr>
+        <p:spPr>
+          <a:xfrm>
+            <a:off x="6757416" y="4315968"/>
+            <a:ext cx="2020824" cy="219456"/>
           </a:xfrm>
           <a:prstGeom prst="rect">
             <a:avLst/>
@@ -7896,14 +8548,14 @@
       </p:sp>
       <p:sp>
         <p:nvSpPr>
-          <p:cNvPr id="133" name="Shape 131"/>
-          <p:cNvSpPr/>
-          <p:nvPr/>
-        </p:nvSpPr>
-        <p:spPr>
-          <a:xfrm>
-            <a:off x="6757416" y="4133088"/>
-            <a:ext cx="2020824" cy="45720"/>
+          <p:cNvPr id="153" name="Shape 151"/>
+          <p:cNvSpPr/>
+          <p:nvPr/>
+        </p:nvSpPr>
+        <p:spPr>
+          <a:xfrm>
+            <a:off x="6757416" y="4315968"/>
+            <a:ext cx="2020824" cy="36576"/>
           </a:xfrm>
           <a:prstGeom prst="rect">
             <a:avLst/>
@@ -7925,14 +8577,14 @@
       </p:sp>
       <p:sp>
         <p:nvSpPr>
-          <p:cNvPr id="134" name="Text 132"/>
-          <p:cNvSpPr/>
-          <p:nvPr/>
-        </p:nvSpPr>
-        <p:spPr>
-          <a:xfrm>
-            <a:off x="6757416" y="4133088"/>
-            <a:ext cx="2020824" cy="329184"/>
+          <p:cNvPr id="154" name="Text 152"/>
+          <p:cNvSpPr/>
+          <p:nvPr/>
+        </p:nvSpPr>
+        <p:spPr>
+          <a:xfrm>
+            <a:off x="6757416" y="4315968"/>
+            <a:ext cx="2020824" cy="219456"/>
           </a:xfrm>
           <a:prstGeom prst="rect">
             <a:avLst/>
@@ -7948,7 +8600,7 @@
               <a:buNone/>
             </a:pPr>
             <a:r>
-              <a:rPr lang="en-US" sz="850" b="1" dirty="0">
+              <a:rPr lang="en-US" sz="800" b="1" dirty="0">
                 <a:solidFill>
                   <a:srgbClr val="FFFFFF"/>
                 </a:solidFill>
@@ -7958,13 +8610,13 @@
               </a:rPr>
               <a:t>The Engine</a:t>
             </a:r>
-            <a:endParaRPr lang="en-US" sz="850" dirty="0"/>
-          </a:p>
-        </p:txBody>
-      </p:sp>
-      <p:sp>
-        <p:nvSpPr>
-          <p:cNvPr id="135" name="Shape 133"/>
+            <a:endParaRPr lang="en-US" sz="800" dirty="0"/>
+          </a:p>
+        </p:txBody>
+      </p:sp>
+      <p:sp>
+        <p:nvSpPr>
+          <p:cNvPr id="155" name="Shape 153"/>
           <p:cNvSpPr/>
           <p:nvPr/>
         </p:nvSpPr>
@@ -7989,7 +8641,7 @@
       </p:sp>
       <p:sp>
         <p:nvSpPr>
-          <p:cNvPr id="136" name="Text 134"/>
+          <p:cNvPr id="156" name="Text 154"/>
           <p:cNvSpPr/>
           <p:nvPr/>
         </p:nvSpPr>
@@ -8028,7 +8680,7 @@
       </p:sp>
       <p:sp>
         <p:nvSpPr>
-          <p:cNvPr id="137" name="Shape 135"/>
+          <p:cNvPr id="157" name="Shape 155"/>
           <p:cNvSpPr/>
           <p:nvPr/>
         </p:nvSpPr>
@@ -8053,7 +8705,7 @@
       </p:sp>
       <p:sp>
         <p:nvSpPr>
-          <p:cNvPr id="138" name="Text 136"/>
+          <p:cNvPr id="158" name="Text 156"/>
           <p:cNvSpPr/>
           <p:nvPr/>
         </p:nvSpPr>
@@ -8092,7 +8744,7 @@
       </p:sp>
       <p:sp>
         <p:nvSpPr>
-          <p:cNvPr id="139" name="Shape 137"/>
+          <p:cNvPr id="159" name="Shape 157"/>
           <p:cNvSpPr/>
           <p:nvPr/>
         </p:nvSpPr>
@@ -8117,7 +8769,7 @@
       </p:sp>
       <p:sp>
         <p:nvSpPr>
-          <p:cNvPr id="140" name="Text 138"/>
+          <p:cNvPr id="160" name="Text 158"/>
           <p:cNvSpPr/>
           <p:nvPr/>
         </p:nvSpPr>

</xml_diff>

<commit_message>
Slide 3: pillar row moved above L3 cards, Nitesh Gupta named hire, remove duplicate pillar ownership block
</commit_message>
<xml_diff>
--- a/jhbi-roadmap-2026.pptx
+++ b/jhbi-roadmap-2026.pptx
@@ -4998,8 +4998,388 @@
         </p:nvSpPr>
         <p:spPr>
           <a:xfrm>
+            <a:off x="91440" y="2103120"/>
+            <a:ext cx="2171700" cy="219456"/>
+          </a:xfrm>
+          <a:prstGeom prst="rect">
+            <a:avLst/>
+          </a:prstGeom>
+          <a:solidFill>
+            <a:srgbClr val="06185F">
+              <a:alpha val="82000"/>
+            </a:srgbClr>
+          </a:solidFill>
+          <a:ln w="12700">
+            <a:solidFill>
+              <a:srgbClr val="06185F"/>
+            </a:solidFill>
+            <a:prstDash val="solid"/>
+          </a:ln>
+        </p:spPr>
+      </p:sp>
+      <p:sp>
+        <p:nvSpPr>
+          <p:cNvPr id="44" name="Shape 42"/>
+          <p:cNvSpPr/>
+          <p:nvPr/>
+        </p:nvSpPr>
+        <p:spPr>
+          <a:xfrm>
+            <a:off x="91440" y="2103120"/>
+            <a:ext cx="2171700" cy="36576"/>
+          </a:xfrm>
+          <a:prstGeom prst="rect">
+            <a:avLst/>
+          </a:prstGeom>
+          <a:solidFill>
+            <a:srgbClr val="FFFFFF">
+              <a:alpha val="50000"/>
+            </a:srgbClr>
+          </a:solidFill>
+          <a:ln w="12700">
+            <a:solidFill>
+              <a:srgbClr val="FFFFFF">
+                <a:alpha val="50000"/>
+              </a:srgbClr>
+            </a:solidFill>
+            <a:prstDash val="solid"/>
+          </a:ln>
+        </p:spPr>
+      </p:sp>
+      <p:sp>
+        <p:nvSpPr>
+          <p:cNvPr id="45" name="Text 43"/>
+          <p:cNvSpPr/>
+          <p:nvPr/>
+        </p:nvSpPr>
+        <p:spPr>
+          <a:xfrm>
+            <a:off x="91440" y="2103120"/>
+            <a:ext cx="2171700" cy="219456"/>
+          </a:xfrm>
+          <a:prstGeom prst="rect">
+            <a:avLst/>
+          </a:prstGeom>
+          <a:noFill/>
+          <a:ln/>
+        </p:spPr>
+        <p:txBody>
+          <a:bodyPr wrap="square" rtlCol="0" anchor="ctr"/>
+          <a:lstStyle/>
+          <a:p>
+            <a:pPr algn="ctr" indent="0" marL="0">
+              <a:buNone/>
+            </a:pPr>
+            <a:r>
+              <a:rPr lang="en-US" sz="800" b="1" dirty="0">
+                <a:solidFill>
+                  <a:srgbClr val="FFFFFF"/>
+                </a:solidFill>
+                <a:latin typeface="Calibri" pitchFamily="34" charset="0"/>
+                <a:ea typeface="Calibri" pitchFamily="34" charset="-122"/>
+                <a:cs typeface="Calibri" pitchFamily="34" charset="-120"/>
+              </a:rPr>
+              <a:t>The Foundation</a:t>
+            </a:r>
+            <a:endParaRPr lang="en-US" sz="800" dirty="0"/>
+          </a:p>
+        </p:txBody>
+      </p:sp>
+      <p:sp>
+        <p:nvSpPr>
+          <p:cNvPr id="46" name="Shape 44"/>
+          <p:cNvSpPr/>
+          <p:nvPr/>
+        </p:nvSpPr>
+        <p:spPr>
+          <a:xfrm>
+            <a:off x="2354580" y="2103120"/>
+            <a:ext cx="2171700" cy="219456"/>
+          </a:xfrm>
+          <a:prstGeom prst="rect">
+            <a:avLst/>
+          </a:prstGeom>
+          <a:solidFill>
+            <a:srgbClr val="085CE5">
+              <a:alpha val="82000"/>
+            </a:srgbClr>
+          </a:solidFill>
+          <a:ln w="12700">
+            <a:solidFill>
+              <a:srgbClr val="085CE5"/>
+            </a:solidFill>
+            <a:prstDash val="solid"/>
+          </a:ln>
+        </p:spPr>
+      </p:sp>
+      <p:sp>
+        <p:nvSpPr>
+          <p:cNvPr id="47" name="Shape 45"/>
+          <p:cNvSpPr/>
+          <p:nvPr/>
+        </p:nvSpPr>
+        <p:spPr>
+          <a:xfrm>
+            <a:off x="2354580" y="2103120"/>
+            <a:ext cx="2171700" cy="36576"/>
+          </a:xfrm>
+          <a:prstGeom prst="rect">
+            <a:avLst/>
+          </a:prstGeom>
+          <a:solidFill>
+            <a:srgbClr val="FFFFFF">
+              <a:alpha val="50000"/>
+            </a:srgbClr>
+          </a:solidFill>
+          <a:ln w="12700">
+            <a:solidFill>
+              <a:srgbClr val="FFFFFF">
+                <a:alpha val="50000"/>
+              </a:srgbClr>
+            </a:solidFill>
+            <a:prstDash val="solid"/>
+          </a:ln>
+        </p:spPr>
+      </p:sp>
+      <p:sp>
+        <p:nvSpPr>
+          <p:cNvPr id="48" name="Text 46"/>
+          <p:cNvSpPr/>
+          <p:nvPr/>
+        </p:nvSpPr>
+        <p:spPr>
+          <a:xfrm>
+            <a:off x="2354580" y="2103120"/>
+            <a:ext cx="2171700" cy="219456"/>
+          </a:xfrm>
+          <a:prstGeom prst="rect">
+            <a:avLst/>
+          </a:prstGeom>
+          <a:noFill/>
+          <a:ln/>
+        </p:spPr>
+        <p:txBody>
+          <a:bodyPr wrap="square" rtlCol="0" anchor="ctr"/>
+          <a:lstStyle/>
+          <a:p>
+            <a:pPr algn="ctr" indent="0" marL="0">
+              <a:buNone/>
+            </a:pPr>
+            <a:r>
+              <a:rPr lang="en-US" sz="800" b="1" dirty="0">
+                <a:solidFill>
+                  <a:srgbClr val="FFFFFF"/>
+                </a:solidFill>
+                <a:latin typeface="Calibri" pitchFamily="34" charset="0"/>
+                <a:ea typeface="Calibri" pitchFamily="34" charset="-122"/>
+                <a:cs typeface="Calibri" pitchFamily="34" charset="-120"/>
+              </a:rPr>
+              <a:t>The Lens</a:t>
+            </a:r>
+            <a:endParaRPr lang="en-US" sz="800" dirty="0"/>
+          </a:p>
+        </p:txBody>
+      </p:sp>
+      <p:sp>
+        <p:nvSpPr>
+          <p:cNvPr id="49" name="Shape 47"/>
+          <p:cNvSpPr/>
+          <p:nvPr/>
+        </p:nvSpPr>
+        <p:spPr>
+          <a:xfrm>
+            <a:off x="4617720" y="2103120"/>
+            <a:ext cx="2171700" cy="219456"/>
+          </a:xfrm>
+          <a:prstGeom prst="rect">
+            <a:avLst/>
+          </a:prstGeom>
+          <a:solidFill>
+            <a:srgbClr val="0A5CA8">
+              <a:alpha val="82000"/>
+            </a:srgbClr>
+          </a:solidFill>
+          <a:ln w="12700">
+            <a:solidFill>
+              <a:srgbClr val="0A5CA8"/>
+            </a:solidFill>
+            <a:prstDash val="solid"/>
+          </a:ln>
+        </p:spPr>
+      </p:sp>
+      <p:sp>
+        <p:nvSpPr>
+          <p:cNvPr id="50" name="Shape 48"/>
+          <p:cNvSpPr/>
+          <p:nvPr/>
+        </p:nvSpPr>
+        <p:spPr>
+          <a:xfrm>
+            <a:off x="4617720" y="2103120"/>
+            <a:ext cx="2171700" cy="36576"/>
+          </a:xfrm>
+          <a:prstGeom prst="rect">
+            <a:avLst/>
+          </a:prstGeom>
+          <a:solidFill>
+            <a:srgbClr val="FFFFFF">
+              <a:alpha val="50000"/>
+            </a:srgbClr>
+          </a:solidFill>
+          <a:ln w="12700">
+            <a:solidFill>
+              <a:srgbClr val="FFFFFF">
+                <a:alpha val="50000"/>
+              </a:srgbClr>
+            </a:solidFill>
+            <a:prstDash val="solid"/>
+          </a:ln>
+        </p:spPr>
+      </p:sp>
+      <p:sp>
+        <p:nvSpPr>
+          <p:cNvPr id="51" name="Text 49"/>
+          <p:cNvSpPr/>
+          <p:nvPr/>
+        </p:nvSpPr>
+        <p:spPr>
+          <a:xfrm>
+            <a:off x="4617720" y="2103120"/>
+            <a:ext cx="2171700" cy="219456"/>
+          </a:xfrm>
+          <a:prstGeom prst="rect">
+            <a:avLst/>
+          </a:prstGeom>
+          <a:noFill/>
+          <a:ln/>
+        </p:spPr>
+        <p:txBody>
+          <a:bodyPr wrap="square" rtlCol="0" anchor="ctr"/>
+          <a:lstStyle/>
+          <a:p>
+            <a:pPr algn="ctr" indent="0" marL="0">
+              <a:buNone/>
+            </a:pPr>
+            <a:r>
+              <a:rPr lang="en-US" sz="800" b="1" dirty="0">
+                <a:solidFill>
+                  <a:srgbClr val="FFFFFF"/>
+                </a:solidFill>
+                <a:latin typeface="Calibri" pitchFamily="34" charset="0"/>
+                <a:ea typeface="Calibri" pitchFamily="34" charset="-122"/>
+                <a:cs typeface="Calibri" pitchFamily="34" charset="-120"/>
+              </a:rPr>
+              <a:t>The Interface</a:t>
+            </a:r>
+            <a:endParaRPr lang="en-US" sz="800" dirty="0"/>
+          </a:p>
+        </p:txBody>
+      </p:sp>
+      <p:sp>
+        <p:nvSpPr>
+          <p:cNvPr id="52" name="Shape 50"/>
+          <p:cNvSpPr/>
+          <p:nvPr/>
+        </p:nvSpPr>
+        <p:spPr>
+          <a:xfrm>
+            <a:off x="6880860" y="2103120"/>
+            <a:ext cx="2171700" cy="219456"/>
+          </a:xfrm>
+          <a:prstGeom prst="rect">
+            <a:avLst/>
+          </a:prstGeom>
+          <a:solidFill>
+            <a:srgbClr val="0A5C47">
+              <a:alpha val="82000"/>
+            </a:srgbClr>
+          </a:solidFill>
+          <a:ln w="12700">
+            <a:solidFill>
+              <a:srgbClr val="0A5C47"/>
+            </a:solidFill>
+            <a:prstDash val="solid"/>
+          </a:ln>
+        </p:spPr>
+      </p:sp>
+      <p:sp>
+        <p:nvSpPr>
+          <p:cNvPr id="53" name="Shape 51"/>
+          <p:cNvSpPr/>
+          <p:nvPr/>
+        </p:nvSpPr>
+        <p:spPr>
+          <a:xfrm>
+            <a:off x="6880860" y="2103120"/>
+            <a:ext cx="2171700" cy="36576"/>
+          </a:xfrm>
+          <a:prstGeom prst="rect">
+            <a:avLst/>
+          </a:prstGeom>
+          <a:solidFill>
+            <a:srgbClr val="FFFFFF">
+              <a:alpha val="50000"/>
+            </a:srgbClr>
+          </a:solidFill>
+          <a:ln w="12700">
+            <a:solidFill>
+              <a:srgbClr val="FFFFFF">
+                <a:alpha val="50000"/>
+              </a:srgbClr>
+            </a:solidFill>
+            <a:prstDash val="solid"/>
+          </a:ln>
+        </p:spPr>
+      </p:sp>
+      <p:sp>
+        <p:nvSpPr>
+          <p:cNvPr id="54" name="Text 52"/>
+          <p:cNvSpPr/>
+          <p:nvPr/>
+        </p:nvSpPr>
+        <p:spPr>
+          <a:xfrm>
+            <a:off x="6880860" y="2103120"/>
+            <a:ext cx="2171700" cy="219456"/>
+          </a:xfrm>
+          <a:prstGeom prst="rect">
+            <a:avLst/>
+          </a:prstGeom>
+          <a:noFill/>
+          <a:ln/>
+        </p:spPr>
+        <p:txBody>
+          <a:bodyPr wrap="square" rtlCol="0" anchor="ctr"/>
+          <a:lstStyle/>
+          <a:p>
+            <a:pPr algn="ctr" indent="0" marL="0">
+              <a:buNone/>
+            </a:pPr>
+            <a:r>
+              <a:rPr lang="en-US" sz="800" b="1" dirty="0">
+                <a:solidFill>
+                  <a:srgbClr val="FFFFFF"/>
+                </a:solidFill>
+                <a:latin typeface="Calibri" pitchFamily="34" charset="0"/>
+                <a:ea typeface="Calibri" pitchFamily="34" charset="-122"/>
+                <a:cs typeface="Calibri" pitchFamily="34" charset="-120"/>
+              </a:rPr>
+              <a:t>The Engine</a:t>
+            </a:r>
+            <a:endParaRPr lang="en-US" sz="800" dirty="0"/>
+          </a:p>
+        </p:txBody>
+      </p:sp>
+      <p:sp>
+        <p:nvSpPr>
+          <p:cNvPr id="55" name="Shape 53"/>
+          <p:cNvSpPr/>
+          <p:nvPr/>
+        </p:nvSpPr>
+        <p:spPr>
+          <a:xfrm>
             <a:off x="1548384" y="2029968"/>
-            <a:ext cx="0" cy="128016"/>
+            <a:ext cx="0" cy="384048"/>
           </a:xfrm>
           <a:prstGeom prst="line">
             <a:avLst/>
@@ -5015,13 +5395,13 @@
       </p:sp>
       <p:sp>
         <p:nvSpPr>
-          <p:cNvPr id="44" name="Shape 42"/>
-          <p:cNvSpPr/>
-          <p:nvPr/>
-        </p:nvSpPr>
-        <p:spPr>
-          <a:xfrm>
-            <a:off x="146304" y="2157984"/>
+          <p:cNvPr id="56" name="Shape 54"/>
+          <p:cNvSpPr/>
+          <p:nvPr/>
+        </p:nvSpPr>
+        <p:spPr>
+          <a:xfrm>
+            <a:off x="146304" y="2414016"/>
             <a:ext cx="2804160" cy="621792"/>
           </a:xfrm>
           <a:prstGeom prst="rect">
@@ -5040,13 +5420,13 @@
       </p:sp>
       <p:sp>
         <p:nvSpPr>
-          <p:cNvPr id="45" name="Shape 43"/>
-          <p:cNvSpPr/>
-          <p:nvPr/>
-        </p:nvSpPr>
-        <p:spPr>
-          <a:xfrm>
-            <a:off x="146304" y="2157984"/>
+          <p:cNvPr id="57" name="Shape 55"/>
+          <p:cNvSpPr/>
+          <p:nvPr/>
+        </p:nvSpPr>
+        <p:spPr>
+          <a:xfrm>
+            <a:off x="146304" y="2414016"/>
             <a:ext cx="50292" cy="621792"/>
           </a:xfrm>
           <a:prstGeom prst="rect">
@@ -5065,13 +5445,13 @@
       </p:sp>
       <p:sp>
         <p:nvSpPr>
-          <p:cNvPr id="46" name="Text 44"/>
-          <p:cNvSpPr/>
-          <p:nvPr/>
-        </p:nvSpPr>
-        <p:spPr>
-          <a:xfrm>
-            <a:off x="237744" y="2185416"/>
+          <p:cNvPr id="58" name="Text 56"/>
+          <p:cNvSpPr/>
+          <p:nvPr/>
+        </p:nvSpPr>
+        <p:spPr>
+          <a:xfrm>
+            <a:off x="237744" y="2441448"/>
             <a:ext cx="2657856" cy="128016"/>
           </a:xfrm>
           <a:prstGeom prst="rect">
@@ -5104,13 +5484,13 @@
       </p:sp>
       <p:sp>
         <p:nvSpPr>
-          <p:cNvPr id="47" name="Shape 45"/>
-          <p:cNvSpPr/>
-          <p:nvPr/>
-        </p:nvSpPr>
-        <p:spPr>
-          <a:xfrm>
-            <a:off x="219456" y="2331720"/>
+          <p:cNvPr id="59" name="Shape 57"/>
+          <p:cNvSpPr/>
+          <p:nvPr/>
+        </p:nvSpPr>
+        <p:spPr>
+          <a:xfrm>
+            <a:off x="219456" y="2587752"/>
             <a:ext cx="2657856" cy="0"/>
           </a:xfrm>
           <a:prstGeom prst="line">
@@ -5127,13 +5507,13 @@
       </p:sp>
       <p:sp>
         <p:nvSpPr>
-          <p:cNvPr id="48" name="Text 46"/>
-          <p:cNvSpPr/>
-          <p:nvPr/>
-        </p:nvSpPr>
-        <p:spPr>
-          <a:xfrm>
-            <a:off x="196596" y="2350008"/>
+          <p:cNvPr id="60" name="Text 58"/>
+          <p:cNvSpPr/>
+          <p:nvPr/>
+        </p:nvSpPr>
+        <p:spPr>
+          <a:xfrm>
+            <a:off x="196596" y="2606040"/>
             <a:ext cx="917956" cy="182880"/>
           </a:xfrm>
           <a:prstGeom prst="rect">
@@ -5166,13 +5546,13 @@
       </p:sp>
       <p:sp>
         <p:nvSpPr>
-          <p:cNvPr id="49" name="Text 47"/>
-          <p:cNvSpPr/>
-          <p:nvPr/>
-        </p:nvSpPr>
-        <p:spPr>
-          <a:xfrm>
-            <a:off x="196596" y="2542032"/>
+          <p:cNvPr id="61" name="Text 59"/>
+          <p:cNvSpPr/>
+          <p:nvPr/>
+        </p:nvSpPr>
+        <p:spPr>
+          <a:xfrm>
+            <a:off x="196596" y="2798064"/>
             <a:ext cx="917956" cy="91440"/>
           </a:xfrm>
           <a:prstGeom prst="rect">
@@ -5205,13 +5585,13 @@
       </p:sp>
       <p:sp>
         <p:nvSpPr>
-          <p:cNvPr id="50" name="Shape 48"/>
-          <p:cNvSpPr/>
-          <p:nvPr/>
-        </p:nvSpPr>
-        <p:spPr>
-          <a:xfrm>
-            <a:off x="1114552" y="2350008"/>
+          <p:cNvPr id="62" name="Shape 60"/>
+          <p:cNvSpPr/>
+          <p:nvPr/>
+        </p:nvSpPr>
+        <p:spPr>
+          <a:xfrm>
+            <a:off x="1114552" y="2606040"/>
             <a:ext cx="0" cy="320040"/>
           </a:xfrm>
           <a:prstGeom prst="line">
@@ -5228,13 +5608,13 @@
       </p:sp>
       <p:sp>
         <p:nvSpPr>
-          <p:cNvPr id="51" name="Text 49"/>
-          <p:cNvSpPr/>
-          <p:nvPr/>
-        </p:nvSpPr>
-        <p:spPr>
-          <a:xfrm>
-            <a:off x="1114552" y="2350008"/>
+          <p:cNvPr id="63" name="Text 61"/>
+          <p:cNvSpPr/>
+          <p:nvPr/>
+        </p:nvSpPr>
+        <p:spPr>
+          <a:xfrm>
+            <a:off x="1114552" y="2606040"/>
             <a:ext cx="917956" cy="182880"/>
           </a:xfrm>
           <a:prstGeom prst="rect">
@@ -5267,13 +5647,13 @@
       </p:sp>
       <p:sp>
         <p:nvSpPr>
-          <p:cNvPr id="52" name="Text 50"/>
-          <p:cNvSpPr/>
-          <p:nvPr/>
-        </p:nvSpPr>
-        <p:spPr>
-          <a:xfrm>
-            <a:off x="1114552" y="2542032"/>
+          <p:cNvPr id="64" name="Text 62"/>
+          <p:cNvSpPr/>
+          <p:nvPr/>
+        </p:nvSpPr>
+        <p:spPr>
+          <a:xfrm>
+            <a:off x="1114552" y="2798064"/>
             <a:ext cx="917956" cy="91440"/>
           </a:xfrm>
           <a:prstGeom prst="rect">
@@ -5306,13 +5686,13 @@
       </p:sp>
       <p:sp>
         <p:nvSpPr>
-          <p:cNvPr id="53" name="Shape 51"/>
-          <p:cNvSpPr/>
-          <p:nvPr/>
-        </p:nvSpPr>
-        <p:spPr>
-          <a:xfrm>
-            <a:off x="2032508" y="2350008"/>
+          <p:cNvPr id="65" name="Shape 63"/>
+          <p:cNvSpPr/>
+          <p:nvPr/>
+        </p:nvSpPr>
+        <p:spPr>
+          <a:xfrm>
+            <a:off x="2032508" y="2606040"/>
             <a:ext cx="0" cy="320040"/>
           </a:xfrm>
           <a:prstGeom prst="line">
@@ -5329,13 +5709,13 @@
       </p:sp>
       <p:sp>
         <p:nvSpPr>
-          <p:cNvPr id="54" name="Text 52"/>
-          <p:cNvSpPr/>
-          <p:nvPr/>
-        </p:nvSpPr>
-        <p:spPr>
-          <a:xfrm>
-            <a:off x="2032508" y="2350008"/>
+          <p:cNvPr id="66" name="Text 64"/>
+          <p:cNvSpPr/>
+          <p:nvPr/>
+        </p:nvSpPr>
+        <p:spPr>
+          <a:xfrm>
+            <a:off x="2032508" y="2606040"/>
             <a:ext cx="917956" cy="182880"/>
           </a:xfrm>
           <a:prstGeom prst="rect">
@@ -5368,13 +5748,13 @@
       </p:sp>
       <p:sp>
         <p:nvSpPr>
-          <p:cNvPr id="55" name="Text 53"/>
-          <p:cNvSpPr/>
-          <p:nvPr/>
-        </p:nvSpPr>
-        <p:spPr>
-          <a:xfrm>
-            <a:off x="2032508" y="2542032"/>
+          <p:cNvPr id="67" name="Text 65"/>
+          <p:cNvSpPr/>
+          <p:nvPr/>
+        </p:nvSpPr>
+        <p:spPr>
+          <a:xfrm>
+            <a:off x="2032508" y="2798064"/>
             <a:ext cx="917956" cy="91440"/>
           </a:xfrm>
           <a:prstGeom prst="rect">
@@ -5407,13 +5787,13 @@
       </p:sp>
       <p:sp>
         <p:nvSpPr>
-          <p:cNvPr id="56" name="Shape 54"/>
-          <p:cNvSpPr/>
-          <p:nvPr/>
-        </p:nvSpPr>
-        <p:spPr>
-          <a:xfrm>
-            <a:off x="237744" y="2660904"/>
+          <p:cNvPr id="68" name="Shape 66"/>
+          <p:cNvSpPr/>
+          <p:nvPr/>
+        </p:nvSpPr>
+        <p:spPr>
+          <a:xfrm>
+            <a:off x="237744" y="2916936"/>
             <a:ext cx="585216" cy="100584"/>
           </a:xfrm>
           <a:prstGeom prst="rect">
@@ -5434,13 +5814,13 @@
       </p:sp>
       <p:sp>
         <p:nvSpPr>
-          <p:cNvPr id="57" name="Text 55"/>
-          <p:cNvSpPr/>
-          <p:nvPr/>
-        </p:nvSpPr>
-        <p:spPr>
-          <a:xfrm>
-            <a:off x="237744" y="2660904"/>
+          <p:cNvPr id="69" name="Text 67"/>
+          <p:cNvSpPr/>
+          <p:nvPr/>
+        </p:nvSpPr>
+        <p:spPr>
+          <a:xfrm>
+            <a:off x="237744" y="2916936"/>
             <a:ext cx="585216" cy="100584"/>
           </a:xfrm>
           <a:prstGeom prst="rect">
@@ -5473,13 +5853,13 @@
       </p:sp>
       <p:sp>
         <p:nvSpPr>
-          <p:cNvPr id="58" name="Shape 56"/>
-          <p:cNvSpPr/>
-          <p:nvPr/>
-        </p:nvSpPr>
-        <p:spPr>
-          <a:xfrm>
-            <a:off x="146304" y="2834640"/>
+          <p:cNvPr id="70" name="Shape 68"/>
+          <p:cNvSpPr/>
+          <p:nvPr/>
+        </p:nvSpPr>
+        <p:spPr>
+          <a:xfrm>
+            <a:off x="146304" y="3090672"/>
             <a:ext cx="2804160" cy="621792"/>
           </a:xfrm>
           <a:prstGeom prst="rect">
@@ -5498,13 +5878,13 @@
       </p:sp>
       <p:sp>
         <p:nvSpPr>
-          <p:cNvPr id="59" name="Shape 57"/>
-          <p:cNvSpPr/>
-          <p:nvPr/>
-        </p:nvSpPr>
-        <p:spPr>
-          <a:xfrm>
-            <a:off x="146304" y="2834640"/>
+          <p:cNvPr id="71" name="Shape 69"/>
+          <p:cNvSpPr/>
+          <p:nvPr/>
+        </p:nvSpPr>
+        <p:spPr>
+          <a:xfrm>
+            <a:off x="146304" y="3090672"/>
             <a:ext cx="50292" cy="621792"/>
           </a:xfrm>
           <a:prstGeom prst="rect">
@@ -5523,13 +5903,13 @@
       </p:sp>
       <p:sp>
         <p:nvSpPr>
-          <p:cNvPr id="60" name="Text 58"/>
-          <p:cNvSpPr/>
-          <p:nvPr/>
-        </p:nvSpPr>
-        <p:spPr>
-          <a:xfrm>
-            <a:off x="237744" y="2862072"/>
+          <p:cNvPr id="72" name="Text 70"/>
+          <p:cNvSpPr/>
+          <p:nvPr/>
+        </p:nvSpPr>
+        <p:spPr>
+          <a:xfrm>
+            <a:off x="237744" y="3118104"/>
             <a:ext cx="2657856" cy="128016"/>
           </a:xfrm>
           <a:prstGeom prst="rect">
@@ -5562,13 +5942,13 @@
       </p:sp>
       <p:sp>
         <p:nvSpPr>
-          <p:cNvPr id="61" name="Shape 59"/>
-          <p:cNvSpPr/>
-          <p:nvPr/>
-        </p:nvSpPr>
-        <p:spPr>
-          <a:xfrm>
-            <a:off x="219456" y="3008376"/>
+          <p:cNvPr id="73" name="Shape 71"/>
+          <p:cNvSpPr/>
+          <p:nvPr/>
+        </p:nvSpPr>
+        <p:spPr>
+          <a:xfrm>
+            <a:off x="219456" y="3264408"/>
             <a:ext cx="2657856" cy="0"/>
           </a:xfrm>
           <a:prstGeom prst="line">
@@ -5585,13 +5965,13 @@
       </p:sp>
       <p:sp>
         <p:nvSpPr>
-          <p:cNvPr id="62" name="Text 60"/>
-          <p:cNvSpPr/>
-          <p:nvPr/>
-        </p:nvSpPr>
-        <p:spPr>
-          <a:xfrm>
-            <a:off x="196596" y="3026664"/>
+          <p:cNvPr id="74" name="Text 72"/>
+          <p:cNvSpPr/>
+          <p:nvPr/>
+        </p:nvSpPr>
+        <p:spPr>
+          <a:xfrm>
+            <a:off x="196596" y="3282696"/>
             <a:ext cx="917956" cy="182880"/>
           </a:xfrm>
           <a:prstGeom prst="rect">
@@ -5624,13 +6004,13 @@
       </p:sp>
       <p:sp>
         <p:nvSpPr>
-          <p:cNvPr id="63" name="Text 61"/>
-          <p:cNvSpPr/>
-          <p:nvPr/>
-        </p:nvSpPr>
-        <p:spPr>
-          <a:xfrm>
-            <a:off x="196596" y="3218688"/>
+          <p:cNvPr id="75" name="Text 73"/>
+          <p:cNvSpPr/>
+          <p:nvPr/>
+        </p:nvSpPr>
+        <p:spPr>
+          <a:xfrm>
+            <a:off x="196596" y="3474720"/>
             <a:ext cx="917956" cy="91440"/>
           </a:xfrm>
           <a:prstGeom prst="rect">
@@ -5663,13 +6043,13 @@
       </p:sp>
       <p:sp>
         <p:nvSpPr>
-          <p:cNvPr id="64" name="Shape 62"/>
-          <p:cNvSpPr/>
-          <p:nvPr/>
-        </p:nvSpPr>
-        <p:spPr>
-          <a:xfrm>
-            <a:off x="1114552" y="3026664"/>
+          <p:cNvPr id="76" name="Shape 74"/>
+          <p:cNvSpPr/>
+          <p:nvPr/>
+        </p:nvSpPr>
+        <p:spPr>
+          <a:xfrm>
+            <a:off x="1114552" y="3282696"/>
             <a:ext cx="0" cy="320040"/>
           </a:xfrm>
           <a:prstGeom prst="line">
@@ -5686,13 +6066,13 @@
       </p:sp>
       <p:sp>
         <p:nvSpPr>
-          <p:cNvPr id="65" name="Text 63"/>
-          <p:cNvSpPr/>
-          <p:nvPr/>
-        </p:nvSpPr>
-        <p:spPr>
-          <a:xfrm>
-            <a:off x="1114552" y="3026664"/>
+          <p:cNvPr id="77" name="Text 75"/>
+          <p:cNvSpPr/>
+          <p:nvPr/>
+        </p:nvSpPr>
+        <p:spPr>
+          <a:xfrm>
+            <a:off x="1114552" y="3282696"/>
             <a:ext cx="917956" cy="182880"/>
           </a:xfrm>
           <a:prstGeom prst="rect">
@@ -5725,13 +6105,13 @@
       </p:sp>
       <p:sp>
         <p:nvSpPr>
-          <p:cNvPr id="66" name="Text 64"/>
-          <p:cNvSpPr/>
-          <p:nvPr/>
-        </p:nvSpPr>
-        <p:spPr>
-          <a:xfrm>
-            <a:off x="1114552" y="3218688"/>
+          <p:cNvPr id="78" name="Text 76"/>
+          <p:cNvSpPr/>
+          <p:nvPr/>
+        </p:nvSpPr>
+        <p:spPr>
+          <a:xfrm>
+            <a:off x="1114552" y="3474720"/>
             <a:ext cx="917956" cy="91440"/>
           </a:xfrm>
           <a:prstGeom prst="rect">
@@ -5764,13 +6144,13 @@
       </p:sp>
       <p:sp>
         <p:nvSpPr>
-          <p:cNvPr id="67" name="Shape 65"/>
-          <p:cNvSpPr/>
-          <p:nvPr/>
-        </p:nvSpPr>
-        <p:spPr>
-          <a:xfrm>
-            <a:off x="2032508" y="3026664"/>
+          <p:cNvPr id="79" name="Shape 77"/>
+          <p:cNvSpPr/>
+          <p:nvPr/>
+        </p:nvSpPr>
+        <p:spPr>
+          <a:xfrm>
+            <a:off x="2032508" y="3282696"/>
             <a:ext cx="0" cy="320040"/>
           </a:xfrm>
           <a:prstGeom prst="line">
@@ -5787,13 +6167,13 @@
       </p:sp>
       <p:sp>
         <p:nvSpPr>
-          <p:cNvPr id="68" name="Text 66"/>
-          <p:cNvSpPr/>
-          <p:nvPr/>
-        </p:nvSpPr>
-        <p:spPr>
-          <a:xfrm>
-            <a:off x="2032508" y="3026664"/>
+          <p:cNvPr id="80" name="Text 78"/>
+          <p:cNvSpPr/>
+          <p:nvPr/>
+        </p:nvSpPr>
+        <p:spPr>
+          <a:xfrm>
+            <a:off x="2032508" y="3282696"/>
             <a:ext cx="917956" cy="182880"/>
           </a:xfrm>
           <a:prstGeom prst="rect">
@@ -5826,13 +6206,13 @@
       </p:sp>
       <p:sp>
         <p:nvSpPr>
-          <p:cNvPr id="69" name="Text 67"/>
-          <p:cNvSpPr/>
-          <p:nvPr/>
-        </p:nvSpPr>
-        <p:spPr>
-          <a:xfrm>
-            <a:off x="2032508" y="3218688"/>
+          <p:cNvPr id="81" name="Text 79"/>
+          <p:cNvSpPr/>
+          <p:nvPr/>
+        </p:nvSpPr>
+        <p:spPr>
+          <a:xfrm>
+            <a:off x="2032508" y="3474720"/>
             <a:ext cx="917956" cy="91440"/>
           </a:xfrm>
           <a:prstGeom prst="rect">
@@ -5865,13 +6245,13 @@
       </p:sp>
       <p:sp>
         <p:nvSpPr>
-          <p:cNvPr id="70" name="Shape 68"/>
-          <p:cNvSpPr/>
-          <p:nvPr/>
-        </p:nvSpPr>
-        <p:spPr>
-          <a:xfrm>
-            <a:off x="237744" y="3337560"/>
+          <p:cNvPr id="82" name="Shape 80"/>
+          <p:cNvSpPr/>
+          <p:nvPr/>
+        </p:nvSpPr>
+        <p:spPr>
+          <a:xfrm>
+            <a:off x="237744" y="3593592"/>
             <a:ext cx="497434" cy="100584"/>
           </a:xfrm>
           <a:prstGeom prst="rect">
@@ -5892,13 +6272,13 @@
       </p:sp>
       <p:sp>
         <p:nvSpPr>
-          <p:cNvPr id="71" name="Text 69"/>
-          <p:cNvSpPr/>
-          <p:nvPr/>
-        </p:nvSpPr>
-        <p:spPr>
-          <a:xfrm>
-            <a:off x="237744" y="3337560"/>
+          <p:cNvPr id="83" name="Text 81"/>
+          <p:cNvSpPr/>
+          <p:nvPr/>
+        </p:nvSpPr>
+        <p:spPr>
+          <a:xfrm>
+            <a:off x="237744" y="3593592"/>
             <a:ext cx="497434" cy="100584"/>
           </a:xfrm>
           <a:prstGeom prst="rect">
@@ -5931,13 +6311,13 @@
       </p:sp>
       <p:sp>
         <p:nvSpPr>
-          <p:cNvPr id="72" name="Shape 70"/>
-          <p:cNvSpPr/>
-          <p:nvPr/>
-        </p:nvSpPr>
-        <p:spPr>
-          <a:xfrm>
-            <a:off x="146304" y="3511296"/>
+          <p:cNvPr id="84" name="Shape 82"/>
+          <p:cNvSpPr/>
+          <p:nvPr/>
+        </p:nvSpPr>
+        <p:spPr>
+          <a:xfrm>
+            <a:off x="146304" y="3767328"/>
             <a:ext cx="2804160" cy="621792"/>
           </a:xfrm>
           <a:prstGeom prst="rect">
@@ -5956,13 +6336,13 @@
       </p:sp>
       <p:sp>
         <p:nvSpPr>
-          <p:cNvPr id="73" name="Shape 71"/>
-          <p:cNvSpPr/>
-          <p:nvPr/>
-        </p:nvSpPr>
-        <p:spPr>
-          <a:xfrm>
-            <a:off x="146304" y="3511296"/>
+          <p:cNvPr id="85" name="Shape 83"/>
+          <p:cNvSpPr/>
+          <p:nvPr/>
+        </p:nvSpPr>
+        <p:spPr>
+          <a:xfrm>
+            <a:off x="146304" y="3767328"/>
             <a:ext cx="50292" cy="621792"/>
           </a:xfrm>
           <a:prstGeom prst="rect">
@@ -5981,13 +6361,13 @@
       </p:sp>
       <p:sp>
         <p:nvSpPr>
-          <p:cNvPr id="74" name="Text 72"/>
-          <p:cNvSpPr/>
-          <p:nvPr/>
-        </p:nvSpPr>
-        <p:spPr>
-          <a:xfrm>
-            <a:off x="237744" y="3538728"/>
+          <p:cNvPr id="86" name="Text 84"/>
+          <p:cNvSpPr/>
+          <p:nvPr/>
+        </p:nvSpPr>
+        <p:spPr>
+          <a:xfrm>
+            <a:off x="237744" y="3794760"/>
             <a:ext cx="2657856" cy="128016"/>
           </a:xfrm>
           <a:prstGeom prst="rect">
@@ -6020,13 +6400,13 @@
       </p:sp>
       <p:sp>
         <p:nvSpPr>
-          <p:cNvPr id="75" name="Shape 73"/>
-          <p:cNvSpPr/>
-          <p:nvPr/>
-        </p:nvSpPr>
-        <p:spPr>
-          <a:xfrm>
-            <a:off x="219456" y="3685032"/>
+          <p:cNvPr id="87" name="Shape 85"/>
+          <p:cNvSpPr/>
+          <p:nvPr/>
+        </p:nvSpPr>
+        <p:spPr>
+          <a:xfrm>
+            <a:off x="219456" y="3941064"/>
             <a:ext cx="2657856" cy="0"/>
           </a:xfrm>
           <a:prstGeom prst="line">
@@ -6043,13 +6423,13 @@
       </p:sp>
       <p:sp>
         <p:nvSpPr>
-          <p:cNvPr id="76" name="Text 74"/>
-          <p:cNvSpPr/>
-          <p:nvPr/>
-        </p:nvSpPr>
-        <p:spPr>
-          <a:xfrm>
-            <a:off x="196596" y="3703320"/>
+          <p:cNvPr id="88" name="Text 86"/>
+          <p:cNvSpPr/>
+          <p:nvPr/>
+        </p:nvSpPr>
+        <p:spPr>
+          <a:xfrm>
+            <a:off x="196596" y="3959352"/>
             <a:ext cx="917956" cy="182880"/>
           </a:xfrm>
           <a:prstGeom prst="rect">
@@ -6082,13 +6462,13 @@
       </p:sp>
       <p:sp>
         <p:nvSpPr>
-          <p:cNvPr id="77" name="Text 75"/>
-          <p:cNvSpPr/>
-          <p:nvPr/>
-        </p:nvSpPr>
-        <p:spPr>
-          <a:xfrm>
-            <a:off x="196596" y="3895344"/>
+          <p:cNvPr id="89" name="Text 87"/>
+          <p:cNvSpPr/>
+          <p:nvPr/>
+        </p:nvSpPr>
+        <p:spPr>
+          <a:xfrm>
+            <a:off x="196596" y="4151376"/>
             <a:ext cx="917956" cy="91440"/>
           </a:xfrm>
           <a:prstGeom prst="rect">
@@ -6121,13 +6501,13 @@
       </p:sp>
       <p:sp>
         <p:nvSpPr>
-          <p:cNvPr id="78" name="Shape 76"/>
-          <p:cNvSpPr/>
-          <p:nvPr/>
-        </p:nvSpPr>
-        <p:spPr>
-          <a:xfrm>
-            <a:off x="1114552" y="3703320"/>
+          <p:cNvPr id="90" name="Shape 88"/>
+          <p:cNvSpPr/>
+          <p:nvPr/>
+        </p:nvSpPr>
+        <p:spPr>
+          <a:xfrm>
+            <a:off x="1114552" y="3959352"/>
             <a:ext cx="0" cy="320040"/>
           </a:xfrm>
           <a:prstGeom prst="line">
@@ -6144,13 +6524,13 @@
       </p:sp>
       <p:sp>
         <p:nvSpPr>
-          <p:cNvPr id="79" name="Text 77"/>
-          <p:cNvSpPr/>
-          <p:nvPr/>
-        </p:nvSpPr>
-        <p:spPr>
-          <a:xfrm>
-            <a:off x="1114552" y="3703320"/>
+          <p:cNvPr id="91" name="Text 89"/>
+          <p:cNvSpPr/>
+          <p:nvPr/>
+        </p:nvSpPr>
+        <p:spPr>
+          <a:xfrm>
+            <a:off x="1114552" y="3959352"/>
             <a:ext cx="917956" cy="182880"/>
           </a:xfrm>
           <a:prstGeom prst="rect">
@@ -6183,13 +6563,13 @@
       </p:sp>
       <p:sp>
         <p:nvSpPr>
-          <p:cNvPr id="80" name="Text 78"/>
-          <p:cNvSpPr/>
-          <p:nvPr/>
-        </p:nvSpPr>
-        <p:spPr>
-          <a:xfrm>
-            <a:off x="1114552" y="3895344"/>
+          <p:cNvPr id="92" name="Text 90"/>
+          <p:cNvSpPr/>
+          <p:nvPr/>
+        </p:nvSpPr>
+        <p:spPr>
+          <a:xfrm>
+            <a:off x="1114552" y="4151376"/>
             <a:ext cx="917956" cy="91440"/>
           </a:xfrm>
           <a:prstGeom prst="rect">
@@ -6222,13 +6602,13 @@
       </p:sp>
       <p:sp>
         <p:nvSpPr>
-          <p:cNvPr id="81" name="Shape 79"/>
-          <p:cNvSpPr/>
-          <p:nvPr/>
-        </p:nvSpPr>
-        <p:spPr>
-          <a:xfrm>
-            <a:off x="2032508" y="3703320"/>
+          <p:cNvPr id="93" name="Shape 91"/>
+          <p:cNvSpPr/>
+          <p:nvPr/>
+        </p:nvSpPr>
+        <p:spPr>
+          <a:xfrm>
+            <a:off x="2032508" y="3959352"/>
             <a:ext cx="0" cy="320040"/>
           </a:xfrm>
           <a:prstGeom prst="line">
@@ -6245,13 +6625,13 @@
       </p:sp>
       <p:sp>
         <p:nvSpPr>
-          <p:cNvPr id="82" name="Text 80"/>
-          <p:cNvSpPr/>
-          <p:nvPr/>
-        </p:nvSpPr>
-        <p:spPr>
-          <a:xfrm>
-            <a:off x="2032508" y="3703320"/>
+          <p:cNvPr id="94" name="Text 92"/>
+          <p:cNvSpPr/>
+          <p:nvPr/>
+        </p:nvSpPr>
+        <p:spPr>
+          <a:xfrm>
+            <a:off x="2032508" y="3959352"/>
             <a:ext cx="917956" cy="182880"/>
           </a:xfrm>
           <a:prstGeom prst="rect">
@@ -6284,13 +6664,13 @@
       </p:sp>
       <p:sp>
         <p:nvSpPr>
-          <p:cNvPr id="83" name="Text 81"/>
-          <p:cNvSpPr/>
-          <p:nvPr/>
-        </p:nvSpPr>
-        <p:spPr>
-          <a:xfrm>
-            <a:off x="2032508" y="3895344"/>
+          <p:cNvPr id="95" name="Text 93"/>
+          <p:cNvSpPr/>
+          <p:nvPr/>
+        </p:nvSpPr>
+        <p:spPr>
+          <a:xfrm>
+            <a:off x="2032508" y="4151376"/>
             <a:ext cx="917956" cy="91440"/>
           </a:xfrm>
           <a:prstGeom prst="rect">
@@ -6323,13 +6703,13 @@
       </p:sp>
       <p:sp>
         <p:nvSpPr>
-          <p:cNvPr id="84" name="Shape 82"/>
-          <p:cNvSpPr/>
-          <p:nvPr/>
-        </p:nvSpPr>
-        <p:spPr>
-          <a:xfrm>
-            <a:off x="237744" y="4014216"/>
+          <p:cNvPr id="96" name="Shape 94"/>
+          <p:cNvSpPr/>
+          <p:nvPr/>
+        </p:nvSpPr>
+        <p:spPr>
+          <a:xfrm>
+            <a:off x="237744" y="4270248"/>
             <a:ext cx="541325" cy="100584"/>
           </a:xfrm>
           <a:prstGeom prst="rect">
@@ -6350,13 +6730,13 @@
       </p:sp>
       <p:sp>
         <p:nvSpPr>
-          <p:cNvPr id="85" name="Text 83"/>
-          <p:cNvSpPr/>
-          <p:nvPr/>
-        </p:nvSpPr>
-        <p:spPr>
-          <a:xfrm>
-            <a:off x="237744" y="4014216"/>
+          <p:cNvPr id="97" name="Text 95"/>
+          <p:cNvSpPr/>
+          <p:nvPr/>
+        </p:nvSpPr>
+        <p:spPr>
+          <a:xfrm>
+            <a:off x="237744" y="4270248"/>
             <a:ext cx="541325" cy="100584"/>
           </a:xfrm>
           <a:prstGeom prst="rect">
@@ -6389,14 +6769,14 @@
       </p:sp>
       <p:sp>
         <p:nvSpPr>
-          <p:cNvPr id="86" name="Shape 84"/>
+          <p:cNvPr id="98" name="Shape 96"/>
           <p:cNvSpPr/>
           <p:nvPr/>
         </p:nvSpPr>
         <p:spPr>
           <a:xfrm>
             <a:off x="4572000" y="2029968"/>
-            <a:ext cx="0" cy="128016"/>
+            <a:ext cx="0" cy="384048"/>
           </a:xfrm>
           <a:prstGeom prst="line">
             <a:avLst/>
@@ -6412,13 +6792,13 @@
       </p:sp>
       <p:sp>
         <p:nvSpPr>
-          <p:cNvPr id="87" name="Shape 85"/>
-          <p:cNvSpPr/>
-          <p:nvPr/>
-        </p:nvSpPr>
-        <p:spPr>
-          <a:xfrm>
-            <a:off x="3169920" y="2157984"/>
+          <p:cNvPr id="99" name="Shape 97"/>
+          <p:cNvSpPr/>
+          <p:nvPr/>
+        </p:nvSpPr>
+        <p:spPr>
+          <a:xfrm>
+            <a:off x="3169920" y="2414016"/>
             <a:ext cx="2804160" cy="438912"/>
           </a:xfrm>
           <a:prstGeom prst="rect">
@@ -6437,13 +6817,13 @@
       </p:sp>
       <p:sp>
         <p:nvSpPr>
-          <p:cNvPr id="88" name="Shape 86"/>
-          <p:cNvSpPr/>
-          <p:nvPr/>
-        </p:nvSpPr>
-        <p:spPr>
-          <a:xfrm>
-            <a:off x="3169920" y="2157984"/>
+          <p:cNvPr id="100" name="Shape 98"/>
+          <p:cNvSpPr/>
+          <p:nvPr/>
+        </p:nvSpPr>
+        <p:spPr>
+          <a:xfrm>
+            <a:off x="3169920" y="2414016"/>
             <a:ext cx="50292" cy="438912"/>
           </a:xfrm>
           <a:prstGeom prst="rect">
@@ -6462,13 +6842,13 @@
       </p:sp>
       <p:sp>
         <p:nvSpPr>
-          <p:cNvPr id="89" name="Text 87"/>
-          <p:cNvSpPr/>
-          <p:nvPr/>
-        </p:nvSpPr>
-        <p:spPr>
-          <a:xfrm>
-            <a:off x="3261360" y="2185416"/>
+          <p:cNvPr id="101" name="Text 99"/>
+          <p:cNvSpPr/>
+          <p:nvPr/>
+        </p:nvSpPr>
+        <p:spPr>
+          <a:xfrm>
+            <a:off x="3261360" y="2441448"/>
             <a:ext cx="2657856" cy="164592"/>
           </a:xfrm>
           <a:prstGeom prst="rect">
@@ -6501,13 +6881,13 @@
       </p:sp>
       <p:sp>
         <p:nvSpPr>
-          <p:cNvPr id="90" name="Text 88"/>
-          <p:cNvSpPr/>
-          <p:nvPr/>
-        </p:nvSpPr>
-        <p:spPr>
-          <a:xfrm>
-            <a:off x="3261360" y="2368296"/>
+          <p:cNvPr id="102" name="Text 100"/>
+          <p:cNvSpPr/>
+          <p:nvPr/>
+        </p:nvSpPr>
+        <p:spPr>
+          <a:xfrm>
+            <a:off x="3261360" y="2624328"/>
             <a:ext cx="2657856" cy="128016"/>
           </a:xfrm>
           <a:prstGeom prst="rect">
@@ -6540,13 +6920,13 @@
       </p:sp>
       <p:sp>
         <p:nvSpPr>
-          <p:cNvPr id="91" name="Shape 89"/>
-          <p:cNvSpPr/>
-          <p:nvPr/>
-        </p:nvSpPr>
-        <p:spPr>
-          <a:xfrm>
-            <a:off x="3261360" y="2478024"/>
+          <p:cNvPr id="103" name="Shape 101"/>
+          <p:cNvSpPr/>
+          <p:nvPr/>
+        </p:nvSpPr>
+        <p:spPr>
+          <a:xfrm>
+            <a:off x="3261360" y="2734056"/>
             <a:ext cx="497434" cy="100584"/>
           </a:xfrm>
           <a:prstGeom prst="rect">
@@ -6567,13 +6947,13 @@
       </p:sp>
       <p:sp>
         <p:nvSpPr>
-          <p:cNvPr id="92" name="Text 90"/>
-          <p:cNvSpPr/>
-          <p:nvPr/>
-        </p:nvSpPr>
-        <p:spPr>
-          <a:xfrm>
-            <a:off x="3261360" y="2478024"/>
+          <p:cNvPr id="104" name="Text 102"/>
+          <p:cNvSpPr/>
+          <p:nvPr/>
+        </p:nvSpPr>
+        <p:spPr>
+          <a:xfrm>
+            <a:off x="3261360" y="2734056"/>
             <a:ext cx="497434" cy="100584"/>
           </a:xfrm>
           <a:prstGeom prst="rect">
@@ -6606,13 +6986,13 @@
       </p:sp>
       <p:sp>
         <p:nvSpPr>
-          <p:cNvPr id="93" name="Shape 91"/>
-          <p:cNvSpPr/>
-          <p:nvPr/>
-        </p:nvSpPr>
-        <p:spPr>
-          <a:xfrm>
-            <a:off x="3169920" y="2651760"/>
+          <p:cNvPr id="105" name="Shape 103"/>
+          <p:cNvSpPr/>
+          <p:nvPr/>
+        </p:nvSpPr>
+        <p:spPr>
+          <a:xfrm>
+            <a:off x="3169920" y="2907792"/>
             <a:ext cx="2804160" cy="438912"/>
           </a:xfrm>
           <a:prstGeom prst="rect">
@@ -6631,13 +7011,13 @@
       </p:sp>
       <p:sp>
         <p:nvSpPr>
-          <p:cNvPr id="94" name="Shape 92"/>
-          <p:cNvSpPr/>
-          <p:nvPr/>
-        </p:nvSpPr>
-        <p:spPr>
-          <a:xfrm>
-            <a:off x="3169920" y="2651760"/>
+          <p:cNvPr id="106" name="Shape 104"/>
+          <p:cNvSpPr/>
+          <p:nvPr/>
+        </p:nvSpPr>
+        <p:spPr>
+          <a:xfrm>
+            <a:off x="3169920" y="2907792"/>
             <a:ext cx="50292" cy="438912"/>
           </a:xfrm>
           <a:prstGeom prst="rect">
@@ -6656,13 +7036,13 @@
       </p:sp>
       <p:sp>
         <p:nvSpPr>
-          <p:cNvPr id="95" name="Text 93"/>
-          <p:cNvSpPr/>
-          <p:nvPr/>
-        </p:nvSpPr>
-        <p:spPr>
-          <a:xfrm>
-            <a:off x="3261360" y="2679192"/>
+          <p:cNvPr id="107" name="Text 105"/>
+          <p:cNvSpPr/>
+          <p:nvPr/>
+        </p:nvSpPr>
+        <p:spPr>
+          <a:xfrm>
+            <a:off x="3261360" y="2935224"/>
             <a:ext cx="2657856" cy="164592"/>
           </a:xfrm>
           <a:prstGeom prst="rect">
@@ -6695,13 +7075,13 @@
       </p:sp>
       <p:sp>
         <p:nvSpPr>
-          <p:cNvPr id="96" name="Text 94"/>
-          <p:cNvSpPr/>
-          <p:nvPr/>
-        </p:nvSpPr>
-        <p:spPr>
-          <a:xfrm>
-            <a:off x="3261360" y="2862072"/>
+          <p:cNvPr id="108" name="Text 106"/>
+          <p:cNvSpPr/>
+          <p:nvPr/>
+        </p:nvSpPr>
+        <p:spPr>
+          <a:xfrm>
+            <a:off x="3261360" y="3118104"/>
             <a:ext cx="2657856" cy="128016"/>
           </a:xfrm>
           <a:prstGeom prst="rect">
@@ -6734,13 +7114,13 @@
       </p:sp>
       <p:sp>
         <p:nvSpPr>
-          <p:cNvPr id="97" name="Shape 95"/>
-          <p:cNvSpPr/>
-          <p:nvPr/>
-        </p:nvSpPr>
-        <p:spPr>
-          <a:xfrm>
-            <a:off x="3261360" y="2971800"/>
+          <p:cNvPr id="109" name="Shape 107"/>
+          <p:cNvSpPr/>
+          <p:nvPr/>
+        </p:nvSpPr>
+        <p:spPr>
+          <a:xfrm>
+            <a:off x="3261360" y="3227832"/>
             <a:ext cx="541325" cy="100584"/>
           </a:xfrm>
           <a:prstGeom prst="rect">
@@ -6761,13 +7141,13 @@
       </p:sp>
       <p:sp>
         <p:nvSpPr>
-          <p:cNvPr id="98" name="Text 96"/>
-          <p:cNvSpPr/>
-          <p:nvPr/>
-        </p:nvSpPr>
-        <p:spPr>
-          <a:xfrm>
-            <a:off x="3261360" y="2971800"/>
+          <p:cNvPr id="110" name="Text 108"/>
+          <p:cNvSpPr/>
+          <p:nvPr/>
+        </p:nvSpPr>
+        <p:spPr>
+          <a:xfrm>
+            <a:off x="3261360" y="3227832"/>
             <a:ext cx="541325" cy="100584"/>
           </a:xfrm>
           <a:prstGeom prst="rect">
@@ -6800,13 +7180,13 @@
       </p:sp>
       <p:sp>
         <p:nvSpPr>
-          <p:cNvPr id="99" name="Shape 97"/>
-          <p:cNvSpPr/>
-          <p:nvPr/>
-        </p:nvSpPr>
-        <p:spPr>
-          <a:xfrm>
-            <a:off x="3169920" y="3145536"/>
+          <p:cNvPr id="111" name="Shape 109"/>
+          <p:cNvSpPr/>
+          <p:nvPr/>
+        </p:nvSpPr>
+        <p:spPr>
+          <a:xfrm>
+            <a:off x="3169920" y="3401568"/>
             <a:ext cx="2804160" cy="438912"/>
           </a:xfrm>
           <a:prstGeom prst="rect">
@@ -6825,13 +7205,13 @@
       </p:sp>
       <p:sp>
         <p:nvSpPr>
-          <p:cNvPr id="100" name="Shape 98"/>
-          <p:cNvSpPr/>
-          <p:nvPr/>
-        </p:nvSpPr>
-        <p:spPr>
-          <a:xfrm>
-            <a:off x="3169920" y="3145536"/>
+          <p:cNvPr id="112" name="Shape 110"/>
+          <p:cNvSpPr/>
+          <p:nvPr/>
+        </p:nvSpPr>
+        <p:spPr>
+          <a:xfrm>
+            <a:off x="3169920" y="3401568"/>
             <a:ext cx="50292" cy="438912"/>
           </a:xfrm>
           <a:prstGeom prst="rect">
@@ -6850,13 +7230,13 @@
       </p:sp>
       <p:sp>
         <p:nvSpPr>
-          <p:cNvPr id="101" name="Text 99"/>
-          <p:cNvSpPr/>
-          <p:nvPr/>
-        </p:nvSpPr>
-        <p:spPr>
-          <a:xfrm>
-            <a:off x="3261360" y="3172968"/>
+          <p:cNvPr id="113" name="Text 111"/>
+          <p:cNvSpPr/>
+          <p:nvPr/>
+        </p:nvSpPr>
+        <p:spPr>
+          <a:xfrm>
+            <a:off x="3261360" y="3429000"/>
             <a:ext cx="2657856" cy="164592"/>
           </a:xfrm>
           <a:prstGeom prst="rect">
@@ -6889,13 +7269,13 @@
       </p:sp>
       <p:sp>
         <p:nvSpPr>
-          <p:cNvPr id="102" name="Text 100"/>
-          <p:cNvSpPr/>
-          <p:nvPr/>
-        </p:nvSpPr>
-        <p:spPr>
-          <a:xfrm>
-            <a:off x="3261360" y="3355848"/>
+          <p:cNvPr id="114" name="Text 112"/>
+          <p:cNvSpPr/>
+          <p:nvPr/>
+        </p:nvSpPr>
+        <p:spPr>
+          <a:xfrm>
+            <a:off x="3261360" y="3611880"/>
             <a:ext cx="2657856" cy="128016"/>
           </a:xfrm>
           <a:prstGeom prst="rect">
@@ -6928,13 +7308,13 @@
       </p:sp>
       <p:sp>
         <p:nvSpPr>
-          <p:cNvPr id="103" name="Shape 101"/>
-          <p:cNvSpPr/>
-          <p:nvPr/>
-        </p:nvSpPr>
-        <p:spPr>
-          <a:xfrm>
-            <a:off x="3261360" y="3465576"/>
+          <p:cNvPr id="115" name="Shape 113"/>
+          <p:cNvSpPr/>
+          <p:nvPr/>
+        </p:nvSpPr>
+        <p:spPr>
+          <a:xfrm>
+            <a:off x="3261360" y="3721608"/>
             <a:ext cx="585216" cy="100584"/>
           </a:xfrm>
           <a:prstGeom prst="rect">
@@ -6955,13 +7335,13 @@
       </p:sp>
       <p:sp>
         <p:nvSpPr>
-          <p:cNvPr id="104" name="Text 102"/>
-          <p:cNvSpPr/>
-          <p:nvPr/>
-        </p:nvSpPr>
-        <p:spPr>
-          <a:xfrm>
-            <a:off x="3261360" y="3465576"/>
+          <p:cNvPr id="116" name="Text 114"/>
+          <p:cNvSpPr/>
+          <p:nvPr/>
+        </p:nvSpPr>
+        <p:spPr>
+          <a:xfrm>
+            <a:off x="3261360" y="3721608"/>
             <a:ext cx="585216" cy="100584"/>
           </a:xfrm>
           <a:prstGeom prst="rect">
@@ -6994,14 +7374,14 @@
       </p:sp>
       <p:sp>
         <p:nvSpPr>
-          <p:cNvPr id="105" name="Shape 103"/>
-          <p:cNvSpPr/>
-          <p:nvPr/>
-        </p:nvSpPr>
-        <p:spPr>
-          <a:xfrm>
-            <a:off x="3169920" y="3639312"/>
-            <a:ext cx="2804160" cy="621792"/>
+          <p:cNvPr id="117" name="Shape 115"/>
+          <p:cNvSpPr/>
+          <p:nvPr/>
+        </p:nvSpPr>
+        <p:spPr>
+          <a:xfrm>
+            <a:off x="3169920" y="3895344"/>
+            <a:ext cx="2804160" cy="438912"/>
           </a:xfrm>
           <a:prstGeom prst="rect">
             <a:avLst/>
@@ -7009,7 +7389,32 @@
           <a:solidFill>
             <a:srgbClr val="FFFFFF"/>
           </a:solidFill>
-          <a:ln w="9525">
+          <a:ln w="6350">
+            <a:solidFill>
+              <a:srgbClr val="B6BBC0"/>
+            </a:solidFill>
+            <a:prstDash val="solid"/>
+          </a:ln>
+        </p:spPr>
+      </p:sp>
+      <p:sp>
+        <p:nvSpPr>
+          <p:cNvPr id="118" name="Shape 116"/>
+          <p:cNvSpPr/>
+          <p:nvPr/>
+        </p:nvSpPr>
+        <p:spPr>
+          <a:xfrm>
+            <a:off x="3169920" y="3895344"/>
+            <a:ext cx="50292" cy="438912"/>
+          </a:xfrm>
+          <a:prstGeom prst="rect">
+            <a:avLst/>
+          </a:prstGeom>
+          <a:solidFill>
+            <a:srgbClr val="0A5CA8"/>
+          </a:solidFill>
+          <a:ln w="12700">
             <a:solidFill>
               <a:srgbClr val="0A5CA8"/>
             </a:solidFill>
@@ -7019,38 +7424,52 @@
       </p:sp>
       <p:sp>
         <p:nvSpPr>
-          <p:cNvPr id="106" name="Shape 104"/>
-          <p:cNvSpPr/>
-          <p:nvPr/>
-        </p:nvSpPr>
-        <p:spPr>
-          <a:xfrm>
-            <a:off x="3169920" y="3639312"/>
-            <a:ext cx="50292" cy="621792"/>
-          </a:xfrm>
-          <a:prstGeom prst="rect">
-            <a:avLst/>
-          </a:prstGeom>
-          <a:solidFill>
-            <a:srgbClr val="0A5CA8"/>
-          </a:solidFill>
-          <a:ln w="12700">
-            <a:solidFill>
-              <a:srgbClr val="0A5CA8"/>
-            </a:solidFill>
-            <a:prstDash val="solid"/>
-          </a:ln>
-        </p:spPr>
-      </p:sp>
-      <p:sp>
-        <p:nvSpPr>
-          <p:cNvPr id="107" name="Text 105"/>
-          <p:cNvSpPr/>
-          <p:nvPr/>
-        </p:nvSpPr>
-        <p:spPr>
-          <a:xfrm>
-            <a:off x="3261360" y="3666744"/>
+          <p:cNvPr id="119" name="Text 117"/>
+          <p:cNvSpPr/>
+          <p:nvPr/>
+        </p:nvSpPr>
+        <p:spPr>
+          <a:xfrm>
+            <a:off x="3261360" y="3922776"/>
+            <a:ext cx="2657856" cy="164592"/>
+          </a:xfrm>
+          <a:prstGeom prst="rect">
+            <a:avLst/>
+          </a:prstGeom>
+          <a:noFill/>
+          <a:ln/>
+        </p:spPr>
+        <p:txBody>
+          <a:bodyPr wrap="square" rtlCol="0" anchor="ctr"/>
+          <a:lstStyle/>
+          <a:p>
+            <a:pPr indent="0" marL="0">
+              <a:buNone/>
+            </a:pPr>
+            <a:r>
+              <a:rPr lang="en-US" sz="850" b="1" dirty="0">
+                <a:solidFill>
+                  <a:srgbClr val="06185F"/>
+                </a:solidFill>
+                <a:latin typeface="Calibri" pitchFamily="34" charset="0"/>
+                <a:ea typeface="Calibri" pitchFamily="34" charset="-122"/>
+                <a:cs typeface="Calibri" pitchFamily="34" charset="-120"/>
+              </a:rPr>
+              <a:t>Nitesh Gupta</a:t>
+            </a:r>
+            <a:endParaRPr lang="en-US" sz="850" dirty="0"/>
+          </a:p>
+        </p:txBody>
+      </p:sp>
+      <p:sp>
+        <p:nvSpPr>
+          <p:cNvPr id="120" name="Text 118"/>
+          <p:cNvSpPr/>
+          <p:nvPr/>
+        </p:nvSpPr>
+        <p:spPr>
+          <a:xfrm>
+            <a:off x="3261360" y="4105656"/>
             <a:ext cx="2657856" cy="128016"/>
           </a:xfrm>
           <a:prstGeom prst="rect">
@@ -7067,108 +7486,7 @@
               <a:buNone/>
             </a:pPr>
             <a:r>
-              <a:rPr lang="en-US" sz="750" b="1" dirty="0">
-                <a:solidFill>
-                  <a:srgbClr val="06185F"/>
-                </a:solidFill>
-                <a:latin typeface="Calibri" pitchFamily="34" charset="0"/>
-                <a:ea typeface="Calibri" pitchFamily="34" charset="-122"/>
-                <a:cs typeface="Calibri" pitchFamily="34" charset="-120"/>
-              </a:rPr>
-              <a:t>[PM Function TBD]</a:t>
-            </a:r>
-            <a:endParaRPr lang="en-US" sz="750" dirty="0"/>
-          </a:p>
-        </p:txBody>
-      </p:sp>
-      <p:sp>
-        <p:nvSpPr>
-          <p:cNvPr id="108" name="Shape 106"/>
-          <p:cNvSpPr/>
-          <p:nvPr/>
-        </p:nvSpPr>
-        <p:spPr>
-          <a:xfrm>
-            <a:off x="3243072" y="3813048"/>
-            <a:ext cx="2657856" cy="0"/>
-          </a:xfrm>
-          <a:prstGeom prst="line">
-            <a:avLst/>
-          </a:prstGeom>
-          <a:noFill/>
-          <a:ln w="6350">
-            <a:solidFill>
-              <a:srgbClr val="E7ECF0"/>
-            </a:solidFill>
-            <a:prstDash val="solid"/>
-          </a:ln>
-        </p:spPr>
-      </p:sp>
-      <p:sp>
-        <p:nvSpPr>
-          <p:cNvPr id="109" name="Text 107"/>
-          <p:cNvSpPr/>
-          <p:nvPr/>
-        </p:nvSpPr>
-        <p:spPr>
-          <a:xfrm>
-            <a:off x="3220212" y="3831336"/>
-            <a:ext cx="917956" cy="182880"/>
-          </a:xfrm>
-          <a:prstGeom prst="rect">
-            <a:avLst/>
-          </a:prstGeom>
-          <a:noFill/>
-          <a:ln/>
-        </p:spPr>
-        <p:txBody>
-          <a:bodyPr wrap="square" rtlCol="0" anchor="ctr"/>
-          <a:lstStyle/>
-          <a:p>
-            <a:pPr algn="ctr" indent="0" marL="0">
-              <a:buNone/>
-            </a:pPr>
-            <a:r>
-              <a:rPr lang="en-US" sz="1300" b="1" dirty="0">
-                <a:solidFill>
-                  <a:srgbClr val="06185F"/>
-                </a:solidFill>
-                <a:latin typeface="Calibri" pitchFamily="34" charset="0"/>
-                <a:ea typeface="Calibri" pitchFamily="34" charset="-122"/>
-                <a:cs typeface="Calibri" pitchFamily="34" charset="-120"/>
-              </a:rPr>
-              <a:t>—</a:t>
-            </a:r>
-            <a:endParaRPr lang="en-US" sz="1300" dirty="0"/>
-          </a:p>
-        </p:txBody>
-      </p:sp>
-      <p:sp>
-        <p:nvSpPr>
-          <p:cNvPr id="110" name="Text 108"/>
-          <p:cNvSpPr/>
-          <p:nvPr/>
-        </p:nvSpPr>
-        <p:spPr>
-          <a:xfrm>
-            <a:off x="3220212" y="4023360"/>
-            <a:ext cx="917956" cy="91440"/>
-          </a:xfrm>
-          <a:prstGeom prst="rect">
-            <a:avLst/>
-          </a:prstGeom>
-          <a:noFill/>
-          <a:ln/>
-        </p:spPr>
-        <p:txBody>
-          <a:bodyPr wrap="square" rtlCol="0" anchor="ctr"/>
-          <a:lstStyle/>
-          <a:p>
-            <a:pPr algn="ctr" indent="0" marL="0">
-              <a:buNone/>
-            </a:pPr>
-            <a:r>
-              <a:rPr lang="en-US" sz="550" dirty="0">
+              <a:rPr lang="en-US" sz="700" dirty="0">
                 <a:solidFill>
                   <a:srgbClr val="575A5D"/>
                 </a:solidFill>
@@ -7176,223 +7494,21 @@
                 <a:ea typeface="Calibri" pitchFamily="34" charset="-122"/>
                 <a:cs typeface="Calibri" pitchFamily="34" charset="-120"/>
               </a:rPr>
-              <a:t>Existing FTEs</a:t>
-            </a:r>
-            <a:endParaRPr lang="en-US" sz="550" dirty="0"/>
-          </a:p>
-        </p:txBody>
-      </p:sp>
-      <p:sp>
-        <p:nvSpPr>
-          <p:cNvPr id="111" name="Shape 109"/>
-          <p:cNvSpPr/>
-          <p:nvPr/>
-        </p:nvSpPr>
-        <p:spPr>
-          <a:xfrm>
-            <a:off x="4138168" y="3831336"/>
-            <a:ext cx="0" cy="320040"/>
-          </a:xfrm>
-          <a:prstGeom prst="line">
-            <a:avLst/>
-          </a:prstGeom>
-          <a:noFill/>
-          <a:ln w="6350">
-            <a:solidFill>
-              <a:srgbClr val="E7ECF0"/>
-            </a:solidFill>
-            <a:prstDash val="solid"/>
-          </a:ln>
-        </p:spPr>
-      </p:sp>
-      <p:sp>
-        <p:nvSpPr>
-          <p:cNvPr id="112" name="Text 110"/>
-          <p:cNvSpPr/>
-          <p:nvPr/>
-        </p:nvSpPr>
-        <p:spPr>
-          <a:xfrm>
-            <a:off x="4138168" y="3831336"/>
-            <a:ext cx="917956" cy="182880"/>
-          </a:xfrm>
-          <a:prstGeom prst="rect">
-            <a:avLst/>
-          </a:prstGeom>
-          <a:noFill/>
-          <a:ln/>
-        </p:spPr>
-        <p:txBody>
-          <a:bodyPr wrap="square" rtlCol="0" anchor="ctr"/>
-          <a:lstStyle/>
-          <a:p>
-            <a:pPr algn="ctr" indent="0" marL="0">
-              <a:buNone/>
-            </a:pPr>
-            <a:r>
-              <a:rPr lang="en-US" sz="1300" b="1" dirty="0">
-                <a:solidFill>
-                  <a:srgbClr val="0A5CA8"/>
-                </a:solidFill>
-                <a:latin typeface="Calibri" pitchFamily="34" charset="0"/>
-                <a:ea typeface="Calibri" pitchFamily="34" charset="-122"/>
-                <a:cs typeface="Calibri" pitchFamily="34" charset="-120"/>
-              </a:rPr>
-              <a:t>—</a:t>
-            </a:r>
-            <a:endParaRPr lang="en-US" sz="1300" dirty="0"/>
-          </a:p>
-        </p:txBody>
-      </p:sp>
-      <p:sp>
-        <p:nvSpPr>
-          <p:cNvPr id="113" name="Text 111"/>
-          <p:cNvSpPr/>
-          <p:nvPr/>
-        </p:nvSpPr>
-        <p:spPr>
-          <a:xfrm>
-            <a:off x="4138168" y="4023360"/>
-            <a:ext cx="917956" cy="91440"/>
-          </a:xfrm>
-          <a:prstGeom prst="rect">
-            <a:avLst/>
-          </a:prstGeom>
-          <a:noFill/>
-          <a:ln/>
-        </p:spPr>
-        <p:txBody>
-          <a:bodyPr wrap="square" rtlCol="0" anchor="ctr"/>
-          <a:lstStyle/>
-          <a:p>
-            <a:pPr algn="ctr" indent="0" marL="0">
-              <a:buNone/>
-            </a:pPr>
-            <a:r>
-              <a:rPr lang="en-US" sz="550" dirty="0">
-                <a:solidFill>
-                  <a:srgbClr val="575A5D"/>
-                </a:solidFill>
-                <a:latin typeface="Calibri" pitchFamily="34" charset="0"/>
-                <a:ea typeface="Calibri" pitchFamily="34" charset="-122"/>
-                <a:cs typeface="Calibri" pitchFamily="34" charset="-120"/>
-              </a:rPr>
-              <a:t>Contractors</a:t>
-            </a:r>
-            <a:endParaRPr lang="en-US" sz="550" dirty="0"/>
-          </a:p>
-        </p:txBody>
-      </p:sp>
-      <p:sp>
-        <p:nvSpPr>
-          <p:cNvPr id="114" name="Shape 112"/>
-          <p:cNvSpPr/>
-          <p:nvPr/>
-        </p:nvSpPr>
-        <p:spPr>
-          <a:xfrm>
-            <a:off x="5056124" y="3831336"/>
-            <a:ext cx="0" cy="320040"/>
-          </a:xfrm>
-          <a:prstGeom prst="line">
-            <a:avLst/>
-          </a:prstGeom>
-          <a:noFill/>
-          <a:ln w="6350">
-            <a:solidFill>
-              <a:srgbClr val="E7ECF0"/>
-            </a:solidFill>
-            <a:prstDash val="solid"/>
-          </a:ln>
-        </p:spPr>
-      </p:sp>
-      <p:sp>
-        <p:nvSpPr>
-          <p:cNvPr id="115" name="Text 113"/>
-          <p:cNvSpPr/>
-          <p:nvPr/>
-        </p:nvSpPr>
-        <p:spPr>
-          <a:xfrm>
-            <a:off x="5056124" y="3831336"/>
-            <a:ext cx="917956" cy="182880"/>
-          </a:xfrm>
-          <a:prstGeom prst="rect">
-            <a:avLst/>
-          </a:prstGeom>
-          <a:noFill/>
-          <a:ln/>
-        </p:spPr>
-        <p:txBody>
-          <a:bodyPr wrap="square" rtlCol="0" anchor="ctr"/>
-          <a:lstStyle/>
-          <a:p>
-            <a:pPr algn="ctr" indent="0" marL="0">
-              <a:buNone/>
-            </a:pPr>
-            <a:r>
-              <a:rPr lang="en-US" sz="1300" b="1" dirty="0">
-                <a:solidFill>
-                  <a:srgbClr val="0A5C47"/>
-                </a:solidFill>
-                <a:latin typeface="Calibri" pitchFamily="34" charset="0"/>
-                <a:ea typeface="Calibri" pitchFamily="34" charset="-122"/>
-                <a:cs typeface="Calibri" pitchFamily="34" charset="-120"/>
-              </a:rPr>
-              <a:t>—</a:t>
-            </a:r>
-            <a:endParaRPr lang="en-US" sz="1300" dirty="0"/>
-          </a:p>
-        </p:txBody>
-      </p:sp>
-      <p:sp>
-        <p:nvSpPr>
-          <p:cNvPr id="116" name="Text 114"/>
-          <p:cNvSpPr/>
-          <p:nvPr/>
-        </p:nvSpPr>
-        <p:spPr>
-          <a:xfrm>
-            <a:off x="5056124" y="4023360"/>
-            <a:ext cx="917956" cy="91440"/>
-          </a:xfrm>
-          <a:prstGeom prst="rect">
-            <a:avLst/>
-          </a:prstGeom>
-          <a:noFill/>
-          <a:ln/>
-        </p:spPr>
-        <p:txBody>
-          <a:bodyPr wrap="square" rtlCol="0" anchor="ctr"/>
-          <a:lstStyle/>
-          <a:p>
-            <a:pPr algn="ctr" indent="0" marL="0">
-              <a:buNone/>
-            </a:pPr>
-            <a:r>
-              <a:rPr lang="en-US" sz="550" dirty="0">
-                <a:solidFill>
-                  <a:srgbClr val="575A5D"/>
-                </a:solidFill>
-                <a:latin typeface="Calibri" pitchFamily="34" charset="0"/>
-                <a:ea typeface="Calibri" pitchFamily="34" charset="-122"/>
-                <a:cs typeface="Calibri" pitchFamily="34" charset="-120"/>
-              </a:rPr>
-              <a:t>New FTEs Req.</a:t>
-            </a:r>
-            <a:endParaRPr lang="en-US" sz="550" dirty="0"/>
-          </a:p>
-        </p:txBody>
-      </p:sp>
-      <p:sp>
-        <p:nvSpPr>
-          <p:cNvPr id="117" name="Shape 115"/>
-          <p:cNvSpPr/>
-          <p:nvPr/>
-        </p:nvSpPr>
-        <p:spPr>
-          <a:xfrm>
-            <a:off x="3261360" y="4142232"/>
+              <a:t>PM, Analytics &amp; DS Platform</a:t>
+            </a:r>
+            <a:endParaRPr lang="en-US" sz="700" dirty="0"/>
+          </a:p>
+        </p:txBody>
+      </p:sp>
+      <p:sp>
+        <p:nvSpPr>
+          <p:cNvPr id="121" name="Shape 119"/>
+          <p:cNvSpPr/>
+          <p:nvPr/>
+        </p:nvSpPr>
+        <p:spPr>
+          <a:xfrm>
+            <a:off x="3261360" y="4215384"/>
             <a:ext cx="585216" cy="100584"/>
           </a:xfrm>
           <a:prstGeom prst="rect">
@@ -7413,13 +7529,13 @@
       </p:sp>
       <p:sp>
         <p:nvSpPr>
-          <p:cNvPr id="118" name="Text 116"/>
-          <p:cNvSpPr/>
-          <p:nvPr/>
-        </p:nvSpPr>
-        <p:spPr>
-          <a:xfrm>
-            <a:off x="3261360" y="4142232"/>
+          <p:cNvPr id="122" name="Text 120"/>
+          <p:cNvSpPr/>
+          <p:nvPr/>
+        </p:nvSpPr>
+        <p:spPr>
+          <a:xfrm>
+            <a:off x="3261360" y="4215384"/>
             <a:ext cx="585216" cy="100584"/>
           </a:xfrm>
           <a:prstGeom prst="rect">
@@ -7452,14 +7568,14 @@
       </p:sp>
       <p:sp>
         <p:nvSpPr>
-          <p:cNvPr id="119" name="Shape 117"/>
+          <p:cNvPr id="123" name="Shape 121"/>
           <p:cNvSpPr/>
           <p:nvPr/>
         </p:nvSpPr>
         <p:spPr>
           <a:xfrm>
             <a:off x="7595616" y="2029968"/>
-            <a:ext cx="0" cy="128016"/>
+            <a:ext cx="0" cy="384048"/>
           </a:xfrm>
           <a:prstGeom prst="line">
             <a:avLst/>
@@ -7475,13 +7591,13 @@
       </p:sp>
       <p:sp>
         <p:nvSpPr>
-          <p:cNvPr id="120" name="Shape 118"/>
-          <p:cNvSpPr/>
-          <p:nvPr/>
-        </p:nvSpPr>
-        <p:spPr>
-          <a:xfrm>
-            <a:off x="6193536" y="2157984"/>
+          <p:cNvPr id="124" name="Shape 122"/>
+          <p:cNvSpPr/>
+          <p:nvPr/>
+        </p:nvSpPr>
+        <p:spPr>
+          <a:xfrm>
+            <a:off x="6193536" y="2414016"/>
             <a:ext cx="2804160" cy="621792"/>
           </a:xfrm>
           <a:prstGeom prst="rect">
@@ -7500,13 +7616,13 @@
       </p:sp>
       <p:sp>
         <p:nvSpPr>
-          <p:cNvPr id="121" name="Shape 119"/>
-          <p:cNvSpPr/>
-          <p:nvPr/>
-        </p:nvSpPr>
-        <p:spPr>
-          <a:xfrm>
-            <a:off x="6193536" y="2157984"/>
+          <p:cNvPr id="125" name="Shape 123"/>
+          <p:cNvSpPr/>
+          <p:nvPr/>
+        </p:nvSpPr>
+        <p:spPr>
+          <a:xfrm>
+            <a:off x="6193536" y="2414016"/>
             <a:ext cx="50292" cy="621792"/>
           </a:xfrm>
           <a:prstGeom prst="rect">
@@ -7525,13 +7641,13 @@
       </p:sp>
       <p:sp>
         <p:nvSpPr>
-          <p:cNvPr id="122" name="Text 120"/>
-          <p:cNvSpPr/>
-          <p:nvPr/>
-        </p:nvSpPr>
-        <p:spPr>
-          <a:xfrm>
-            <a:off x="6284976" y="2185416"/>
+          <p:cNvPr id="126" name="Text 124"/>
+          <p:cNvSpPr/>
+          <p:nvPr/>
+        </p:nvSpPr>
+        <p:spPr>
+          <a:xfrm>
+            <a:off x="6284976" y="2441448"/>
             <a:ext cx="2657856" cy="128016"/>
           </a:xfrm>
           <a:prstGeom prst="rect">
@@ -7564,13 +7680,13 @@
       </p:sp>
       <p:sp>
         <p:nvSpPr>
-          <p:cNvPr id="123" name="Shape 121"/>
-          <p:cNvSpPr/>
-          <p:nvPr/>
-        </p:nvSpPr>
-        <p:spPr>
-          <a:xfrm>
-            <a:off x="6266688" y="2331720"/>
+          <p:cNvPr id="127" name="Shape 125"/>
+          <p:cNvSpPr/>
+          <p:nvPr/>
+        </p:nvSpPr>
+        <p:spPr>
+          <a:xfrm>
+            <a:off x="6266688" y="2587752"/>
             <a:ext cx="2657856" cy="0"/>
           </a:xfrm>
           <a:prstGeom prst="line">
@@ -7587,13 +7703,13 @@
       </p:sp>
       <p:sp>
         <p:nvSpPr>
-          <p:cNvPr id="124" name="Text 122"/>
-          <p:cNvSpPr/>
-          <p:nvPr/>
-        </p:nvSpPr>
-        <p:spPr>
-          <a:xfrm>
-            <a:off x="6243828" y="2350008"/>
+          <p:cNvPr id="128" name="Text 126"/>
+          <p:cNvSpPr/>
+          <p:nvPr/>
+        </p:nvSpPr>
+        <p:spPr>
+          <a:xfrm>
+            <a:off x="6243828" y="2606040"/>
             <a:ext cx="917956" cy="182880"/>
           </a:xfrm>
           <a:prstGeom prst="rect">
@@ -7626,13 +7742,13 @@
       </p:sp>
       <p:sp>
         <p:nvSpPr>
-          <p:cNvPr id="125" name="Text 123"/>
-          <p:cNvSpPr/>
-          <p:nvPr/>
-        </p:nvSpPr>
-        <p:spPr>
-          <a:xfrm>
-            <a:off x="6243828" y="2542032"/>
+          <p:cNvPr id="129" name="Text 127"/>
+          <p:cNvSpPr/>
+          <p:nvPr/>
+        </p:nvSpPr>
+        <p:spPr>
+          <a:xfrm>
+            <a:off x="6243828" y="2798064"/>
             <a:ext cx="917956" cy="91440"/>
           </a:xfrm>
           <a:prstGeom prst="rect">
@@ -7665,13 +7781,13 @@
       </p:sp>
       <p:sp>
         <p:nvSpPr>
-          <p:cNvPr id="126" name="Shape 124"/>
-          <p:cNvSpPr/>
-          <p:nvPr/>
-        </p:nvSpPr>
-        <p:spPr>
-          <a:xfrm>
-            <a:off x="7161784" y="2350008"/>
+          <p:cNvPr id="130" name="Shape 128"/>
+          <p:cNvSpPr/>
+          <p:nvPr/>
+        </p:nvSpPr>
+        <p:spPr>
+          <a:xfrm>
+            <a:off x="7161784" y="2606040"/>
             <a:ext cx="0" cy="320040"/>
           </a:xfrm>
           <a:prstGeom prst="line">
@@ -7688,13 +7804,13 @@
       </p:sp>
       <p:sp>
         <p:nvSpPr>
-          <p:cNvPr id="127" name="Text 125"/>
-          <p:cNvSpPr/>
-          <p:nvPr/>
-        </p:nvSpPr>
-        <p:spPr>
-          <a:xfrm>
-            <a:off x="7161784" y="2350008"/>
+          <p:cNvPr id="131" name="Text 129"/>
+          <p:cNvSpPr/>
+          <p:nvPr/>
+        </p:nvSpPr>
+        <p:spPr>
+          <a:xfrm>
+            <a:off x="7161784" y="2606040"/>
             <a:ext cx="917956" cy="182880"/>
           </a:xfrm>
           <a:prstGeom prst="rect">
@@ -7727,13 +7843,13 @@
       </p:sp>
       <p:sp>
         <p:nvSpPr>
-          <p:cNvPr id="128" name="Text 126"/>
-          <p:cNvSpPr/>
-          <p:nvPr/>
-        </p:nvSpPr>
-        <p:spPr>
-          <a:xfrm>
-            <a:off x="7161784" y="2542032"/>
+          <p:cNvPr id="132" name="Text 130"/>
+          <p:cNvSpPr/>
+          <p:nvPr/>
+        </p:nvSpPr>
+        <p:spPr>
+          <a:xfrm>
+            <a:off x="7161784" y="2798064"/>
             <a:ext cx="917956" cy="91440"/>
           </a:xfrm>
           <a:prstGeom prst="rect">
@@ -7766,13 +7882,13 @@
       </p:sp>
       <p:sp>
         <p:nvSpPr>
-          <p:cNvPr id="129" name="Shape 127"/>
-          <p:cNvSpPr/>
-          <p:nvPr/>
-        </p:nvSpPr>
-        <p:spPr>
-          <a:xfrm>
-            <a:off x="8079740" y="2350008"/>
+          <p:cNvPr id="133" name="Shape 131"/>
+          <p:cNvSpPr/>
+          <p:nvPr/>
+        </p:nvSpPr>
+        <p:spPr>
+          <a:xfrm>
+            <a:off x="8079740" y="2606040"/>
             <a:ext cx="0" cy="320040"/>
           </a:xfrm>
           <a:prstGeom prst="line">
@@ -7789,13 +7905,13 @@
       </p:sp>
       <p:sp>
         <p:nvSpPr>
-          <p:cNvPr id="130" name="Text 128"/>
-          <p:cNvSpPr/>
-          <p:nvPr/>
-        </p:nvSpPr>
-        <p:spPr>
-          <a:xfrm>
-            <a:off x="8079740" y="2350008"/>
+          <p:cNvPr id="134" name="Text 132"/>
+          <p:cNvSpPr/>
+          <p:nvPr/>
+        </p:nvSpPr>
+        <p:spPr>
+          <a:xfrm>
+            <a:off x="8079740" y="2606040"/>
             <a:ext cx="917956" cy="182880"/>
           </a:xfrm>
           <a:prstGeom prst="rect">
@@ -7828,13 +7944,13 @@
       </p:sp>
       <p:sp>
         <p:nvSpPr>
-          <p:cNvPr id="131" name="Text 129"/>
-          <p:cNvSpPr/>
-          <p:nvPr/>
-        </p:nvSpPr>
-        <p:spPr>
-          <a:xfrm>
-            <a:off x="8079740" y="2542032"/>
+          <p:cNvPr id="135" name="Text 133"/>
+          <p:cNvSpPr/>
+          <p:nvPr/>
+        </p:nvSpPr>
+        <p:spPr>
+          <a:xfrm>
+            <a:off x="8079740" y="2798064"/>
             <a:ext cx="917956" cy="91440"/>
           </a:xfrm>
           <a:prstGeom prst="rect">
@@ -7867,13 +7983,13 @@
       </p:sp>
       <p:sp>
         <p:nvSpPr>
-          <p:cNvPr id="132" name="Shape 130"/>
-          <p:cNvSpPr/>
-          <p:nvPr/>
-        </p:nvSpPr>
-        <p:spPr>
-          <a:xfrm>
-            <a:off x="6284976" y="2660904"/>
+          <p:cNvPr id="136" name="Shape 134"/>
+          <p:cNvSpPr/>
+          <p:nvPr/>
+        </p:nvSpPr>
+        <p:spPr>
+          <a:xfrm>
+            <a:off x="6284976" y="2916936"/>
             <a:ext cx="585216" cy="100584"/>
           </a:xfrm>
           <a:prstGeom prst="rect">
@@ -7894,13 +8010,13 @@
       </p:sp>
       <p:sp>
         <p:nvSpPr>
-          <p:cNvPr id="133" name="Text 131"/>
-          <p:cNvSpPr/>
-          <p:nvPr/>
-        </p:nvSpPr>
-        <p:spPr>
-          <a:xfrm>
-            <a:off x="6284976" y="2660904"/>
+          <p:cNvPr id="137" name="Text 135"/>
+          <p:cNvSpPr/>
+          <p:nvPr/>
+        </p:nvSpPr>
+        <p:spPr>
+          <a:xfrm>
+            <a:off x="6284976" y="2916936"/>
             <a:ext cx="585216" cy="100584"/>
           </a:xfrm>
           <a:prstGeom prst="rect">
@@ -7933,13 +8049,13 @@
       </p:sp>
       <p:sp>
         <p:nvSpPr>
-          <p:cNvPr id="134" name="Shape 132"/>
-          <p:cNvSpPr/>
-          <p:nvPr/>
-        </p:nvSpPr>
-        <p:spPr>
-          <a:xfrm>
-            <a:off x="6193536" y="2834640"/>
+          <p:cNvPr id="138" name="Shape 136"/>
+          <p:cNvSpPr/>
+          <p:nvPr/>
+        </p:nvSpPr>
+        <p:spPr>
+          <a:xfrm>
+            <a:off x="6193536" y="3090672"/>
             <a:ext cx="2804160" cy="457200"/>
           </a:xfrm>
           <a:prstGeom prst="rect">
@@ -7960,13 +8076,13 @@
       </p:sp>
       <p:sp>
         <p:nvSpPr>
-          <p:cNvPr id="135" name="Shape 133"/>
-          <p:cNvSpPr/>
-          <p:nvPr/>
-        </p:nvSpPr>
-        <p:spPr>
-          <a:xfrm>
-            <a:off x="6193536" y="2834640"/>
+          <p:cNvPr id="139" name="Shape 137"/>
+          <p:cNvSpPr/>
+          <p:nvPr/>
+        </p:nvSpPr>
+        <p:spPr>
+          <a:xfrm>
+            <a:off x="6193536" y="3090672"/>
             <a:ext cx="50292" cy="457200"/>
           </a:xfrm>
           <a:prstGeom prst="rect">
@@ -7989,13 +8105,13 @@
       </p:sp>
       <p:sp>
         <p:nvSpPr>
-          <p:cNvPr id="136" name="Text 134"/>
-          <p:cNvSpPr/>
-          <p:nvPr/>
-        </p:nvSpPr>
-        <p:spPr>
-          <a:xfrm>
-            <a:off x="6284976" y="2862072"/>
+          <p:cNvPr id="140" name="Text 138"/>
+          <p:cNvSpPr/>
+          <p:nvPr/>
+        </p:nvSpPr>
+        <p:spPr>
+          <a:xfrm>
+            <a:off x="6284976" y="3118104"/>
             <a:ext cx="2328672" cy="182880"/>
           </a:xfrm>
           <a:prstGeom prst="rect">
@@ -8028,13 +8144,13 @@
       </p:sp>
       <p:sp>
         <p:nvSpPr>
-          <p:cNvPr id="137" name="Shape 135"/>
-          <p:cNvSpPr/>
-          <p:nvPr/>
-        </p:nvSpPr>
-        <p:spPr>
-          <a:xfrm>
-            <a:off x="8595360" y="2880360"/>
+          <p:cNvPr id="141" name="Shape 139"/>
+          <p:cNvSpPr/>
+          <p:nvPr/>
+        </p:nvSpPr>
+        <p:spPr>
+          <a:xfrm>
+            <a:off x="8595360" y="3136392"/>
             <a:ext cx="347472" cy="182880"/>
           </a:xfrm>
           <a:prstGeom prst="rect">
@@ -8053,13 +8169,13 @@
       </p:sp>
       <p:sp>
         <p:nvSpPr>
-          <p:cNvPr id="138" name="Text 136"/>
-          <p:cNvSpPr/>
-          <p:nvPr/>
-        </p:nvSpPr>
-        <p:spPr>
-          <a:xfrm>
-            <a:off x="8595360" y="2880360"/>
+          <p:cNvPr id="142" name="Text 140"/>
+          <p:cNvSpPr/>
+          <p:nvPr/>
+        </p:nvSpPr>
+        <p:spPr>
+          <a:xfrm>
+            <a:off x="8595360" y="3136392"/>
             <a:ext cx="347472" cy="182880"/>
           </a:xfrm>
           <a:prstGeom prst="rect">
@@ -8092,13 +8208,13 @@
       </p:sp>
       <p:sp>
         <p:nvSpPr>
-          <p:cNvPr id="139" name="Text 137"/>
-          <p:cNvSpPr/>
-          <p:nvPr/>
-        </p:nvSpPr>
-        <p:spPr>
-          <a:xfrm>
-            <a:off x="6284976" y="3081528"/>
+          <p:cNvPr id="143" name="Text 141"/>
+          <p:cNvSpPr/>
+          <p:nvPr/>
+        </p:nvSpPr>
+        <p:spPr>
+          <a:xfrm>
+            <a:off x="6284976" y="3337560"/>
             <a:ext cx="2657856" cy="118872"/>
           </a:xfrm>
           <a:prstGeom prst="rect">
@@ -8131,13 +8247,13 @@
       </p:sp>
       <p:sp>
         <p:nvSpPr>
-          <p:cNvPr id="140" name="Shape 138"/>
-          <p:cNvSpPr/>
-          <p:nvPr/>
-        </p:nvSpPr>
-        <p:spPr>
-          <a:xfrm>
-            <a:off x="6284976" y="3172968"/>
+          <p:cNvPr id="144" name="Shape 142"/>
+          <p:cNvSpPr/>
+          <p:nvPr/>
+        </p:nvSpPr>
+        <p:spPr>
+          <a:xfrm>
+            <a:off x="6284976" y="3429000"/>
             <a:ext cx="585216" cy="100584"/>
           </a:xfrm>
           <a:prstGeom prst="rect">
@@ -8158,13 +8274,13 @@
       </p:sp>
       <p:sp>
         <p:nvSpPr>
-          <p:cNvPr id="141" name="Text 139"/>
-          <p:cNvSpPr/>
-          <p:nvPr/>
-        </p:nvSpPr>
-        <p:spPr>
-          <a:xfrm>
-            <a:off x="6284976" y="3172968"/>
+          <p:cNvPr id="145" name="Text 143"/>
+          <p:cNvSpPr/>
+          <p:nvPr/>
+        </p:nvSpPr>
+        <p:spPr>
+          <a:xfrm>
+            <a:off x="6284976" y="3429000"/>
             <a:ext cx="585216" cy="100584"/>
           </a:xfrm>
           <a:prstGeom prst="rect">
@@ -8197,426 +8313,7 @@
       </p:sp>
       <p:sp>
         <p:nvSpPr>
-          <p:cNvPr id="142" name="Text 140"/>
-          <p:cNvSpPr/>
-          <p:nvPr/>
-        </p:nvSpPr>
-        <p:spPr>
-          <a:xfrm>
-            <a:off x="365760" y="4169664"/>
-            <a:ext cx="2743200" cy="128016"/>
-          </a:xfrm>
-          <a:prstGeom prst="rect">
-            <a:avLst/>
-          </a:prstGeom>
-          <a:noFill/>
-          <a:ln/>
-        </p:spPr>
-        <p:txBody>
-          <a:bodyPr wrap="square" rtlCol="0" anchor="ctr"/>
-          <a:lstStyle/>
-          <a:p>
-            <a:pPr indent="0" marL="0">
-              <a:buNone/>
-            </a:pPr>
-            <a:r>
-              <a:rPr lang="en-US" sz="600" b="1" dirty="0">
-                <a:solidFill>
-                  <a:srgbClr val="B6BBC0"/>
-                </a:solidFill>
-                <a:latin typeface="Calibri" pitchFamily="34" charset="0"/>
-                <a:ea typeface="Calibri" pitchFamily="34" charset="-122"/>
-                <a:cs typeface="Calibri" pitchFamily="34" charset="-120"/>
-              </a:rPr>
-              <a:t>PILLAR OWNERSHIP</a:t>
-            </a:r>
-            <a:endParaRPr lang="en-US" sz="600" dirty="0"/>
-          </a:p>
-        </p:txBody>
-      </p:sp>
-      <p:sp>
-        <p:nvSpPr>
-          <p:cNvPr id="143" name="Shape 141"/>
-          <p:cNvSpPr/>
-          <p:nvPr/>
-        </p:nvSpPr>
-        <p:spPr>
-          <a:xfrm>
-            <a:off x="365760" y="4315968"/>
-            <a:ext cx="2020824" cy="219456"/>
-          </a:xfrm>
-          <a:prstGeom prst="rect">
-            <a:avLst/>
-          </a:prstGeom>
-          <a:solidFill>
-            <a:srgbClr val="06185F">
-              <a:alpha val="82000"/>
-            </a:srgbClr>
-          </a:solidFill>
-          <a:ln w="12700">
-            <a:solidFill>
-              <a:srgbClr val="06185F"/>
-            </a:solidFill>
-            <a:prstDash val="solid"/>
-          </a:ln>
-        </p:spPr>
-      </p:sp>
-      <p:sp>
-        <p:nvSpPr>
-          <p:cNvPr id="144" name="Shape 142"/>
-          <p:cNvSpPr/>
-          <p:nvPr/>
-        </p:nvSpPr>
-        <p:spPr>
-          <a:xfrm>
-            <a:off x="365760" y="4315968"/>
-            <a:ext cx="2020824" cy="36576"/>
-          </a:xfrm>
-          <a:prstGeom prst="rect">
-            <a:avLst/>
-          </a:prstGeom>
-          <a:solidFill>
-            <a:srgbClr val="FFFFFF">
-              <a:alpha val="50000"/>
-            </a:srgbClr>
-          </a:solidFill>
-          <a:ln w="12700">
-            <a:solidFill>
-              <a:srgbClr val="FFFFFF">
-                <a:alpha val="50000"/>
-              </a:srgbClr>
-            </a:solidFill>
-            <a:prstDash val="solid"/>
-          </a:ln>
-        </p:spPr>
-      </p:sp>
-      <p:sp>
-        <p:nvSpPr>
-          <p:cNvPr id="145" name="Text 143"/>
-          <p:cNvSpPr/>
-          <p:nvPr/>
-        </p:nvSpPr>
-        <p:spPr>
-          <a:xfrm>
-            <a:off x="365760" y="4315968"/>
-            <a:ext cx="2020824" cy="219456"/>
-          </a:xfrm>
-          <a:prstGeom prst="rect">
-            <a:avLst/>
-          </a:prstGeom>
-          <a:noFill/>
-          <a:ln/>
-        </p:spPr>
-        <p:txBody>
-          <a:bodyPr wrap="square" rtlCol="0" anchor="ctr"/>
-          <a:lstStyle/>
-          <a:p>
-            <a:pPr algn="ctr" indent="0" marL="0">
-              <a:buNone/>
-            </a:pPr>
-            <a:r>
-              <a:rPr lang="en-US" sz="800" b="1" dirty="0">
-                <a:solidFill>
-                  <a:srgbClr val="FFFFFF"/>
-                </a:solidFill>
-                <a:latin typeface="Calibri" pitchFamily="34" charset="0"/>
-                <a:ea typeface="Calibri" pitchFamily="34" charset="-122"/>
-                <a:cs typeface="Calibri" pitchFamily="34" charset="-120"/>
-              </a:rPr>
-              <a:t>The Foundation</a:t>
-            </a:r>
-            <a:endParaRPr lang="en-US" sz="800" dirty="0"/>
-          </a:p>
-        </p:txBody>
-      </p:sp>
-      <p:sp>
-        <p:nvSpPr>
           <p:cNvPr id="146" name="Shape 144"/>
-          <p:cNvSpPr/>
-          <p:nvPr/>
-        </p:nvSpPr>
-        <p:spPr>
-          <a:xfrm>
-            <a:off x="2496312" y="4315968"/>
-            <a:ext cx="2020824" cy="219456"/>
-          </a:xfrm>
-          <a:prstGeom prst="rect">
-            <a:avLst/>
-          </a:prstGeom>
-          <a:solidFill>
-            <a:srgbClr val="085CE5">
-              <a:alpha val="82000"/>
-            </a:srgbClr>
-          </a:solidFill>
-          <a:ln w="12700">
-            <a:solidFill>
-              <a:srgbClr val="085CE5"/>
-            </a:solidFill>
-            <a:prstDash val="solid"/>
-          </a:ln>
-        </p:spPr>
-      </p:sp>
-      <p:sp>
-        <p:nvSpPr>
-          <p:cNvPr id="147" name="Shape 145"/>
-          <p:cNvSpPr/>
-          <p:nvPr/>
-        </p:nvSpPr>
-        <p:spPr>
-          <a:xfrm>
-            <a:off x="2496312" y="4315968"/>
-            <a:ext cx="2020824" cy="36576"/>
-          </a:xfrm>
-          <a:prstGeom prst="rect">
-            <a:avLst/>
-          </a:prstGeom>
-          <a:solidFill>
-            <a:srgbClr val="FFFFFF">
-              <a:alpha val="50000"/>
-            </a:srgbClr>
-          </a:solidFill>
-          <a:ln w="12700">
-            <a:solidFill>
-              <a:srgbClr val="FFFFFF">
-                <a:alpha val="50000"/>
-              </a:srgbClr>
-            </a:solidFill>
-            <a:prstDash val="solid"/>
-          </a:ln>
-        </p:spPr>
-      </p:sp>
-      <p:sp>
-        <p:nvSpPr>
-          <p:cNvPr id="148" name="Text 146"/>
-          <p:cNvSpPr/>
-          <p:nvPr/>
-        </p:nvSpPr>
-        <p:spPr>
-          <a:xfrm>
-            <a:off x="2496312" y="4315968"/>
-            <a:ext cx="2020824" cy="219456"/>
-          </a:xfrm>
-          <a:prstGeom prst="rect">
-            <a:avLst/>
-          </a:prstGeom>
-          <a:noFill/>
-          <a:ln/>
-        </p:spPr>
-        <p:txBody>
-          <a:bodyPr wrap="square" rtlCol="0" anchor="ctr"/>
-          <a:lstStyle/>
-          <a:p>
-            <a:pPr algn="ctr" indent="0" marL="0">
-              <a:buNone/>
-            </a:pPr>
-            <a:r>
-              <a:rPr lang="en-US" sz="800" b="1" dirty="0">
-                <a:solidFill>
-                  <a:srgbClr val="FFFFFF"/>
-                </a:solidFill>
-                <a:latin typeface="Calibri" pitchFamily="34" charset="0"/>
-                <a:ea typeface="Calibri" pitchFamily="34" charset="-122"/>
-                <a:cs typeface="Calibri" pitchFamily="34" charset="-120"/>
-              </a:rPr>
-              <a:t>The Lens</a:t>
-            </a:r>
-            <a:endParaRPr lang="en-US" sz="800" dirty="0"/>
-          </a:p>
-        </p:txBody>
-      </p:sp>
-      <p:sp>
-        <p:nvSpPr>
-          <p:cNvPr id="149" name="Shape 147"/>
-          <p:cNvSpPr/>
-          <p:nvPr/>
-        </p:nvSpPr>
-        <p:spPr>
-          <a:xfrm>
-            <a:off x="4626864" y="4315968"/>
-            <a:ext cx="2020824" cy="219456"/>
-          </a:xfrm>
-          <a:prstGeom prst="rect">
-            <a:avLst/>
-          </a:prstGeom>
-          <a:solidFill>
-            <a:srgbClr val="0A5CA8">
-              <a:alpha val="82000"/>
-            </a:srgbClr>
-          </a:solidFill>
-          <a:ln w="12700">
-            <a:solidFill>
-              <a:srgbClr val="0A5CA8"/>
-            </a:solidFill>
-            <a:prstDash val="solid"/>
-          </a:ln>
-        </p:spPr>
-      </p:sp>
-      <p:sp>
-        <p:nvSpPr>
-          <p:cNvPr id="150" name="Shape 148"/>
-          <p:cNvSpPr/>
-          <p:nvPr/>
-        </p:nvSpPr>
-        <p:spPr>
-          <a:xfrm>
-            <a:off x="4626864" y="4315968"/>
-            <a:ext cx="2020824" cy="36576"/>
-          </a:xfrm>
-          <a:prstGeom prst="rect">
-            <a:avLst/>
-          </a:prstGeom>
-          <a:solidFill>
-            <a:srgbClr val="FFFFFF">
-              <a:alpha val="50000"/>
-            </a:srgbClr>
-          </a:solidFill>
-          <a:ln w="12700">
-            <a:solidFill>
-              <a:srgbClr val="FFFFFF">
-                <a:alpha val="50000"/>
-              </a:srgbClr>
-            </a:solidFill>
-            <a:prstDash val="solid"/>
-          </a:ln>
-        </p:spPr>
-      </p:sp>
-      <p:sp>
-        <p:nvSpPr>
-          <p:cNvPr id="151" name="Text 149"/>
-          <p:cNvSpPr/>
-          <p:nvPr/>
-        </p:nvSpPr>
-        <p:spPr>
-          <a:xfrm>
-            <a:off x="4626864" y="4315968"/>
-            <a:ext cx="2020824" cy="219456"/>
-          </a:xfrm>
-          <a:prstGeom prst="rect">
-            <a:avLst/>
-          </a:prstGeom>
-          <a:noFill/>
-          <a:ln/>
-        </p:spPr>
-        <p:txBody>
-          <a:bodyPr wrap="square" rtlCol="0" anchor="ctr"/>
-          <a:lstStyle/>
-          <a:p>
-            <a:pPr algn="ctr" indent="0" marL="0">
-              <a:buNone/>
-            </a:pPr>
-            <a:r>
-              <a:rPr lang="en-US" sz="800" b="1" dirty="0">
-                <a:solidFill>
-                  <a:srgbClr val="FFFFFF"/>
-                </a:solidFill>
-                <a:latin typeface="Calibri" pitchFamily="34" charset="0"/>
-                <a:ea typeface="Calibri" pitchFamily="34" charset="-122"/>
-                <a:cs typeface="Calibri" pitchFamily="34" charset="-120"/>
-              </a:rPr>
-              <a:t>The Interface</a:t>
-            </a:r>
-            <a:endParaRPr lang="en-US" sz="800" dirty="0"/>
-          </a:p>
-        </p:txBody>
-      </p:sp>
-      <p:sp>
-        <p:nvSpPr>
-          <p:cNvPr id="152" name="Shape 150"/>
-          <p:cNvSpPr/>
-          <p:nvPr/>
-        </p:nvSpPr>
-        <p:spPr>
-          <a:xfrm>
-            <a:off x="6757416" y="4315968"/>
-            <a:ext cx="2020824" cy="219456"/>
-          </a:xfrm>
-          <a:prstGeom prst="rect">
-            <a:avLst/>
-          </a:prstGeom>
-          <a:solidFill>
-            <a:srgbClr val="0A5C47">
-              <a:alpha val="82000"/>
-            </a:srgbClr>
-          </a:solidFill>
-          <a:ln w="12700">
-            <a:solidFill>
-              <a:srgbClr val="0A5C47"/>
-            </a:solidFill>
-            <a:prstDash val="solid"/>
-          </a:ln>
-        </p:spPr>
-      </p:sp>
-      <p:sp>
-        <p:nvSpPr>
-          <p:cNvPr id="153" name="Shape 151"/>
-          <p:cNvSpPr/>
-          <p:nvPr/>
-        </p:nvSpPr>
-        <p:spPr>
-          <a:xfrm>
-            <a:off x="6757416" y="4315968"/>
-            <a:ext cx="2020824" cy="36576"/>
-          </a:xfrm>
-          <a:prstGeom prst="rect">
-            <a:avLst/>
-          </a:prstGeom>
-          <a:solidFill>
-            <a:srgbClr val="FFFFFF">
-              <a:alpha val="50000"/>
-            </a:srgbClr>
-          </a:solidFill>
-          <a:ln w="12700">
-            <a:solidFill>
-              <a:srgbClr val="FFFFFF">
-                <a:alpha val="50000"/>
-              </a:srgbClr>
-            </a:solidFill>
-            <a:prstDash val="solid"/>
-          </a:ln>
-        </p:spPr>
-      </p:sp>
-      <p:sp>
-        <p:nvSpPr>
-          <p:cNvPr id="154" name="Text 152"/>
-          <p:cNvSpPr/>
-          <p:nvPr/>
-        </p:nvSpPr>
-        <p:spPr>
-          <a:xfrm>
-            <a:off x="6757416" y="4315968"/>
-            <a:ext cx="2020824" cy="219456"/>
-          </a:xfrm>
-          <a:prstGeom prst="rect">
-            <a:avLst/>
-          </a:prstGeom>
-          <a:noFill/>
-          <a:ln/>
-        </p:spPr>
-        <p:txBody>
-          <a:bodyPr wrap="square" rtlCol="0" anchor="ctr"/>
-          <a:lstStyle/>
-          <a:p>
-            <a:pPr algn="ctr" indent="0" marL="0">
-              <a:buNone/>
-            </a:pPr>
-            <a:r>
-              <a:rPr lang="en-US" sz="800" b="1" dirty="0">
-                <a:solidFill>
-                  <a:srgbClr val="FFFFFF"/>
-                </a:solidFill>
-                <a:latin typeface="Calibri" pitchFamily="34" charset="0"/>
-                <a:ea typeface="Calibri" pitchFamily="34" charset="-122"/>
-                <a:cs typeface="Calibri" pitchFamily="34" charset="-120"/>
-              </a:rPr>
-              <a:t>The Engine</a:t>
-            </a:r>
-            <a:endParaRPr lang="en-US" sz="800" dirty="0"/>
-          </a:p>
-        </p:txBody>
-      </p:sp>
-      <p:sp>
-        <p:nvSpPr>
-          <p:cNvPr id="155" name="Shape 153"/>
           <p:cNvSpPr/>
           <p:nvPr/>
         </p:nvSpPr>
@@ -8641,7 +8338,7 @@
       </p:sp>
       <p:sp>
         <p:nvSpPr>
-          <p:cNvPr id="156" name="Text 154"/>
+          <p:cNvPr id="147" name="Text 145"/>
           <p:cNvSpPr/>
           <p:nvPr/>
         </p:nvSpPr>
@@ -8680,7 +8377,7 @@
       </p:sp>
       <p:sp>
         <p:nvSpPr>
-          <p:cNvPr id="157" name="Shape 155"/>
+          <p:cNvPr id="148" name="Shape 146"/>
           <p:cNvSpPr/>
           <p:nvPr/>
         </p:nvSpPr>
@@ -8705,7 +8402,7 @@
       </p:sp>
       <p:sp>
         <p:nvSpPr>
-          <p:cNvPr id="158" name="Text 156"/>
+          <p:cNvPr id="149" name="Text 147"/>
           <p:cNvSpPr/>
           <p:nvPr/>
         </p:nvSpPr>
@@ -8744,7 +8441,7 @@
       </p:sp>
       <p:sp>
         <p:nvSpPr>
-          <p:cNvPr id="159" name="Shape 157"/>
+          <p:cNvPr id="150" name="Shape 148"/>
           <p:cNvSpPr/>
           <p:nvPr/>
         </p:nvSpPr>
@@ -8769,7 +8466,7 @@
       </p:sp>
       <p:sp>
         <p:nvSpPr>
-          <p:cNvPr id="160" name="Text 158"/>
+          <p:cNvPr id="151" name="Text 149"/>
           <p:cNvSpPr/>
           <p:nvPr/>
         </p:nvSpPr>

</xml_diff>

<commit_message>
Slide 3: pillar chips moved to upper-right of each L2 manager box
</commit_message>
<xml_diff>
--- a/jhbi-roadmap-2026.pptx
+++ b/jhbi-roadmap-2026.pptx
@@ -4734,7 +4734,7 @@
         </p:nvSpPr>
         <p:spPr>
           <a:xfrm>
-            <a:off x="2237232" y="1810512"/>
+            <a:off x="2237232" y="1508760"/>
             <a:ext cx="676656" cy="155448"/>
           </a:xfrm>
           <a:prstGeom prst="rect">
@@ -4761,7 +4761,7 @@
         </p:nvSpPr>
         <p:spPr>
           <a:xfrm>
-            <a:off x="2237232" y="1810512"/>
+            <a:off x="2237232" y="1508760"/>
             <a:ext cx="676656" cy="155448"/>
           </a:xfrm>
           <a:prstGeom prst="rect">
@@ -4932,7 +4932,7 @@
         </p:nvSpPr>
         <p:spPr>
           <a:xfrm>
-            <a:off x="5312054" y="1810512"/>
+            <a:off x="5312054" y="1508760"/>
             <a:ext cx="625450" cy="155448"/>
           </a:xfrm>
           <a:prstGeom prst="rect">
@@ -4959,7 +4959,7 @@
         </p:nvSpPr>
         <p:spPr>
           <a:xfrm>
-            <a:off x="5312054" y="1810512"/>
+            <a:off x="5312054" y="1508760"/>
             <a:ext cx="625450" cy="155448"/>
           </a:xfrm>
           <a:prstGeom prst="rect">
@@ -4998,7 +4998,7 @@
         </p:nvSpPr>
         <p:spPr>
           <a:xfrm>
-            <a:off x="4682947" y="1810512"/>
+            <a:off x="4682947" y="1508760"/>
             <a:ext cx="574243" cy="155448"/>
           </a:xfrm>
           <a:prstGeom prst="rect">
@@ -5025,7 +5025,7 @@
         </p:nvSpPr>
         <p:spPr>
           <a:xfrm>
-            <a:off x="4682947" y="1810512"/>
+            <a:off x="4682947" y="1508760"/>
             <a:ext cx="574243" cy="155448"/>
           </a:xfrm>
           <a:prstGeom prst="rect">
@@ -5196,7 +5196,7 @@
         </p:nvSpPr>
         <p:spPr>
           <a:xfrm>
-            <a:off x="8284464" y="1810512"/>
+            <a:off x="8284464" y="1508760"/>
             <a:ext cx="676656" cy="155448"/>
           </a:xfrm>
           <a:prstGeom prst="rect">
@@ -5223,7 +5223,7 @@
         </p:nvSpPr>
         <p:spPr>
           <a:xfrm>
-            <a:off x="8284464" y="1810512"/>
+            <a:off x="8284464" y="1508760"/>
             <a:ext cx="676656" cy="155448"/>
           </a:xfrm>
           <a:prstGeom prst="rect">

</xml_diff>

<commit_message>
Slide 6: full Gantt rewrite — Foundation/Lens/Interface/Engine all updated with real 3-wave structure
</commit_message>
<xml_diff>
--- a/jhbi-roadmap-2026.pptx
+++ b/jhbi-roadmap-2026.pptx
@@ -15741,7 +15741,7 @@
         <p:spPr>
           <a:xfrm>
             <a:off x="137160" y="950976"/>
-            <a:ext cx="8915400" cy="155448"/>
+            <a:ext cx="8915400" cy="146304"/>
           </a:xfrm>
           <a:prstGeom prst="rect">
             <a:avLst/>
@@ -15768,7 +15768,7 @@
         <p:spPr>
           <a:xfrm>
             <a:off x="228600" y="950976"/>
-            <a:ext cx="8686800" cy="155448"/>
+            <a:ext cx="8686800" cy="146304"/>
           </a:xfrm>
           <a:prstGeom prst="rect">
             <a:avLst/>
@@ -15806,8 +15806,8 @@
         </p:nvSpPr>
         <p:spPr>
           <a:xfrm>
-            <a:off x="137160" y="1106424"/>
-            <a:ext cx="8915400" cy="228600"/>
+            <a:off x="137160" y="1097280"/>
+            <a:ext cx="8915400" cy="210312"/>
           </a:xfrm>
           <a:prstGeom prst="rect">
             <a:avLst/>
@@ -15833,8 +15833,8 @@
         </p:nvSpPr>
         <p:spPr>
           <a:xfrm>
-            <a:off x="192024" y="1115568"/>
-            <a:ext cx="1920240" cy="210312"/>
+            <a:off x="192024" y="1106424"/>
+            <a:ext cx="1920240" cy="192024"/>
           </a:xfrm>
           <a:prstGeom prst="rect">
             <a:avLst/>
@@ -15858,7 +15858,7 @@
                 <a:ea typeface="Calibri" pitchFamily="34" charset="-122"/>
                 <a:cs typeface="Calibri" pitchFamily="34" charset="-120"/>
               </a:rPr>
-              <a:t>FI Data Pipeline Architecture &amp; Core Banking Integration</a:t>
+              <a:t>Payment Sources — Data Acquisition &amp; Pipeline</a:t>
             </a:r>
             <a:endParaRPr lang="en-US" sz="650" dirty="0"/>
           </a:p>
@@ -15872,8 +15872,8 @@
         </p:nvSpPr>
         <p:spPr>
           <a:xfrm>
-            <a:off x="2194560" y="1143000"/>
-            <a:ext cx="2255520" cy="155448"/>
+            <a:off x="2194560" y="1133856"/>
+            <a:ext cx="2255520" cy="137160"/>
           </a:xfrm>
           <a:prstGeom prst="rect">
             <a:avLst/>
@@ -15899,8 +15899,8 @@
         </p:nvSpPr>
         <p:spPr>
           <a:xfrm>
-            <a:off x="2231136" y="1143000"/>
-            <a:ext cx="2200656" cy="155448"/>
+            <a:off x="2231136" y="1133856"/>
+            <a:ext cx="2200656" cy="137160"/>
           </a:xfrm>
           <a:prstGeom prst="rect">
             <a:avLst/>
@@ -15938,8 +15938,8 @@
         </p:nvSpPr>
         <p:spPr>
           <a:xfrm>
-            <a:off x="137160" y="1353312"/>
-            <a:ext cx="8915400" cy="228600"/>
+            <a:off x="137160" y="1316736"/>
+            <a:ext cx="8915400" cy="210312"/>
           </a:xfrm>
           <a:prstGeom prst="rect">
             <a:avLst/>
@@ -15963,8 +15963,8 @@
         </p:nvSpPr>
         <p:spPr>
           <a:xfrm>
-            <a:off x="192024" y="1362456"/>
-            <a:ext cx="1920240" cy="210312"/>
+            <a:off x="192024" y="1325880"/>
+            <a:ext cx="1920240" cy="192024"/>
           </a:xfrm>
           <a:prstGeom prst="rect">
             <a:avLst/>
@@ -15988,7 +15988,7 @@
                 <a:ea typeface="Calibri" pitchFamily="34" charset="-122"/>
                 <a:cs typeface="Calibri" pitchFamily="34" charset="-120"/>
               </a:rPr>
-              <a:t>Core Banking Pipeline Integration</a:t>
+              <a:t>Core Systems — JH Banking Integration</a:t>
             </a:r>
             <a:endParaRPr lang="en-US" sz="650" dirty="0"/>
           </a:p>
@@ -16002,8 +16002,8 @@
         </p:nvSpPr>
         <p:spPr>
           <a:xfrm>
-            <a:off x="4486656" y="1389888"/>
-            <a:ext cx="1109472" cy="155448"/>
+            <a:off x="4486656" y="1353312"/>
+            <a:ext cx="2255520" cy="137160"/>
           </a:xfrm>
           <a:prstGeom prst="rect">
             <a:avLst/>
@@ -16029,8 +16029,8 @@
         </p:nvSpPr>
         <p:spPr>
           <a:xfrm>
-            <a:off x="4523232" y="1389888"/>
-            <a:ext cx="1054608" cy="155448"/>
+            <a:off x="4523232" y="1353312"/>
+            <a:ext cx="2200656" cy="137160"/>
           </a:xfrm>
           <a:prstGeom prst="rect">
             <a:avLst/>
@@ -16054,7 +16054,7 @@
                 <a:ea typeface="Calibri" pitchFamily="34" charset="-122"/>
                 <a:cs typeface="Calibri" pitchFamily="34" charset="-120"/>
               </a:rPr>
-              <a:t>Core Banking Pipeline …</a:t>
+              <a:t>Core Systems — JH Bank…</a:t>
             </a:r>
             <a:endParaRPr lang="en-US" sz="600" dirty="0"/>
           </a:p>
@@ -16068,8 +16068,8 @@
         </p:nvSpPr>
         <p:spPr>
           <a:xfrm>
-            <a:off x="137160" y="1600200"/>
-            <a:ext cx="8915400" cy="228600"/>
+            <a:off x="137160" y="1536192"/>
+            <a:ext cx="8915400" cy="210312"/>
           </a:xfrm>
           <a:prstGeom prst="rect">
             <a:avLst/>
@@ -16095,8 +16095,8 @@
         </p:nvSpPr>
         <p:spPr>
           <a:xfrm>
-            <a:off x="192024" y="1609344"/>
-            <a:ext cx="1920240" cy="210312"/>
+            <a:off x="192024" y="1545336"/>
+            <a:ext cx="1920240" cy="192024"/>
           </a:xfrm>
           <a:prstGeom prst="rect">
             <a:avLst/>
@@ -16120,7 +16120,7 @@
                 <a:ea typeface="Calibri" pitchFamily="34" charset="-122"/>
                 <a:cs typeface="Calibri" pitchFamily="34" charset="-120"/>
               </a:rPr>
-              <a:t>Data Quality Framework &amp; Enterprise Catalog</a:t>
+              <a:t>Complementary Solutions — Third-Party &amp; Enrichment</a:t>
             </a:r>
             <a:endParaRPr lang="en-US" sz="650" dirty="0"/>
           </a:p>
@@ -16134,8 +16134,8 @@
         </p:nvSpPr>
         <p:spPr>
           <a:xfrm>
-            <a:off x="5632704" y="1636776"/>
-            <a:ext cx="3401568" cy="155448"/>
+            <a:off x="6778752" y="1572768"/>
+            <a:ext cx="2255520" cy="137160"/>
           </a:xfrm>
           <a:prstGeom prst="rect">
             <a:avLst/>
@@ -16161,8 +16161,8 @@
         </p:nvSpPr>
         <p:spPr>
           <a:xfrm>
-            <a:off x="5669280" y="1636776"/>
-            <a:ext cx="3346704" cy="155448"/>
+            <a:off x="6815328" y="1572768"/>
+            <a:ext cx="2200656" cy="137160"/>
           </a:xfrm>
           <a:prstGeom prst="rect">
             <a:avLst/>
@@ -16186,7 +16186,7 @@
                 <a:ea typeface="Calibri" pitchFamily="34" charset="-122"/>
                 <a:cs typeface="Calibri" pitchFamily="34" charset="-120"/>
               </a:rPr>
-              <a:t>Data Quality Framework…</a:t>
+              <a:t>Complementary Solution…</a:t>
             </a:r>
             <a:endParaRPr lang="en-US" sz="600" dirty="0"/>
           </a:p>
@@ -16200,8 +16200,8 @@
         </p:nvSpPr>
         <p:spPr>
           <a:xfrm>
-            <a:off x="137160" y="1883664"/>
-            <a:ext cx="8915400" cy="155448"/>
+            <a:off x="137160" y="1783080"/>
+            <a:ext cx="8915400" cy="146304"/>
           </a:xfrm>
           <a:prstGeom prst="rect">
             <a:avLst/>
@@ -16227,8 +16227,8 @@
         </p:nvSpPr>
         <p:spPr>
           <a:xfrm>
-            <a:off x="228600" y="1883664"/>
-            <a:ext cx="8686800" cy="155448"/>
+            <a:off x="228600" y="1783080"/>
+            <a:ext cx="8686800" cy="146304"/>
           </a:xfrm>
           <a:prstGeom prst="rect">
             <a:avLst/>
@@ -16266,8 +16266,8 @@
         </p:nvSpPr>
         <p:spPr>
           <a:xfrm>
-            <a:off x="137160" y="2039112"/>
-            <a:ext cx="8915400" cy="228600"/>
+            <a:off x="137160" y="1929384"/>
+            <a:ext cx="8915400" cy="210312"/>
           </a:xfrm>
           <a:prstGeom prst="rect">
             <a:avLst/>
@@ -16293,8 +16293,8 @@
         </p:nvSpPr>
         <p:spPr>
           <a:xfrm>
-            <a:off x="192024" y="2048256"/>
-            <a:ext cx="1920240" cy="210312"/>
+            <a:off x="192024" y="1938528"/>
+            <a:ext cx="1920240" cy="192024"/>
           </a:xfrm>
           <a:prstGeom prst="rect">
             <a:avLst/>
@@ -16318,7 +16318,7 @@
                 <a:ea typeface="Calibri" pitchFamily="34" charset="-122"/>
                 <a:cs typeface="Calibri" pitchFamily="34" charset="-120"/>
               </a:rPr>
-              <a:t>Dashboard Requirements &amp; Design Baseline</a:t>
+              <a:t>Wave 1 — Payment Source Reports &amp; Dashboards</a:t>
             </a:r>
             <a:endParaRPr lang="en-US" sz="650" dirty="0"/>
           </a:p>
@@ -16332,8 +16332,8 @@
         </p:nvSpPr>
         <p:spPr>
           <a:xfrm>
-            <a:off x="2194560" y="2075688"/>
-            <a:ext cx="2255520" cy="155448"/>
+            <a:off x="2194560" y="1965960"/>
+            <a:ext cx="2255520" cy="137160"/>
           </a:xfrm>
           <a:prstGeom prst="rect">
             <a:avLst/>
@@ -16359,8 +16359,8 @@
         </p:nvSpPr>
         <p:spPr>
           <a:xfrm>
-            <a:off x="2231136" y="2075688"/>
-            <a:ext cx="2200656" cy="155448"/>
+            <a:off x="2231136" y="1965960"/>
+            <a:ext cx="2200656" cy="137160"/>
           </a:xfrm>
           <a:prstGeom prst="rect">
             <a:avLst/>
@@ -16398,8 +16398,8 @@
         </p:nvSpPr>
         <p:spPr>
           <a:xfrm>
-            <a:off x="137160" y="2286000"/>
-            <a:ext cx="8915400" cy="228600"/>
+            <a:off x="137160" y="2148840"/>
+            <a:ext cx="8915400" cy="210312"/>
           </a:xfrm>
           <a:prstGeom prst="rect">
             <a:avLst/>
@@ -16423,8 +16423,8 @@
         </p:nvSpPr>
         <p:spPr>
           <a:xfrm>
-            <a:off x="192024" y="2295144"/>
-            <a:ext cx="1920240" cy="210312"/>
+            <a:off x="192024" y="2157984"/>
+            <a:ext cx="1920240" cy="192024"/>
           </a:xfrm>
           <a:prstGeom prst="rect">
             <a:avLst/>
@@ -16448,7 +16448,7 @@
                 <a:ea typeface="Calibri" pitchFamily="34" charset="-122"/>
                 <a:cs typeface="Calibri" pitchFamily="34" charset="-120"/>
               </a:rPr>
-              <a:t>Executive KPI Dashboard — Platform Launch</a:t>
+              <a:t>Wave 2 — Core Systems Analytics &amp; KPIs</a:t>
             </a:r>
             <a:endParaRPr lang="en-US" sz="650" dirty="0"/>
           </a:p>
@@ -16462,8 +16462,8 @@
         </p:nvSpPr>
         <p:spPr>
           <a:xfrm>
-            <a:off x="4486656" y="2322576"/>
-            <a:ext cx="1491488" cy="155448"/>
+            <a:off x="4486656" y="2185416"/>
+            <a:ext cx="2255520" cy="137160"/>
           </a:xfrm>
           <a:prstGeom prst="rect">
             <a:avLst/>
@@ -16489,8 +16489,8 @@
         </p:nvSpPr>
         <p:spPr>
           <a:xfrm>
-            <a:off x="4523232" y="2322576"/>
-            <a:ext cx="1436624" cy="155448"/>
+            <a:off x="4523232" y="2185416"/>
+            <a:ext cx="2200656" cy="137160"/>
           </a:xfrm>
           <a:prstGeom prst="rect">
             <a:avLst/>
@@ -16514,7 +16514,7 @@
                 <a:ea typeface="Calibri" pitchFamily="34" charset="-122"/>
                 <a:cs typeface="Calibri" pitchFamily="34" charset="-120"/>
               </a:rPr>
-              <a:t>Executive KPI Dashboar…</a:t>
+              <a:t>Wave 2 — Core Systems …</a:t>
             </a:r>
             <a:endParaRPr lang="en-US" sz="600" dirty="0"/>
           </a:p>
@@ -16528,8 +16528,8 @@
         </p:nvSpPr>
         <p:spPr>
           <a:xfrm>
-            <a:off x="137160" y="2532888"/>
-            <a:ext cx="8915400" cy="228600"/>
+            <a:off x="137160" y="2368296"/>
+            <a:ext cx="8915400" cy="210312"/>
           </a:xfrm>
           <a:prstGeom prst="rect">
             <a:avLst/>
@@ -16555,8 +16555,8 @@
         </p:nvSpPr>
         <p:spPr>
           <a:xfrm>
-            <a:off x="192024" y="2542032"/>
-            <a:ext cx="1920240" cy="210312"/>
+            <a:off x="192024" y="2377440"/>
+            <a:ext cx="1920240" cy="192024"/>
           </a:xfrm>
           <a:prstGeom prst="rect">
             <a:avLst/>
@@ -16580,7 +16580,7 @@
                 <a:ea typeface="Calibri" pitchFamily="34" charset="-122"/>
                 <a:cs typeface="Calibri" pitchFamily="34" charset="-120"/>
               </a:rPr>
-              <a:t>Risk Score Explorer + Drift Monitoring</a:t>
+              <a:t>Wave 3 — Complementary Solutions Insights</a:t>
             </a:r>
             <a:endParaRPr lang="en-US" sz="650" dirty="0"/>
           </a:p>
@@ -16594,8 +16594,8 @@
         </p:nvSpPr>
         <p:spPr>
           <a:xfrm>
-            <a:off x="5632704" y="2569464"/>
-            <a:ext cx="3401568" cy="155448"/>
+            <a:off x="6778752" y="2404872"/>
+            <a:ext cx="2255520" cy="137160"/>
           </a:xfrm>
           <a:prstGeom prst="rect">
             <a:avLst/>
@@ -16621,8 +16621,8 @@
         </p:nvSpPr>
         <p:spPr>
           <a:xfrm>
-            <a:off x="5669280" y="2569464"/>
-            <a:ext cx="3346704" cy="155448"/>
+            <a:off x="6815328" y="2404872"/>
+            <a:ext cx="2200656" cy="137160"/>
           </a:xfrm>
           <a:prstGeom prst="rect">
             <a:avLst/>
@@ -16646,7 +16646,7 @@
                 <a:ea typeface="Calibri" pitchFamily="34" charset="-122"/>
                 <a:cs typeface="Calibri" pitchFamily="34" charset="-120"/>
               </a:rPr>
-              <a:t>Risk Score Explorer + …</a:t>
+              <a:t>Wave 3 — Complementary…</a:t>
             </a:r>
             <a:endParaRPr lang="en-US" sz="600" dirty="0"/>
           </a:p>
@@ -16660,8 +16660,8 @@
         </p:nvSpPr>
         <p:spPr>
           <a:xfrm>
-            <a:off x="137160" y="2816352"/>
-            <a:ext cx="8915400" cy="155448"/>
+            <a:off x="137160" y="2615184"/>
+            <a:ext cx="8915400" cy="146304"/>
           </a:xfrm>
           <a:prstGeom prst="rect">
             <a:avLst/>
@@ -16687,8 +16687,8 @@
         </p:nvSpPr>
         <p:spPr>
           <a:xfrm>
-            <a:off x="228600" y="2816352"/>
-            <a:ext cx="8686800" cy="155448"/>
+            <a:off x="228600" y="2615184"/>
+            <a:ext cx="8686800" cy="146304"/>
           </a:xfrm>
           <a:prstGeom prst="rect">
             <a:avLst/>
@@ -16726,8 +16726,8 @@
         </p:nvSpPr>
         <p:spPr>
           <a:xfrm>
-            <a:off x="137160" y="2971800"/>
-            <a:ext cx="8915400" cy="228600"/>
+            <a:off x="137160" y="2761488"/>
+            <a:ext cx="8915400" cy="210312"/>
           </a:xfrm>
           <a:prstGeom prst="rect">
             <a:avLst/>
@@ -16753,8 +16753,8 @@
         </p:nvSpPr>
         <p:spPr>
           <a:xfrm>
-            <a:off x="192024" y="2980944"/>
-            <a:ext cx="1920240" cy="210312"/>
+            <a:off x="192024" y="2770632"/>
+            <a:ext cx="1920240" cy="192024"/>
           </a:xfrm>
           <a:prstGeom prst="rect">
             <a:avLst/>
@@ -16778,7 +16778,7 @@
                 <a:ea typeface="Calibri" pitchFamily="34" charset="-122"/>
                 <a:cs typeface="Calibri" pitchFamily="34" charset="-120"/>
               </a:rPr>
-              <a:t>AI App Architecture &amp; FI Data Access Agreements</a:t>
+              <a:t>Portal Development &amp; Alation Integration</a:t>
             </a:r>
             <a:endParaRPr lang="en-US" sz="650" dirty="0"/>
           </a:p>
@@ -16792,8 +16792,8 @@
         </p:nvSpPr>
         <p:spPr>
           <a:xfrm>
-            <a:off x="2194560" y="3008376"/>
-            <a:ext cx="2255520" cy="155448"/>
+            <a:off x="2194560" y="2798064"/>
+            <a:ext cx="2255520" cy="137160"/>
           </a:xfrm>
           <a:prstGeom prst="rect">
             <a:avLst/>
@@ -16819,8 +16819,8 @@
         </p:nvSpPr>
         <p:spPr>
           <a:xfrm>
-            <a:off x="2231136" y="3008376"/>
-            <a:ext cx="2200656" cy="155448"/>
+            <a:off x="2231136" y="2798064"/>
+            <a:ext cx="2200656" cy="137160"/>
           </a:xfrm>
           <a:prstGeom prst="rect">
             <a:avLst/>
@@ -16858,8 +16858,8 @@
         </p:nvSpPr>
         <p:spPr>
           <a:xfrm>
-            <a:off x="137160" y="3218688"/>
-            <a:ext cx="8915400" cy="228600"/>
+            <a:off x="137160" y="2980944"/>
+            <a:ext cx="8915400" cy="210312"/>
           </a:xfrm>
           <a:prstGeom prst="rect">
             <a:avLst/>
@@ -16883,8 +16883,8 @@
         </p:nvSpPr>
         <p:spPr>
           <a:xfrm>
-            <a:off x="192024" y="3227832"/>
-            <a:ext cx="1920240" cy="210312"/>
+            <a:off x="192024" y="2990088"/>
+            <a:ext cx="1920240" cy="192024"/>
           </a:xfrm>
           <a:prstGeom prst="rect">
             <a:avLst/>
@@ -16908,7 +16908,7 @@
                 <a:ea typeface="Calibri" pitchFamily="34" charset="-122"/>
                 <a:cs typeface="Calibri" pitchFamily="34" charset="-120"/>
               </a:rPr>
-              <a:t>Churn Mediation + Zelle Memo Intelligence</a:t>
+              <a:t>DS App Interface — Personal as Commercial</a:t>
             </a:r>
             <a:endParaRPr lang="en-US" sz="650" dirty="0"/>
           </a:p>
@@ -16922,8 +16922,8 @@
         </p:nvSpPr>
         <p:spPr>
           <a:xfrm>
-            <a:off x="4486656" y="3255264"/>
-            <a:ext cx="2255520" cy="155448"/>
+            <a:off x="4486656" y="3017520"/>
+            <a:ext cx="1491488" cy="137160"/>
           </a:xfrm>
           <a:prstGeom prst="rect">
             <a:avLst/>
@@ -16949,8 +16949,8 @@
         </p:nvSpPr>
         <p:spPr>
           <a:xfrm>
-            <a:off x="4523232" y="3255264"/>
-            <a:ext cx="2200656" cy="155448"/>
+            <a:off x="4523232" y="3017520"/>
+            <a:ext cx="1436624" cy="137160"/>
           </a:xfrm>
           <a:prstGeom prst="rect">
             <a:avLst/>
@@ -16974,7 +16974,7 @@
                 <a:ea typeface="Calibri" pitchFamily="34" charset="-122"/>
                 <a:cs typeface="Calibri" pitchFamily="34" charset="-120"/>
               </a:rPr>
-              <a:t>Churn Mediation + Zell…</a:t>
+              <a:t>DS App Interface — Per…</a:t>
             </a:r>
             <a:endParaRPr lang="en-US" sz="600" dirty="0"/>
           </a:p>
@@ -16988,8 +16988,8 @@
         </p:nvSpPr>
         <p:spPr>
           <a:xfrm>
-            <a:off x="137160" y="3465576"/>
-            <a:ext cx="8915400" cy="228600"/>
+            <a:off x="137160" y="3200400"/>
+            <a:ext cx="8915400" cy="210312"/>
           </a:xfrm>
           <a:prstGeom prst="rect">
             <a:avLst/>
@@ -17015,8 +17015,8 @@
         </p:nvSpPr>
         <p:spPr>
           <a:xfrm>
-            <a:off x="192024" y="3474720"/>
-            <a:ext cx="1920240" cy="210312"/>
+            <a:off x="192024" y="3209544"/>
+            <a:ext cx="1920240" cy="192024"/>
           </a:xfrm>
           <a:prstGeom prst="rect">
             <a:avLst/>
@@ -17040,7 +17040,7 @@
                 <a:ea typeface="Calibri" pitchFamily="34" charset="-122"/>
                 <a:cs typeface="Calibri" pitchFamily="34" charset="-120"/>
               </a:rPr>
-              <a:t>Call Report AI Scale + Account Opening LTV</a:t>
+              <a:t>DS App Interface — [Churn App]</a:t>
             </a:r>
             <a:endParaRPr lang="en-US" sz="650" dirty="0"/>
           </a:p>
@@ -17054,8 +17054,8 @@
         </p:nvSpPr>
         <p:spPr>
           <a:xfrm>
-            <a:off x="6778752" y="3502152"/>
-            <a:ext cx="2255520" cy="155448"/>
+            <a:off x="5632704" y="3236976"/>
+            <a:ext cx="2255520" cy="137160"/>
           </a:xfrm>
           <a:prstGeom prst="rect">
             <a:avLst/>
@@ -17081,8 +17081,8 @@
         </p:nvSpPr>
         <p:spPr>
           <a:xfrm>
-            <a:off x="6815328" y="3502152"/>
-            <a:ext cx="2200656" cy="155448"/>
+            <a:off x="5669280" y="3236976"/>
+            <a:ext cx="2200656" cy="137160"/>
           </a:xfrm>
           <a:prstGeom prst="rect">
             <a:avLst/>
@@ -17106,7 +17106,7 @@
                 <a:ea typeface="Calibri" pitchFamily="34" charset="-122"/>
                 <a:cs typeface="Calibri" pitchFamily="34" charset="-120"/>
               </a:rPr>
-              <a:t>Call Report AI Scale +…</a:t>
+              <a:t>DS App Interface — [Ch…</a:t>
             </a:r>
             <a:endParaRPr lang="en-US" sz="600" dirty="0"/>
           </a:p>
@@ -17120,8 +17120,138 @@
         </p:nvSpPr>
         <p:spPr>
           <a:xfrm>
-            <a:off x="137160" y="3749040"/>
-            <a:ext cx="8915400" cy="155448"/>
+            <a:off x="137160" y="3419856"/>
+            <a:ext cx="8915400" cy="210312"/>
+          </a:xfrm>
+          <a:prstGeom prst="rect">
+            <a:avLst/>
+          </a:prstGeom>
+          <a:solidFill>
+            <a:srgbClr val="FFFFFF"/>
+          </a:solidFill>
+          <a:ln w="3810">
+            <a:solidFill>
+              <a:srgbClr val="E0E4E8"/>
+            </a:solidFill>
+            <a:prstDash val="solid"/>
+          </a:ln>
+        </p:spPr>
+      </p:sp>
+      <p:sp>
+        <p:nvSpPr>
+          <p:cNvPr id="116" name="Text 114"/>
+          <p:cNvSpPr/>
+          <p:nvPr/>
+        </p:nvSpPr>
+        <p:spPr>
+          <a:xfrm>
+            <a:off x="192024" y="3429000"/>
+            <a:ext cx="1920240" cy="192024"/>
+          </a:xfrm>
+          <a:prstGeom prst="rect">
+            <a:avLst/>
+          </a:prstGeom>
+          <a:noFill/>
+          <a:ln/>
+        </p:spPr>
+        <p:txBody>
+          <a:bodyPr wrap="square" rtlCol="0" anchor="ctr"/>
+          <a:lstStyle/>
+          <a:p>
+            <a:pPr indent="0" marL="0">
+              <a:buNone/>
+            </a:pPr>
+            <a:r>
+              <a:rPr lang="en-US" sz="650" dirty="0">
+                <a:solidFill>
+                  <a:srgbClr val="575A5D"/>
+                </a:solidFill>
+                <a:latin typeface="Calibri" pitchFamily="34" charset="0"/>
+                <a:ea typeface="Calibri" pitchFamily="34" charset="-122"/>
+                <a:cs typeface="Calibri" pitchFamily="34" charset="-120"/>
+              </a:rPr>
+              <a:t>DS App Interface — Wealth Deflection</a:t>
+            </a:r>
+            <a:endParaRPr lang="en-US" sz="650" dirty="0"/>
+          </a:p>
+        </p:txBody>
+      </p:sp>
+      <p:sp>
+        <p:nvSpPr>
+          <p:cNvPr id="117" name="Shape 115"/>
+          <p:cNvSpPr/>
+          <p:nvPr/>
+        </p:nvSpPr>
+        <p:spPr>
+          <a:xfrm>
+            <a:off x="6778752" y="3456432"/>
+            <a:ext cx="2255520" cy="137160"/>
+          </a:xfrm>
+          <a:prstGeom prst="rect">
+            <a:avLst/>
+          </a:prstGeom>
+          <a:solidFill>
+            <a:srgbClr val="0A5CA8">
+              <a:alpha val="88000"/>
+            </a:srgbClr>
+          </a:solidFill>
+          <a:ln w="15240">
+            <a:solidFill>
+              <a:srgbClr val="0A5CA8"/>
+            </a:solidFill>
+            <a:prstDash val="solid"/>
+          </a:ln>
+        </p:spPr>
+      </p:sp>
+      <p:sp>
+        <p:nvSpPr>
+          <p:cNvPr id="118" name="Text 116"/>
+          <p:cNvSpPr/>
+          <p:nvPr/>
+        </p:nvSpPr>
+        <p:spPr>
+          <a:xfrm>
+            <a:off x="6815328" y="3456432"/>
+            <a:ext cx="2200656" cy="137160"/>
+          </a:xfrm>
+          <a:prstGeom prst="rect">
+            <a:avLst/>
+          </a:prstGeom>
+          <a:noFill/>
+          <a:ln/>
+        </p:spPr>
+        <p:txBody>
+          <a:bodyPr wrap="square" rtlCol="0" anchor="ctr"/>
+          <a:lstStyle/>
+          <a:p>
+            <a:pPr indent="0" marL="0">
+              <a:buNone/>
+            </a:pPr>
+            <a:r>
+              <a:rPr lang="en-US" sz="600" dirty="0">
+                <a:solidFill>
+                  <a:srgbClr val="FFFFFF"/>
+                </a:solidFill>
+                <a:latin typeface="Calibri" pitchFamily="34" charset="0"/>
+                <a:ea typeface="Calibri" pitchFamily="34" charset="-122"/>
+                <a:cs typeface="Calibri" pitchFamily="34" charset="-120"/>
+              </a:rPr>
+              <a:t>DS App Interface — Wea…</a:t>
+            </a:r>
+            <a:endParaRPr lang="en-US" sz="600" dirty="0"/>
+          </a:p>
+        </p:txBody>
+      </p:sp>
+      <p:sp>
+        <p:nvSpPr>
+          <p:cNvPr id="119" name="Shape 117"/>
+          <p:cNvSpPr/>
+          <p:nvPr/>
+        </p:nvSpPr>
+        <p:spPr>
+          <a:xfrm>
+            <a:off x="137160" y="3666744"/>
+            <a:ext cx="8915400" cy="146304"/>
           </a:xfrm>
           <a:prstGeom prst="rect">
             <a:avLst/>
@@ -17141,14 +17271,14 @@
       </p:sp>
       <p:sp>
         <p:nvSpPr>
-          <p:cNvPr id="116" name="Text 114"/>
-          <p:cNvSpPr/>
-          <p:nvPr/>
-        </p:nvSpPr>
-        <p:spPr>
-          <a:xfrm>
-            <a:off x="228600" y="3749040"/>
-            <a:ext cx="8686800" cy="155448"/>
+          <p:cNvPr id="120" name="Text 118"/>
+          <p:cNvSpPr/>
+          <p:nvPr/>
+        </p:nvSpPr>
+        <p:spPr>
+          <a:xfrm>
+            <a:off x="228600" y="3666744"/>
+            <a:ext cx="8686800" cy="146304"/>
           </a:xfrm>
           <a:prstGeom prst="rect">
             <a:avLst/>
@@ -17180,14 +17310,14 @@
       </p:sp>
       <p:sp>
         <p:nvSpPr>
-          <p:cNvPr id="117" name="Shape 115"/>
-          <p:cNvSpPr/>
-          <p:nvPr/>
-        </p:nvSpPr>
-        <p:spPr>
-          <a:xfrm>
-            <a:off x="137160" y="3904488"/>
-            <a:ext cx="8915400" cy="228600"/>
+          <p:cNvPr id="121" name="Shape 119"/>
+          <p:cNvSpPr/>
+          <p:nvPr/>
+        </p:nvSpPr>
+        <p:spPr>
+          <a:xfrm>
+            <a:off x="137160" y="3813048"/>
+            <a:ext cx="8915400" cy="210312"/>
           </a:xfrm>
           <a:prstGeom prst="rect">
             <a:avLst/>
@@ -17207,14 +17337,14 @@
       </p:sp>
       <p:sp>
         <p:nvSpPr>
-          <p:cNvPr id="118" name="Text 116"/>
-          <p:cNvSpPr/>
-          <p:nvPr/>
-        </p:nvSpPr>
-        <p:spPr>
-          <a:xfrm>
-            <a:off x="192024" y="3913632"/>
-            <a:ext cx="1920240" cy="210312"/>
+          <p:cNvPr id="122" name="Text 120"/>
+          <p:cNvSpPr/>
+          <p:nvPr/>
+        </p:nvSpPr>
+        <p:spPr>
+          <a:xfrm>
+            <a:off x="192024" y="3822192"/>
+            <a:ext cx="1920240" cy="192024"/>
           </a:xfrm>
           <a:prstGeom prst="rect">
             <a:avLst/>
@@ -17238,7 +17368,7 @@
                 <a:ea typeface="Calibri" pitchFamily="34" charset="-122"/>
                 <a:cs typeface="Calibri" pitchFamily="34" charset="-120"/>
               </a:rPr>
-              <a:t>ML Platform: Feature Store, Experiment Tracking &amp; Registry</a:t>
+              <a:t>ML Platform Foundation — Feature Store &amp; Registry</a:t>
             </a:r>
             <a:endParaRPr lang="en-US" sz="650" dirty="0"/>
           </a:p>
@@ -17246,14 +17376,14 @@
       </p:sp>
       <p:sp>
         <p:nvSpPr>
-          <p:cNvPr id="119" name="Shape 117"/>
-          <p:cNvSpPr/>
-          <p:nvPr/>
-        </p:nvSpPr>
-        <p:spPr>
-          <a:xfrm>
-            <a:off x="2194560" y="3941064"/>
-            <a:ext cx="2255520" cy="155448"/>
+          <p:cNvPr id="123" name="Shape 121"/>
+          <p:cNvSpPr/>
+          <p:nvPr/>
+        </p:nvSpPr>
+        <p:spPr>
+          <a:xfrm>
+            <a:off x="2194560" y="3849624"/>
+            <a:ext cx="2255520" cy="137160"/>
           </a:xfrm>
           <a:prstGeom prst="rect">
             <a:avLst/>
@@ -17273,14 +17403,14 @@
       </p:sp>
       <p:sp>
         <p:nvSpPr>
-          <p:cNvPr id="120" name="Text 118"/>
-          <p:cNvSpPr/>
-          <p:nvPr/>
-        </p:nvSpPr>
-        <p:spPr>
-          <a:xfrm>
-            <a:off x="2231136" y="3941064"/>
-            <a:ext cx="2200656" cy="155448"/>
+          <p:cNvPr id="124" name="Text 122"/>
+          <p:cNvSpPr/>
+          <p:nvPr/>
+        </p:nvSpPr>
+        <p:spPr>
+          <a:xfrm>
+            <a:off x="2231136" y="3849624"/>
+            <a:ext cx="2200656" cy="137160"/>
           </a:xfrm>
           <a:prstGeom prst="rect">
             <a:avLst/>
@@ -17312,14 +17442,14 @@
       </p:sp>
       <p:sp>
         <p:nvSpPr>
-          <p:cNvPr id="121" name="Shape 119"/>
-          <p:cNvSpPr/>
-          <p:nvPr/>
-        </p:nvSpPr>
-        <p:spPr>
-          <a:xfrm>
-            <a:off x="137160" y="4151376"/>
-            <a:ext cx="8915400" cy="228600"/>
+          <p:cNvPr id="125" name="Shape 123"/>
+          <p:cNvSpPr/>
+          <p:nvPr/>
+        </p:nvSpPr>
+        <p:spPr>
+          <a:xfrm>
+            <a:off x="137160" y="4032504"/>
+            <a:ext cx="8915400" cy="210312"/>
           </a:xfrm>
           <a:prstGeom prst="rect">
             <a:avLst/>
@@ -17337,14 +17467,14 @@
       </p:sp>
       <p:sp>
         <p:nvSpPr>
-          <p:cNvPr id="122" name="Text 120"/>
-          <p:cNvSpPr/>
-          <p:nvPr/>
-        </p:nvSpPr>
-        <p:spPr>
-          <a:xfrm>
-            <a:off x="192024" y="4160520"/>
-            <a:ext cx="1920240" cy="210312"/>
+          <p:cNvPr id="126" name="Text 124"/>
+          <p:cNvSpPr/>
+          <p:nvPr/>
+        </p:nvSpPr>
+        <p:spPr>
+          <a:xfrm>
+            <a:off x="192024" y="4041648"/>
+            <a:ext cx="1920240" cy="192024"/>
           </a:xfrm>
           <a:prstGeom prst="rect">
             <a:avLst/>
@@ -17368,7 +17498,7 @@
                 <a:ea typeface="Calibri" pitchFamily="34" charset="-122"/>
                 <a:cs typeface="Calibri" pitchFamily="34" charset="-120"/>
               </a:rPr>
-              <a:t>Anomaly Detection — Streaming Production</a:t>
+              <a:t>Personal as Commercial Detection</a:t>
             </a:r>
             <a:endParaRPr lang="en-US" sz="650" dirty="0"/>
           </a:p>
@@ -17376,14 +17506,14 @@
       </p:sp>
       <p:sp>
         <p:nvSpPr>
-          <p:cNvPr id="123" name="Shape 121"/>
-          <p:cNvSpPr/>
-          <p:nvPr/>
-        </p:nvSpPr>
-        <p:spPr>
-          <a:xfrm>
-            <a:off x="4486656" y="4187952"/>
-            <a:ext cx="2255520" cy="155448"/>
+          <p:cNvPr id="127" name="Shape 125"/>
+          <p:cNvSpPr/>
+          <p:nvPr/>
+        </p:nvSpPr>
+        <p:spPr>
+          <a:xfrm>
+            <a:off x="4486656" y="4069080"/>
+            <a:ext cx="1491488" cy="137160"/>
           </a:xfrm>
           <a:prstGeom prst="rect">
             <a:avLst/>
@@ -17403,14 +17533,14 @@
       </p:sp>
       <p:sp>
         <p:nvSpPr>
-          <p:cNvPr id="124" name="Text 122"/>
-          <p:cNvSpPr/>
-          <p:nvPr/>
-        </p:nvSpPr>
-        <p:spPr>
-          <a:xfrm>
-            <a:off x="4523232" y="4187952"/>
-            <a:ext cx="2200656" cy="155448"/>
+          <p:cNvPr id="128" name="Text 126"/>
+          <p:cNvSpPr/>
+          <p:nvPr/>
+        </p:nvSpPr>
+        <p:spPr>
+          <a:xfrm>
+            <a:off x="4523232" y="4069080"/>
+            <a:ext cx="1436624" cy="137160"/>
           </a:xfrm>
           <a:prstGeom prst="rect">
             <a:avLst/>
@@ -17434,7 +17564,7 @@
                 <a:ea typeface="Calibri" pitchFamily="34" charset="-122"/>
                 <a:cs typeface="Calibri" pitchFamily="34" charset="-120"/>
               </a:rPr>
-              <a:t>Anomaly Detection — St…</a:t>
+              <a:t>Personal as Commercial…</a:t>
             </a:r>
             <a:endParaRPr lang="en-US" sz="600" dirty="0"/>
           </a:p>
@@ -17442,14 +17572,14 @@
       </p:sp>
       <p:sp>
         <p:nvSpPr>
-          <p:cNvPr id="125" name="Shape 123"/>
-          <p:cNvSpPr/>
-          <p:nvPr/>
-        </p:nvSpPr>
-        <p:spPr>
-          <a:xfrm>
-            <a:off x="137160" y="4398264"/>
-            <a:ext cx="8915400" cy="228600"/>
+          <p:cNvPr id="129" name="Shape 127"/>
+          <p:cNvSpPr/>
+          <p:nvPr/>
+        </p:nvSpPr>
+        <p:spPr>
+          <a:xfrm>
+            <a:off x="137160" y="4251960"/>
+            <a:ext cx="8915400" cy="210312"/>
           </a:xfrm>
           <a:prstGeom prst="rect">
             <a:avLst/>
@@ -17469,14 +17599,14 @@
       </p:sp>
       <p:sp>
         <p:nvSpPr>
-          <p:cNvPr id="126" name="Text 124"/>
-          <p:cNvSpPr/>
-          <p:nvPr/>
-        </p:nvSpPr>
-        <p:spPr>
-          <a:xfrm>
-            <a:off x="192024" y="4407408"/>
-            <a:ext cx="1920240" cy="210312"/>
+          <p:cNvPr id="130" name="Text 128"/>
+          <p:cNvSpPr/>
+          <p:nvPr/>
+        </p:nvSpPr>
+        <p:spPr>
+          <a:xfrm>
+            <a:off x="192024" y="4261104"/>
+            <a:ext cx="1920240" cy="192024"/>
           </a:xfrm>
           <a:prstGeom prst="rect">
             <a:avLst/>
@@ -17500,7 +17630,7 @@
                 <a:ea typeface="Calibri" pitchFamily="34" charset="-122"/>
                 <a:cs typeface="Calibri" pitchFamily="34" charset="-120"/>
               </a:rPr>
-              <a:t>MLOps Pipeline + Horizon App Scoping</a:t>
+              <a:t>[Churn App] — Attrition Detection</a:t>
             </a:r>
             <a:endParaRPr lang="en-US" sz="650" dirty="0"/>
           </a:p>
@@ -17508,14 +17638,14 @@
       </p:sp>
       <p:sp>
         <p:nvSpPr>
-          <p:cNvPr id="127" name="Shape 125"/>
-          <p:cNvSpPr/>
-          <p:nvPr/>
-        </p:nvSpPr>
-        <p:spPr>
-          <a:xfrm>
-            <a:off x="6778752" y="4434840"/>
-            <a:ext cx="2255520" cy="155448"/>
+          <p:cNvPr id="131" name="Shape 129"/>
+          <p:cNvSpPr/>
+          <p:nvPr/>
+        </p:nvSpPr>
+        <p:spPr>
+          <a:xfrm>
+            <a:off x="5632704" y="4288536"/>
+            <a:ext cx="2255520" cy="137160"/>
           </a:xfrm>
           <a:prstGeom prst="rect">
             <a:avLst/>
@@ -17535,14 +17665,14 @@
       </p:sp>
       <p:sp>
         <p:nvSpPr>
-          <p:cNvPr id="128" name="Text 126"/>
-          <p:cNvSpPr/>
-          <p:nvPr/>
-        </p:nvSpPr>
-        <p:spPr>
-          <a:xfrm>
-            <a:off x="6815328" y="4434840"/>
-            <a:ext cx="2200656" cy="155448"/>
+          <p:cNvPr id="132" name="Text 130"/>
+          <p:cNvSpPr/>
+          <p:nvPr/>
+        </p:nvSpPr>
+        <p:spPr>
+          <a:xfrm>
+            <a:off x="5669280" y="4288536"/>
+            <a:ext cx="2200656" cy="137160"/>
           </a:xfrm>
           <a:prstGeom prst="rect">
             <a:avLst/>
@@ -17566,7 +17696,7 @@
                 <a:ea typeface="Calibri" pitchFamily="34" charset="-122"/>
                 <a:cs typeface="Calibri" pitchFamily="34" charset="-120"/>
               </a:rPr>
-              <a:t>MLOps Pipeline + Horiz…</a:t>
+              <a:t>[Churn App] — Attritio…</a:t>
             </a:r>
             <a:endParaRPr lang="en-US" sz="600" dirty="0"/>
           </a:p>
@@ -17574,7 +17704,137 @@
       </p:sp>
       <p:sp>
         <p:nvSpPr>
-          <p:cNvPr id="129" name="Shape 127"/>
+          <p:cNvPr id="133" name="Shape 131"/>
+          <p:cNvSpPr/>
+          <p:nvPr/>
+        </p:nvSpPr>
+        <p:spPr>
+          <a:xfrm>
+            <a:off x="137160" y="4471416"/>
+            <a:ext cx="8915400" cy="210312"/>
+          </a:xfrm>
+          <a:prstGeom prst="rect">
+            <a:avLst/>
+          </a:prstGeom>
+          <a:solidFill>
+            <a:srgbClr val="FFFFFF"/>
+          </a:solidFill>
+          <a:ln w="3810">
+            <a:solidFill>
+              <a:srgbClr val="E0E4E8"/>
+            </a:solidFill>
+            <a:prstDash val="solid"/>
+          </a:ln>
+        </p:spPr>
+      </p:sp>
+      <p:sp>
+        <p:nvSpPr>
+          <p:cNvPr id="134" name="Text 132"/>
+          <p:cNvSpPr/>
+          <p:nvPr/>
+        </p:nvSpPr>
+        <p:spPr>
+          <a:xfrm>
+            <a:off x="192024" y="4480560"/>
+            <a:ext cx="1920240" cy="192024"/>
+          </a:xfrm>
+          <a:prstGeom prst="rect">
+            <a:avLst/>
+          </a:prstGeom>
+          <a:noFill/>
+          <a:ln/>
+        </p:spPr>
+        <p:txBody>
+          <a:bodyPr wrap="square" rtlCol="0" anchor="ctr"/>
+          <a:lstStyle/>
+          <a:p>
+            <a:pPr indent="0" marL="0">
+              <a:buNone/>
+            </a:pPr>
+            <a:r>
+              <a:rPr lang="en-US" sz="650" dirty="0">
+                <a:solidFill>
+                  <a:srgbClr val="575A5D"/>
+                </a:solidFill>
+                <a:latin typeface="Calibri" pitchFamily="34" charset="0"/>
+                <a:ea typeface="Calibri" pitchFamily="34" charset="-122"/>
+                <a:cs typeface="Calibri" pitchFamily="34" charset="-120"/>
+              </a:rPr>
+              <a:t>Wealth Deflection — Generational Retention</a:t>
+            </a:r>
+            <a:endParaRPr lang="en-US" sz="650" dirty="0"/>
+          </a:p>
+        </p:txBody>
+      </p:sp>
+      <p:sp>
+        <p:nvSpPr>
+          <p:cNvPr id="135" name="Shape 133"/>
+          <p:cNvSpPr/>
+          <p:nvPr/>
+        </p:nvSpPr>
+        <p:spPr>
+          <a:xfrm>
+            <a:off x="6778752" y="4507992"/>
+            <a:ext cx="2255520" cy="137160"/>
+          </a:xfrm>
+          <a:prstGeom prst="rect">
+            <a:avLst/>
+          </a:prstGeom>
+          <a:solidFill>
+            <a:srgbClr val="0A5C47">
+              <a:alpha val="88000"/>
+            </a:srgbClr>
+          </a:solidFill>
+          <a:ln w="15240">
+            <a:solidFill>
+              <a:srgbClr val="0A5C47"/>
+            </a:solidFill>
+            <a:prstDash val="solid"/>
+          </a:ln>
+        </p:spPr>
+      </p:sp>
+      <p:sp>
+        <p:nvSpPr>
+          <p:cNvPr id="136" name="Text 134"/>
+          <p:cNvSpPr/>
+          <p:nvPr/>
+        </p:nvSpPr>
+        <p:spPr>
+          <a:xfrm>
+            <a:off x="6815328" y="4507992"/>
+            <a:ext cx="2200656" cy="137160"/>
+          </a:xfrm>
+          <a:prstGeom prst="rect">
+            <a:avLst/>
+          </a:prstGeom>
+          <a:noFill/>
+          <a:ln/>
+        </p:spPr>
+        <p:txBody>
+          <a:bodyPr wrap="square" rtlCol="0" anchor="ctr"/>
+          <a:lstStyle/>
+          <a:p>
+            <a:pPr indent="0" marL="0">
+              <a:buNone/>
+            </a:pPr>
+            <a:r>
+              <a:rPr lang="en-US" sz="600" dirty="0">
+                <a:solidFill>
+                  <a:srgbClr val="FFFFFF"/>
+                </a:solidFill>
+                <a:latin typeface="Calibri" pitchFamily="34" charset="0"/>
+                <a:ea typeface="Calibri" pitchFamily="34" charset="-122"/>
+                <a:cs typeface="Calibri" pitchFamily="34" charset="-120"/>
+              </a:rPr>
+              <a:t>Wealth Deflection — Ge…</a:t>
+            </a:r>
+            <a:endParaRPr lang="en-US" sz="600" dirty="0"/>
+          </a:p>
+        </p:txBody>
+      </p:sp>
+      <p:sp>
+        <p:nvSpPr>
+          <p:cNvPr id="137" name="Shape 135"/>
           <p:cNvSpPr/>
           <p:nvPr/>
         </p:nvSpPr>
@@ -17597,7 +17857,7 @@
       </p:sp>
       <p:sp>
         <p:nvSpPr>
-          <p:cNvPr id="130" name="Text 128"/>
+          <p:cNvPr id="138" name="Text 136"/>
           <p:cNvSpPr/>
           <p:nvPr/>
         </p:nvSpPr>

</xml_diff>

<commit_message>
Rename Personal as Commercial → CommercialSignal across Gantt, Interface, and Financial Impact slides
</commit_message>
<xml_diff>
--- a/jhbi-roadmap-2026.pptx
+++ b/jhbi-roadmap-2026.pptx
@@ -16908,7 +16908,7 @@
                 <a:ea typeface="Calibri" pitchFamily="34" charset="-122"/>
                 <a:cs typeface="Calibri" pitchFamily="34" charset="-120"/>
               </a:rPr>
-              <a:t>DS App Interface — Personal as Commercial</a:t>
+              <a:t>DS App Interface — CommercialSignal</a:t>
             </a:r>
             <a:endParaRPr lang="en-US" sz="650" dirty="0"/>
           </a:p>
@@ -16974,7 +16974,7 @@
                 <a:ea typeface="Calibri" pitchFamily="34" charset="-122"/>
                 <a:cs typeface="Calibri" pitchFamily="34" charset="-120"/>
               </a:rPr>
-              <a:t>DS App Interface — Per…</a:t>
+              <a:t>DS App Interface — Com…</a:t>
             </a:r>
             <a:endParaRPr lang="en-US" sz="600" dirty="0"/>
           </a:p>
@@ -17498,7 +17498,7 @@
                 <a:ea typeface="Calibri" pitchFamily="34" charset="-122"/>
                 <a:cs typeface="Calibri" pitchFamily="34" charset="-120"/>
               </a:rPr>
-              <a:t>Personal as Commercial Detection</a:t>
+              <a:t>CommercialSignal — P2C Detection</a:t>
             </a:r>
             <a:endParaRPr lang="en-US" sz="650" dirty="0"/>
           </a:p>
@@ -17564,7 +17564,7 @@
                 <a:ea typeface="Calibri" pitchFamily="34" charset="-122"/>
                 <a:cs typeface="Calibri" pitchFamily="34" charset="-120"/>
               </a:rPr>
-              <a:t>Personal as Commercial…</a:t>
+              <a:t>CommercialSignal — P2C…</a:t>
             </a:r>
             <a:endParaRPr lang="en-US" sz="600" dirty="0"/>
           </a:p>
@@ -22334,7 +22334,7 @@
                 <a:ea typeface="Calibri" pitchFamily="34" charset="-122"/>
                 <a:cs typeface="Calibri" pitchFamily="34" charset="-120"/>
               </a:rPr>
-              <a:t>Personal vs</a:t>
+              <a:t>Commercial</a:t>
             </a:r>
             <a:endParaRPr lang="en-US" sz="950" dirty="0"/>
           </a:p>
@@ -22351,7 +22351,7 @@
                 <a:ea typeface="Calibri" pitchFamily="34" charset="-122"/>
                 <a:cs typeface="Calibri" pitchFamily="34" charset="-120"/>
               </a:rPr>
-              <a:t>Commercial</a:t>
+              <a:t>Signal</a:t>
             </a:r>
             <a:endParaRPr lang="en-US" sz="950" dirty="0"/>
           </a:p>

</xml_diff>

<commit_message>
QA pass: remove JHBI Analytics → JHBI everywhere; sync Q_INITIATIVES and DELIVERABLES to new app names
</commit_message>
<xml_diff>
--- a/jhbi-roadmap-2026.pptx
+++ b/jhbi-roadmap-2026.pptx
@@ -1734,7 +1734,7 @@
                 <a:ea typeface="Calibri" pitchFamily="34" charset="-122"/>
                 <a:cs typeface="Calibri" pitchFamily="34" charset="-120"/>
               </a:rPr>
-              <a:t>JHBI Analytics</a:t>
+              <a:t>JHBI</a:t>
             </a:r>
             <a:endParaRPr lang="en-US" sz="4600" dirty="0"/>
           </a:p>
@@ -3743,7 +3743,7 @@
                 <a:ea typeface="Calibri" pitchFamily="34" charset="-122"/>
                 <a:cs typeface="Calibri" pitchFamily="34" charset="-120"/>
               </a:rPr>
-              <a:t>JHBI Analytics Team</a:t>
+              <a:t>JHBI Team</a:t>
             </a:r>
             <a:endParaRPr lang="en-US" sz="1300" dirty="0"/>
           </a:p>
@@ -8477,7 +8477,7 @@
                 <a:ea typeface="Calibri" pitchFamily="34" charset="-122"/>
                 <a:cs typeface="Calibri" pitchFamily="34" charset="-120"/>
               </a:rPr>
-              <a:t>JHBI Analytics — Program Overview</a:t>
+              <a:t>JHBI — Program Overview</a:t>
             </a:r>
             <a:endParaRPr lang="en-US" sz="1300" dirty="0"/>
           </a:p>
@@ -9810,7 +9810,7 @@
                 <a:ea typeface="Calibri" pitchFamily="34" charset="-122"/>
                 <a:cs typeface="Calibri" pitchFamily="34" charset="-120"/>
               </a:rPr>
-              <a:t>AI apps in JH ecosystem (Churn, Anomaly, Zelle Memo)</a:t>
+              <a:t>DS apps: CommercialSignal, [Churn App], Wealth Deflection</a:t>
             </a:r>
             <a:endParaRPr lang="en-US" sz="950" dirty="0"/>
           </a:p>
@@ -10347,7 +10347,7 @@
                 <a:ea typeface="Calibri" pitchFamily="34" charset="-122"/>
                 <a:cs typeface="Calibri" pitchFamily="34" charset="-120"/>
               </a:rPr>
-              <a:t>JHBI Analytics — Quarterly Roadmap</a:t>
+              <a:t>JHBI — Quarterly Roadmap</a:t>
             </a:r>
             <a:endParaRPr lang="en-US" sz="1300" dirty="0"/>
           </a:p>
@@ -11311,7 +11311,7 @@
                 <a:ea typeface="Calibri" pitchFamily="34" charset="-122"/>
                 <a:cs typeface="Calibri" pitchFamily="34" charset="-120"/>
               </a:rPr>
-              <a:t>Core Banking Data Pipeline — FI Connectivity Layer</a:t>
+              <a:t>Core Systems — JH Banking Data Integration</a:t>
             </a:r>
             <a:endParaRPr lang="en-US" sz="850" dirty="0"/>
           </a:p>
@@ -11407,7 +11407,7 @@
                 <a:ea typeface="Calibri" pitchFamily="34" charset="-122"/>
                 <a:cs typeface="Calibri" pitchFamily="34" charset="-120"/>
               </a:rPr>
-              <a:t>Data Quality Framework &amp; Lineage Tracking</a:t>
+              <a:t>Core Systems — Data Quality Framework &amp; Lineage</a:t>
             </a:r>
             <a:endParaRPr lang="en-US" sz="850" dirty="0"/>
           </a:p>
@@ -11503,7 +11503,7 @@
                 <a:ea typeface="Calibri" pitchFamily="34" charset="-122"/>
                 <a:cs typeface="Calibri" pitchFamily="34" charset="-120"/>
               </a:rPr>
-              <a:t>Real-time Kafka Streaming Infrastructure</a:t>
+              <a:t>Complementary Solutions — Third-Party Integration</a:t>
             </a:r>
             <a:endParaRPr lang="en-US" sz="850" dirty="0"/>
           </a:p>
@@ -11599,7 +11599,7 @@
                 <a:ea typeface="Calibri" pitchFamily="34" charset="-122"/>
                 <a:cs typeface="Calibri" pitchFamily="34" charset="-120"/>
               </a:rPr>
-              <a:t>Enterprise Data Catalog &amp; Governance Framework</a:t>
+              <a:t>Complementary Solutions — Enterprise Catalog</a:t>
             </a:r>
             <a:endParaRPr lang="en-US" sz="850" dirty="0"/>
           </a:p>
@@ -11972,7 +11972,7 @@
                 <a:ea typeface="Calibri" pitchFamily="34" charset="-122"/>
                 <a:cs typeface="Calibri" pitchFamily="34" charset="-120"/>
               </a:rPr>
-              <a:t>Executive KPI Dashboard — Platform MVP Launch</a:t>
+              <a:t>Wave 2 — Core Systems KPIs &amp; Executive Dashboards</a:t>
             </a:r>
             <a:endParaRPr lang="en-US" sz="850" dirty="0"/>
           </a:p>
@@ -12068,7 +12068,7 @@
                 <a:ea typeface="Calibri" pitchFamily="34" charset="-122"/>
                 <a:cs typeface="Calibri" pitchFamily="34" charset="-120"/>
               </a:rPr>
-              <a:t>Risk Score Explorer — Banker-Facing Interface</a:t>
+              <a:t>Wave 2 — Risk Score Explorer, Banker-Facing</a:t>
             </a:r>
             <a:endParaRPr lang="en-US" sz="850" dirty="0"/>
           </a:p>
@@ -12164,7 +12164,7 @@
                 <a:ea typeface="Calibri" pitchFamily="34" charset="-122"/>
                 <a:cs typeface="Calibri" pitchFamily="34" charset="-120"/>
               </a:rPr>
-              <a:t>Model Drift Monitoring &amp; Alert Engine</a:t>
+              <a:t>Wave 3 — Complementary Solutions Insights</a:t>
             </a:r>
             <a:endParaRPr lang="en-US" sz="850" dirty="0"/>
           </a:p>
@@ -12260,7 +12260,7 @@
                 <a:ea typeface="Calibri" pitchFamily="34" charset="-122"/>
                 <a:cs typeface="Calibri" pitchFamily="34" charset="-120"/>
               </a:rPr>
-              <a:t>Self-Serve Analytics Surface — Business Users</a:t>
+              <a:t>Wave 3 — Self-Serve Analytics Surface</a:t>
             </a:r>
             <a:endParaRPr lang="en-US" sz="850" dirty="0"/>
           </a:p>
@@ -12606,7 +12606,7 @@
                 <a:ea typeface="Calibri" pitchFamily="34" charset="-122"/>
                 <a:cs typeface="Calibri" pitchFamily="34" charset="-120"/>
               </a:rPr>
-              <a:t>Churn Mediation MVP — JH CRM Integration</a:t>
+              <a:t>CommercialSignal — Banker Interface MVP</a:t>
             </a:r>
             <a:endParaRPr lang="en-US" sz="850" dirty="0"/>
           </a:p>
@@ -12702,7 +12702,7 @@
                 <a:ea typeface="Calibri" pitchFamily="34" charset="-122"/>
                 <a:cs typeface="Calibri" pitchFamily="34" charset="-120"/>
               </a:rPr>
-              <a:t>Zelle Memo Intelligence — NLP Pipeline Live</a:t>
+              <a:t>[Churn App] — Attrition Interface Build</a:t>
             </a:r>
             <a:endParaRPr lang="en-US" sz="850" dirty="0"/>
           </a:p>
@@ -12798,7 +12798,7 @@
                 <a:ea typeface="Calibri" pitchFamily="34" charset="-122"/>
                 <a:cs typeface="Calibri" pitchFamily="34" charset="-120"/>
               </a:rPr>
-              <a:t>Call Report AI — Full CU Client Rollout</a:t>
+              <a:t>Wealth Deflection — Interface Launch</a:t>
             </a:r>
             <a:endParaRPr lang="en-US" sz="850" dirty="0"/>
           </a:p>
@@ -12894,7 +12894,7 @@
                 <a:ea typeface="Calibri" pitchFamily="34" charset="-122"/>
                 <a:cs typeface="Calibri" pitchFamily="34" charset="-120"/>
               </a:rPr>
-              <a:t>Account Opening LTV — JH Platform Launch</a:t>
+              <a:t>DS App Platform — Integration &amp; Scale</a:t>
             </a:r>
             <a:endParaRPr lang="en-US" sz="850" dirty="0"/>
           </a:p>
@@ -13267,7 +13267,7 @@
                 <a:ea typeface="Calibri" pitchFamily="34" charset="-122"/>
                 <a:cs typeface="Calibri" pitchFamily="34" charset="-120"/>
               </a:rPr>
-              <a:t>ML Model Serving Infrastructure &amp; Feature Store</a:t>
+              <a:t>CommercialSignal — P2C Detection Model Launch</a:t>
             </a:r>
             <a:endParaRPr lang="en-US" sz="850" dirty="0"/>
           </a:p>
@@ -13363,7 +13363,7 @@
                 <a:ea typeface="Calibri" pitchFamily="34" charset="-122"/>
                 <a:cs typeface="Calibri" pitchFamily="34" charset="-120"/>
               </a:rPr>
-              <a:t>Anomaly Detection — Streaming Production Launch</a:t>
+              <a:t>[Churn App] — Attrition Detection Model Build</a:t>
             </a:r>
             <a:endParaRPr lang="en-US" sz="850" dirty="0"/>
           </a:p>
@@ -13459,7 +13459,7 @@
                 <a:ea typeface="Calibri" pitchFamily="34" charset="-122"/>
                 <a:cs typeface="Calibri" pitchFamily="34" charset="-120"/>
               </a:rPr>
-              <a:t>MLOps Pipeline — Full CI/CD &amp; Governance</a:t>
+              <a:t>Wealth Deflection — Generational Retention Model</a:t>
             </a:r>
             <a:endParaRPr lang="en-US" sz="850" dirty="0"/>
           </a:p>
@@ -13555,7 +13555,7 @@
                 <a:ea typeface="Calibri" pitchFamily="34" charset="-122"/>
                 <a:cs typeface="Calibri" pitchFamily="34" charset="-120"/>
               </a:rPr>
-              <a:t>Cross-Sell Propensity Engine (Horizon Phase 1)</a:t>
+              <a:t>MLOps — Full CI/CD &amp; Governance Complete</a:t>
             </a:r>
             <a:endParaRPr lang="en-US" sz="850" dirty="0"/>
           </a:p>
@@ -13651,7 +13651,7 @@
                 <a:ea typeface="Calibri" pitchFamily="34" charset="-122"/>
                 <a:cs typeface="Calibri" pitchFamily="34" charset="-120"/>
               </a:rPr>
-              <a:t>JHBI Analytics — Gantt Chart</a:t>
+              <a:t>JHBI — Gantt Chart</a:t>
             </a:r>
             <a:endParaRPr lang="en-US" sz="1300" dirty="0"/>
           </a:p>
@@ -22135,7 +22135,7 @@
                 <a:ea typeface="Calibri" pitchFamily="34" charset="-122"/>
                 <a:cs typeface="Calibri" pitchFamily="34" charset="-120"/>
               </a:rPr>
-              <a:t>JHBI Analytics — Phase 1 Business Case</a:t>
+              <a:t>JHBI — Phase 1 Business Case</a:t>
             </a:r>
             <a:endParaRPr lang="en-US" sz="1300" dirty="0"/>
           </a:p>
@@ -24347,7 +24347,7 @@
                 <a:ea typeface="Calibri" pitchFamily="34" charset="-122"/>
                 <a:cs typeface="Calibri" pitchFamily="34" charset="-120"/>
               </a:rPr>
-              <a:t>JHBI Analytics — FY27 Quarterly View</a:t>
+              <a:t>JHBI — FY27 Quarterly View</a:t>
             </a:r>
             <a:endParaRPr lang="en-US" sz="1300" dirty="0"/>
           </a:p>
@@ -24711,7 +24711,7 @@
                 <a:ea typeface="Calibri" pitchFamily="34" charset="-122"/>
                 <a:cs typeface="Calibri" pitchFamily="34" charset="-120"/>
               </a:rPr>
-              <a:t>Core Banking Data Pipeline — FI Connectivity Layer</a:t>
+              <a:t>Core Systems — JH Banking Data Integration</a:t>
             </a:r>
             <a:endParaRPr lang="en-US" sz="850" dirty="0"/>
           </a:p>
@@ -24869,7 +24869,7 @@
                 <a:ea typeface="Calibri" pitchFamily="34" charset="-122"/>
                 <a:cs typeface="Calibri" pitchFamily="34" charset="-120"/>
               </a:rPr>
-              <a:t>Executive KPI Dashboard — Platform MVP Launch</a:t>
+              <a:t>Wave 2 — Core Systems KPIs &amp; Executive Dashboards</a:t>
             </a:r>
             <a:endParaRPr lang="en-US" sz="850" dirty="0"/>
           </a:p>
@@ -25027,7 +25027,7 @@
                 <a:ea typeface="Calibri" pitchFamily="34" charset="-122"/>
                 <a:cs typeface="Calibri" pitchFamily="34" charset="-120"/>
               </a:rPr>
-              <a:t>Churn Mediation MVP — JH CRM Integration</a:t>
+              <a:t>CommercialSignal — Banker Interface MVP</a:t>
             </a:r>
             <a:endParaRPr lang="en-US" sz="850" dirty="0"/>
           </a:p>
@@ -25185,7 +25185,7 @@
                 <a:ea typeface="Calibri" pitchFamily="34" charset="-122"/>
                 <a:cs typeface="Calibri" pitchFamily="34" charset="-120"/>
               </a:rPr>
-              <a:t>ML Model Serving Infrastructure &amp; Feature Store</a:t>
+              <a:t>CommercialSignal — P2C Detection Model Launch</a:t>
             </a:r>
             <a:endParaRPr lang="en-US" sz="850" dirty="0"/>
           </a:p>
@@ -25446,7 +25446,7 @@
                 <a:ea typeface="Calibri" pitchFamily="34" charset="-122"/>
                 <a:cs typeface="Calibri" pitchFamily="34" charset="-120"/>
               </a:rPr>
-              <a:t>Data Quality Framework &amp; Lineage Tracking</a:t>
+              <a:t>Core Systems — Data Quality Framework &amp; Lineage</a:t>
             </a:r>
             <a:endParaRPr lang="en-US" sz="850" dirty="0"/>
           </a:p>
@@ -25604,7 +25604,7 @@
                 <a:ea typeface="Calibri" pitchFamily="34" charset="-122"/>
                 <a:cs typeface="Calibri" pitchFamily="34" charset="-120"/>
               </a:rPr>
-              <a:t>Risk Score Explorer — Banker-Facing Interface</a:t>
+              <a:t>Wave 2 — Risk Score Explorer, Banker-Facing</a:t>
             </a:r>
             <a:endParaRPr lang="en-US" sz="850" dirty="0"/>
           </a:p>
@@ -25762,7 +25762,7 @@
                 <a:ea typeface="Calibri" pitchFamily="34" charset="-122"/>
                 <a:cs typeface="Calibri" pitchFamily="34" charset="-120"/>
               </a:rPr>
-              <a:t>Zelle Memo Intelligence — NLP Pipeline Live</a:t>
+              <a:t>[Churn App] — Attrition Interface Build</a:t>
             </a:r>
             <a:endParaRPr lang="en-US" sz="850" dirty="0"/>
           </a:p>
@@ -25920,7 +25920,7 @@
                 <a:ea typeface="Calibri" pitchFamily="34" charset="-122"/>
                 <a:cs typeface="Calibri" pitchFamily="34" charset="-120"/>
               </a:rPr>
-              <a:t>Anomaly Detection — Streaming Production Launch</a:t>
+              <a:t>[Churn App] — Attrition Detection Model Build</a:t>
             </a:r>
             <a:endParaRPr lang="en-US" sz="850" dirty="0"/>
           </a:p>
@@ -26181,7 +26181,7 @@
                 <a:ea typeface="Calibri" pitchFamily="34" charset="-122"/>
                 <a:cs typeface="Calibri" pitchFamily="34" charset="-120"/>
               </a:rPr>
-              <a:t>Real-time Kafka Streaming Infrastructure</a:t>
+              <a:t>Complementary Solutions — Third-Party Integration</a:t>
             </a:r>
             <a:endParaRPr lang="en-US" sz="850" dirty="0"/>
           </a:p>
@@ -26339,7 +26339,7 @@
                 <a:ea typeface="Calibri" pitchFamily="34" charset="-122"/>
                 <a:cs typeface="Calibri" pitchFamily="34" charset="-120"/>
               </a:rPr>
-              <a:t>Model Drift Monitoring &amp; Alert Engine</a:t>
+              <a:t>Wave 3 — Complementary Solutions Insights</a:t>
             </a:r>
             <a:endParaRPr lang="en-US" sz="850" dirty="0"/>
           </a:p>
@@ -26497,7 +26497,7 @@
                 <a:ea typeface="Calibri" pitchFamily="34" charset="-122"/>
                 <a:cs typeface="Calibri" pitchFamily="34" charset="-120"/>
               </a:rPr>
-              <a:t>Call Report AI — Full CU Client Rollout</a:t>
+              <a:t>Wealth Deflection — Interface Launch</a:t>
             </a:r>
             <a:endParaRPr lang="en-US" sz="850" dirty="0"/>
           </a:p>
@@ -26655,7 +26655,7 @@
                 <a:ea typeface="Calibri" pitchFamily="34" charset="-122"/>
                 <a:cs typeface="Calibri" pitchFamily="34" charset="-120"/>
               </a:rPr>
-              <a:t>MLOps Pipeline — Full CI/CD &amp; Governance</a:t>
+              <a:t>Wealth Deflection — Generational Retention Model</a:t>
             </a:r>
             <a:endParaRPr lang="en-US" sz="850" dirty="0"/>
           </a:p>
@@ -26916,7 +26916,7 @@
                 <a:ea typeface="Calibri" pitchFamily="34" charset="-122"/>
                 <a:cs typeface="Calibri" pitchFamily="34" charset="-120"/>
               </a:rPr>
-              <a:t>Enterprise Data Catalog &amp; Governance Framework</a:t>
+              <a:t>Complementary Solutions — Enterprise Catalog</a:t>
             </a:r>
             <a:endParaRPr lang="en-US" sz="850" dirty="0"/>
           </a:p>
@@ -27074,7 +27074,7 @@
                 <a:ea typeface="Calibri" pitchFamily="34" charset="-122"/>
                 <a:cs typeface="Calibri" pitchFamily="34" charset="-120"/>
               </a:rPr>
-              <a:t>Self-Serve Analytics Surface — Business Users</a:t>
+              <a:t>Wave 3 — Self-Serve Analytics Surface</a:t>
             </a:r>
             <a:endParaRPr lang="en-US" sz="850" dirty="0"/>
           </a:p>
@@ -27232,7 +27232,7 @@
                 <a:ea typeface="Calibri" pitchFamily="34" charset="-122"/>
                 <a:cs typeface="Calibri" pitchFamily="34" charset="-120"/>
               </a:rPr>
-              <a:t>Account Opening LTV — JH Platform Launch</a:t>
+              <a:t>DS App Platform — Integration &amp; Scale</a:t>
             </a:r>
             <a:endParaRPr lang="en-US" sz="850" dirty="0"/>
           </a:p>
@@ -27390,7 +27390,7 @@
                 <a:ea typeface="Calibri" pitchFamily="34" charset="-122"/>
                 <a:cs typeface="Calibri" pitchFamily="34" charset="-120"/>
               </a:rPr>
-              <a:t>Cross-Sell Propensity Engine (Horizon Phase 1)</a:t>
+              <a:t>MLOps — Full CI/CD &amp; Governance Complete</a:t>
             </a:r>
             <a:endParaRPr lang="en-US" sz="850" dirty="0"/>
           </a:p>

</xml_diff>

<commit_message>
Slide 6: resequence Engine/Interface apps by data availability — Churn anchor, Zelle Memo, Anomaly Detection, CommercialSignal
</commit_message>
<xml_diff>
--- a/jhbi-roadmap-2026.pptx
+++ b/jhbi-roadmap-2026.pptx
@@ -12606,7 +12606,7 @@
                 <a:ea typeface="Calibri" pitchFamily="34" charset="-122"/>
                 <a:cs typeface="Calibri" pitchFamily="34" charset="-120"/>
               </a:rPr>
-              <a:t>CommercialSignal — Banker Interface MVP</a:t>
+              <a:t>[Churn App] — MVP Interface Launch</a:t>
             </a:r>
             <a:endParaRPr lang="en-US" sz="850" dirty="0"/>
           </a:p>
@@ -12702,7 +12702,7 @@
                 <a:ea typeface="Calibri" pitchFamily="34" charset="-122"/>
                 <a:cs typeface="Calibri" pitchFamily="34" charset="-120"/>
               </a:rPr>
-              <a:t>[Churn App] — Attrition Interface Build</a:t>
+              <a:t>Zelle Memo Intelligence — Interface Live</a:t>
             </a:r>
             <a:endParaRPr lang="en-US" sz="850" dirty="0"/>
           </a:p>
@@ -12798,7 +12798,7 @@
                 <a:ea typeface="Calibri" pitchFamily="34" charset="-122"/>
                 <a:cs typeface="Calibri" pitchFamily="34" charset="-120"/>
               </a:rPr>
-              <a:t>Wealth Deflection — Interface Launch</a:t>
+              <a:t>Anomaly Detection — Interface Launch</a:t>
             </a:r>
             <a:endParaRPr lang="en-US" sz="850" dirty="0"/>
           </a:p>
@@ -12894,7 +12894,7 @@
                 <a:ea typeface="Calibri" pitchFamily="34" charset="-122"/>
                 <a:cs typeface="Calibri" pitchFamily="34" charset="-120"/>
               </a:rPr>
-              <a:t>DS App Platform — Integration &amp; Scale</a:t>
+              <a:t>CommercialSignal — Interface Launch</a:t>
             </a:r>
             <a:endParaRPr lang="en-US" sz="850" dirty="0"/>
           </a:p>
@@ -13267,7 +13267,7 @@
                 <a:ea typeface="Calibri" pitchFamily="34" charset="-122"/>
                 <a:cs typeface="Calibri" pitchFamily="34" charset="-120"/>
               </a:rPr>
-              <a:t>CommercialSignal — P2C Detection Model Launch</a:t>
+              <a:t>[Churn App] — Foundation Anchor MVP</a:t>
             </a:r>
             <a:endParaRPr lang="en-US" sz="850" dirty="0"/>
           </a:p>
@@ -13363,7 +13363,7 @@
                 <a:ea typeface="Calibri" pitchFamily="34" charset="-122"/>
                 <a:cs typeface="Calibri" pitchFamily="34" charset="-120"/>
               </a:rPr>
-              <a:t>[Churn App] — Attrition Detection Model Build</a:t>
+              <a:t>Zelle Memo Intelligence — Payment Memo NLP Live</a:t>
             </a:r>
             <a:endParaRPr lang="en-US" sz="850" dirty="0"/>
           </a:p>
@@ -13459,7 +13459,7 @@
                 <a:ea typeface="Calibri" pitchFamily="34" charset="-122"/>
                 <a:cs typeface="Calibri" pitchFamily="34" charset="-120"/>
               </a:rPr>
-              <a:t>Wealth Deflection — Generational Retention Model</a:t>
+              <a:t>Anomaly Detection — Multi-Rail Payments Live</a:t>
             </a:r>
             <a:endParaRPr lang="en-US" sz="850" dirty="0"/>
           </a:p>
@@ -13555,7 +13555,7 @@
                 <a:ea typeface="Calibri" pitchFamily="34" charset="-122"/>
                 <a:cs typeface="Calibri" pitchFamily="34" charset="-120"/>
               </a:rPr>
-              <a:t>MLOps — Full CI/CD &amp; Governance Complete</a:t>
+              <a:t>CommercialSignal — P2C Detection Launch</a:t>
             </a:r>
             <a:endParaRPr lang="en-US" sz="850" dirty="0"/>
           </a:p>
@@ -15807,7 +15807,7 @@
         <p:spPr>
           <a:xfrm>
             <a:off x="137160" y="1097280"/>
-            <a:ext cx="8915400" cy="210312"/>
+            <a:ext cx="8915400" cy="192024"/>
           </a:xfrm>
           <a:prstGeom prst="rect">
             <a:avLst/>
@@ -15834,7 +15834,7 @@
         <p:spPr>
           <a:xfrm>
             <a:off x="192024" y="1106424"/>
-            <a:ext cx="1920240" cy="192024"/>
+            <a:ext cx="1920240" cy="173736"/>
           </a:xfrm>
           <a:prstGeom prst="rect">
             <a:avLst/>
@@ -15873,7 +15873,7 @@
         <p:spPr>
           <a:xfrm>
             <a:off x="2194560" y="1133856"/>
-            <a:ext cx="2255520" cy="137160"/>
+            <a:ext cx="2255520" cy="118872"/>
           </a:xfrm>
           <a:prstGeom prst="rect">
             <a:avLst/>
@@ -15900,7 +15900,7 @@
         <p:spPr>
           <a:xfrm>
             <a:off x="2231136" y="1133856"/>
-            <a:ext cx="2200656" cy="137160"/>
+            <a:ext cx="2200656" cy="118872"/>
           </a:xfrm>
           <a:prstGeom prst="rect">
             <a:avLst/>
@@ -15938,8 +15938,8 @@
         </p:nvSpPr>
         <p:spPr>
           <a:xfrm>
-            <a:off x="137160" y="1316736"/>
-            <a:ext cx="8915400" cy="210312"/>
+            <a:off x="137160" y="1298448"/>
+            <a:ext cx="8915400" cy="192024"/>
           </a:xfrm>
           <a:prstGeom prst="rect">
             <a:avLst/>
@@ -15963,8 +15963,8 @@
         </p:nvSpPr>
         <p:spPr>
           <a:xfrm>
-            <a:off x="192024" y="1325880"/>
-            <a:ext cx="1920240" cy="192024"/>
+            <a:off x="192024" y="1307592"/>
+            <a:ext cx="1920240" cy="173736"/>
           </a:xfrm>
           <a:prstGeom prst="rect">
             <a:avLst/>
@@ -16002,8 +16002,8 @@
         </p:nvSpPr>
         <p:spPr>
           <a:xfrm>
-            <a:off x="4486656" y="1353312"/>
-            <a:ext cx="2255520" cy="137160"/>
+            <a:off x="4486656" y="1335024"/>
+            <a:ext cx="2255520" cy="118872"/>
           </a:xfrm>
           <a:prstGeom prst="rect">
             <a:avLst/>
@@ -16029,8 +16029,8 @@
         </p:nvSpPr>
         <p:spPr>
           <a:xfrm>
-            <a:off x="4523232" y="1353312"/>
-            <a:ext cx="2200656" cy="137160"/>
+            <a:off x="4523232" y="1335024"/>
+            <a:ext cx="2200656" cy="118872"/>
           </a:xfrm>
           <a:prstGeom prst="rect">
             <a:avLst/>
@@ -16068,8 +16068,8 @@
         </p:nvSpPr>
         <p:spPr>
           <a:xfrm>
-            <a:off x="137160" y="1536192"/>
-            <a:ext cx="8915400" cy="210312"/>
+            <a:off x="137160" y="1499616"/>
+            <a:ext cx="8915400" cy="192024"/>
           </a:xfrm>
           <a:prstGeom prst="rect">
             <a:avLst/>
@@ -16095,8 +16095,8 @@
         </p:nvSpPr>
         <p:spPr>
           <a:xfrm>
-            <a:off x="192024" y="1545336"/>
-            <a:ext cx="1920240" cy="192024"/>
+            <a:off x="192024" y="1508760"/>
+            <a:ext cx="1920240" cy="173736"/>
           </a:xfrm>
           <a:prstGeom prst="rect">
             <a:avLst/>
@@ -16134,8 +16134,8 @@
         </p:nvSpPr>
         <p:spPr>
           <a:xfrm>
-            <a:off x="6778752" y="1572768"/>
-            <a:ext cx="2255520" cy="137160"/>
+            <a:off x="6778752" y="1536192"/>
+            <a:ext cx="2255520" cy="118872"/>
           </a:xfrm>
           <a:prstGeom prst="rect">
             <a:avLst/>
@@ -16161,8 +16161,8 @@
         </p:nvSpPr>
         <p:spPr>
           <a:xfrm>
-            <a:off x="6815328" y="1572768"/>
-            <a:ext cx="2200656" cy="137160"/>
+            <a:off x="6815328" y="1536192"/>
+            <a:ext cx="2200656" cy="118872"/>
           </a:xfrm>
           <a:prstGeom prst="rect">
             <a:avLst/>
@@ -16200,7 +16200,7 @@
         </p:nvSpPr>
         <p:spPr>
           <a:xfrm>
-            <a:off x="137160" y="1783080"/>
+            <a:off x="137160" y="1728216"/>
             <a:ext cx="8915400" cy="146304"/>
           </a:xfrm>
           <a:prstGeom prst="rect">
@@ -16227,7 +16227,7 @@
         </p:nvSpPr>
         <p:spPr>
           <a:xfrm>
-            <a:off x="228600" y="1783080"/>
+            <a:off x="228600" y="1728216"/>
             <a:ext cx="8686800" cy="146304"/>
           </a:xfrm>
           <a:prstGeom prst="rect">
@@ -16266,8 +16266,8 @@
         </p:nvSpPr>
         <p:spPr>
           <a:xfrm>
-            <a:off x="137160" y="1929384"/>
-            <a:ext cx="8915400" cy="210312"/>
+            <a:off x="137160" y="1874520"/>
+            <a:ext cx="8915400" cy="192024"/>
           </a:xfrm>
           <a:prstGeom prst="rect">
             <a:avLst/>
@@ -16293,8 +16293,8 @@
         </p:nvSpPr>
         <p:spPr>
           <a:xfrm>
-            <a:off x="192024" y="1938528"/>
-            <a:ext cx="1920240" cy="192024"/>
+            <a:off x="192024" y="1883664"/>
+            <a:ext cx="1920240" cy="173736"/>
           </a:xfrm>
           <a:prstGeom prst="rect">
             <a:avLst/>
@@ -16332,8 +16332,8 @@
         </p:nvSpPr>
         <p:spPr>
           <a:xfrm>
-            <a:off x="2194560" y="1965960"/>
-            <a:ext cx="2255520" cy="137160"/>
+            <a:off x="2194560" y="1911096"/>
+            <a:ext cx="2255520" cy="118872"/>
           </a:xfrm>
           <a:prstGeom prst="rect">
             <a:avLst/>
@@ -16359,8 +16359,8 @@
         </p:nvSpPr>
         <p:spPr>
           <a:xfrm>
-            <a:off x="2231136" y="1965960"/>
-            <a:ext cx="2200656" cy="137160"/>
+            <a:off x="2231136" y="1911096"/>
+            <a:ext cx="2200656" cy="118872"/>
           </a:xfrm>
           <a:prstGeom prst="rect">
             <a:avLst/>
@@ -16398,8 +16398,8 @@
         </p:nvSpPr>
         <p:spPr>
           <a:xfrm>
-            <a:off x="137160" y="2148840"/>
-            <a:ext cx="8915400" cy="210312"/>
+            <a:off x="137160" y="2075688"/>
+            <a:ext cx="8915400" cy="192024"/>
           </a:xfrm>
           <a:prstGeom prst="rect">
             <a:avLst/>
@@ -16423,8 +16423,8 @@
         </p:nvSpPr>
         <p:spPr>
           <a:xfrm>
-            <a:off x="192024" y="2157984"/>
-            <a:ext cx="1920240" cy="192024"/>
+            <a:off x="192024" y="2084832"/>
+            <a:ext cx="1920240" cy="173736"/>
           </a:xfrm>
           <a:prstGeom prst="rect">
             <a:avLst/>
@@ -16462,8 +16462,8 @@
         </p:nvSpPr>
         <p:spPr>
           <a:xfrm>
-            <a:off x="4486656" y="2185416"/>
-            <a:ext cx="2255520" cy="137160"/>
+            <a:off x="4486656" y="2112264"/>
+            <a:ext cx="2255520" cy="118872"/>
           </a:xfrm>
           <a:prstGeom prst="rect">
             <a:avLst/>
@@ -16489,8 +16489,8 @@
         </p:nvSpPr>
         <p:spPr>
           <a:xfrm>
-            <a:off x="4523232" y="2185416"/>
-            <a:ext cx="2200656" cy="137160"/>
+            <a:off x="4523232" y="2112264"/>
+            <a:ext cx="2200656" cy="118872"/>
           </a:xfrm>
           <a:prstGeom prst="rect">
             <a:avLst/>
@@ -16528,8 +16528,8 @@
         </p:nvSpPr>
         <p:spPr>
           <a:xfrm>
-            <a:off x="137160" y="2368296"/>
-            <a:ext cx="8915400" cy="210312"/>
+            <a:off x="137160" y="2276856"/>
+            <a:ext cx="8915400" cy="192024"/>
           </a:xfrm>
           <a:prstGeom prst="rect">
             <a:avLst/>
@@ -16555,8 +16555,8 @@
         </p:nvSpPr>
         <p:spPr>
           <a:xfrm>
-            <a:off x="192024" y="2377440"/>
-            <a:ext cx="1920240" cy="192024"/>
+            <a:off x="192024" y="2286000"/>
+            <a:ext cx="1920240" cy="173736"/>
           </a:xfrm>
           <a:prstGeom prst="rect">
             <a:avLst/>
@@ -16594,8 +16594,8 @@
         </p:nvSpPr>
         <p:spPr>
           <a:xfrm>
-            <a:off x="6778752" y="2404872"/>
-            <a:ext cx="2255520" cy="137160"/>
+            <a:off x="6778752" y="2313432"/>
+            <a:ext cx="2255520" cy="118872"/>
           </a:xfrm>
           <a:prstGeom prst="rect">
             <a:avLst/>
@@ -16621,8 +16621,8 @@
         </p:nvSpPr>
         <p:spPr>
           <a:xfrm>
-            <a:off x="6815328" y="2404872"/>
-            <a:ext cx="2200656" cy="137160"/>
+            <a:off x="6815328" y="2313432"/>
+            <a:ext cx="2200656" cy="118872"/>
           </a:xfrm>
           <a:prstGeom prst="rect">
             <a:avLst/>
@@ -16660,7 +16660,7 @@
         </p:nvSpPr>
         <p:spPr>
           <a:xfrm>
-            <a:off x="137160" y="2615184"/>
+            <a:off x="137160" y="2505456"/>
             <a:ext cx="8915400" cy="146304"/>
           </a:xfrm>
           <a:prstGeom prst="rect">
@@ -16687,7 +16687,7 @@
         </p:nvSpPr>
         <p:spPr>
           <a:xfrm>
-            <a:off x="228600" y="2615184"/>
+            <a:off x="228600" y="2505456"/>
             <a:ext cx="8686800" cy="146304"/>
           </a:xfrm>
           <a:prstGeom prst="rect">
@@ -16726,8 +16726,8 @@
         </p:nvSpPr>
         <p:spPr>
           <a:xfrm>
-            <a:off x="137160" y="2761488"/>
-            <a:ext cx="8915400" cy="210312"/>
+            <a:off x="137160" y="2651760"/>
+            <a:ext cx="8915400" cy="192024"/>
           </a:xfrm>
           <a:prstGeom prst="rect">
             <a:avLst/>
@@ -16753,8 +16753,8 @@
         </p:nvSpPr>
         <p:spPr>
           <a:xfrm>
-            <a:off x="192024" y="2770632"/>
-            <a:ext cx="1920240" cy="192024"/>
+            <a:off x="192024" y="2660904"/>
+            <a:ext cx="1920240" cy="173736"/>
           </a:xfrm>
           <a:prstGeom prst="rect">
             <a:avLst/>
@@ -16792,8 +16792,8 @@
         </p:nvSpPr>
         <p:spPr>
           <a:xfrm>
-            <a:off x="2194560" y="2798064"/>
-            <a:ext cx="2255520" cy="137160"/>
+            <a:off x="2194560" y="2688336"/>
+            <a:ext cx="2255520" cy="118872"/>
           </a:xfrm>
           <a:prstGeom prst="rect">
             <a:avLst/>
@@ -16819,8 +16819,8 @@
         </p:nvSpPr>
         <p:spPr>
           <a:xfrm>
-            <a:off x="2231136" y="2798064"/>
-            <a:ext cx="2200656" cy="137160"/>
+            <a:off x="2231136" y="2688336"/>
+            <a:ext cx="2200656" cy="118872"/>
           </a:xfrm>
           <a:prstGeom prst="rect">
             <a:avLst/>
@@ -16858,8 +16858,8 @@
         </p:nvSpPr>
         <p:spPr>
           <a:xfrm>
-            <a:off x="137160" y="2980944"/>
-            <a:ext cx="8915400" cy="210312"/>
+            <a:off x="137160" y="2852928"/>
+            <a:ext cx="8915400" cy="192024"/>
           </a:xfrm>
           <a:prstGeom prst="rect">
             <a:avLst/>
@@ -16883,8 +16883,8 @@
         </p:nvSpPr>
         <p:spPr>
           <a:xfrm>
-            <a:off x="192024" y="2990088"/>
-            <a:ext cx="1920240" cy="192024"/>
+            <a:off x="192024" y="2862072"/>
+            <a:ext cx="1920240" cy="173736"/>
           </a:xfrm>
           <a:prstGeom prst="rect">
             <a:avLst/>
@@ -16908,7 +16908,7 @@
                 <a:ea typeface="Calibri" pitchFamily="34" charset="-122"/>
                 <a:cs typeface="Calibri" pitchFamily="34" charset="-120"/>
               </a:rPr>
-              <a:t>DS App Interface — CommercialSignal</a:t>
+              <a:t>DS App Interface — [Churn App]</a:t>
             </a:r>
             <a:endParaRPr lang="en-US" sz="650" dirty="0"/>
           </a:p>
@@ -16922,8 +16922,8 @@
         </p:nvSpPr>
         <p:spPr>
           <a:xfrm>
-            <a:off x="4486656" y="3017520"/>
-            <a:ext cx="1491488" cy="137160"/>
+            <a:off x="2958592" y="2889504"/>
+            <a:ext cx="2637536" cy="118872"/>
           </a:xfrm>
           <a:prstGeom prst="rect">
             <a:avLst/>
@@ -16949,8 +16949,8 @@
         </p:nvSpPr>
         <p:spPr>
           <a:xfrm>
-            <a:off x="4523232" y="3017520"/>
-            <a:ext cx="1436624" cy="137160"/>
+            <a:off x="2995168" y="2889504"/>
+            <a:ext cx="2582672" cy="118872"/>
           </a:xfrm>
           <a:prstGeom prst="rect">
             <a:avLst/>
@@ -16974,7 +16974,7 @@
                 <a:ea typeface="Calibri" pitchFamily="34" charset="-122"/>
                 <a:cs typeface="Calibri" pitchFamily="34" charset="-120"/>
               </a:rPr>
-              <a:t>DS App Interface — Com…</a:t>
+              <a:t>DS App Interface — [Ch…</a:t>
             </a:r>
             <a:endParaRPr lang="en-US" sz="600" dirty="0"/>
           </a:p>
@@ -16988,8 +16988,8 @@
         </p:nvSpPr>
         <p:spPr>
           <a:xfrm>
-            <a:off x="137160" y="3200400"/>
-            <a:ext cx="8915400" cy="210312"/>
+            <a:off x="137160" y="3054096"/>
+            <a:ext cx="8915400" cy="192024"/>
           </a:xfrm>
           <a:prstGeom prst="rect">
             <a:avLst/>
@@ -17015,8 +17015,8 @@
         </p:nvSpPr>
         <p:spPr>
           <a:xfrm>
-            <a:off x="192024" y="3209544"/>
-            <a:ext cx="1920240" cy="192024"/>
+            <a:off x="192024" y="3063240"/>
+            <a:ext cx="1920240" cy="173736"/>
           </a:xfrm>
           <a:prstGeom prst="rect">
             <a:avLst/>
@@ -17040,7 +17040,7 @@
                 <a:ea typeface="Calibri" pitchFamily="34" charset="-122"/>
                 <a:cs typeface="Calibri" pitchFamily="34" charset="-120"/>
               </a:rPr>
-              <a:t>DS App Interface — [Churn App]</a:t>
+              <a:t>DS App Interface — Zelle Memo Intelligence</a:t>
             </a:r>
             <a:endParaRPr lang="en-US" sz="650" dirty="0"/>
           </a:p>
@@ -17054,8 +17054,8 @@
         </p:nvSpPr>
         <p:spPr>
           <a:xfrm>
-            <a:off x="5632704" y="3236976"/>
-            <a:ext cx="2255520" cy="137160"/>
+            <a:off x="4486656" y="3090672"/>
+            <a:ext cx="1491488" cy="118872"/>
           </a:xfrm>
           <a:prstGeom prst="rect">
             <a:avLst/>
@@ -17081,8 +17081,8 @@
         </p:nvSpPr>
         <p:spPr>
           <a:xfrm>
-            <a:off x="5669280" y="3236976"/>
-            <a:ext cx="2200656" cy="137160"/>
+            <a:off x="4523232" y="3090672"/>
+            <a:ext cx="1436624" cy="118872"/>
           </a:xfrm>
           <a:prstGeom prst="rect">
             <a:avLst/>
@@ -17106,7 +17106,7 @@
                 <a:ea typeface="Calibri" pitchFamily="34" charset="-122"/>
                 <a:cs typeface="Calibri" pitchFamily="34" charset="-120"/>
               </a:rPr>
-              <a:t>DS App Interface — [Ch…</a:t>
+              <a:t>DS App Interface — Zel…</a:t>
             </a:r>
             <a:endParaRPr lang="en-US" sz="600" dirty="0"/>
           </a:p>
@@ -17120,8 +17120,8 @@
         </p:nvSpPr>
         <p:spPr>
           <a:xfrm>
-            <a:off x="137160" y="3419856"/>
-            <a:ext cx="8915400" cy="210312"/>
+            <a:off x="137160" y="3255264"/>
+            <a:ext cx="8915400" cy="192024"/>
           </a:xfrm>
           <a:prstGeom prst="rect">
             <a:avLst/>
@@ -17145,8 +17145,8 @@
         </p:nvSpPr>
         <p:spPr>
           <a:xfrm>
-            <a:off x="192024" y="3429000"/>
-            <a:ext cx="1920240" cy="192024"/>
+            <a:off x="192024" y="3264408"/>
+            <a:ext cx="1920240" cy="173736"/>
           </a:xfrm>
           <a:prstGeom prst="rect">
             <a:avLst/>
@@ -17170,7 +17170,7 @@
                 <a:ea typeface="Calibri" pitchFamily="34" charset="-122"/>
                 <a:cs typeface="Calibri" pitchFamily="34" charset="-120"/>
               </a:rPr>
-              <a:t>DS App Interface — Wealth Deflection</a:t>
+              <a:t>DS App Interface — Anomaly Detection</a:t>
             </a:r>
             <a:endParaRPr lang="en-US" sz="650" dirty="0"/>
           </a:p>
@@ -17184,8 +17184,8 @@
         </p:nvSpPr>
         <p:spPr>
           <a:xfrm>
-            <a:off x="6778752" y="3456432"/>
-            <a:ext cx="2255520" cy="137160"/>
+            <a:off x="5632704" y="3291840"/>
+            <a:ext cx="1109472" cy="118872"/>
           </a:xfrm>
           <a:prstGeom prst="rect">
             <a:avLst/>
@@ -17211,8 +17211,8 @@
         </p:nvSpPr>
         <p:spPr>
           <a:xfrm>
-            <a:off x="6815328" y="3456432"/>
-            <a:ext cx="2200656" cy="137160"/>
+            <a:off x="5669280" y="3291840"/>
+            <a:ext cx="1054608" cy="118872"/>
           </a:xfrm>
           <a:prstGeom prst="rect">
             <a:avLst/>
@@ -17236,7 +17236,7 @@
                 <a:ea typeface="Calibri" pitchFamily="34" charset="-122"/>
                 <a:cs typeface="Calibri" pitchFamily="34" charset="-120"/>
               </a:rPr>
-              <a:t>DS App Interface — Wea…</a:t>
+              <a:t>DS App Interface — Ano…</a:t>
             </a:r>
             <a:endParaRPr lang="en-US" sz="600" dirty="0"/>
           </a:p>
@@ -17250,7 +17250,139 @@
         </p:nvSpPr>
         <p:spPr>
           <a:xfrm>
-            <a:off x="137160" y="3666744"/>
+            <a:off x="137160" y="3456432"/>
+            <a:ext cx="8915400" cy="192024"/>
+          </a:xfrm>
+          <a:prstGeom prst="rect">
+            <a:avLst/>
+          </a:prstGeom>
+          <a:solidFill>
+            <a:srgbClr val="E7ECF0">
+              <a:alpha val="30000"/>
+            </a:srgbClr>
+          </a:solidFill>
+          <a:ln w="3810">
+            <a:solidFill>
+              <a:srgbClr val="E0E4E8"/>
+            </a:solidFill>
+            <a:prstDash val="solid"/>
+          </a:ln>
+        </p:spPr>
+      </p:sp>
+      <p:sp>
+        <p:nvSpPr>
+          <p:cNvPr id="120" name="Text 118"/>
+          <p:cNvSpPr/>
+          <p:nvPr/>
+        </p:nvSpPr>
+        <p:spPr>
+          <a:xfrm>
+            <a:off x="192024" y="3465576"/>
+            <a:ext cx="1920240" cy="173736"/>
+          </a:xfrm>
+          <a:prstGeom prst="rect">
+            <a:avLst/>
+          </a:prstGeom>
+          <a:noFill/>
+          <a:ln/>
+        </p:spPr>
+        <p:txBody>
+          <a:bodyPr wrap="square" rtlCol="0" anchor="ctr"/>
+          <a:lstStyle/>
+          <a:p>
+            <a:pPr indent="0" marL="0">
+              <a:buNone/>
+            </a:pPr>
+            <a:r>
+              <a:rPr lang="en-US" sz="650" dirty="0">
+                <a:solidFill>
+                  <a:srgbClr val="575A5D"/>
+                </a:solidFill>
+                <a:latin typeface="Calibri" pitchFamily="34" charset="0"/>
+                <a:ea typeface="Calibri" pitchFamily="34" charset="-122"/>
+                <a:cs typeface="Calibri" pitchFamily="34" charset="-120"/>
+              </a:rPr>
+              <a:t>DS App Interface — CommercialSignal</a:t>
+            </a:r>
+            <a:endParaRPr lang="en-US" sz="650" dirty="0"/>
+          </a:p>
+        </p:txBody>
+      </p:sp>
+      <p:sp>
+        <p:nvSpPr>
+          <p:cNvPr id="121" name="Shape 119"/>
+          <p:cNvSpPr/>
+          <p:nvPr/>
+        </p:nvSpPr>
+        <p:spPr>
+          <a:xfrm>
+            <a:off x="6778752" y="3493008"/>
+            <a:ext cx="2255520" cy="118872"/>
+          </a:xfrm>
+          <a:prstGeom prst="rect">
+            <a:avLst/>
+          </a:prstGeom>
+          <a:solidFill>
+            <a:srgbClr val="0A5CA8">
+              <a:alpha val="88000"/>
+            </a:srgbClr>
+          </a:solidFill>
+          <a:ln w="15240">
+            <a:solidFill>
+              <a:srgbClr val="0A5CA8"/>
+            </a:solidFill>
+            <a:prstDash val="solid"/>
+          </a:ln>
+        </p:spPr>
+      </p:sp>
+      <p:sp>
+        <p:nvSpPr>
+          <p:cNvPr id="122" name="Text 120"/>
+          <p:cNvSpPr/>
+          <p:nvPr/>
+        </p:nvSpPr>
+        <p:spPr>
+          <a:xfrm>
+            <a:off x="6815328" y="3493008"/>
+            <a:ext cx="2200656" cy="118872"/>
+          </a:xfrm>
+          <a:prstGeom prst="rect">
+            <a:avLst/>
+          </a:prstGeom>
+          <a:noFill/>
+          <a:ln/>
+        </p:spPr>
+        <p:txBody>
+          <a:bodyPr wrap="square" rtlCol="0" anchor="ctr"/>
+          <a:lstStyle/>
+          <a:p>
+            <a:pPr indent="0" marL="0">
+              <a:buNone/>
+            </a:pPr>
+            <a:r>
+              <a:rPr lang="en-US" sz="600" dirty="0">
+                <a:solidFill>
+                  <a:srgbClr val="FFFFFF"/>
+                </a:solidFill>
+                <a:latin typeface="Calibri" pitchFamily="34" charset="0"/>
+                <a:ea typeface="Calibri" pitchFamily="34" charset="-122"/>
+                <a:cs typeface="Calibri" pitchFamily="34" charset="-120"/>
+              </a:rPr>
+              <a:t>DS App Interface — Com…</a:t>
+            </a:r>
+            <a:endParaRPr lang="en-US" sz="600" dirty="0"/>
+          </a:p>
+        </p:txBody>
+      </p:sp>
+      <p:sp>
+        <p:nvSpPr>
+          <p:cNvPr id="123" name="Shape 121"/>
+          <p:cNvSpPr/>
+          <p:nvPr/>
+        </p:nvSpPr>
+        <p:spPr>
+          <a:xfrm>
+            <a:off x="137160" y="3685032"/>
             <a:ext cx="8915400" cy="146304"/>
           </a:xfrm>
           <a:prstGeom prst="rect">
@@ -17271,13 +17403,13 @@
       </p:sp>
       <p:sp>
         <p:nvSpPr>
-          <p:cNvPr id="120" name="Text 118"/>
-          <p:cNvSpPr/>
-          <p:nvPr/>
-        </p:nvSpPr>
-        <p:spPr>
-          <a:xfrm>
-            <a:off x="228600" y="3666744"/>
+          <p:cNvPr id="124" name="Text 122"/>
+          <p:cNvSpPr/>
+          <p:nvPr/>
+        </p:nvSpPr>
+        <p:spPr>
+          <a:xfrm>
+            <a:off x="228600" y="3685032"/>
             <a:ext cx="8686800" cy="146304"/>
           </a:xfrm>
           <a:prstGeom prst="rect">
@@ -17310,14 +17442,14 @@
       </p:sp>
       <p:sp>
         <p:nvSpPr>
-          <p:cNvPr id="121" name="Shape 119"/>
-          <p:cNvSpPr/>
-          <p:nvPr/>
-        </p:nvSpPr>
-        <p:spPr>
-          <a:xfrm>
-            <a:off x="137160" y="3813048"/>
-            <a:ext cx="8915400" cy="210312"/>
+          <p:cNvPr id="125" name="Shape 123"/>
+          <p:cNvSpPr/>
+          <p:nvPr/>
+        </p:nvSpPr>
+        <p:spPr>
+          <a:xfrm>
+            <a:off x="137160" y="3831336"/>
+            <a:ext cx="8915400" cy="192024"/>
           </a:xfrm>
           <a:prstGeom prst="rect">
             <a:avLst/>
@@ -17337,14 +17469,14 @@
       </p:sp>
       <p:sp>
         <p:nvSpPr>
-          <p:cNvPr id="122" name="Text 120"/>
-          <p:cNvSpPr/>
-          <p:nvPr/>
-        </p:nvSpPr>
-        <p:spPr>
-          <a:xfrm>
-            <a:off x="192024" y="3822192"/>
-            <a:ext cx="1920240" cy="192024"/>
+          <p:cNvPr id="126" name="Text 124"/>
+          <p:cNvSpPr/>
+          <p:nvPr/>
+        </p:nvSpPr>
+        <p:spPr>
+          <a:xfrm>
+            <a:off x="192024" y="3840480"/>
+            <a:ext cx="1920240" cy="173736"/>
           </a:xfrm>
           <a:prstGeom prst="rect">
             <a:avLst/>
@@ -17376,14 +17508,14 @@
       </p:sp>
       <p:sp>
         <p:nvSpPr>
-          <p:cNvPr id="123" name="Shape 121"/>
-          <p:cNvSpPr/>
-          <p:nvPr/>
-        </p:nvSpPr>
-        <p:spPr>
-          <a:xfrm>
-            <a:off x="2194560" y="3849624"/>
-            <a:ext cx="2255520" cy="137160"/>
+          <p:cNvPr id="127" name="Shape 125"/>
+          <p:cNvSpPr/>
+          <p:nvPr/>
+        </p:nvSpPr>
+        <p:spPr>
+          <a:xfrm>
+            <a:off x="2194560" y="3867912"/>
+            <a:ext cx="2255520" cy="118872"/>
           </a:xfrm>
           <a:prstGeom prst="rect">
             <a:avLst/>
@@ -17403,14 +17535,14 @@
       </p:sp>
       <p:sp>
         <p:nvSpPr>
-          <p:cNvPr id="124" name="Text 122"/>
-          <p:cNvSpPr/>
-          <p:nvPr/>
-        </p:nvSpPr>
-        <p:spPr>
-          <a:xfrm>
-            <a:off x="2231136" y="3849624"/>
-            <a:ext cx="2200656" cy="137160"/>
+          <p:cNvPr id="128" name="Text 126"/>
+          <p:cNvSpPr/>
+          <p:nvPr/>
+        </p:nvSpPr>
+        <p:spPr>
+          <a:xfrm>
+            <a:off x="2231136" y="3867912"/>
+            <a:ext cx="2200656" cy="118872"/>
           </a:xfrm>
           <a:prstGeom prst="rect">
             <a:avLst/>
@@ -17442,14 +17574,14 @@
       </p:sp>
       <p:sp>
         <p:nvSpPr>
-          <p:cNvPr id="125" name="Shape 123"/>
+          <p:cNvPr id="129" name="Shape 127"/>
           <p:cNvSpPr/>
           <p:nvPr/>
         </p:nvSpPr>
         <p:spPr>
           <a:xfrm>
             <a:off x="137160" y="4032504"/>
-            <a:ext cx="8915400" cy="210312"/>
+            <a:ext cx="8915400" cy="192024"/>
           </a:xfrm>
           <a:prstGeom prst="rect">
             <a:avLst/>
@@ -17467,14 +17599,14 @@
       </p:sp>
       <p:sp>
         <p:nvSpPr>
-          <p:cNvPr id="126" name="Text 124"/>
+          <p:cNvPr id="130" name="Text 128"/>
           <p:cNvSpPr/>
           <p:nvPr/>
         </p:nvSpPr>
         <p:spPr>
           <a:xfrm>
             <a:off x="192024" y="4041648"/>
-            <a:ext cx="1920240" cy="192024"/>
+            <a:ext cx="1920240" cy="173736"/>
           </a:xfrm>
           <a:prstGeom prst="rect">
             <a:avLst/>
@@ -17498,7 +17630,7 @@
                 <a:ea typeface="Calibri" pitchFamily="34" charset="-122"/>
                 <a:cs typeface="Calibri" pitchFamily="34" charset="-120"/>
               </a:rPr>
-              <a:t>CommercialSignal — P2C Detection</a:t>
+              <a:t>[Churn App] — Foundation Anchor</a:t>
             </a:r>
             <a:endParaRPr lang="en-US" sz="650" dirty="0"/>
           </a:p>
@@ -17506,14 +17638,14 @@
       </p:sp>
       <p:sp>
         <p:nvSpPr>
-          <p:cNvPr id="127" name="Shape 125"/>
-          <p:cNvSpPr/>
-          <p:nvPr/>
-        </p:nvSpPr>
-        <p:spPr>
-          <a:xfrm>
-            <a:off x="4486656" y="4069080"/>
-            <a:ext cx="1491488" cy="137160"/>
+          <p:cNvPr id="131" name="Shape 129"/>
+          <p:cNvSpPr/>
+          <p:nvPr/>
+        </p:nvSpPr>
+        <p:spPr>
+          <a:xfrm>
+            <a:off x="2958592" y="4069080"/>
+            <a:ext cx="2637536" cy="118872"/>
           </a:xfrm>
           <a:prstGeom prst="rect">
             <a:avLst/>
@@ -17533,14 +17665,14 @@
       </p:sp>
       <p:sp>
         <p:nvSpPr>
-          <p:cNvPr id="128" name="Text 126"/>
-          <p:cNvSpPr/>
-          <p:nvPr/>
-        </p:nvSpPr>
-        <p:spPr>
-          <a:xfrm>
-            <a:off x="4523232" y="4069080"/>
-            <a:ext cx="1436624" cy="137160"/>
+          <p:cNvPr id="132" name="Text 130"/>
+          <p:cNvSpPr/>
+          <p:nvPr/>
+        </p:nvSpPr>
+        <p:spPr>
+          <a:xfrm>
+            <a:off x="2995168" y="4069080"/>
+            <a:ext cx="2582672" cy="118872"/>
           </a:xfrm>
           <a:prstGeom prst="rect">
             <a:avLst/>
@@ -17564,7 +17696,7 @@
                 <a:ea typeface="Calibri" pitchFamily="34" charset="-122"/>
                 <a:cs typeface="Calibri" pitchFamily="34" charset="-120"/>
               </a:rPr>
-              <a:t>CommercialSignal — P2C…</a:t>
+              <a:t>[Churn App] — Foundati…</a:t>
             </a:r>
             <a:endParaRPr lang="en-US" sz="600" dirty="0"/>
           </a:p>
@@ -17572,14 +17704,14 @@
       </p:sp>
       <p:sp>
         <p:nvSpPr>
-          <p:cNvPr id="129" name="Shape 127"/>
-          <p:cNvSpPr/>
-          <p:nvPr/>
-        </p:nvSpPr>
-        <p:spPr>
-          <a:xfrm>
-            <a:off x="137160" y="4251960"/>
-            <a:ext cx="8915400" cy="210312"/>
+          <p:cNvPr id="133" name="Shape 131"/>
+          <p:cNvSpPr/>
+          <p:nvPr/>
+        </p:nvSpPr>
+        <p:spPr>
+          <a:xfrm>
+            <a:off x="137160" y="4233672"/>
+            <a:ext cx="8915400" cy="192024"/>
           </a:xfrm>
           <a:prstGeom prst="rect">
             <a:avLst/>
@@ -17599,14 +17731,14 @@
       </p:sp>
       <p:sp>
         <p:nvSpPr>
-          <p:cNvPr id="130" name="Text 128"/>
-          <p:cNvSpPr/>
-          <p:nvPr/>
-        </p:nvSpPr>
-        <p:spPr>
-          <a:xfrm>
-            <a:off x="192024" y="4261104"/>
-            <a:ext cx="1920240" cy="192024"/>
+          <p:cNvPr id="134" name="Text 132"/>
+          <p:cNvSpPr/>
+          <p:nvPr/>
+        </p:nvSpPr>
+        <p:spPr>
+          <a:xfrm>
+            <a:off x="192024" y="4242816"/>
+            <a:ext cx="1920240" cy="173736"/>
           </a:xfrm>
           <a:prstGeom prst="rect">
             <a:avLst/>
@@ -17630,7 +17762,7 @@
                 <a:ea typeface="Calibri" pitchFamily="34" charset="-122"/>
                 <a:cs typeface="Calibri" pitchFamily="34" charset="-120"/>
               </a:rPr>
-              <a:t>[Churn App] — Attrition Detection</a:t>
+              <a:t>Zelle Memo Intelligence — Payment Memo NLP</a:t>
             </a:r>
             <a:endParaRPr lang="en-US" sz="650" dirty="0"/>
           </a:p>
@@ -17638,14 +17770,14 @@
       </p:sp>
       <p:sp>
         <p:nvSpPr>
-          <p:cNvPr id="131" name="Shape 129"/>
-          <p:cNvSpPr/>
-          <p:nvPr/>
-        </p:nvSpPr>
-        <p:spPr>
-          <a:xfrm>
-            <a:off x="5632704" y="4288536"/>
-            <a:ext cx="2255520" cy="137160"/>
+          <p:cNvPr id="135" name="Shape 133"/>
+          <p:cNvSpPr/>
+          <p:nvPr/>
+        </p:nvSpPr>
+        <p:spPr>
+          <a:xfrm>
+            <a:off x="4486656" y="4270248"/>
+            <a:ext cx="1491488" cy="118872"/>
           </a:xfrm>
           <a:prstGeom prst="rect">
             <a:avLst/>
@@ -17665,14 +17797,14 @@
       </p:sp>
       <p:sp>
         <p:nvSpPr>
-          <p:cNvPr id="132" name="Text 130"/>
-          <p:cNvSpPr/>
-          <p:nvPr/>
-        </p:nvSpPr>
-        <p:spPr>
-          <a:xfrm>
-            <a:off x="5669280" y="4288536"/>
-            <a:ext cx="2200656" cy="137160"/>
+          <p:cNvPr id="136" name="Text 134"/>
+          <p:cNvSpPr/>
+          <p:nvPr/>
+        </p:nvSpPr>
+        <p:spPr>
+          <a:xfrm>
+            <a:off x="4523232" y="4270248"/>
+            <a:ext cx="1436624" cy="118872"/>
           </a:xfrm>
           <a:prstGeom prst="rect">
             <a:avLst/>
@@ -17696,7 +17828,7 @@
                 <a:ea typeface="Calibri" pitchFamily="34" charset="-122"/>
                 <a:cs typeface="Calibri" pitchFamily="34" charset="-120"/>
               </a:rPr>
-              <a:t>[Churn App] — Attritio…</a:t>
+              <a:t>Zelle Memo Intelligenc…</a:t>
             </a:r>
             <a:endParaRPr lang="en-US" sz="600" dirty="0"/>
           </a:p>
@@ -17704,14 +17836,14 @@
       </p:sp>
       <p:sp>
         <p:nvSpPr>
-          <p:cNvPr id="133" name="Shape 131"/>
-          <p:cNvSpPr/>
-          <p:nvPr/>
-        </p:nvSpPr>
-        <p:spPr>
-          <a:xfrm>
-            <a:off x="137160" y="4471416"/>
-            <a:ext cx="8915400" cy="210312"/>
+          <p:cNvPr id="137" name="Shape 135"/>
+          <p:cNvSpPr/>
+          <p:nvPr/>
+        </p:nvSpPr>
+        <p:spPr>
+          <a:xfrm>
+            <a:off x="137160" y="4434840"/>
+            <a:ext cx="8915400" cy="192024"/>
           </a:xfrm>
           <a:prstGeom prst="rect">
             <a:avLst/>
@@ -17729,14 +17861,14 @@
       </p:sp>
       <p:sp>
         <p:nvSpPr>
-          <p:cNvPr id="134" name="Text 132"/>
-          <p:cNvSpPr/>
-          <p:nvPr/>
-        </p:nvSpPr>
-        <p:spPr>
-          <a:xfrm>
-            <a:off x="192024" y="4480560"/>
-            <a:ext cx="1920240" cy="192024"/>
+          <p:cNvPr id="138" name="Text 136"/>
+          <p:cNvSpPr/>
+          <p:nvPr/>
+        </p:nvSpPr>
+        <p:spPr>
+          <a:xfrm>
+            <a:off x="192024" y="4443984"/>
+            <a:ext cx="1920240" cy="173736"/>
           </a:xfrm>
           <a:prstGeom prst="rect">
             <a:avLst/>
@@ -17760,7 +17892,7 @@
                 <a:ea typeface="Calibri" pitchFamily="34" charset="-122"/>
                 <a:cs typeface="Calibri" pitchFamily="34" charset="-120"/>
               </a:rPr>
-              <a:t>Wealth Deflection — Generational Retention</a:t>
+              <a:t>Anomaly Detection — Multi-Rail Payments</a:t>
             </a:r>
             <a:endParaRPr lang="en-US" sz="650" dirty="0"/>
           </a:p>
@@ -17768,14 +17900,14 @@
       </p:sp>
       <p:sp>
         <p:nvSpPr>
-          <p:cNvPr id="135" name="Shape 133"/>
-          <p:cNvSpPr/>
-          <p:nvPr/>
-        </p:nvSpPr>
-        <p:spPr>
-          <a:xfrm>
-            <a:off x="6778752" y="4507992"/>
-            <a:ext cx="2255520" cy="137160"/>
+          <p:cNvPr id="139" name="Shape 137"/>
+          <p:cNvSpPr/>
+          <p:nvPr/>
+        </p:nvSpPr>
+        <p:spPr>
+          <a:xfrm>
+            <a:off x="5632704" y="4471416"/>
+            <a:ext cx="1109472" cy="118872"/>
           </a:xfrm>
           <a:prstGeom prst="rect">
             <a:avLst/>
@@ -17795,14 +17927,14 @@
       </p:sp>
       <p:sp>
         <p:nvSpPr>
-          <p:cNvPr id="136" name="Text 134"/>
-          <p:cNvSpPr/>
-          <p:nvPr/>
-        </p:nvSpPr>
-        <p:spPr>
-          <a:xfrm>
-            <a:off x="6815328" y="4507992"/>
-            <a:ext cx="2200656" cy="137160"/>
+          <p:cNvPr id="140" name="Text 138"/>
+          <p:cNvSpPr/>
+          <p:nvPr/>
+        </p:nvSpPr>
+        <p:spPr>
+          <a:xfrm>
+            <a:off x="5669280" y="4471416"/>
+            <a:ext cx="1054608" cy="118872"/>
           </a:xfrm>
           <a:prstGeom prst="rect">
             <a:avLst/>
@@ -17826,7 +17958,7 @@
                 <a:ea typeface="Calibri" pitchFamily="34" charset="-122"/>
                 <a:cs typeface="Calibri" pitchFamily="34" charset="-120"/>
               </a:rPr>
-              <a:t>Wealth Deflection — Ge…</a:t>
+              <a:t>Anomaly Detection — Mu…</a:t>
             </a:r>
             <a:endParaRPr lang="en-US" sz="600" dirty="0"/>
           </a:p>
@@ -17834,7 +17966,139 @@
       </p:sp>
       <p:sp>
         <p:nvSpPr>
-          <p:cNvPr id="137" name="Shape 135"/>
+          <p:cNvPr id="141" name="Shape 139"/>
+          <p:cNvSpPr/>
+          <p:nvPr/>
+        </p:nvSpPr>
+        <p:spPr>
+          <a:xfrm>
+            <a:off x="137160" y="4636008"/>
+            <a:ext cx="8915400" cy="192024"/>
+          </a:xfrm>
+          <a:prstGeom prst="rect">
+            <a:avLst/>
+          </a:prstGeom>
+          <a:solidFill>
+            <a:srgbClr val="E7ECF0">
+              <a:alpha val="30000"/>
+            </a:srgbClr>
+          </a:solidFill>
+          <a:ln w="3810">
+            <a:solidFill>
+              <a:srgbClr val="E0E4E8"/>
+            </a:solidFill>
+            <a:prstDash val="solid"/>
+          </a:ln>
+        </p:spPr>
+      </p:sp>
+      <p:sp>
+        <p:nvSpPr>
+          <p:cNvPr id="142" name="Text 140"/>
+          <p:cNvSpPr/>
+          <p:nvPr/>
+        </p:nvSpPr>
+        <p:spPr>
+          <a:xfrm>
+            <a:off x="192024" y="4645152"/>
+            <a:ext cx="1920240" cy="173736"/>
+          </a:xfrm>
+          <a:prstGeom prst="rect">
+            <a:avLst/>
+          </a:prstGeom>
+          <a:noFill/>
+          <a:ln/>
+        </p:spPr>
+        <p:txBody>
+          <a:bodyPr wrap="square" rtlCol="0" anchor="ctr"/>
+          <a:lstStyle/>
+          <a:p>
+            <a:pPr indent="0" marL="0">
+              <a:buNone/>
+            </a:pPr>
+            <a:r>
+              <a:rPr lang="en-US" sz="650" dirty="0">
+                <a:solidFill>
+                  <a:srgbClr val="575A5D"/>
+                </a:solidFill>
+                <a:latin typeface="Calibri" pitchFamily="34" charset="0"/>
+                <a:ea typeface="Calibri" pitchFamily="34" charset="-122"/>
+                <a:cs typeface="Calibri" pitchFamily="34" charset="-120"/>
+              </a:rPr>
+              <a:t>CommercialSignal — P2C Detection</a:t>
+            </a:r>
+            <a:endParaRPr lang="en-US" sz="650" dirty="0"/>
+          </a:p>
+        </p:txBody>
+      </p:sp>
+      <p:sp>
+        <p:nvSpPr>
+          <p:cNvPr id="143" name="Shape 141"/>
+          <p:cNvSpPr/>
+          <p:nvPr/>
+        </p:nvSpPr>
+        <p:spPr>
+          <a:xfrm>
+            <a:off x="6778752" y="4672584"/>
+            <a:ext cx="2255520" cy="118872"/>
+          </a:xfrm>
+          <a:prstGeom prst="rect">
+            <a:avLst/>
+          </a:prstGeom>
+          <a:solidFill>
+            <a:srgbClr val="0A5C47">
+              <a:alpha val="88000"/>
+            </a:srgbClr>
+          </a:solidFill>
+          <a:ln w="15240">
+            <a:solidFill>
+              <a:srgbClr val="0A5C47"/>
+            </a:solidFill>
+            <a:prstDash val="solid"/>
+          </a:ln>
+        </p:spPr>
+      </p:sp>
+      <p:sp>
+        <p:nvSpPr>
+          <p:cNvPr id="144" name="Text 142"/>
+          <p:cNvSpPr/>
+          <p:nvPr/>
+        </p:nvSpPr>
+        <p:spPr>
+          <a:xfrm>
+            <a:off x="6815328" y="4672584"/>
+            <a:ext cx="2200656" cy="118872"/>
+          </a:xfrm>
+          <a:prstGeom prst="rect">
+            <a:avLst/>
+          </a:prstGeom>
+          <a:noFill/>
+          <a:ln/>
+        </p:spPr>
+        <p:txBody>
+          <a:bodyPr wrap="square" rtlCol="0" anchor="ctr"/>
+          <a:lstStyle/>
+          <a:p>
+            <a:pPr indent="0" marL="0">
+              <a:buNone/>
+            </a:pPr>
+            <a:r>
+              <a:rPr lang="en-US" sz="600" dirty="0">
+                <a:solidFill>
+                  <a:srgbClr val="FFFFFF"/>
+                </a:solidFill>
+                <a:latin typeface="Calibri" pitchFamily="34" charset="0"/>
+                <a:ea typeface="Calibri" pitchFamily="34" charset="-122"/>
+                <a:cs typeface="Calibri" pitchFamily="34" charset="-120"/>
+              </a:rPr>
+              <a:t>CommercialSignal — P2C…</a:t>
+            </a:r>
+            <a:endParaRPr lang="en-US" sz="600" dirty="0"/>
+          </a:p>
+        </p:txBody>
+      </p:sp>
+      <p:sp>
+        <p:nvSpPr>
+          <p:cNvPr id="145" name="Shape 143"/>
           <p:cNvSpPr/>
           <p:nvPr/>
         </p:nvSpPr>
@@ -17857,7 +18121,7 @@
       </p:sp>
       <p:sp>
         <p:nvSpPr>
-          <p:cNvPr id="138" name="Text 136"/>
+          <p:cNvPr id="146" name="Text 144"/>
           <p:cNvSpPr/>
           <p:nvPr/>
         </p:nvSpPr>
@@ -25027,7 +25291,7 @@
                 <a:ea typeface="Calibri" pitchFamily="34" charset="-122"/>
                 <a:cs typeface="Calibri" pitchFamily="34" charset="-120"/>
               </a:rPr>
-              <a:t>CommercialSignal — Banker Interface MVP</a:t>
+              <a:t>[Churn App] — MVP Interface Launch</a:t>
             </a:r>
             <a:endParaRPr lang="en-US" sz="850" dirty="0"/>
           </a:p>
@@ -25185,7 +25449,7 @@
                 <a:ea typeface="Calibri" pitchFamily="34" charset="-122"/>
                 <a:cs typeface="Calibri" pitchFamily="34" charset="-120"/>
               </a:rPr>
-              <a:t>CommercialSignal — P2C Detection Model Launch</a:t>
+              <a:t>[Churn App] — Foundation Anchor MVP</a:t>
             </a:r>
             <a:endParaRPr lang="en-US" sz="850" dirty="0"/>
           </a:p>
@@ -25762,7 +26026,7 @@
                 <a:ea typeface="Calibri" pitchFamily="34" charset="-122"/>
                 <a:cs typeface="Calibri" pitchFamily="34" charset="-120"/>
               </a:rPr>
-              <a:t>[Churn App] — Attrition Interface Build</a:t>
+              <a:t>Zelle Memo Intelligence — Interface Live</a:t>
             </a:r>
             <a:endParaRPr lang="en-US" sz="850" dirty="0"/>
           </a:p>
@@ -25920,7 +26184,7 @@
                 <a:ea typeface="Calibri" pitchFamily="34" charset="-122"/>
                 <a:cs typeface="Calibri" pitchFamily="34" charset="-120"/>
               </a:rPr>
-              <a:t>[Churn App] — Attrition Detection Model Build</a:t>
+              <a:t>Zelle Memo Intelligence — Payment Memo NLP Live</a:t>
             </a:r>
             <a:endParaRPr lang="en-US" sz="850" dirty="0"/>
           </a:p>
@@ -26497,7 +26761,7 @@
                 <a:ea typeface="Calibri" pitchFamily="34" charset="-122"/>
                 <a:cs typeface="Calibri" pitchFamily="34" charset="-120"/>
               </a:rPr>
-              <a:t>Wealth Deflection — Interface Launch</a:t>
+              <a:t>Anomaly Detection — Interface Launch</a:t>
             </a:r>
             <a:endParaRPr lang="en-US" sz="850" dirty="0"/>
           </a:p>
@@ -26655,7 +26919,7 @@
                 <a:ea typeface="Calibri" pitchFamily="34" charset="-122"/>
                 <a:cs typeface="Calibri" pitchFamily="34" charset="-120"/>
               </a:rPr>
-              <a:t>Wealth Deflection — Generational Retention Model</a:t>
+              <a:t>Anomaly Detection — Multi-Rail Payments Live</a:t>
             </a:r>
             <a:endParaRPr lang="en-US" sz="850" dirty="0"/>
           </a:p>
@@ -27232,7 +27496,7 @@
                 <a:ea typeface="Calibri" pitchFamily="34" charset="-122"/>
                 <a:cs typeface="Calibri" pitchFamily="34" charset="-120"/>
               </a:rPr>
-              <a:t>DS App Platform — Integration &amp; Scale</a:t>
+              <a:t>CommercialSignal — Interface Launch</a:t>
             </a:r>
             <a:endParaRPr lang="en-US" sz="850" dirty="0"/>
           </a:p>
@@ -27390,7 +27654,7 @@
                 <a:ea typeface="Calibri" pitchFamily="34" charset="-122"/>
                 <a:cs typeface="Calibri" pitchFamily="34" charset="-120"/>
               </a:rPr>
-              <a:t>MLOps — Full CI/CD &amp; Governance Complete</a:t>
+              <a:t>CommercialSignal — P2C Detection Launch</a:t>
             </a:r>
             <a:endParaRPr lang="en-US" sz="850" dirty="0"/>
           </a:p>

</xml_diff>

<commit_message>
Slide 6: Zelle Memo first, Churn split Ph.1 ACH / Ph.2 digital signals, Anomaly Detection replaced
</commit_message>
<xml_diff>
--- a/jhbi-roadmap-2026.pptx
+++ b/jhbi-roadmap-2026.pptx
@@ -12606,7 +12606,7 @@
                 <a:ea typeface="Calibri" pitchFamily="34" charset="-122"/>
                 <a:cs typeface="Calibri" pitchFamily="34" charset="-120"/>
               </a:rPr>
-              <a:t>[Churn App] — MVP Interface Launch</a:t>
+              <a:t>Zelle Memo Live  ·  [Churn App] Ph.1 Interface Build</a:t>
             </a:r>
             <a:endParaRPr lang="en-US" sz="850" dirty="0"/>
           </a:p>
@@ -12702,7 +12702,7 @@
                 <a:ea typeface="Calibri" pitchFamily="34" charset="-122"/>
                 <a:cs typeface="Calibri" pitchFamily="34" charset="-120"/>
               </a:rPr>
-              <a:t>Zelle Memo Intelligence — Interface Live</a:t>
+              <a:t>[Churn App] Ph.1 Live  ·  Ph.2 Interface Build</a:t>
             </a:r>
             <a:endParaRPr lang="en-US" sz="850" dirty="0"/>
           </a:p>
@@ -12798,7 +12798,7 @@
                 <a:ea typeface="Calibri" pitchFamily="34" charset="-122"/>
                 <a:cs typeface="Calibri" pitchFamily="34" charset="-120"/>
               </a:rPr>
-              <a:t>Anomaly Detection — Interface Launch</a:t>
+              <a:t>[Churn App] Ph.2 Live  ·  CommercialSignal Interface</a:t>
             </a:r>
             <a:endParaRPr lang="en-US" sz="850" dirty="0"/>
           </a:p>
@@ -13267,7 +13267,7 @@
                 <a:ea typeface="Calibri" pitchFamily="34" charset="-122"/>
                 <a:cs typeface="Calibri" pitchFamily="34" charset="-120"/>
               </a:rPr>
-              <a:t>[Churn App] — Foundation Anchor MVP</a:t>
+              <a:t>Zelle Memo Intelligence Live  ·  [Churn App] Ph.1 ACH Build</a:t>
             </a:r>
             <a:endParaRPr lang="en-US" sz="850" dirty="0"/>
           </a:p>
@@ -13363,7 +13363,7 @@
                 <a:ea typeface="Calibri" pitchFamily="34" charset="-122"/>
                 <a:cs typeface="Calibri" pitchFamily="34" charset="-120"/>
               </a:rPr>
-              <a:t>Zelle Memo Intelligence — Payment Memo NLP Live</a:t>
+              <a:t>[Churn App] Ph.1 Live  ·  Ph.2 Digital Signals Build</a:t>
             </a:r>
             <a:endParaRPr lang="en-US" sz="850" dirty="0"/>
           </a:p>
@@ -13459,7 +13459,7 @@
                 <a:ea typeface="Calibri" pitchFamily="34" charset="-122"/>
                 <a:cs typeface="Calibri" pitchFamily="34" charset="-120"/>
               </a:rPr>
-              <a:t>Anomaly Detection — Multi-Rail Payments Live</a:t>
+              <a:t>[Churn App] Ph.2 Live  ·  CommercialSignal Build</a:t>
             </a:r>
             <a:endParaRPr lang="en-US" sz="850" dirty="0"/>
           </a:p>
@@ -16908,7 +16908,7 @@
                 <a:ea typeface="Calibri" pitchFamily="34" charset="-122"/>
                 <a:cs typeface="Calibri" pitchFamily="34" charset="-120"/>
               </a:rPr>
-              <a:t>DS App Interface — [Churn App]</a:t>
+              <a:t>DS App Interface — Zelle Memo Intelligence</a:t>
             </a:r>
             <a:endParaRPr lang="en-US" sz="650" dirty="0"/>
           </a:p>
@@ -16974,7 +16974,7 @@
                 <a:ea typeface="Calibri" pitchFamily="34" charset="-122"/>
                 <a:cs typeface="Calibri" pitchFamily="34" charset="-120"/>
               </a:rPr>
-              <a:t>DS App Interface — [Ch…</a:t>
+              <a:t>DS App Interface — Zel…</a:t>
             </a:r>
             <a:endParaRPr lang="en-US" sz="600" dirty="0"/>
           </a:p>
@@ -17040,7 +17040,7 @@
                 <a:ea typeface="Calibri" pitchFamily="34" charset="-122"/>
                 <a:cs typeface="Calibri" pitchFamily="34" charset="-120"/>
               </a:rPr>
-              <a:t>DS App Interface — Zelle Memo Intelligence</a:t>
+              <a:t>DS App Interface — [Churn App] Ph.1</a:t>
             </a:r>
             <a:endParaRPr lang="en-US" sz="650" dirty="0"/>
           </a:p>
@@ -17055,7 +17055,7 @@
         <p:spPr>
           <a:xfrm>
             <a:off x="4486656" y="3090672"/>
-            <a:ext cx="1491488" cy="118872"/>
+            <a:ext cx="1873504" cy="118872"/>
           </a:xfrm>
           <a:prstGeom prst="rect">
             <a:avLst/>
@@ -17082,7 +17082,7 @@
         <p:spPr>
           <a:xfrm>
             <a:off x="4523232" y="3090672"/>
-            <a:ext cx="1436624" cy="118872"/>
+            <a:ext cx="1818640" cy="118872"/>
           </a:xfrm>
           <a:prstGeom prst="rect">
             <a:avLst/>
@@ -17106,7 +17106,7 @@
                 <a:ea typeface="Calibri" pitchFamily="34" charset="-122"/>
                 <a:cs typeface="Calibri" pitchFamily="34" charset="-120"/>
               </a:rPr>
-              <a:t>DS App Interface — Zel…</a:t>
+              <a:t>DS App Interface — [Ch…</a:t>
             </a:r>
             <a:endParaRPr lang="en-US" sz="600" dirty="0"/>
           </a:p>
@@ -17170,7 +17170,7 @@
                 <a:ea typeface="Calibri" pitchFamily="34" charset="-122"/>
                 <a:cs typeface="Calibri" pitchFamily="34" charset="-120"/>
               </a:rPr>
-              <a:t>DS App Interface — Anomaly Detection</a:t>
+              <a:t>DS App Interface — [Churn App] Ph.2</a:t>
             </a:r>
             <a:endParaRPr lang="en-US" sz="650" dirty="0"/>
           </a:p>
@@ -17185,7 +17185,7 @@
         <p:spPr>
           <a:xfrm>
             <a:off x="5632704" y="3291840"/>
-            <a:ext cx="1109472" cy="118872"/>
+            <a:ext cx="2255520" cy="118872"/>
           </a:xfrm>
           <a:prstGeom prst="rect">
             <a:avLst/>
@@ -17212,7 +17212,7 @@
         <p:spPr>
           <a:xfrm>
             <a:off x="5669280" y="3291840"/>
-            <a:ext cx="1054608" cy="118872"/>
+            <a:ext cx="2200656" cy="118872"/>
           </a:xfrm>
           <a:prstGeom prst="rect">
             <a:avLst/>
@@ -17236,7 +17236,7 @@
                 <a:ea typeface="Calibri" pitchFamily="34" charset="-122"/>
                 <a:cs typeface="Calibri" pitchFamily="34" charset="-120"/>
               </a:rPr>
-              <a:t>DS App Interface — Ano…</a:t>
+              <a:t>DS App Interface — [Ch…</a:t>
             </a:r>
             <a:endParaRPr lang="en-US" sz="600" dirty="0"/>
           </a:p>
@@ -17630,7 +17630,7 @@
                 <a:ea typeface="Calibri" pitchFamily="34" charset="-122"/>
                 <a:cs typeface="Calibri" pitchFamily="34" charset="-120"/>
               </a:rPr>
-              <a:t>[Churn App] — Foundation Anchor</a:t>
+              <a:t>Zelle Memo Intelligence — Payment Memo NLP</a:t>
             </a:r>
             <a:endParaRPr lang="en-US" sz="650" dirty="0"/>
           </a:p>
@@ -17696,7 +17696,7 @@
                 <a:ea typeface="Calibri" pitchFamily="34" charset="-122"/>
                 <a:cs typeface="Calibri" pitchFamily="34" charset="-120"/>
               </a:rPr>
-              <a:t>[Churn App] — Foundati…</a:t>
+              <a:t>Zelle Memo Intelligenc…</a:t>
             </a:r>
             <a:endParaRPr lang="en-US" sz="600" dirty="0"/>
           </a:p>
@@ -17762,7 +17762,7 @@
                 <a:ea typeface="Calibri" pitchFamily="34" charset="-122"/>
                 <a:cs typeface="Calibri" pitchFamily="34" charset="-120"/>
               </a:rPr>
-              <a:t>Zelle Memo Intelligence — Payment Memo NLP</a:t>
+              <a:t>[Churn App] Ph.1 — ACH &amp; Payments Model</a:t>
             </a:r>
             <a:endParaRPr lang="en-US" sz="650" dirty="0"/>
           </a:p>
@@ -17777,7 +17777,7 @@
         <p:spPr>
           <a:xfrm>
             <a:off x="4486656" y="4270248"/>
-            <a:ext cx="1491488" cy="118872"/>
+            <a:ext cx="1873504" cy="118872"/>
           </a:xfrm>
           <a:prstGeom prst="rect">
             <a:avLst/>
@@ -17804,7 +17804,7 @@
         <p:spPr>
           <a:xfrm>
             <a:off x="4523232" y="4270248"/>
-            <a:ext cx="1436624" cy="118872"/>
+            <a:ext cx="1818640" cy="118872"/>
           </a:xfrm>
           <a:prstGeom prst="rect">
             <a:avLst/>
@@ -17828,7 +17828,7 @@
                 <a:ea typeface="Calibri" pitchFamily="34" charset="-122"/>
                 <a:cs typeface="Calibri" pitchFamily="34" charset="-120"/>
               </a:rPr>
-              <a:t>Zelle Memo Intelligenc…</a:t>
+              <a:t>[Churn App] Ph.1 — ACH…</a:t>
             </a:r>
             <a:endParaRPr lang="en-US" sz="600" dirty="0"/>
           </a:p>
@@ -17892,7 +17892,7 @@
                 <a:ea typeface="Calibri" pitchFamily="34" charset="-122"/>
                 <a:cs typeface="Calibri" pitchFamily="34" charset="-120"/>
               </a:rPr>
-              <a:t>Anomaly Detection — Multi-Rail Payments</a:t>
+              <a:t>[Churn App] Ph.2 — Digital &amp; Extended Signals</a:t>
             </a:r>
             <a:endParaRPr lang="en-US" sz="650" dirty="0"/>
           </a:p>
@@ -17907,7 +17907,7 @@
         <p:spPr>
           <a:xfrm>
             <a:off x="5632704" y="4471416"/>
-            <a:ext cx="1109472" cy="118872"/>
+            <a:ext cx="2255520" cy="118872"/>
           </a:xfrm>
           <a:prstGeom prst="rect">
             <a:avLst/>
@@ -17934,7 +17934,7 @@
         <p:spPr>
           <a:xfrm>
             <a:off x="5669280" y="4471416"/>
-            <a:ext cx="1054608" cy="118872"/>
+            <a:ext cx="2200656" cy="118872"/>
           </a:xfrm>
           <a:prstGeom prst="rect">
             <a:avLst/>
@@ -17958,7 +17958,7 @@
                 <a:ea typeface="Calibri" pitchFamily="34" charset="-122"/>
                 <a:cs typeface="Calibri" pitchFamily="34" charset="-120"/>
               </a:rPr>
-              <a:t>Anomaly Detection — Mu…</a:t>
+              <a:t>[Churn App] Ph.2 — Dig…</a:t>
             </a:r>
             <a:endParaRPr lang="en-US" sz="600" dirty="0"/>
           </a:p>
@@ -25291,7 +25291,7 @@
                 <a:ea typeface="Calibri" pitchFamily="34" charset="-122"/>
                 <a:cs typeface="Calibri" pitchFamily="34" charset="-120"/>
               </a:rPr>
-              <a:t>[Churn App] — MVP Interface Launch</a:t>
+              <a:t>Zelle Memo Live  ·  [Churn App] Ph.1 Interface Build</a:t>
             </a:r>
             <a:endParaRPr lang="en-US" sz="850" dirty="0"/>
           </a:p>
@@ -25449,7 +25449,7 @@
                 <a:ea typeface="Calibri" pitchFamily="34" charset="-122"/>
                 <a:cs typeface="Calibri" pitchFamily="34" charset="-120"/>
               </a:rPr>
-              <a:t>[Churn App] — Foundation Anchor MVP</a:t>
+              <a:t>Zelle Memo Intelligence Live  ·  [Churn App] Ph.1 ACH Build</a:t>
             </a:r>
             <a:endParaRPr lang="en-US" sz="850" dirty="0"/>
           </a:p>
@@ -26026,7 +26026,7 @@
                 <a:ea typeface="Calibri" pitchFamily="34" charset="-122"/>
                 <a:cs typeface="Calibri" pitchFamily="34" charset="-120"/>
               </a:rPr>
-              <a:t>Zelle Memo Intelligence — Interface Live</a:t>
+              <a:t>[Churn App] Ph.1 Live  ·  Ph.2 Interface Build</a:t>
             </a:r>
             <a:endParaRPr lang="en-US" sz="850" dirty="0"/>
           </a:p>
@@ -26184,7 +26184,7 @@
                 <a:ea typeface="Calibri" pitchFamily="34" charset="-122"/>
                 <a:cs typeface="Calibri" pitchFamily="34" charset="-120"/>
               </a:rPr>
-              <a:t>Zelle Memo Intelligence — Payment Memo NLP Live</a:t>
+              <a:t>[Churn App] Ph.1 Live  ·  Ph.2 Digital Signals Build</a:t>
             </a:r>
             <a:endParaRPr lang="en-US" sz="850" dirty="0"/>
           </a:p>
@@ -26761,7 +26761,7 @@
                 <a:ea typeface="Calibri" pitchFamily="34" charset="-122"/>
                 <a:cs typeface="Calibri" pitchFamily="34" charset="-120"/>
               </a:rPr>
-              <a:t>Anomaly Detection — Interface Launch</a:t>
+              <a:t>[Churn App] Ph.2 Live  ·  CommercialSignal Interface</a:t>
             </a:r>
             <a:endParaRPr lang="en-US" sz="850" dirty="0"/>
           </a:p>
@@ -26919,7 +26919,7 @@
                 <a:ea typeface="Calibri" pitchFamily="34" charset="-122"/>
                 <a:cs typeface="Calibri" pitchFamily="34" charset="-120"/>
               </a:rPr>
-              <a:t>Anomaly Detection — Multi-Rail Payments Live</a:t>
+              <a:t>[Churn App] Ph.2 Live  ·  CommercialSignal Build</a:t>
             </a:r>
             <a:endParaRPr lang="en-US" sz="850" dirty="0"/>
           </a:p>

</xml_diff>